<commit_message>
Add baseline simulation results and dashboard evidence to presentation; update slide formatting
</commit_message>
<xml_diff>
--- a/presentation/FracHIV_SITA_Presentation.pptx
+++ b/presentation/FracHIV_SITA_Presentation.pptx
@@ -2,7 +2,7 @@
 <file path=ppt/presentation.xml><?xml version="1.0" encoding="utf-8"?>
 <p:presentation xmlns:a="http://schemas.openxmlformats.org/drawingml/2006/main" xmlns:r="http://schemas.openxmlformats.org/officeDocument/2006/relationships" xmlns:p="http://schemas.openxmlformats.org/presentationml/2006/main">
   <p:sldMasterIdLst>
-    <p:sldMasterId id="2147483648" r:id="rId11"/>
+    <p:sldMasterId id="2147483648" r:id="rId13"/>
   </p:sldMasterIdLst>
   <p:sldIdLst>
     <p:sldId id="256" r:id="rId1"/>
@@ -15,6 +15,8 @@
     <p:sldId id="263" r:id="rId8"/>
     <p:sldId id="264" r:id="rId9"/>
     <p:sldId id="265" r:id="rId10"/>
+    <p:sldId id="266" r:id="rId11"/>
+    <p:sldId id="267" r:id="rId12"/>
   </p:sldIdLst>
   <p:sldSz cx="12191999" cy="6858000" type="screen16x9"/>
   <p:notesSz cx="6858000" cy="9144000"/>
@@ -450,7 +452,7 @@
       </p:grpSpPr>
       <p:sp>
         <p:nvSpPr>
-          <p:cNvPr id="92" name="Text 92"/>
+          <p:cNvPr id="94" name="Text 94"/>
           <p:cNvSpPr txBox="1"/>
           <p:nvPr/>
         </p:nvSpPr>
@@ -481,14 +483,14 @@
                 </a:solidFill>
                 <a:latin typeface="Aptos"/>
               </a:rPr>
-              <a:t>Live Demo, Conclusion + Recommendations</a:t>
-            </a:r>
-          </a:p>
-        </p:txBody>
-      </p:sp>
-      <p:sp>
-        <p:nvSpPr>
-          <p:cNvPr id="93" name="Text 93"/>
+              <a:t>Simulation Results: Fractional Memory</a:t>
+            </a:r>
+          </a:p>
+        </p:txBody>
+      </p:sp>
+      <p:sp>
+        <p:nvSpPr>
+          <p:cNvPr id="95" name="Text 95"/>
           <p:cNvSpPr txBox="1"/>
           <p:nvPr/>
         </p:nvSpPr>
@@ -528,7 +530,7 @@
       </p:sp>
       <p:sp>
         <p:nvSpPr>
-          <p:cNvPr id="94" name="Text 94"/>
+          <p:cNvPr id="96" name="Text 96"/>
           <p:cNvSpPr txBox="1"/>
           <p:nvPr/>
         </p:nvSpPr>
@@ -566,16 +568,38 @@
           </a:p>
         </p:txBody>
       </p:sp>
-      <p:sp>
-        <p:nvSpPr>
-          <p:cNvPr id="95" name="Text 95"/>
-          <p:cNvSpPr txBox="1"/>
-          <p:nvPr/>
-        </p:nvSpPr>
-        <p:spPr>
-          <a:xfrm>
-            <a:off x="658368" y="1234440"/>
-            <a:ext cx="4709160" cy="320040"/>
+      <p:pic>
+        <p:nvPicPr>
+          <p:cNvPr id="93" name="memoryChart.png"/>
+          <p:cNvPicPr/>
+          <p:nvPr/>
+        </p:nvPicPr>
+        <p:blipFill>
+          <a:blip r:embed="rId2"/>
+          <a:stretch>
+            <a:fillRect/>
+          </a:stretch>
+        </p:blipFill>
+        <p:spPr>
+          <a:xfrm>
+            <a:off x="658368" y="1298448"/>
+            <a:ext cx="6217920" cy="4206240"/>
+          </a:xfrm>
+          <a:prstGeom prst="rect">
+            <a:avLst/>
+          </a:prstGeom>
+        </p:spPr>
+      </p:pic>
+      <p:sp>
+        <p:nvSpPr>
+          <p:cNvPr id="97" name="Text 97"/>
+          <p:cNvSpPr txBox="1"/>
+          <p:nvPr/>
+        </p:nvSpPr>
+        <p:spPr>
+          <a:xfrm>
+            <a:off x="7360920" y="1325880"/>
+            <a:ext cx="3566160" cy="320040"/>
           </a:xfrm>
           <a:prstGeom prst="rect">
             <a:avLst/>
@@ -599,21 +623,21 @@
                 </a:solidFill>
                 <a:latin typeface="Aptos"/>
               </a:rPr>
-              <a:t>Live demo plan</a:t>
-            </a:r>
-          </a:p>
-        </p:txBody>
-      </p:sp>
-      <p:sp>
-        <p:nvSpPr>
-          <p:cNvPr id="96" name="Text 96"/>
-          <p:cNvSpPr txBox="1"/>
-          <p:nvPr/>
-        </p:nvSpPr>
-        <p:spPr>
-          <a:xfrm>
-            <a:off x="713232" y="1627632"/>
-            <a:ext cx="4800600" cy="2880360"/>
+              <a:t>Why q matters</a:t>
+            </a:r>
+          </a:p>
+        </p:txBody>
+      </p:sp>
+      <p:sp>
+        <p:nvSpPr>
+          <p:cNvPr id="98" name="Text 98"/>
+          <p:cNvSpPr txBox="1"/>
+          <p:nvPr/>
+        </p:nvSpPr>
+        <p:spPr>
+          <a:xfrm>
+            <a:off x="7406640" y="1719072"/>
+            <a:ext cx="3520440" cy="1691640"/>
           </a:xfrm>
           <a:prstGeom prst="rect">
             <a:avLst/>
@@ -634,13 +658,13 @@
               <a:buFont typeface="Arial"/>
             </a:pPr>
             <a:r>
-              <a:rPr lang="en-US" sz="1800" b="0">
-                <a:solidFill>
-                  <a:srgbClr val="142030"/>
-                </a:solidFill>
-                <a:latin typeface="Aptos"/>
-              </a:rPr>
-              <a:t>Open the deployed simulator.</a:t>
+              <a:rPr lang="en-US" sz="1600" b="0">
+                <a:solidFill>
+                  <a:srgbClr val="142030"/>
+                </a:solidFill>
+                <a:latin typeface="Aptos"/>
+              </a:rPr>
+              <a:t>q = 1 represents the ordinary model.</a:t>
             </a:r>
           </a:p>
           <a:p>
@@ -649,13 +673,13 @@
               <a:buFont typeface="Arial"/>
             </a:pPr>
             <a:r>
-              <a:rPr lang="en-US" sz="1800" b="0">
-                <a:solidFill>
-                  <a:srgbClr val="142030"/>
-                </a:solidFill>
-                <a:latin typeface="Aptos"/>
-              </a:rPr>
-              <a:t>Run the moving SITA graph.</a:t>
+              <a:rPr lang="en-US" sz="1600" b="0">
+                <a:solidFill>
+                  <a:srgbClr val="142030"/>
+                </a:solidFill>
+                <a:latin typeface="Aptos"/>
+              </a:rPr>
+              <a:t>Smaller q values strengthen the memory effect.</a:t>
             </a:r>
           </a:p>
           <a:p>
@@ -664,28 +688,311 @@
               <a:buFont typeface="Arial"/>
             </a:pPr>
             <a:r>
-              <a:rPr lang="en-US" sz="1800" b="0">
-                <a:solidFill>
-                  <a:srgbClr val="142030"/>
-                </a:solidFill>
-                <a:latin typeface="Aptos"/>
-              </a:rPr>
-              <a:t>Compare no intervention with combined intervention.</a:t>
-            </a:r>
-          </a:p>
+              <a:rPr lang="en-US" sz="1600" b="0">
+                <a:solidFill>
+                  <a:srgbClr val="142030"/>
+                </a:solidFill>
+                <a:latin typeface="Aptos"/>
+              </a:rPr>
+              <a:t>Different q values produce visibly different trajectories.</a:t>
+            </a:r>
+          </a:p>
+        </p:txBody>
+      </p:sp>
+      <p:sp>
+        <p:nvSpPr>
+          <p:cNvPr id="99" name="Text 99"/>
+          <p:cNvSpPr txBox="1"/>
+          <p:nvPr/>
+        </p:nvSpPr>
+        <p:spPr>
+          <a:xfrm>
+            <a:off x="7360920" y="4005072"/>
+            <a:ext cx="3611880" cy="914400"/>
+          </a:xfrm>
+          <a:prstGeom prst="rect">
+            <a:avLst/>
+          </a:prstGeom>
+          <a:solidFill>
+            <a:srgbClr val="FFF7E0"/>
+          </a:solidFill>
+          <a:ln w="9525">
+            <a:solidFill>
+              <a:srgbClr val="CC9900"/>
+            </a:solidFill>
+          </a:ln>
+        </p:spPr>
+        <p:txBody>
+          <a:bodyPr wrap="square" lIns="91440" rIns="91440" tIns="45720" bIns="45720">
+            <a:normAutofit fontScale="85000" lnSpcReduction="20000"/>
+          </a:bodyPr>
+          <a:lstStyle/>
+          <a:p>
+            <a:pPr algn="l"/>
+            <a:r>
+              <a:rPr lang="en-US" sz="1500" b="0">
+                <a:solidFill>
+                  <a:srgbClr val="142030"/>
+                </a:solidFill>
+                <a:latin typeface="Aptos"/>
+              </a:rPr>
+              <a:t>Defense point</a:t>
+            </a:r>
+          </a:p>
+          <a:p>
+            <a:pPr algn="l"/>
+            <a:r>
+              <a:rPr lang="en-US" sz="1500" b="0">
+                <a:solidFill>
+                  <a:srgbClr val="142030"/>
+                </a:solidFill>
+                <a:latin typeface="Aptos"/>
+              </a:rPr>
+              <a:t>Fractional calculus is not decorative; it changes the simulated dynamics.</a:t>
+            </a:r>
+          </a:p>
+        </p:txBody>
+      </p:sp>
+    </p:spTree>
+  </p:cSld>
+  <p:clrMapOvr>
+    <a:masterClrMapping/>
+  </p:clrMapOvr>
+</p:sld>
+</file>
+
+<file path=ppt/slides/slide11.xml><?xml version="1.0" encoding="utf-8"?>
+<p:sld xmlns:a="http://schemas.openxmlformats.org/drawingml/2006/main" xmlns:r="http://schemas.openxmlformats.org/officeDocument/2006/relationships" xmlns:p="http://schemas.openxmlformats.org/presentationml/2006/main">
+  <p:cSld>
+    <p:spTree>
+      <p:nvGrpSpPr>
+        <p:cNvPr id="1" name=""/>
+        <p:cNvGrpSpPr/>
+        <p:nvPr/>
+      </p:nvGrpSpPr>
+      <p:grpSpPr>
+        <a:xfrm>
+          <a:off x="0" y="0"/>
+          <a:ext cx="0" cy="0"/>
+          <a:chOff x="0" y="0"/>
+          <a:chExt cx="0" cy="0"/>
+        </a:xfrm>
+      </p:grpSpPr>
+      <p:sp>
+        <p:nvSpPr>
+          <p:cNvPr id="102" name="Text 102"/>
+          <p:cNvSpPr txBox="1"/>
+          <p:nvPr/>
+        </p:nvSpPr>
+        <p:spPr>
+          <a:xfrm>
+            <a:off x="502920" y="292608"/>
+            <a:ext cx="10058400" cy="384048"/>
+          </a:xfrm>
+          <a:prstGeom prst="rect">
+            <a:avLst/>
+          </a:prstGeom>
+          <a:noFill/>
+          <a:ln>
+            <a:noFill/>
+          </a:ln>
+        </p:spPr>
+        <p:txBody>
+          <a:bodyPr wrap="square" lIns="91440" rIns="91440" tIns="45720" bIns="45720">
+            <a:normAutofit fontScale="85000" lnSpcReduction="20000"/>
+          </a:bodyPr>
+          <a:lstStyle/>
+          <a:p>
+            <a:pPr algn="l"/>
+            <a:r>
+              <a:rPr lang="en-US" sz="2300" b="1">
+                <a:solidFill>
+                  <a:srgbClr val="0A1B30"/>
+                </a:solidFill>
+                <a:latin typeface="Aptos"/>
+              </a:rPr>
+              <a:t>Dashboard and Sensitivity Evidence</a:t>
+            </a:r>
+          </a:p>
+        </p:txBody>
+      </p:sp>
+      <p:sp>
+        <p:nvSpPr>
+          <p:cNvPr id="103" name="Text 103"/>
+          <p:cNvSpPr txBox="1"/>
+          <p:nvPr/>
+        </p:nvSpPr>
+        <p:spPr>
+          <a:xfrm>
+            <a:off x="502920" y="868680"/>
+            <a:ext cx="1828800" cy="27432"/>
+          </a:xfrm>
+          <a:prstGeom prst="rect">
+            <a:avLst/>
+          </a:prstGeom>
+          <a:solidFill>
+            <a:srgbClr val="CC9900"/>
+          </a:solidFill>
+          <a:ln>
+            <a:noFill/>
+          </a:ln>
+        </p:spPr>
+        <p:txBody>
+          <a:bodyPr wrap="square" lIns="91440" rIns="91440" tIns="45720" bIns="45720">
+            <a:normAutofit fontScale="85000" lnSpcReduction="20000"/>
+          </a:bodyPr>
+          <a:lstStyle/>
+          <a:p>
+            <a:pPr algn="l"/>
+            <a:r>
+              <a:rPr lang="en-US" sz="2400" b="0">
+                <a:solidFill>
+                  <a:srgbClr val="142030"/>
+                </a:solidFill>
+                <a:latin typeface="Aptos"/>
+              </a:rPr>
+              <a:t/>
+            </a:r>
+          </a:p>
+        </p:txBody>
+      </p:sp>
+      <p:sp>
+        <p:nvSpPr>
+          <p:cNvPr id="104" name="Text 104"/>
+          <p:cNvSpPr txBox="1"/>
+          <p:nvPr/>
+        </p:nvSpPr>
+        <p:spPr>
+          <a:xfrm>
+            <a:off x="2331720" y="868680"/>
+            <a:ext cx="6949440" cy="27432"/>
+          </a:xfrm>
+          <a:prstGeom prst="rect">
+            <a:avLst/>
+          </a:prstGeom>
+          <a:solidFill>
+            <a:srgbClr val="007E70"/>
+          </a:solidFill>
+          <a:ln>
+            <a:noFill/>
+          </a:ln>
+        </p:spPr>
+        <p:txBody>
+          <a:bodyPr wrap="square" lIns="91440" rIns="91440" tIns="45720" bIns="45720">
+            <a:normAutofit fontScale="85000" lnSpcReduction="20000"/>
+          </a:bodyPr>
+          <a:lstStyle/>
+          <a:p>
+            <a:pPr algn="l"/>
+            <a:r>
+              <a:rPr lang="en-US" sz="2400" b="0">
+                <a:solidFill>
+                  <a:srgbClr val="142030"/>
+                </a:solidFill>
+                <a:latin typeface="Aptos"/>
+              </a:rPr>
+              <a:t/>
+            </a:r>
+          </a:p>
+        </p:txBody>
+      </p:sp>
+      <p:pic>
+        <p:nvPicPr>
+          <p:cNvPr id="100" name="sensitivityChart.png"/>
+          <p:cNvPicPr/>
+          <p:nvPr/>
+        </p:nvPicPr>
+        <p:blipFill>
+          <a:blip r:embed="rId2"/>
+          <a:stretch>
+            <a:fillRect/>
+          </a:stretch>
+        </p:blipFill>
+        <p:spPr>
+          <a:xfrm>
+            <a:off x="658368" y="1298448"/>
+            <a:ext cx="6217920" cy="4206240"/>
+          </a:xfrm>
+          <a:prstGeom prst="rect">
+            <a:avLst/>
+          </a:prstGeom>
+        </p:spPr>
+      </p:pic>
+      <p:sp>
+        <p:nvSpPr>
+          <p:cNvPr id="105" name="Text 105"/>
+          <p:cNvSpPr txBox="1"/>
+          <p:nvPr/>
+        </p:nvSpPr>
+        <p:spPr>
+          <a:xfrm>
+            <a:off x="7360920" y="1325880"/>
+            <a:ext cx="3566160" cy="320040"/>
+          </a:xfrm>
+          <a:prstGeom prst="rect">
+            <a:avLst/>
+          </a:prstGeom>
+          <a:noFill/>
+          <a:ln>
+            <a:noFill/>
+          </a:ln>
+        </p:spPr>
+        <p:txBody>
+          <a:bodyPr wrap="square" lIns="91440" rIns="91440" tIns="45720" bIns="45720">
+            <a:normAutofit fontScale="85000" lnSpcReduction="20000"/>
+          </a:bodyPr>
+          <a:lstStyle/>
+          <a:p>
+            <a:pPr algn="l"/>
+            <a:r>
+              <a:rPr lang="en-US" sz="1500" b="1">
+                <a:solidFill>
+                  <a:srgbClr val="CC9900"/>
+                </a:solidFill>
+                <a:latin typeface="Aptos"/>
+              </a:rPr>
+              <a:t>Main evidence</a:t>
+            </a:r>
+          </a:p>
+        </p:txBody>
+      </p:sp>
+      <p:sp>
+        <p:nvSpPr>
+          <p:cNvPr id="106" name="Text 106"/>
+          <p:cNvSpPr txBox="1"/>
+          <p:nvPr/>
+        </p:nvSpPr>
+        <p:spPr>
+          <a:xfrm>
+            <a:off x="7406640" y="1719072"/>
+            <a:ext cx="3520440" cy="1600200"/>
+          </a:xfrm>
+          <a:prstGeom prst="rect">
+            <a:avLst/>
+          </a:prstGeom>
+          <a:noFill/>
+          <a:ln>
+            <a:noFill/>
+          </a:ln>
+        </p:spPr>
+        <p:txBody>
+          <a:bodyPr wrap="square" lIns="91440" rIns="91440" tIns="45720" bIns="45720">
+            <a:normAutofit fontScale="85000" lnSpcReduction="20000"/>
+          </a:bodyPr>
+          <a:lstStyle/>
           <a:p>
             <a:pPr algn="l">
               <a:buChar char="•"/>
               <a:buFont typeface="Arial"/>
             </a:pPr>
             <a:r>
-              <a:rPr lang="en-US" sz="1800" b="0">
-                <a:solidFill>
-                  <a:srgbClr val="142030"/>
-                </a:solidFill>
-                <a:latin typeface="Aptos"/>
-              </a:rPr>
-              <a:t>Compare q = 1 with q &lt; 1.</a:t>
+              <a:rPr lang="en-US" sz="1500" b="0">
+                <a:solidFill>
+                  <a:srgbClr val="142030"/>
+                </a:solidFill>
+                <a:latin typeface="Aptos"/>
+              </a:rPr>
+              <a:t>Transmission-related quantities dominate R0 sensitivity.</a:t>
             </a:r>
           </a:p>
           <a:p>
@@ -694,94 +1001,259 @@
               <a:buFont typeface="Arial"/>
             </a:pPr>
             <a:r>
-              <a:rPr lang="en-US" sz="1800" b="0">
-                <a:solidFill>
-                  <a:srgbClr val="142030"/>
-                </a:solidFill>
-                <a:latin typeface="Aptos"/>
-              </a:rPr>
-              <a:t>Show scenario and sensitivity views briefly.</a:t>
-            </a:r>
-          </a:p>
-        </p:txBody>
-      </p:sp>
-      <p:sp>
-        <p:nvSpPr>
-          <p:cNvPr id="97" name="Text 97"/>
-          <p:cNvSpPr txBox="1"/>
-          <p:nvPr/>
-        </p:nvSpPr>
-        <p:spPr>
-          <a:xfrm>
-            <a:off x="6080760" y="1234440"/>
-            <a:ext cx="4663440" cy="320040"/>
-          </a:xfrm>
-          <a:prstGeom prst="rect">
-            <a:avLst/>
-          </a:prstGeom>
-          <a:noFill/>
-          <a:ln>
-            <a:noFill/>
-          </a:ln>
-        </p:spPr>
-        <p:txBody>
-          <a:bodyPr wrap="square" lIns="91440" rIns="91440" tIns="45720" bIns="45720">
-            <a:normAutofit fontScale="85000" lnSpcReduction="20000"/>
-          </a:bodyPr>
-          <a:lstStyle/>
-          <a:p>
-            <a:pPr algn="l"/>
-            <a:r>
-              <a:rPr lang="en-US" sz="1500" b="1">
-                <a:solidFill>
-                  <a:srgbClr val="CC9900"/>
-                </a:solidFill>
-                <a:latin typeface="Aptos"/>
-              </a:rPr>
-              <a:t>Conclusion</a:t>
-            </a:r>
-          </a:p>
-        </p:txBody>
-      </p:sp>
-      <p:sp>
-        <p:nvSpPr>
-          <p:cNvPr id="98" name="Text 98"/>
-          <p:cNvSpPr txBox="1"/>
-          <p:nvPr/>
-        </p:nvSpPr>
-        <p:spPr>
-          <a:xfrm>
-            <a:off x="6144768" y="1627632"/>
-            <a:ext cx="4800600" cy="2880360"/>
-          </a:xfrm>
-          <a:prstGeom prst="rect">
-            <a:avLst/>
-          </a:prstGeom>
-          <a:noFill/>
-          <a:ln>
-            <a:noFill/>
-          </a:ln>
-        </p:spPr>
-        <p:txBody>
-          <a:bodyPr wrap="square" lIns="91440" rIns="91440" tIns="45720" bIns="45720">
-            <a:normAutofit fontScale="85000" lnSpcReduction="20000"/>
-          </a:bodyPr>
-          <a:lstStyle/>
+              <a:rPr lang="en-US" sz="1500" b="0">
+                <a:solidFill>
+                  <a:srgbClr val="142030"/>
+                </a:solidFill>
+                <a:latin typeface="Aptos"/>
+              </a:rPr>
+              <a:t>Safer behaviour and awareness reduce R0 strongly.</a:t>
+            </a:r>
+          </a:p>
           <a:p>
             <a:pPr algn="l">
               <a:buChar char="•"/>
               <a:buFont typeface="Arial"/>
             </a:pPr>
             <a:r>
-              <a:rPr lang="en-US" sz="1800" b="0">
-                <a:solidFill>
-                  <a:srgbClr val="142030"/>
-                </a:solidFill>
-                <a:latin typeface="Aptos"/>
-              </a:rPr>
-              <a:t>The SITA HIV model was extended using fractional memory.</a:t>
-            </a:r>
-          </a:p>
+              <a:rPr lang="en-US" sz="1500" b="0">
+                <a:solidFill>
+                  <a:srgbClr val="142030"/>
+                </a:solidFill>
+                <a:latin typeface="Aptos"/>
+              </a:rPr>
+              <a:t>Dashboard outputs support thesis discussion and live defense.</a:t>
+            </a:r>
+          </a:p>
+        </p:txBody>
+      </p:sp>
+      <p:pic>
+        <p:nvPicPr>
+          <p:cNvPr id="101" name="dashboardBaselineFigure.png"/>
+          <p:cNvPicPr/>
+          <p:nvPr/>
+        </p:nvPicPr>
+        <p:blipFill>
+          <a:blip r:embed="rId3"/>
+          <a:stretch>
+            <a:fillRect/>
+          </a:stretch>
+        </p:blipFill>
+        <p:spPr>
+          <a:xfrm>
+            <a:off x="7406640" y="3767328"/>
+            <a:ext cx="3383280" cy="1627632"/>
+          </a:xfrm>
+          <a:prstGeom prst="rect">
+            <a:avLst/>
+          </a:prstGeom>
+        </p:spPr>
+      </p:pic>
+    </p:spTree>
+  </p:cSld>
+  <p:clrMapOvr>
+    <a:masterClrMapping/>
+  </p:clrMapOvr>
+</p:sld>
+</file>
+
+<file path=ppt/slides/slide12.xml><?xml version="1.0" encoding="utf-8"?>
+<p:sld xmlns:a="http://schemas.openxmlformats.org/drawingml/2006/main" xmlns:r="http://schemas.openxmlformats.org/officeDocument/2006/relationships" xmlns:p="http://schemas.openxmlformats.org/presentationml/2006/main">
+  <p:cSld>
+    <p:spTree>
+      <p:nvGrpSpPr>
+        <p:cNvPr id="1" name=""/>
+        <p:cNvGrpSpPr/>
+        <p:nvPr/>
+      </p:nvGrpSpPr>
+      <p:grpSpPr>
+        <a:xfrm>
+          <a:off x="0" y="0"/>
+          <a:ext cx="0" cy="0"/>
+          <a:chOff x="0" y="0"/>
+          <a:chExt cx="0" cy="0"/>
+        </a:xfrm>
+      </p:grpSpPr>
+      <p:sp>
+        <p:nvSpPr>
+          <p:cNvPr id="107" name="Text 107"/>
+          <p:cNvSpPr txBox="1"/>
+          <p:nvPr/>
+        </p:nvSpPr>
+        <p:spPr>
+          <a:xfrm>
+            <a:off x="502920" y="292608"/>
+            <a:ext cx="10058400" cy="384048"/>
+          </a:xfrm>
+          <a:prstGeom prst="rect">
+            <a:avLst/>
+          </a:prstGeom>
+          <a:noFill/>
+          <a:ln>
+            <a:noFill/>
+          </a:ln>
+        </p:spPr>
+        <p:txBody>
+          <a:bodyPr wrap="square" lIns="91440" rIns="91440" tIns="45720" bIns="45720">
+            <a:normAutofit fontScale="85000" lnSpcReduction="20000"/>
+          </a:bodyPr>
+          <a:lstStyle/>
+          <a:p>
+            <a:pPr algn="l"/>
+            <a:r>
+              <a:rPr lang="en-US" sz="2300" b="1">
+                <a:solidFill>
+                  <a:srgbClr val="0A1B30"/>
+                </a:solidFill>
+                <a:latin typeface="Aptos"/>
+              </a:rPr>
+              <a:t>Live Demo, Conclusion + Recommendations</a:t>
+            </a:r>
+          </a:p>
+        </p:txBody>
+      </p:sp>
+      <p:sp>
+        <p:nvSpPr>
+          <p:cNvPr id="108" name="Text 108"/>
+          <p:cNvSpPr txBox="1"/>
+          <p:nvPr/>
+        </p:nvSpPr>
+        <p:spPr>
+          <a:xfrm>
+            <a:off x="502920" y="868680"/>
+            <a:ext cx="1828800" cy="27432"/>
+          </a:xfrm>
+          <a:prstGeom prst="rect">
+            <a:avLst/>
+          </a:prstGeom>
+          <a:solidFill>
+            <a:srgbClr val="CC9900"/>
+          </a:solidFill>
+          <a:ln>
+            <a:noFill/>
+          </a:ln>
+        </p:spPr>
+        <p:txBody>
+          <a:bodyPr wrap="square" lIns="91440" rIns="91440" tIns="45720" bIns="45720">
+            <a:normAutofit fontScale="85000" lnSpcReduction="20000"/>
+          </a:bodyPr>
+          <a:lstStyle/>
+          <a:p>
+            <a:pPr algn="l"/>
+            <a:r>
+              <a:rPr lang="en-US" sz="2400" b="0">
+                <a:solidFill>
+                  <a:srgbClr val="142030"/>
+                </a:solidFill>
+                <a:latin typeface="Aptos"/>
+              </a:rPr>
+              <a:t/>
+            </a:r>
+          </a:p>
+        </p:txBody>
+      </p:sp>
+      <p:sp>
+        <p:nvSpPr>
+          <p:cNvPr id="109" name="Text 109"/>
+          <p:cNvSpPr txBox="1"/>
+          <p:nvPr/>
+        </p:nvSpPr>
+        <p:spPr>
+          <a:xfrm>
+            <a:off x="2331720" y="868680"/>
+            <a:ext cx="6949440" cy="27432"/>
+          </a:xfrm>
+          <a:prstGeom prst="rect">
+            <a:avLst/>
+          </a:prstGeom>
+          <a:solidFill>
+            <a:srgbClr val="007E70"/>
+          </a:solidFill>
+          <a:ln>
+            <a:noFill/>
+          </a:ln>
+        </p:spPr>
+        <p:txBody>
+          <a:bodyPr wrap="square" lIns="91440" rIns="91440" tIns="45720" bIns="45720">
+            <a:normAutofit fontScale="85000" lnSpcReduction="20000"/>
+          </a:bodyPr>
+          <a:lstStyle/>
+          <a:p>
+            <a:pPr algn="l"/>
+            <a:r>
+              <a:rPr lang="en-US" sz="2400" b="0">
+                <a:solidFill>
+                  <a:srgbClr val="142030"/>
+                </a:solidFill>
+                <a:latin typeface="Aptos"/>
+              </a:rPr>
+              <a:t/>
+            </a:r>
+          </a:p>
+        </p:txBody>
+      </p:sp>
+      <p:sp>
+        <p:nvSpPr>
+          <p:cNvPr id="110" name="Text 110"/>
+          <p:cNvSpPr txBox="1"/>
+          <p:nvPr/>
+        </p:nvSpPr>
+        <p:spPr>
+          <a:xfrm>
+            <a:off x="658368" y="1234440"/>
+            <a:ext cx="4709160" cy="320040"/>
+          </a:xfrm>
+          <a:prstGeom prst="rect">
+            <a:avLst/>
+          </a:prstGeom>
+          <a:noFill/>
+          <a:ln>
+            <a:noFill/>
+          </a:ln>
+        </p:spPr>
+        <p:txBody>
+          <a:bodyPr wrap="square" lIns="91440" rIns="91440" tIns="45720" bIns="45720">
+            <a:normAutofit fontScale="85000" lnSpcReduction="20000"/>
+          </a:bodyPr>
+          <a:lstStyle/>
+          <a:p>
+            <a:pPr algn="l"/>
+            <a:r>
+              <a:rPr lang="en-US" sz="1500" b="1">
+                <a:solidFill>
+                  <a:srgbClr val="CC9900"/>
+                </a:solidFill>
+                <a:latin typeface="Aptos"/>
+              </a:rPr>
+              <a:t>Live demo plan</a:t>
+            </a:r>
+          </a:p>
+        </p:txBody>
+      </p:sp>
+      <p:sp>
+        <p:nvSpPr>
+          <p:cNvPr id="111" name="Text 111"/>
+          <p:cNvSpPr txBox="1"/>
+          <p:nvPr/>
+        </p:nvSpPr>
+        <p:spPr>
+          <a:xfrm>
+            <a:off x="713232" y="1627632"/>
+            <a:ext cx="4800600" cy="2880360"/>
+          </a:xfrm>
+          <a:prstGeom prst="rect">
+            <a:avLst/>
+          </a:prstGeom>
+          <a:noFill/>
+          <a:ln>
+            <a:noFill/>
+          </a:ln>
+        </p:spPr>
+        <p:txBody>
+          <a:bodyPr wrap="square" lIns="91440" rIns="91440" tIns="45720" bIns="45720">
+            <a:normAutofit fontScale="85000" lnSpcReduction="20000"/>
+          </a:bodyPr>
+          <a:lstStyle/>
           <a:p>
             <a:pPr algn="l">
               <a:buChar char="•"/>
@@ -794,7 +1266,7 @@
                 </a:solidFill>
                 <a:latin typeface="Aptos"/>
               </a:rPr>
-              <a:t>Behavioural interventions were represented through effective rates.</a:t>
+              <a:t>Open the deployed simulator.</a:t>
             </a:r>
           </a:p>
           <a:p>
@@ -809,7 +1281,7 @@
                 </a:solidFill>
                 <a:latin typeface="Aptos"/>
               </a:rPr>
-              <a:t>Numerical simulations support combined intervention strategies.</a:t>
+              <a:t>Run the moving SITA graph.</a:t>
             </a:r>
           </a:p>
           <a:p>
@@ -824,6 +1296,160 @@
                 </a:solidFill>
                 <a:latin typeface="Aptos"/>
               </a:rPr>
+              <a:t>Compare no intervention with combined intervention.</a:t>
+            </a:r>
+          </a:p>
+          <a:p>
+            <a:pPr algn="l">
+              <a:buChar char="•"/>
+              <a:buFont typeface="Arial"/>
+            </a:pPr>
+            <a:r>
+              <a:rPr lang="en-US" sz="1800" b="0">
+                <a:solidFill>
+                  <a:srgbClr val="142030"/>
+                </a:solidFill>
+                <a:latin typeface="Aptos"/>
+              </a:rPr>
+              <a:t>Compare q = 1 with q &lt; 1.</a:t>
+            </a:r>
+          </a:p>
+          <a:p>
+            <a:pPr algn="l">
+              <a:buChar char="•"/>
+              <a:buFont typeface="Arial"/>
+            </a:pPr>
+            <a:r>
+              <a:rPr lang="en-US" sz="1800" b="0">
+                <a:solidFill>
+                  <a:srgbClr val="142030"/>
+                </a:solidFill>
+                <a:latin typeface="Aptos"/>
+              </a:rPr>
+              <a:t>Show scenario and sensitivity views briefly.</a:t>
+            </a:r>
+          </a:p>
+        </p:txBody>
+      </p:sp>
+      <p:sp>
+        <p:nvSpPr>
+          <p:cNvPr id="112" name="Text 112"/>
+          <p:cNvSpPr txBox="1"/>
+          <p:nvPr/>
+        </p:nvSpPr>
+        <p:spPr>
+          <a:xfrm>
+            <a:off x="6080760" y="1234440"/>
+            <a:ext cx="4663440" cy="320040"/>
+          </a:xfrm>
+          <a:prstGeom prst="rect">
+            <a:avLst/>
+          </a:prstGeom>
+          <a:noFill/>
+          <a:ln>
+            <a:noFill/>
+          </a:ln>
+        </p:spPr>
+        <p:txBody>
+          <a:bodyPr wrap="square" lIns="91440" rIns="91440" tIns="45720" bIns="45720">
+            <a:normAutofit fontScale="85000" lnSpcReduction="20000"/>
+          </a:bodyPr>
+          <a:lstStyle/>
+          <a:p>
+            <a:pPr algn="l"/>
+            <a:r>
+              <a:rPr lang="en-US" sz="1500" b="1">
+                <a:solidFill>
+                  <a:srgbClr val="CC9900"/>
+                </a:solidFill>
+                <a:latin typeface="Aptos"/>
+              </a:rPr>
+              <a:t>Conclusion</a:t>
+            </a:r>
+          </a:p>
+        </p:txBody>
+      </p:sp>
+      <p:sp>
+        <p:nvSpPr>
+          <p:cNvPr id="113" name="Text 113"/>
+          <p:cNvSpPr txBox="1"/>
+          <p:nvPr/>
+        </p:nvSpPr>
+        <p:spPr>
+          <a:xfrm>
+            <a:off x="6144768" y="1627632"/>
+            <a:ext cx="4800600" cy="2880360"/>
+          </a:xfrm>
+          <a:prstGeom prst="rect">
+            <a:avLst/>
+          </a:prstGeom>
+          <a:noFill/>
+          <a:ln>
+            <a:noFill/>
+          </a:ln>
+        </p:spPr>
+        <p:txBody>
+          <a:bodyPr wrap="square" lIns="91440" rIns="91440" tIns="45720" bIns="45720">
+            <a:normAutofit fontScale="85000" lnSpcReduction="20000"/>
+          </a:bodyPr>
+          <a:lstStyle/>
+          <a:p>
+            <a:pPr algn="l">
+              <a:buChar char="•"/>
+              <a:buFont typeface="Arial"/>
+            </a:pPr>
+            <a:r>
+              <a:rPr lang="en-US" sz="1800" b="0">
+                <a:solidFill>
+                  <a:srgbClr val="142030"/>
+                </a:solidFill>
+                <a:latin typeface="Aptos"/>
+              </a:rPr>
+              <a:t>The SITA HIV model was extended using fractional memory.</a:t>
+            </a:r>
+          </a:p>
+          <a:p>
+            <a:pPr algn="l">
+              <a:buChar char="•"/>
+              <a:buFont typeface="Arial"/>
+            </a:pPr>
+            <a:r>
+              <a:rPr lang="en-US" sz="1800" b="0">
+                <a:solidFill>
+                  <a:srgbClr val="142030"/>
+                </a:solidFill>
+                <a:latin typeface="Aptos"/>
+              </a:rPr>
+              <a:t>Behavioural interventions were represented through effective rates.</a:t>
+            </a:r>
+          </a:p>
+          <a:p>
+            <a:pPr algn="l">
+              <a:buChar char="•"/>
+              <a:buFont typeface="Arial"/>
+            </a:pPr>
+            <a:r>
+              <a:rPr lang="en-US" sz="1800" b="0">
+                <a:solidFill>
+                  <a:srgbClr val="142030"/>
+                </a:solidFill>
+                <a:latin typeface="Aptos"/>
+              </a:rPr>
+              <a:t>Numerical simulations support combined intervention strategies.</a:t>
+            </a:r>
+          </a:p>
+          <a:p>
+            <a:pPr algn="l">
+              <a:buChar char="•"/>
+              <a:buFont typeface="Arial"/>
+            </a:pPr>
+            <a:r>
+              <a:rPr lang="en-US" sz="1800" b="0">
+                <a:solidFill>
+                  <a:srgbClr val="142030"/>
+                </a:solidFill>
+                <a:latin typeface="Aptos"/>
+              </a:rPr>
               <a:t>Future work should calibrate parameters with Rwanda-specific data.</a:t>
             </a:r>
           </a:p>
@@ -831,7 +1457,7 @@
       </p:sp>
       <p:sp>
         <p:nvSpPr>
-          <p:cNvPr id="99" name="Text 99"/>
+          <p:cNvPr id="114" name="Text 114"/>
           <p:cNvSpPr txBox="1"/>
           <p:nvPr/>
         </p:nvSpPr>
@@ -2963,8 +3589,8 @@
         </p:nvSpPr>
         <p:spPr>
           <a:xfrm>
-            <a:off x="914400" y="4279392"/>
-            <a:ext cx="4846320" cy="822960"/>
+            <a:off x="914400" y="4224528"/>
+            <a:ext cx="4846320" cy="960120"/>
           </a:xfrm>
           <a:prstGeom prst="rect">
             <a:avLst/>
@@ -2986,7 +3612,7 @@
           <a:p>
             <a:pPr algn="l"/>
             <a:r>
-              <a:rPr lang="en-US" sz="1700" b="0">
+              <a:rPr lang="en-US" sz="1500" b="0">
                 <a:solidFill>
                   <a:srgbClr val="142030"/>
                 </a:solidFill>
@@ -2998,7 +3624,7 @@
           <a:p>
             <a:pPr algn="l"/>
             <a:r>
-              <a:rPr lang="en-US" sz="1700" b="0">
+              <a:rPr lang="en-US" sz="1500" b="0">
                 <a:solidFill>
                   <a:srgbClr val="142030"/>
                 </a:solidFill>
@@ -3017,8 +3643,8 @@
         </p:nvSpPr>
         <p:spPr>
           <a:xfrm>
-            <a:off x="6355080" y="4279392"/>
-            <a:ext cx="4709160" cy="822960"/>
+            <a:off x="6355080" y="4224528"/>
+            <a:ext cx="4709160" cy="960120"/>
           </a:xfrm>
           <a:prstGeom prst="rect">
             <a:avLst/>
@@ -3040,7 +3666,7 @@
           <a:p>
             <a:pPr algn="l"/>
             <a:r>
-              <a:rPr lang="en-US" sz="1700" b="0">
+              <a:rPr lang="en-US" sz="1500" b="0">
                 <a:solidFill>
                   <a:srgbClr val="142030"/>
                 </a:solidFill>
@@ -3052,7 +3678,7 @@
           <a:p>
             <a:pPr algn="l"/>
             <a:r>
-              <a:rPr lang="en-US" sz="1700" b="0">
+              <a:rPr lang="en-US" sz="1500" b="0">
                 <a:solidFill>
                   <a:srgbClr val="142030"/>
                 </a:solidFill>
@@ -3763,8 +4389,8 @@
         </p:nvSpPr>
         <p:spPr>
           <a:xfrm>
-            <a:off x="6355080" y="1207008"/>
-            <a:ext cx="4297680" cy="594360"/>
+            <a:off x="6355080" y="1170432"/>
+            <a:ext cx="4297680" cy="749808"/>
           </a:xfrm>
           <a:prstGeom prst="rect">
             <a:avLst/>
@@ -3786,7 +4412,7 @@
           <a:p>
             <a:pPr algn="l"/>
             <a:r>
-              <a:rPr lang="en-US" sz="1500" b="0">
+              <a:rPr lang="en-US" sz="1400" b="0">
                 <a:solidFill>
                   <a:srgbClr val="142030"/>
                 </a:solidFill>
@@ -3798,7 +4424,7 @@
           <a:p>
             <a:pPr algn="l"/>
             <a:r>
-              <a:rPr lang="en-US" sz="1500" b="0">
+              <a:rPr lang="en-US" sz="1400" b="0">
                 <a:solidFill>
                   <a:srgbClr val="142030"/>
                 </a:solidFill>
@@ -3817,8 +4443,8 @@
         </p:nvSpPr>
         <p:spPr>
           <a:xfrm>
-            <a:off x="6355080" y="2057400"/>
-            <a:ext cx="4297680" cy="594360"/>
+            <a:off x="6355080" y="2084831"/>
+            <a:ext cx="4297680" cy="749808"/>
           </a:xfrm>
           <a:prstGeom prst="rect">
             <a:avLst/>
@@ -3840,7 +4466,7 @@
           <a:p>
             <a:pPr algn="l"/>
             <a:r>
-              <a:rPr lang="en-US" sz="1500" b="0">
+              <a:rPr lang="en-US" sz="1400" b="0">
                 <a:solidFill>
                   <a:srgbClr val="142030"/>
                 </a:solidFill>
@@ -3852,7 +4478,7 @@
           <a:p>
             <a:pPr algn="l"/>
             <a:r>
-              <a:rPr lang="en-US" sz="1500" b="0">
+              <a:rPr lang="en-US" sz="1400" b="0">
                 <a:solidFill>
                   <a:srgbClr val="142030"/>
                 </a:solidFill>
@@ -3871,8 +4497,8 @@
         </p:nvSpPr>
         <p:spPr>
           <a:xfrm>
-            <a:off x="6355080" y="2907792"/>
-            <a:ext cx="4297680" cy="594360"/>
+            <a:off x="6355080" y="2999232"/>
+            <a:ext cx="4297680" cy="749808"/>
           </a:xfrm>
           <a:prstGeom prst="rect">
             <a:avLst/>
@@ -3894,7 +4520,7 @@
           <a:p>
             <a:pPr algn="l"/>
             <a:r>
-              <a:rPr lang="en-US" sz="1500" b="0">
+              <a:rPr lang="en-US" sz="1400" b="0">
                 <a:solidFill>
                   <a:srgbClr val="142030"/>
                 </a:solidFill>
@@ -3906,7 +4532,7 @@
           <a:p>
             <a:pPr algn="l"/>
             <a:r>
-              <a:rPr lang="en-US" sz="1500" b="0">
+              <a:rPr lang="en-US" sz="1400" b="0">
                 <a:solidFill>
                   <a:srgbClr val="142030"/>
                 </a:solidFill>
@@ -3925,8 +4551,8 @@
         </p:nvSpPr>
         <p:spPr>
           <a:xfrm>
-            <a:off x="6355080" y="3758184"/>
-            <a:ext cx="4297680" cy="594360"/>
+            <a:off x="6355080" y="3913632"/>
+            <a:ext cx="4297680" cy="749808"/>
           </a:xfrm>
           <a:prstGeom prst="rect">
             <a:avLst/>
@@ -3948,7 +4574,7 @@
           <a:p>
             <a:pPr algn="l"/>
             <a:r>
-              <a:rPr lang="en-US" sz="1500" b="0">
+              <a:rPr lang="en-US" sz="1400" b="0">
                 <a:solidFill>
                   <a:srgbClr val="142030"/>
                 </a:solidFill>
@@ -3960,7 +4586,7 @@
           <a:p>
             <a:pPr algn="l"/>
             <a:r>
-              <a:rPr lang="en-US" sz="1500" b="0">
+              <a:rPr lang="en-US" sz="1400" b="0">
                 <a:solidFill>
                   <a:srgbClr val="142030"/>
                 </a:solidFill>
@@ -3979,8 +4605,8 @@
         </p:nvCxnSpPr>
         <p:spPr>
           <a:xfrm>
-            <a:off x="8503920" y="1801368"/>
-            <a:ext cx="0" cy="256032"/>
+            <a:off x="8503920" y="1920240"/>
+            <a:ext cx="0" cy="164591"/>
           </a:xfrm>
           <a:prstGeom prst="line">
             <a:avLst/>
@@ -4015,8 +4641,8 @@
         </p:nvCxnSpPr>
         <p:spPr>
           <a:xfrm>
-            <a:off x="8503920" y="2651760"/>
-            <a:ext cx="0" cy="256032"/>
+            <a:off x="8503920" y="2834640"/>
+            <a:ext cx="0" cy="164591"/>
           </a:xfrm>
           <a:prstGeom prst="line">
             <a:avLst/>
@@ -4051,8 +4677,8 @@
         </p:nvCxnSpPr>
         <p:spPr>
           <a:xfrm>
-            <a:off x="8503920" y="3502152"/>
-            <a:ext cx="0" cy="256032"/>
+            <a:off x="8503920" y="3749039"/>
+            <a:ext cx="0" cy="164592"/>
           </a:xfrm>
           <a:prstGeom prst="line">
             <a:avLst/>
@@ -4179,7 +4805,7 @@
                 </a:solidFill>
                 <a:latin typeface="Aptos"/>
               </a:rPr>
-              <a:t>Simulation Results: Intervention Comparison</a:t>
+              <a:t>Baseline Simulation Result</a:t>
             </a:r>
           </a:p>
         </p:txBody>
@@ -4266,7 +4892,7 @@
       </p:sp>
       <p:pic>
         <p:nvPicPr>
-          <p:cNvPr id="78" name="combinedInterventionsChart.png"/>
+          <p:cNvPr id="78" name="mainChartlinear.png"/>
           <p:cNvPicPr/>
           <p:nvPr/>
         </p:nvPicPr>
@@ -4278,8 +4904,8 @@
         </p:blipFill>
         <p:spPr>
           <a:xfrm>
-            <a:off x="658368" y="1298448"/>
-            <a:ext cx="6217920" cy="4206240"/>
+            <a:off x="640080" y="1261872"/>
+            <a:ext cx="6309360" cy="4251960"/>
           </a:xfrm>
           <a:prstGeom prst="rect">
             <a:avLst/>
@@ -4294,7 +4920,7 @@
         </p:nvSpPr>
         <p:spPr>
           <a:xfrm>
-            <a:off x="7360920" y="1325880"/>
+            <a:off x="7360920" y="1234440"/>
             <a:ext cx="3566160" cy="320040"/>
           </a:xfrm>
           <a:prstGeom prst="rect">
@@ -4319,7 +4945,7 @@
                 </a:solidFill>
                 <a:latin typeface="Aptos"/>
               </a:rPr>
-              <a:t>Main interpretation</a:t>
+              <a:t>Computed baseline</a:t>
             </a:r>
           </a:p>
         </p:txBody>
@@ -4332,8 +4958,8 @@
         </p:nvSpPr>
         <p:spPr>
           <a:xfrm>
-            <a:off x="7406640" y="1719072"/>
-            <a:ext cx="3520440" cy="1920240"/>
+            <a:off x="7406640" y="1627632"/>
+            <a:ext cx="3566160" cy="1234440"/>
           </a:xfrm>
           <a:prstGeom prst="rect">
             <a:avLst/>
@@ -4354,13 +4980,13 @@
               <a:buFont typeface="Arial"/>
             </a:pPr>
             <a:r>
-              <a:rPr lang="en-US" sz="1600" b="0">
-                <a:solidFill>
-                  <a:srgbClr val="142030"/>
-                </a:solidFill>
-                <a:latin typeface="Aptos"/>
-              </a:rPr>
-              <a:t>Single interventions help, but each targets only one mechanism.</a:t>
+              <a:rPr lang="en-US" sz="1500" b="0">
+                <a:solidFill>
+                  <a:srgbClr val="142030"/>
+                </a:solidFill>
+                <a:latin typeface="Aptos"/>
+              </a:rPr>
+              <a:t>R0 = 0.430, below the epidemic threshold.</a:t>
             </a:r>
           </a:p>
           <a:p>
@@ -4369,13 +4995,13 @@
               <a:buFont typeface="Arial"/>
             </a:pPr>
             <a:r>
-              <a:rPr lang="en-US" sz="1600" b="0">
-                <a:solidFill>
-                  <a:srgbClr val="142030"/>
-                </a:solidFill>
-                <a:latin typeface="Aptos"/>
-              </a:rPr>
-              <a:t>Combined intervention acts on transmission, treatment uptake, and progression.</a:t>
+              <a:rPr lang="en-US" sz="1500" b="0">
+                <a:solidFill>
+                  <a:srgbClr val="142030"/>
+                </a:solidFill>
+                <a:latin typeface="Aptos"/>
+              </a:rPr>
+              <a:t>Peak infected population is 150 at t = 0 years.</a:t>
             </a:r>
           </a:p>
           <a:p>
@@ -4384,13 +5010,13 @@
               <a:buFont typeface="Arial"/>
             </a:pPr>
             <a:r>
-              <a:rPr lang="en-US" sz="1600" b="0">
-                <a:solidFill>
-                  <a:srgbClr val="142030"/>
-                </a:solidFill>
-                <a:latin typeface="Aptos"/>
-              </a:rPr>
-              <a:t>The combined strategy gives stronger simulated control than isolated changes.</a:t>
+              <a:rPr lang="en-US" sz="1500" b="0">
+                <a:solidFill>
+                  <a:srgbClr val="142030"/>
+                </a:solidFill>
+                <a:latin typeface="Aptos"/>
+              </a:rPr>
+              <a:t>Final values after 50 years: I = 3.1, T = 94.3, A = 3.6.</a:t>
             </a:r>
           </a:p>
         </p:txBody>
@@ -4403,8 +5029,8 @@
         </p:nvSpPr>
         <p:spPr>
           <a:xfrm>
-            <a:off x="7360920" y="4133087"/>
-            <a:ext cx="3611880" cy="868680"/>
+            <a:off x="7360920" y="3310128"/>
+            <a:ext cx="3657600" cy="1024128"/>
           </a:xfrm>
           <a:prstGeom prst="rect">
             <a:avLst/>
@@ -4426,25 +5052,79 @@
           <a:p>
             <a:pPr algn="l"/>
             <a:r>
-              <a:rPr lang="en-US" sz="1500" b="0">
-                <a:solidFill>
-                  <a:srgbClr val="142030"/>
-                </a:solidFill>
-                <a:latin typeface="Aptos"/>
-              </a:rPr>
-              <a:t>Public-health meaning</a:t>
-            </a:r>
-          </a:p>
-          <a:p>
-            <a:pPr algn="l"/>
-            <a:r>
-              <a:rPr lang="en-US" sz="1500" b="0">
-                <a:solidFill>
-                  <a:srgbClr val="142030"/>
-                </a:solidFill>
-                <a:latin typeface="Aptos"/>
-              </a:rPr>
-              <a:t>Prevention and treatment support should work together.</a:t>
+              <a:rPr lang="en-US" sz="1400" b="0">
+                <a:solidFill>
+                  <a:srgbClr val="142030"/>
+                </a:solidFill>
+                <a:latin typeface="Aptos"/>
+              </a:rPr>
+              <a:t>Interpretation</a:t>
+            </a:r>
+          </a:p>
+          <a:p>
+            <a:pPr algn="l"/>
+            <a:r>
+              <a:rPr lang="en-US" sz="1400" b="0">
+                <a:solidFill>
+                  <a:srgbClr val="142030"/>
+                </a:solidFill>
+                <a:latin typeface="Aptos"/>
+              </a:rPr>
+              <a:t>The baseline intervention-adjusted configuration leads toward disease-free behaviour in the simulation.</a:t>
+            </a:r>
+          </a:p>
+        </p:txBody>
+      </p:sp>
+      <p:sp>
+        <p:nvSpPr>
+          <p:cNvPr id="85" name="Text 85"/>
+          <p:cNvSpPr txBox="1"/>
+          <p:nvPr/>
+        </p:nvSpPr>
+        <p:spPr>
+          <a:xfrm>
+            <a:off x="7360920" y="4645152"/>
+            <a:ext cx="3657600" cy="694944"/>
+          </a:xfrm>
+          <a:prstGeom prst="rect">
+            <a:avLst/>
+          </a:prstGeom>
+          <a:solidFill>
+            <a:srgbClr val="FFF7E0"/>
+          </a:solidFill>
+          <a:ln w="9525">
+            <a:solidFill>
+              <a:srgbClr val="CC9900"/>
+            </a:solidFill>
+          </a:ln>
+        </p:spPr>
+        <p:txBody>
+          <a:bodyPr wrap="square" lIns="91440" rIns="91440" tIns="45720" bIns="45720">
+            <a:normAutofit fontScale="85000" lnSpcReduction="20000"/>
+          </a:bodyPr>
+          <a:lstStyle/>
+          <a:p>
+            <a:pPr algn="l"/>
+            <a:r>
+              <a:rPr lang="en-US" sz="1300" b="0">
+                <a:solidFill>
+                  <a:srgbClr val="142030"/>
+                </a:solidFill>
+                <a:latin typeface="Aptos"/>
+              </a:rPr>
+              <a:t>Defense point</a:t>
+            </a:r>
+          </a:p>
+          <a:p>
+            <a:pPr algn="l"/>
+            <a:r>
+              <a:rPr lang="en-US" sz="1300" b="0">
+                <a:solidFill>
+                  <a:srgbClr val="142030"/>
+                </a:solidFill>
+                <a:latin typeface="Aptos"/>
+              </a:rPr>
+              <a:t>These numbers come from the Python simulation engine and match the dashboard summary table.</a:t>
             </a:r>
           </a:p>
         </p:txBody>
@@ -4476,7 +5156,7 @@
       </p:grpSpPr>
       <p:sp>
         <p:nvSpPr>
-          <p:cNvPr id="86" name="Text 86"/>
+          <p:cNvPr id="87" name="Text 87"/>
           <p:cNvSpPr txBox="1"/>
           <p:nvPr/>
         </p:nvSpPr>
@@ -4507,14 +5187,14 @@
                 </a:solidFill>
                 <a:latin typeface="Aptos"/>
               </a:rPr>
-              <a:t>Simulation Results: Fractional Memory</a:t>
-            </a:r>
-          </a:p>
-        </p:txBody>
-      </p:sp>
-      <p:sp>
-        <p:nvSpPr>
-          <p:cNvPr id="87" name="Text 87"/>
+              <a:t>Simulation Results: Intervention Comparison</a:t>
+            </a:r>
+          </a:p>
+        </p:txBody>
+      </p:sp>
+      <p:sp>
+        <p:nvSpPr>
+          <p:cNvPr id="88" name="Text 88"/>
           <p:cNvSpPr txBox="1"/>
           <p:nvPr/>
         </p:nvSpPr>
@@ -4554,7 +5234,7 @@
       </p:sp>
       <p:sp>
         <p:nvSpPr>
-          <p:cNvPr id="88" name="Text 88"/>
+          <p:cNvPr id="89" name="Text 89"/>
           <p:cNvSpPr txBox="1"/>
           <p:nvPr/>
         </p:nvSpPr>
@@ -4594,7 +5274,7 @@
       </p:sp>
       <p:pic>
         <p:nvPicPr>
-          <p:cNvPr id="85" name="memoryChart.png"/>
+          <p:cNvPr id="86" name="combinedInterventionsChart.png"/>
           <p:cNvPicPr/>
           <p:nvPr/>
         </p:nvPicPr>
@@ -4616,7 +5296,7 @@
       </p:pic>
       <p:sp>
         <p:nvSpPr>
-          <p:cNvPr id="89" name="Text 89"/>
+          <p:cNvPr id="90" name="Text 90"/>
           <p:cNvSpPr txBox="1"/>
           <p:nvPr/>
         </p:nvSpPr>
@@ -4647,21 +5327,21 @@
                 </a:solidFill>
                 <a:latin typeface="Aptos"/>
               </a:rPr>
-              <a:t>Why q matters</a:t>
-            </a:r>
-          </a:p>
-        </p:txBody>
-      </p:sp>
-      <p:sp>
-        <p:nvSpPr>
-          <p:cNvPr id="90" name="Text 90"/>
+              <a:t>Main interpretation</a:t>
+            </a:r>
+          </a:p>
+        </p:txBody>
+      </p:sp>
+      <p:sp>
+        <p:nvSpPr>
+          <p:cNvPr id="91" name="Text 91"/>
           <p:cNvSpPr txBox="1"/>
           <p:nvPr/>
         </p:nvSpPr>
         <p:spPr>
           <a:xfrm>
             <a:off x="7406640" y="1719072"/>
-            <a:ext cx="3520440" cy="1691640"/>
+            <a:ext cx="3520440" cy="1920240"/>
           </a:xfrm>
           <a:prstGeom prst="rect">
             <a:avLst/>
@@ -4688,7 +5368,7 @@
                 </a:solidFill>
                 <a:latin typeface="Aptos"/>
               </a:rPr>
-              <a:t>q = 1 represents the ordinary model.</a:t>
+              <a:t>Single interventions help, but each targets only one mechanism.</a:t>
             </a:r>
           </a:p>
           <a:p>
@@ -4703,7 +5383,7 @@
                 </a:solidFill>
                 <a:latin typeface="Aptos"/>
               </a:rPr>
-              <a:t>Smaller q values strengthen the memory effect.</a:t>
+              <a:t>Combined intervention acts on transmission, treatment uptake, and progression.</a:t>
             </a:r>
           </a:p>
           <a:p>
@@ -4718,31 +5398,31 @@
                 </a:solidFill>
                 <a:latin typeface="Aptos"/>
               </a:rPr>
-              <a:t>Different q values produce visibly different trajectories.</a:t>
-            </a:r>
-          </a:p>
-        </p:txBody>
-      </p:sp>
-      <p:sp>
-        <p:nvSpPr>
-          <p:cNvPr id="91" name="Text 91"/>
-          <p:cNvSpPr txBox="1"/>
-          <p:nvPr/>
-        </p:nvSpPr>
-        <p:spPr>
-          <a:xfrm>
-            <a:off x="7360920" y="4005072"/>
-            <a:ext cx="3611880" cy="914400"/>
+              <a:t>The combined strategy gives stronger simulated control than isolated changes.</a:t>
+            </a:r>
+          </a:p>
+        </p:txBody>
+      </p:sp>
+      <p:sp>
+        <p:nvSpPr>
+          <p:cNvPr id="92" name="Text 92"/>
+          <p:cNvSpPr txBox="1"/>
+          <p:nvPr/>
+        </p:nvSpPr>
+        <p:spPr>
+          <a:xfrm>
+            <a:off x="7360920" y="4133087"/>
+            <a:ext cx="3611880" cy="868680"/>
           </a:xfrm>
           <a:prstGeom prst="rect">
             <a:avLst/>
           </a:prstGeom>
           <a:solidFill>
-            <a:srgbClr val="FFF7E0"/>
+            <a:srgbClr val="E6F7F4"/>
           </a:solidFill>
           <a:ln w="9525">
             <a:solidFill>
-              <a:srgbClr val="CC9900"/>
+              <a:srgbClr val="007E70"/>
             </a:solidFill>
           </a:ln>
         </p:spPr>
@@ -4760,7 +5440,7 @@
                 </a:solidFill>
                 <a:latin typeface="Aptos"/>
               </a:rPr>
-              <a:t>Defense point</a:t>
+              <a:t>Public-health meaning</a:t>
             </a:r>
           </a:p>
           <a:p>
@@ -4772,7 +5452,7 @@
                 </a:solidFill>
                 <a:latin typeface="Aptos"/>
               </a:rPr>
-              <a:t>Fractional calculus is not decorative; it changes the simulated dynamics.</a:t>
+              <a:t>Prevention and treatment support should work together.</a:t>
             </a:r>
           </a:p>
         </p:txBody>

</xml_diff>

<commit_message>
Update FracHIV SITA presentation with new dashboard links and content adjustments
</commit_message>
<xml_diff>
--- a/presentation/FracHIV_SITA_Presentation.pptx
+++ b/presentation/FracHIV_SITA_Presentation.pptx
@@ -291,8 +291,8 @@
         </p:nvSpPr>
         <p:spPr>
           <a:xfrm>
-            <a:off x="713232" y="4187952"/>
-            <a:ext cx="5029200" cy="822960"/>
+            <a:off x="713232" y="4133087"/>
+            <a:ext cx="5852160" cy="1005840"/>
           </a:xfrm>
           <a:prstGeom prst="rect">
             <a:avLst/>
@@ -310,7 +310,7 @@
           <a:p>
             <a:pPr algn="l"/>
             <a:r>
-              <a:rPr lang="en-US" sz="1400" b="0">
+              <a:rPr lang="en-US" sz="1300" b="0">
                 <a:solidFill>
                   <a:srgbClr val="FFFFFF"/>
                 </a:solidFill>
@@ -322,7 +322,7 @@
           <a:p>
             <a:pPr algn="l"/>
             <a:r>
-              <a:rPr lang="en-US" sz="1400" b="0">
+              <a:rPr lang="en-US" sz="1300" b="0">
                 <a:solidFill>
                   <a:srgbClr val="FFFFFF"/>
                 </a:solidFill>
@@ -334,13 +334,25 @@
           <a:p>
             <a:pPr algn="l"/>
             <a:r>
-              <a:rPr lang="en-US" sz="1400" b="0">
+              <a:rPr lang="en-US" sz="1300" b="0">
                 <a:solidFill>
                   <a:srgbClr val="FFFFFF"/>
                 </a:solidFill>
                 <a:latin typeface="Aptos"/>
               </a:rPr>
               <a:t>Kigali, Rwanda</a:t>
+            </a:r>
+          </a:p>
+          <a:p>
+            <a:pPr algn="l"/>
+            <a:r>
+              <a:rPr lang="en-US" sz="1300" b="0">
+                <a:solidFill>
+                  <a:srgbClr val="FFFFFF"/>
+                </a:solidFill>
+                <a:latin typeface="Aptos"/>
+              </a:rPr>
+              <a:t>Dashboard: https://hiv-model.onrender.com/</a:t>
             </a:r>
           </a:p>
         </p:txBody>
@@ -1266,7 +1278,7 @@
                 </a:solidFill>
                 <a:latin typeface="Aptos"/>
               </a:rPr>
-              <a:t>Open the deployed simulator.</a:t>
+              <a:t>Open the deployed simulator: https://hiv-model.onrender.com/</a:t>
             </a:r>
           </a:p>
           <a:p>
@@ -1326,7 +1338,7 @@
                 </a:solidFill>
                 <a:latin typeface="Aptos"/>
               </a:rPr>
-              <a:t>Show scenario and sensitivity views briefly.</a:t>
+              <a:t>Move from dashboard results to conclusion and recommendations.</a:t>
             </a:r>
           </a:p>
         </p:txBody>
@@ -1492,7 +1504,7 @@
                 </a:solidFill>
                 <a:latin typeface="Aptos"/>
               </a:rPr>
-              <a:t>Final message: this project connects mathematical analysis, numerical simulation, and a working interactive tool for explaining HIV intervention dynamics.</a:t>
+              <a:t>Final message: this project connects mathematical analysis, numerical simulation, and the working dashboard at https://hiv-model.onrender.com/.</a:t>
             </a:r>
           </a:p>
         </p:txBody>

</xml_diff>

<commit_message>
Update FracHIV SITA presentation with revised content, formatting, and dashboard links
</commit_message>
<xml_diff>
--- a/presentation/FracHIV_SITA_Presentation.pptx
+++ b/presentation/FracHIV_SITA_Presentation.pptx
@@ -2,7 +2,7 @@
 <file path=ppt/presentation.xml><?xml version="1.0" encoding="utf-8"?>
 <p:presentation xmlns:a="http://schemas.openxmlformats.org/drawingml/2006/main" xmlns:r="http://schemas.openxmlformats.org/officeDocument/2006/relationships" xmlns:p="http://schemas.openxmlformats.org/presentationml/2006/main">
   <p:sldMasterIdLst>
-    <p:sldMasterId id="2147483648" r:id="rId13"/>
+    <p:sldMasterId id="2147483648" r:id="rId14"/>
   </p:sldMasterIdLst>
   <p:sldIdLst>
     <p:sldId id="256" r:id="rId1"/>
@@ -17,6 +17,7 @@
     <p:sldId id="265" r:id="rId10"/>
     <p:sldId id="266" r:id="rId11"/>
     <p:sldId id="267" r:id="rId12"/>
+    <p:sldId id="268" r:id="rId13"/>
   </p:sldIdLst>
   <p:sldSz cx="12191999" cy="6858000" type="screen16x9"/>
   <p:notesSz cx="6858000" cy="9144000"/>
@@ -203,8 +204,48 @@
         </p:nvSpPr>
         <p:spPr>
           <a:xfrm>
-            <a:off x="685800" y="1938528"/>
-            <a:ext cx="6675120" cy="1325880"/>
+            <a:off x="530352" y="1664208"/>
+            <a:ext cx="6812280" cy="3383280"/>
+          </a:xfrm>
+          <a:prstGeom prst="rect">
+            <a:avLst/>
+          </a:prstGeom>
+          <a:solidFill>
+            <a:srgbClr val="0A1B30"/>
+          </a:solidFill>
+          <a:ln>
+            <a:noFill/>
+          </a:ln>
+        </p:spPr>
+        <p:txBody>
+          <a:bodyPr wrap="square" lIns="91440" rIns="91440" tIns="45720" bIns="45720">
+            <a:normAutofit fontScale="85000" lnSpcReduction="20000"/>
+          </a:bodyPr>
+          <a:lstStyle/>
+          <a:p>
+            <a:pPr algn="l"/>
+            <a:r>
+              <a:rPr lang="en-US" sz="2400" b="0">
+                <a:solidFill>
+                  <a:srgbClr val="142030"/>
+                </a:solidFill>
+                <a:latin typeface="Aptos"/>
+              </a:rPr>
+              <a:t/>
+            </a:r>
+          </a:p>
+        </p:txBody>
+      </p:sp>
+      <p:sp>
+        <p:nvSpPr>
+          <p:cNvPr id="6" name="Text 6"/>
+          <p:cNvSpPr txBox="1"/>
+          <p:nvPr/>
+        </p:nvSpPr>
+        <p:spPr>
+          <a:xfrm>
+            <a:off x="749808" y="1901952"/>
+            <a:ext cx="6400800" cy="1298448"/>
           </a:xfrm>
           <a:prstGeom prst="rect">
             <a:avLst/>
@@ -247,14 +288,14 @@
       </p:sp>
       <p:sp>
         <p:nvSpPr>
-          <p:cNvPr id="6" name="Text 6"/>
-          <p:cNvSpPr txBox="1"/>
-          <p:nvPr/>
-        </p:nvSpPr>
-        <p:spPr>
-          <a:xfrm>
-            <a:off x="713232" y="3355848"/>
-            <a:ext cx="6400800" cy="502920"/>
+          <p:cNvPr id="7" name="Text 7"/>
+          <p:cNvSpPr txBox="1"/>
+          <p:nvPr/>
+        </p:nvSpPr>
+        <p:spPr>
+          <a:xfrm>
+            <a:off x="786384" y="3310128"/>
+            <a:ext cx="6263640" cy="502920"/>
           </a:xfrm>
           <a:prstGeom prst="rect">
             <a:avLst/>
@@ -278,21 +319,21 @@
                 </a:solidFill>
                 <a:latin typeface="Aptos"/>
               </a:rPr>
-              <a:t>Social behaviour interventions and simulation-based analysis</a:t>
-            </a:r>
-          </a:p>
-        </p:txBody>
-      </p:sp>
-      <p:sp>
-        <p:nvSpPr>
-          <p:cNvPr id="7" name="Text 7"/>
-          <p:cNvSpPr txBox="1"/>
-          <p:nvPr/>
-        </p:nvSpPr>
-        <p:spPr>
-          <a:xfrm>
-            <a:off x="713232" y="4133087"/>
-            <a:ext cx="5852160" cy="1005840"/>
+              <a:t>Social Behaviour Interventions and Memory Effects</a:t>
+            </a:r>
+          </a:p>
+        </p:txBody>
+      </p:sp>
+      <p:sp>
+        <p:nvSpPr>
+          <p:cNvPr id="8" name="Text 8"/>
+          <p:cNvSpPr txBox="1"/>
+          <p:nvPr/>
+        </p:nvSpPr>
+        <p:spPr>
+          <a:xfrm>
+            <a:off x="786384" y="4069080"/>
+            <a:ext cx="5303520" cy="749808"/>
           </a:xfrm>
           <a:prstGeom prst="rect">
             <a:avLst/>
@@ -343,30 +384,18 @@
               <a:t>Kigali, Rwanda</a:t>
             </a:r>
           </a:p>
-          <a:p>
-            <a:pPr algn="l"/>
-            <a:r>
-              <a:rPr lang="en-US" sz="1300" b="0">
-                <a:solidFill>
-                  <a:srgbClr val="FFFFFF"/>
-                </a:solidFill>
-                <a:latin typeface="Aptos"/>
-              </a:rPr>
-              <a:t>Dashboard: https://hiv-model.onrender.com/</a:t>
-            </a:r>
-          </a:p>
-        </p:txBody>
-      </p:sp>
-      <p:sp>
-        <p:nvSpPr>
-          <p:cNvPr id="8" name="Text 8"/>
-          <p:cNvSpPr txBox="1"/>
-          <p:nvPr/>
-        </p:nvSpPr>
-        <p:spPr>
-          <a:xfrm>
-            <a:off x="713232" y="5257800"/>
-            <a:ext cx="3657600" cy="36576"/>
+        </p:txBody>
+      </p:sp>
+      <p:sp>
+        <p:nvSpPr>
+          <p:cNvPr id="9" name="Text 9"/>
+          <p:cNvSpPr txBox="1"/>
+          <p:nvPr/>
+        </p:nvSpPr>
+        <p:spPr>
+          <a:xfrm>
+            <a:off x="786384" y="5010912"/>
+            <a:ext cx="3429000" cy="36576"/>
           </a:xfrm>
           <a:prstGeom prst="rect">
             <a:avLst/>
@@ -399,14 +428,14 @@
       </p:sp>
       <p:sp>
         <p:nvSpPr>
-          <p:cNvPr id="9" name="Text 9"/>
-          <p:cNvSpPr txBox="1"/>
-          <p:nvPr/>
-        </p:nvSpPr>
-        <p:spPr>
-          <a:xfrm>
-            <a:off x="4443984" y="5257800"/>
-            <a:ext cx="2926080" cy="36576"/>
+          <p:cNvPr id="10" name="Text 10"/>
+          <p:cNvSpPr txBox="1"/>
+          <p:nvPr/>
+        </p:nvSpPr>
+        <p:spPr>
+          <a:xfrm>
+            <a:off x="4315968" y="5010912"/>
+            <a:ext cx="2743200" cy="36576"/>
           </a:xfrm>
           <a:prstGeom prst="rect">
             <a:avLst/>
@@ -464,7 +493,7 @@
       </p:grpSpPr>
       <p:sp>
         <p:nvSpPr>
-          <p:cNvPr id="94" name="Text 94"/>
+          <p:cNvPr id="95" name="Text 95"/>
           <p:cNvSpPr txBox="1"/>
           <p:nvPr/>
         </p:nvSpPr>
@@ -502,7 +531,7 @@
       </p:sp>
       <p:sp>
         <p:nvSpPr>
-          <p:cNvPr id="95" name="Text 95"/>
+          <p:cNvPr id="96" name="Text 96"/>
           <p:cNvSpPr txBox="1"/>
           <p:nvPr/>
         </p:nvSpPr>
@@ -542,7 +571,7 @@
       </p:sp>
       <p:sp>
         <p:nvSpPr>
-          <p:cNvPr id="96" name="Text 96"/>
+          <p:cNvPr id="97" name="Text 97"/>
           <p:cNvSpPr txBox="1"/>
           <p:nvPr/>
         </p:nvSpPr>
@@ -582,7 +611,7 @@
       </p:sp>
       <p:pic>
         <p:nvPicPr>
-          <p:cNvPr id="93" name="memoryChart.png"/>
+          <p:cNvPr id="94" name="memoryChart.png"/>
           <p:cNvPicPr/>
           <p:nvPr/>
         </p:nvPicPr>
@@ -604,7 +633,7 @@
       </p:pic>
       <p:sp>
         <p:nvSpPr>
-          <p:cNvPr id="97" name="Text 97"/>
+          <p:cNvPr id="98" name="Text 98"/>
           <p:cNvSpPr txBox="1"/>
           <p:nvPr/>
         </p:nvSpPr>
@@ -642,7 +671,7 @@
       </p:sp>
       <p:sp>
         <p:nvSpPr>
-          <p:cNvPr id="98" name="Text 98"/>
+          <p:cNvPr id="99" name="Text 99"/>
           <p:cNvSpPr txBox="1"/>
           <p:nvPr/>
         </p:nvSpPr>
@@ -713,7 +742,7 @@
       </p:sp>
       <p:sp>
         <p:nvSpPr>
-          <p:cNvPr id="99" name="Text 99"/>
+          <p:cNvPr id="100" name="Text 100"/>
           <p:cNvSpPr txBox="1"/>
           <p:nvPr/>
         </p:nvSpPr>
@@ -792,7 +821,7 @@
       </p:grpSpPr>
       <p:sp>
         <p:nvSpPr>
-          <p:cNvPr id="102" name="Text 102"/>
+          <p:cNvPr id="103" name="Text 103"/>
           <p:cNvSpPr txBox="1"/>
           <p:nvPr/>
         </p:nvSpPr>
@@ -830,7 +859,7 @@
       </p:sp>
       <p:sp>
         <p:nvSpPr>
-          <p:cNvPr id="103" name="Text 103"/>
+          <p:cNvPr id="104" name="Text 104"/>
           <p:cNvSpPr txBox="1"/>
           <p:nvPr/>
         </p:nvSpPr>
@@ -870,7 +899,7 @@
       </p:sp>
       <p:sp>
         <p:nvSpPr>
-          <p:cNvPr id="104" name="Text 104"/>
+          <p:cNvPr id="105" name="Text 105"/>
           <p:cNvSpPr txBox="1"/>
           <p:nvPr/>
         </p:nvSpPr>
@@ -910,7 +939,7 @@
       </p:sp>
       <p:pic>
         <p:nvPicPr>
-          <p:cNvPr id="100" name="sensitivityChart.png"/>
+          <p:cNvPr id="101" name="sensitivityChart.png"/>
           <p:cNvPicPr/>
           <p:nvPr/>
         </p:nvPicPr>
@@ -932,7 +961,7 @@
       </p:pic>
       <p:sp>
         <p:nvSpPr>
-          <p:cNvPr id="105" name="Text 105"/>
+          <p:cNvPr id="106" name="Text 106"/>
           <p:cNvSpPr txBox="1"/>
           <p:nvPr/>
         </p:nvSpPr>
@@ -970,7 +999,7 @@
       </p:sp>
       <p:sp>
         <p:nvSpPr>
-          <p:cNvPr id="106" name="Text 106"/>
+          <p:cNvPr id="107" name="Text 107"/>
           <p:cNvSpPr txBox="1"/>
           <p:nvPr/>
         </p:nvSpPr>
@@ -1041,7 +1070,7 @@
       </p:sp>
       <p:pic>
         <p:nvPicPr>
-          <p:cNvPr id="101" name="dashboardBaselineFigure.png"/>
+          <p:cNvPr id="102" name="dashboardBaselineFigure.png"/>
           <p:cNvPicPr/>
           <p:nvPr/>
         </p:nvPicPr>
@@ -1088,7 +1117,7 @@
       </p:grpSpPr>
       <p:sp>
         <p:nvSpPr>
-          <p:cNvPr id="107" name="Text 107"/>
+          <p:cNvPr id="109" name="Text 109"/>
           <p:cNvSpPr txBox="1"/>
           <p:nvPr/>
         </p:nvSpPr>
@@ -1119,14 +1148,14 @@
                 </a:solidFill>
                 <a:latin typeface="Aptos"/>
               </a:rPr>
-              <a:t>Live Demo, Conclusion + Recommendations</a:t>
-            </a:r>
-          </a:p>
-        </p:txBody>
-      </p:sp>
-      <p:sp>
-        <p:nvSpPr>
-          <p:cNvPr id="108" name="Text 108"/>
+              <a:t>Live Dashboard Demonstration</a:t>
+            </a:r>
+          </a:p>
+        </p:txBody>
+      </p:sp>
+      <p:sp>
+        <p:nvSpPr>
+          <p:cNvPr id="110" name="Text 110"/>
           <p:cNvSpPr txBox="1"/>
           <p:nvPr/>
         </p:nvSpPr>
@@ -1166,7 +1195,7 @@
       </p:sp>
       <p:sp>
         <p:nvSpPr>
-          <p:cNvPr id="109" name="Text 109"/>
+          <p:cNvPr id="111" name="Text 111"/>
           <p:cNvSpPr txBox="1"/>
           <p:nvPr/>
         </p:nvSpPr>
@@ -1206,14 +1235,14 @@
       </p:sp>
       <p:sp>
         <p:nvSpPr>
-          <p:cNvPr id="110" name="Text 110"/>
+          <p:cNvPr id="112" name="Text 112"/>
           <p:cNvSpPr txBox="1"/>
           <p:nvPr/>
         </p:nvSpPr>
         <p:spPr>
           <a:xfrm>
             <a:off x="658368" y="1234440"/>
-            <a:ext cx="4709160" cy="320040"/>
+            <a:ext cx="5074920" cy="320040"/>
           </a:xfrm>
           <a:prstGeom prst="rect">
             <a:avLst/>
@@ -1237,21 +1266,75 @@
                 </a:solidFill>
                 <a:latin typeface="Aptos"/>
               </a:rPr>
-              <a:t>Live demo plan</a:t>
-            </a:r>
-          </a:p>
-        </p:txBody>
-      </p:sp>
-      <p:sp>
-        <p:nvSpPr>
-          <p:cNvPr id="111" name="Text 111"/>
-          <p:cNvSpPr txBox="1"/>
-          <p:nvPr/>
-        </p:nvSpPr>
-        <p:spPr>
-          <a:xfrm>
-            <a:off x="713232" y="1627632"/>
-            <a:ext cx="4800600" cy="2880360"/>
+              <a:t>Open during the defense</a:t>
+            </a:r>
+          </a:p>
+        </p:txBody>
+      </p:sp>
+      <p:sp>
+        <p:nvSpPr>
+          <p:cNvPr id="113" name="Text 113"/>
+          <p:cNvSpPr txBox="1"/>
+          <p:nvPr/>
+        </p:nvSpPr>
+        <p:spPr>
+          <a:xfrm>
+            <a:off x="749808" y="1664208"/>
+            <a:ext cx="5029200" cy="731520"/>
+          </a:xfrm>
+          <a:prstGeom prst="rect">
+            <a:avLst/>
+          </a:prstGeom>
+          <a:solidFill>
+            <a:srgbClr val="E8F2FA"/>
+          </a:solidFill>
+          <a:ln w="9525">
+            <a:solidFill>
+              <a:srgbClr val="004A80"/>
+            </a:solidFill>
+          </a:ln>
+        </p:spPr>
+        <p:txBody>
+          <a:bodyPr wrap="square" lIns="91440" rIns="91440" tIns="45720" bIns="45720">
+            <a:normAutofit fontScale="85000" lnSpcReduction="20000"/>
+          </a:bodyPr>
+          <a:lstStyle/>
+          <a:p>
+            <a:pPr algn="l"/>
+            <a:r>
+              <a:rPr lang="en-US" sz="1800" b="0">
+                <a:solidFill>
+                  <a:srgbClr val="142030"/>
+                </a:solidFill>
+                <a:latin typeface="Aptos"/>
+              </a:rPr>
+              <a:t>Dashboard link</a:t>
+            </a:r>
+          </a:p>
+          <a:p>
+            <a:pPr algn="l"/>
+            <a:r>
+              <a:rPr lang="en-US" sz="1800" b="0">
+                <a:solidFill>
+                  <a:srgbClr val="142030"/>
+                </a:solidFill>
+                <a:latin typeface="Aptos"/>
+              </a:rPr>
+              <a:t>https://hiv-model.onrender.com/</a:t>
+            </a:r>
+          </a:p>
+        </p:txBody>
+      </p:sp>
+      <p:sp>
+        <p:nvSpPr>
+          <p:cNvPr id="114" name="Text 114"/>
+          <p:cNvSpPr txBox="1"/>
+          <p:nvPr/>
+        </p:nvSpPr>
+        <p:spPr>
+          <a:xfrm>
+            <a:off x="768096" y="2788920"/>
+            <a:ext cx="5120640" cy="1645920"/>
           </a:xfrm>
           <a:prstGeom prst="rect">
             <a:avLst/>
@@ -1272,13 +1355,13 @@
               <a:buFont typeface="Arial"/>
             </a:pPr>
             <a:r>
-              <a:rPr lang="en-US" sz="1800" b="0">
-                <a:solidFill>
-                  <a:srgbClr val="142030"/>
-                </a:solidFill>
-                <a:latin typeface="Aptos"/>
-              </a:rPr>
-              <a:t>Open the deployed simulator: https://hiv-model.onrender.com/</a:t>
+              <a:rPr lang="en-US" sz="1600" b="0">
+                <a:solidFill>
+                  <a:srgbClr val="142030"/>
+                </a:solidFill>
+                <a:latin typeface="Aptos"/>
+              </a:rPr>
+              <a:t>Run the baseline simulation.</a:t>
             </a:r>
           </a:p>
           <a:p>
@@ -1287,13 +1370,13 @@
               <a:buFont typeface="Arial"/>
             </a:pPr>
             <a:r>
-              <a:rPr lang="en-US" sz="1800" b="0">
-                <a:solidFill>
-                  <a:srgbClr val="142030"/>
-                </a:solidFill>
-                <a:latin typeface="Aptos"/>
-              </a:rPr>
-              <a:t>Run the moving SITA graph.</a:t>
+              <a:rPr lang="en-US" sz="1600" b="0">
+                <a:solidFill>
+                  <a:srgbClr val="142030"/>
+                </a:solidFill>
+                <a:latin typeface="Aptos"/>
+              </a:rPr>
+              <a:t>Show the final state summary and interpretation.</a:t>
             </a:r>
           </a:p>
           <a:p>
@@ -1302,7 +1385,7 @@
               <a:buFont typeface="Arial"/>
             </a:pPr>
             <a:r>
-              <a:rPr lang="en-US" sz="1800" b="0">
+              <a:rPr lang="en-US" sz="1600" b="0">
                 <a:solidFill>
                   <a:srgbClr val="142030"/>
                 </a:solidFill>
@@ -1317,15 +1400,298 @@
               <a:buFont typeface="Arial"/>
             </a:pPr>
             <a:r>
-              <a:rPr lang="en-US" sz="1800" b="0">
-                <a:solidFill>
-                  <a:srgbClr val="142030"/>
-                </a:solidFill>
-                <a:latin typeface="Aptos"/>
-              </a:rPr>
-              <a:t>Compare q = 1 with q &lt; 1.</a:t>
-            </a:r>
-          </a:p>
+              <a:rPr lang="en-US" sz="1600" b="0">
+                <a:solidFill>
+                  <a:srgbClr val="142030"/>
+                </a:solidFill>
+                <a:latin typeface="Aptos"/>
+              </a:rPr>
+              <a:t>Change q to show the fractional memory effect.</a:t>
+            </a:r>
+          </a:p>
+        </p:txBody>
+      </p:sp>
+      <p:pic>
+        <p:nvPicPr>
+          <p:cNvPr id="108" name="dashboardBaselineFigure.png"/>
+          <p:cNvPicPr/>
+          <p:nvPr/>
+        </p:nvPicPr>
+        <p:blipFill>
+          <a:blip r:embed="rId2"/>
+          <a:stretch>
+            <a:fillRect/>
+          </a:stretch>
+        </p:blipFill>
+        <p:spPr>
+          <a:xfrm>
+            <a:off x="6583680" y="1417320"/>
+            <a:ext cx="4297680" cy="2331720"/>
+          </a:xfrm>
+          <a:prstGeom prst="rect">
+            <a:avLst/>
+          </a:prstGeom>
+        </p:spPr>
+      </p:pic>
+      <p:sp>
+        <p:nvSpPr>
+          <p:cNvPr id="115" name="Text 115"/>
+          <p:cNvSpPr txBox="1"/>
+          <p:nvPr/>
+        </p:nvSpPr>
+        <p:spPr>
+          <a:xfrm>
+            <a:off x="6601968" y="4160520"/>
+            <a:ext cx="4297680" cy="822960"/>
+          </a:xfrm>
+          <a:prstGeom prst="rect">
+            <a:avLst/>
+          </a:prstGeom>
+          <a:solidFill>
+            <a:srgbClr val="FFF7E0"/>
+          </a:solidFill>
+          <a:ln w="9525">
+            <a:solidFill>
+              <a:srgbClr val="CC9900"/>
+            </a:solidFill>
+          </a:ln>
+        </p:spPr>
+        <p:txBody>
+          <a:bodyPr wrap="square" lIns="91440" rIns="91440" tIns="45720" bIns="45720">
+            <a:normAutofit fontScale="85000" lnSpcReduction="20000"/>
+          </a:bodyPr>
+          <a:lstStyle/>
+          <a:p>
+            <a:pPr algn="l"/>
+            <a:r>
+              <a:rPr lang="en-US" sz="1500" b="0">
+                <a:solidFill>
+                  <a:srgbClr val="142030"/>
+                </a:solidFill>
+                <a:latin typeface="Aptos"/>
+              </a:rPr>
+              <a:t>After the demo</a:t>
+            </a:r>
+          </a:p>
+          <a:p>
+            <a:pPr algn="l"/>
+            <a:r>
+              <a:rPr lang="en-US" sz="1500" b="0">
+                <a:solidFill>
+                  <a:srgbClr val="142030"/>
+                </a:solidFill>
+                <a:latin typeface="Aptos"/>
+              </a:rPr>
+              <a:t>Return to the next slide for conclusion and recommendations.</a:t>
+            </a:r>
+          </a:p>
+        </p:txBody>
+      </p:sp>
+    </p:spTree>
+  </p:cSld>
+  <p:clrMapOvr>
+    <a:masterClrMapping/>
+  </p:clrMapOvr>
+</p:sld>
+</file>
+
+<file path=ppt/slides/slide13.xml><?xml version="1.0" encoding="utf-8"?>
+<p:sld xmlns:a="http://schemas.openxmlformats.org/drawingml/2006/main" xmlns:r="http://schemas.openxmlformats.org/officeDocument/2006/relationships" xmlns:p="http://schemas.openxmlformats.org/presentationml/2006/main">
+  <p:cSld>
+    <p:spTree>
+      <p:nvGrpSpPr>
+        <p:cNvPr id="1" name=""/>
+        <p:cNvGrpSpPr/>
+        <p:nvPr/>
+      </p:nvGrpSpPr>
+      <p:grpSpPr>
+        <a:xfrm>
+          <a:off x="0" y="0"/>
+          <a:ext cx="0" cy="0"/>
+          <a:chOff x="0" y="0"/>
+          <a:chExt cx="0" cy="0"/>
+        </a:xfrm>
+      </p:grpSpPr>
+      <p:sp>
+        <p:nvSpPr>
+          <p:cNvPr id="116" name="Text 116"/>
+          <p:cNvSpPr txBox="1"/>
+          <p:nvPr/>
+        </p:nvSpPr>
+        <p:spPr>
+          <a:xfrm>
+            <a:off x="502920" y="292608"/>
+            <a:ext cx="10058400" cy="384048"/>
+          </a:xfrm>
+          <a:prstGeom prst="rect">
+            <a:avLst/>
+          </a:prstGeom>
+          <a:noFill/>
+          <a:ln>
+            <a:noFill/>
+          </a:ln>
+        </p:spPr>
+        <p:txBody>
+          <a:bodyPr wrap="square" lIns="91440" rIns="91440" tIns="45720" bIns="45720">
+            <a:normAutofit fontScale="85000" lnSpcReduction="20000"/>
+          </a:bodyPr>
+          <a:lstStyle/>
+          <a:p>
+            <a:pPr algn="l"/>
+            <a:r>
+              <a:rPr lang="en-US" sz="2300" b="1">
+                <a:solidFill>
+                  <a:srgbClr val="0A1B30"/>
+                </a:solidFill>
+                <a:latin typeface="Aptos"/>
+              </a:rPr>
+              <a:t>Conclusion + Recommendations</a:t>
+            </a:r>
+          </a:p>
+        </p:txBody>
+      </p:sp>
+      <p:sp>
+        <p:nvSpPr>
+          <p:cNvPr id="117" name="Text 117"/>
+          <p:cNvSpPr txBox="1"/>
+          <p:nvPr/>
+        </p:nvSpPr>
+        <p:spPr>
+          <a:xfrm>
+            <a:off x="502920" y="868680"/>
+            <a:ext cx="1828800" cy="27432"/>
+          </a:xfrm>
+          <a:prstGeom prst="rect">
+            <a:avLst/>
+          </a:prstGeom>
+          <a:solidFill>
+            <a:srgbClr val="CC9900"/>
+          </a:solidFill>
+          <a:ln>
+            <a:noFill/>
+          </a:ln>
+        </p:spPr>
+        <p:txBody>
+          <a:bodyPr wrap="square" lIns="91440" rIns="91440" tIns="45720" bIns="45720">
+            <a:normAutofit fontScale="85000" lnSpcReduction="20000"/>
+          </a:bodyPr>
+          <a:lstStyle/>
+          <a:p>
+            <a:pPr algn="l"/>
+            <a:r>
+              <a:rPr lang="en-US" sz="2400" b="0">
+                <a:solidFill>
+                  <a:srgbClr val="142030"/>
+                </a:solidFill>
+                <a:latin typeface="Aptos"/>
+              </a:rPr>
+              <a:t/>
+            </a:r>
+          </a:p>
+        </p:txBody>
+      </p:sp>
+      <p:sp>
+        <p:nvSpPr>
+          <p:cNvPr id="118" name="Text 118"/>
+          <p:cNvSpPr txBox="1"/>
+          <p:nvPr/>
+        </p:nvSpPr>
+        <p:spPr>
+          <a:xfrm>
+            <a:off x="2331720" y="868680"/>
+            <a:ext cx="6949440" cy="27432"/>
+          </a:xfrm>
+          <a:prstGeom prst="rect">
+            <a:avLst/>
+          </a:prstGeom>
+          <a:solidFill>
+            <a:srgbClr val="007E70"/>
+          </a:solidFill>
+          <a:ln>
+            <a:noFill/>
+          </a:ln>
+        </p:spPr>
+        <p:txBody>
+          <a:bodyPr wrap="square" lIns="91440" rIns="91440" tIns="45720" bIns="45720">
+            <a:normAutofit fontScale="85000" lnSpcReduction="20000"/>
+          </a:bodyPr>
+          <a:lstStyle/>
+          <a:p>
+            <a:pPr algn="l"/>
+            <a:r>
+              <a:rPr lang="en-US" sz="2400" b="0">
+                <a:solidFill>
+                  <a:srgbClr val="142030"/>
+                </a:solidFill>
+                <a:latin typeface="Aptos"/>
+              </a:rPr>
+              <a:t/>
+            </a:r>
+          </a:p>
+        </p:txBody>
+      </p:sp>
+      <p:sp>
+        <p:nvSpPr>
+          <p:cNvPr id="119" name="Text 119"/>
+          <p:cNvSpPr txBox="1"/>
+          <p:nvPr/>
+        </p:nvSpPr>
+        <p:spPr>
+          <a:xfrm>
+            <a:off x="658368" y="1234440"/>
+            <a:ext cx="4709160" cy="320040"/>
+          </a:xfrm>
+          <a:prstGeom prst="rect">
+            <a:avLst/>
+          </a:prstGeom>
+          <a:noFill/>
+          <a:ln>
+            <a:noFill/>
+          </a:ln>
+        </p:spPr>
+        <p:txBody>
+          <a:bodyPr wrap="square" lIns="91440" rIns="91440" tIns="45720" bIns="45720">
+            <a:normAutofit fontScale="85000" lnSpcReduction="20000"/>
+          </a:bodyPr>
+          <a:lstStyle/>
+          <a:p>
+            <a:pPr algn="l"/>
+            <a:r>
+              <a:rPr lang="en-US" sz="1500" b="1">
+                <a:solidFill>
+                  <a:srgbClr val="CC9900"/>
+                </a:solidFill>
+                <a:latin typeface="Aptos"/>
+              </a:rPr>
+              <a:t>Conclusion</a:t>
+            </a:r>
+          </a:p>
+        </p:txBody>
+      </p:sp>
+      <p:sp>
+        <p:nvSpPr>
+          <p:cNvPr id="120" name="Text 120"/>
+          <p:cNvSpPr txBox="1"/>
+          <p:nvPr/>
+        </p:nvSpPr>
+        <p:spPr>
+          <a:xfrm>
+            <a:off x="713232" y="1627632"/>
+            <a:ext cx="4800600" cy="2880360"/>
+          </a:xfrm>
+          <a:prstGeom prst="rect">
+            <a:avLst/>
+          </a:prstGeom>
+          <a:noFill/>
+          <a:ln>
+            <a:noFill/>
+          </a:ln>
+        </p:spPr>
+        <p:txBody>
+          <a:bodyPr wrap="square" lIns="91440" rIns="91440" tIns="45720" bIns="45720">
+            <a:normAutofit fontScale="85000" lnSpcReduction="20000"/>
+          </a:bodyPr>
+          <a:lstStyle/>
           <a:p>
             <a:pPr algn="l">
               <a:buChar char="•"/>
@@ -1338,73 +1704,9 @@
                 </a:solidFill>
                 <a:latin typeface="Aptos"/>
               </a:rPr>
-              <a:t>Move from dashboard results to conclusion and recommendations.</a:t>
-            </a:r>
-          </a:p>
-        </p:txBody>
-      </p:sp>
-      <p:sp>
-        <p:nvSpPr>
-          <p:cNvPr id="112" name="Text 112"/>
-          <p:cNvSpPr txBox="1"/>
-          <p:nvPr/>
-        </p:nvSpPr>
-        <p:spPr>
-          <a:xfrm>
-            <a:off x="6080760" y="1234440"/>
-            <a:ext cx="4663440" cy="320040"/>
-          </a:xfrm>
-          <a:prstGeom prst="rect">
-            <a:avLst/>
-          </a:prstGeom>
-          <a:noFill/>
-          <a:ln>
-            <a:noFill/>
-          </a:ln>
-        </p:spPr>
-        <p:txBody>
-          <a:bodyPr wrap="square" lIns="91440" rIns="91440" tIns="45720" bIns="45720">
-            <a:normAutofit fontScale="85000" lnSpcReduction="20000"/>
-          </a:bodyPr>
-          <a:lstStyle/>
-          <a:p>
-            <a:pPr algn="l"/>
-            <a:r>
-              <a:rPr lang="en-US" sz="1500" b="1">
-                <a:solidFill>
-                  <a:srgbClr val="CC9900"/>
-                </a:solidFill>
-                <a:latin typeface="Aptos"/>
-              </a:rPr>
-              <a:t>Conclusion</a:t>
-            </a:r>
-          </a:p>
-        </p:txBody>
-      </p:sp>
-      <p:sp>
-        <p:nvSpPr>
-          <p:cNvPr id="113" name="Text 113"/>
-          <p:cNvSpPr txBox="1"/>
-          <p:nvPr/>
-        </p:nvSpPr>
-        <p:spPr>
-          <a:xfrm>
-            <a:off x="6144768" y="1627632"/>
-            <a:ext cx="4800600" cy="2880360"/>
-          </a:xfrm>
-          <a:prstGeom prst="rect">
-            <a:avLst/>
-          </a:prstGeom>
-          <a:noFill/>
-          <a:ln>
-            <a:noFill/>
-          </a:ln>
-        </p:spPr>
-        <p:txBody>
-          <a:bodyPr wrap="square" lIns="91440" rIns="91440" tIns="45720" bIns="45720">
-            <a:normAutofit fontScale="85000" lnSpcReduction="20000"/>
-          </a:bodyPr>
-          <a:lstStyle/>
+              <a:t>The SITA HIV model was extended using fractional memory.</a:t>
+            </a:r>
+          </a:p>
           <a:p>
             <a:pPr algn="l">
               <a:buChar char="•"/>
@@ -1417,7 +1719,7 @@
                 </a:solidFill>
                 <a:latin typeface="Aptos"/>
               </a:rPr>
-              <a:t>The SITA HIV model was extended using fractional memory.</a:t>
+              <a:t>Behavioural interventions were represented through effective rates.</a:t>
             </a:r>
           </a:p>
           <a:p>
@@ -1432,9 +1734,73 @@
                 </a:solidFill>
                 <a:latin typeface="Aptos"/>
               </a:rPr>
-              <a:t>Behavioural interventions were represented through effective rates.</a:t>
-            </a:r>
-          </a:p>
+              <a:t>Numerical simulations support combined intervention strategies.</a:t>
+            </a:r>
+          </a:p>
+        </p:txBody>
+      </p:sp>
+      <p:sp>
+        <p:nvSpPr>
+          <p:cNvPr id="121" name="Text 121"/>
+          <p:cNvSpPr txBox="1"/>
+          <p:nvPr/>
+        </p:nvSpPr>
+        <p:spPr>
+          <a:xfrm>
+            <a:off x="6080760" y="1234440"/>
+            <a:ext cx="4663440" cy="320040"/>
+          </a:xfrm>
+          <a:prstGeom prst="rect">
+            <a:avLst/>
+          </a:prstGeom>
+          <a:noFill/>
+          <a:ln>
+            <a:noFill/>
+          </a:ln>
+        </p:spPr>
+        <p:txBody>
+          <a:bodyPr wrap="square" lIns="91440" rIns="91440" tIns="45720" bIns="45720">
+            <a:normAutofit fontScale="85000" lnSpcReduction="20000"/>
+          </a:bodyPr>
+          <a:lstStyle/>
+          <a:p>
+            <a:pPr algn="l"/>
+            <a:r>
+              <a:rPr lang="en-US" sz="1500" b="1">
+                <a:solidFill>
+                  <a:srgbClr val="CC9900"/>
+                </a:solidFill>
+                <a:latin typeface="Aptos"/>
+              </a:rPr>
+              <a:t>Recommendations</a:t>
+            </a:r>
+          </a:p>
+        </p:txBody>
+      </p:sp>
+      <p:sp>
+        <p:nvSpPr>
+          <p:cNvPr id="122" name="Text 122"/>
+          <p:cNvSpPr txBox="1"/>
+          <p:nvPr/>
+        </p:nvSpPr>
+        <p:spPr>
+          <a:xfrm>
+            <a:off x="6144768" y="1627632"/>
+            <a:ext cx="4800600" cy="2880360"/>
+          </a:xfrm>
+          <a:prstGeom prst="rect">
+            <a:avLst/>
+          </a:prstGeom>
+          <a:noFill/>
+          <a:ln>
+            <a:noFill/>
+          </a:ln>
+        </p:spPr>
+        <p:txBody>
+          <a:bodyPr wrap="square" lIns="91440" rIns="91440" tIns="45720" bIns="45720">
+            <a:normAutofit fontScale="85000" lnSpcReduction="20000"/>
+          </a:bodyPr>
+          <a:lstStyle/>
           <a:p>
             <a:pPr algn="l">
               <a:buChar char="•"/>
@@ -1447,7 +1813,7 @@
                 </a:solidFill>
                 <a:latin typeface="Aptos"/>
               </a:rPr>
-              <a:t>Numerical simulations support combined intervention strategies.</a:t>
+              <a:t>Calibrate parameters with Rwanda-specific data.</a:t>
             </a:r>
           </a:p>
           <a:p>
@@ -1462,14 +1828,44 @@
                 </a:solidFill>
                 <a:latin typeface="Aptos"/>
               </a:rPr>
-              <a:t>Future work should calibrate parameters with Rwanda-specific data.</a:t>
-            </a:r>
-          </a:p>
-        </p:txBody>
-      </p:sp>
-      <p:sp>
-        <p:nvSpPr>
-          <p:cNvPr id="114" name="Text 114"/>
+              <a:t>Extend the model using age, gender, or stochastic structure.</a:t>
+            </a:r>
+          </a:p>
+          <a:p>
+            <a:pPr algn="l">
+              <a:buChar char="•"/>
+              <a:buFont typeface="Arial"/>
+            </a:pPr>
+            <a:r>
+              <a:rPr lang="en-US" sz="1800" b="0">
+                <a:solidFill>
+                  <a:srgbClr val="142030"/>
+                </a:solidFill>
+                <a:latin typeface="Aptos"/>
+              </a:rPr>
+              <a:t>Compare other fractional operators.</a:t>
+            </a:r>
+          </a:p>
+          <a:p>
+            <a:pPr algn="l">
+              <a:buChar char="•"/>
+              <a:buFont typeface="Arial"/>
+            </a:pPr>
+            <a:r>
+              <a:rPr lang="en-US" sz="1800" b="0">
+                <a:solidFill>
+                  <a:srgbClr val="142030"/>
+                </a:solidFill>
+                <a:latin typeface="Aptos"/>
+              </a:rPr>
+              <a:t>Improve the dashboard into an educational decision-support tool.</a:t>
+            </a:r>
+          </a:p>
+        </p:txBody>
+      </p:sp>
+      <p:sp>
+        <p:nvSpPr>
+          <p:cNvPr id="123" name="Text 123"/>
           <p:cNvSpPr txBox="1"/>
           <p:nvPr/>
         </p:nvSpPr>
@@ -1504,7 +1900,7 @@
                 </a:solidFill>
                 <a:latin typeface="Aptos"/>
               </a:rPr>
-              <a:t>Final message: this project connects mathematical analysis, numerical simulation, and the working dashboard at https://hiv-model.onrender.com/.</a:t>
+              <a:t>Final message: the work connects mathematical analysis, numerical simulation, and a working dashboard for communicating HIV intervention dynamics.</a:t>
             </a:r>
           </a:p>
         </p:txBody>
@@ -1536,7 +1932,7 @@
       </p:grpSpPr>
       <p:sp>
         <p:nvSpPr>
-          <p:cNvPr id="10" name="Text 10"/>
+          <p:cNvPr id="11" name="Text 11"/>
           <p:cNvSpPr txBox="1"/>
           <p:nvPr/>
         </p:nvSpPr>
@@ -1574,7 +1970,7 @@
       </p:sp>
       <p:sp>
         <p:nvSpPr>
-          <p:cNvPr id="11" name="Text 11"/>
+          <p:cNvPr id="12" name="Text 12"/>
           <p:cNvSpPr txBox="1"/>
           <p:nvPr/>
         </p:nvSpPr>
@@ -1614,7 +2010,7 @@
       </p:sp>
       <p:sp>
         <p:nvSpPr>
-          <p:cNvPr id="12" name="Text 12"/>
+          <p:cNvPr id="13" name="Text 13"/>
           <p:cNvSpPr txBox="1"/>
           <p:nvPr/>
         </p:nvSpPr>
@@ -1654,7 +2050,7 @@
       </p:sp>
       <p:sp>
         <p:nvSpPr>
-          <p:cNvPr id="13" name="Text 13"/>
+          <p:cNvPr id="14" name="Text 14"/>
           <p:cNvSpPr txBox="1"/>
           <p:nvPr/>
         </p:nvSpPr>
@@ -1692,7 +2088,7 @@
       </p:sp>
       <p:sp>
         <p:nvSpPr>
-          <p:cNvPr id="14" name="Text 14"/>
+          <p:cNvPr id="15" name="Text 15"/>
           <p:cNvSpPr txBox="1"/>
           <p:nvPr/>
         </p:nvSpPr>
@@ -1763,7 +2159,7 @@
       </p:sp>
       <p:sp>
         <p:nvSpPr>
-          <p:cNvPr id="15" name="Text 15"/>
+          <p:cNvPr id="16" name="Text 16"/>
           <p:cNvSpPr txBox="1"/>
           <p:nvPr/>
         </p:nvSpPr>
@@ -1817,7 +2213,7 @@
       </p:sp>
       <p:sp>
         <p:nvSpPr>
-          <p:cNvPr id="16" name="Text 16"/>
+          <p:cNvPr id="17" name="Text 17"/>
           <p:cNvSpPr txBox="1"/>
           <p:nvPr/>
         </p:nvSpPr>
@@ -1857,7 +2253,7 @@
       </p:sp>
       <p:sp>
         <p:nvSpPr>
-          <p:cNvPr id="17" name="Text 17"/>
+          <p:cNvPr id="18" name="Text 18"/>
           <p:cNvSpPr txBox="1"/>
           <p:nvPr/>
         </p:nvSpPr>
@@ -1897,7 +2293,7 @@
       </p:sp>
       <p:sp>
         <p:nvSpPr>
-          <p:cNvPr id="18" name="Text 18"/>
+          <p:cNvPr id="19" name="Text 19"/>
           <p:cNvSpPr txBox="1"/>
           <p:nvPr/>
         </p:nvSpPr>
@@ -1937,7 +2333,7 @@
       </p:sp>
       <p:sp>
         <p:nvSpPr>
-          <p:cNvPr id="19" name="Text 19"/>
+          <p:cNvPr id="20" name="Text 20"/>
           <p:cNvSpPr txBox="1"/>
           <p:nvPr/>
         </p:nvSpPr>
@@ -2002,7 +2398,7 @@
       </p:grpSpPr>
       <p:sp>
         <p:nvSpPr>
-          <p:cNvPr id="20" name="Text 20"/>
+          <p:cNvPr id="21" name="Text 21"/>
           <p:cNvSpPr txBox="1"/>
           <p:nvPr/>
         </p:nvSpPr>
@@ -2040,7 +2436,7 @@
       </p:sp>
       <p:sp>
         <p:nvSpPr>
-          <p:cNvPr id="21" name="Text 21"/>
+          <p:cNvPr id="22" name="Text 22"/>
           <p:cNvSpPr txBox="1"/>
           <p:nvPr/>
         </p:nvSpPr>
@@ -2080,7 +2476,7 @@
       </p:sp>
       <p:sp>
         <p:nvSpPr>
-          <p:cNvPr id="22" name="Text 22"/>
+          <p:cNvPr id="23" name="Text 23"/>
           <p:cNvSpPr txBox="1"/>
           <p:nvPr/>
         </p:nvSpPr>
@@ -2120,7 +2516,7 @@
       </p:sp>
       <p:sp>
         <p:nvSpPr>
-          <p:cNvPr id="23" name="Text 23"/>
+          <p:cNvPr id="24" name="Text 24"/>
           <p:cNvSpPr txBox="1"/>
           <p:nvPr/>
         </p:nvSpPr>
@@ -2158,7 +2554,7 @@
       </p:sp>
       <p:sp>
         <p:nvSpPr>
-          <p:cNvPr id="24" name="Text 24"/>
+          <p:cNvPr id="25" name="Text 25"/>
           <p:cNvSpPr txBox="1"/>
           <p:nvPr/>
         </p:nvSpPr>
@@ -2229,7 +2625,7 @@
       </p:sp>
       <p:sp>
         <p:nvSpPr>
-          <p:cNvPr id="25" name="Text 25"/>
+          <p:cNvPr id="26" name="Text 26"/>
           <p:cNvSpPr txBox="1"/>
           <p:nvPr/>
         </p:nvSpPr>
@@ -2267,7 +2663,7 @@
       </p:sp>
       <p:sp>
         <p:nvSpPr>
-          <p:cNvPr id="26" name="Text 26"/>
+          <p:cNvPr id="27" name="Text 27"/>
           <p:cNvSpPr txBox="1"/>
           <p:nvPr/>
         </p:nvSpPr>
@@ -2338,7 +2734,7 @@
       </p:sp>
       <p:sp>
         <p:nvSpPr>
-          <p:cNvPr id="27" name="Text 27"/>
+          <p:cNvPr id="28" name="Text 28"/>
           <p:cNvSpPr txBox="1"/>
           <p:nvPr/>
         </p:nvSpPr>
@@ -2405,7 +2801,7 @@
       </p:grpSpPr>
       <p:sp>
         <p:nvSpPr>
-          <p:cNvPr id="28" name="Text 28"/>
+          <p:cNvPr id="29" name="Text 29"/>
           <p:cNvSpPr txBox="1"/>
           <p:nvPr/>
         </p:nvSpPr>
@@ -2443,7 +2839,7 @@
       </p:sp>
       <p:sp>
         <p:nvSpPr>
-          <p:cNvPr id="29" name="Text 29"/>
+          <p:cNvPr id="30" name="Text 30"/>
           <p:cNvSpPr txBox="1"/>
           <p:nvPr/>
         </p:nvSpPr>
@@ -2483,7 +2879,7 @@
       </p:sp>
       <p:sp>
         <p:nvSpPr>
-          <p:cNvPr id="30" name="Text 30"/>
+          <p:cNvPr id="31" name="Text 31"/>
           <p:cNvSpPr txBox="1"/>
           <p:nvPr/>
         </p:nvSpPr>
@@ -2523,7 +2919,7 @@
       </p:sp>
       <p:sp>
         <p:nvSpPr>
-          <p:cNvPr id="31" name="Text 31"/>
+          <p:cNvPr id="32" name="Text 32"/>
           <p:cNvSpPr txBox="1"/>
           <p:nvPr/>
         </p:nvSpPr>
@@ -2561,7 +2957,7 @@
       </p:sp>
       <p:sp>
         <p:nvSpPr>
-          <p:cNvPr id="32" name="Text 32"/>
+          <p:cNvPr id="33" name="Text 33"/>
           <p:cNvSpPr txBox="1"/>
           <p:nvPr/>
         </p:nvSpPr>
@@ -2599,7 +2995,7 @@
       </p:sp>
       <p:sp>
         <p:nvSpPr>
-          <p:cNvPr id="33" name="Text 33"/>
+          <p:cNvPr id="34" name="Text 34"/>
           <p:cNvSpPr txBox="1"/>
           <p:nvPr/>
         </p:nvSpPr>
@@ -2637,7 +3033,7 @@
       </p:sp>
       <p:sp>
         <p:nvSpPr>
-          <p:cNvPr id="34" name="Text 34"/>
+          <p:cNvPr id="35" name="Text 35"/>
           <p:cNvSpPr txBox="1"/>
           <p:nvPr/>
         </p:nvSpPr>
@@ -2738,7 +3134,7 @@
       </p:sp>
       <p:sp>
         <p:nvSpPr>
-          <p:cNvPr id="35" name="Text 35"/>
+          <p:cNvPr id="36" name="Text 36"/>
           <p:cNvSpPr txBox="1"/>
           <p:nvPr/>
         </p:nvSpPr>
@@ -2780,7 +3176,7 @@
       </p:sp>
       <p:sp>
         <p:nvSpPr>
-          <p:cNvPr id="36" name="Text 36"/>
+          <p:cNvPr id="37" name="Text 37"/>
           <p:cNvSpPr txBox="1"/>
           <p:nvPr/>
         </p:nvSpPr>
@@ -2822,7 +3218,7 @@
       </p:sp>
       <p:sp>
         <p:nvSpPr>
-          <p:cNvPr id="37" name="Text 37"/>
+          <p:cNvPr id="38" name="Text 38"/>
           <p:cNvSpPr txBox="1"/>
           <p:nvPr/>
         </p:nvSpPr>
@@ -2864,7 +3260,7 @@
       </p:sp>
       <p:sp>
         <p:nvSpPr>
-          <p:cNvPr id="38" name="Text 38"/>
+          <p:cNvPr id="39" name="Text 39"/>
           <p:cNvSpPr txBox="1"/>
           <p:nvPr/>
         </p:nvSpPr>
@@ -2906,49 +3302,13 @@
       </p:sp>
       <p:cxnSp>
         <p:nvCxnSpPr>
-          <p:cNvPr id="39" name="Arrow 39"/>
-          <p:cNvCxnSpPr/>
-          <p:nvPr/>
-        </p:nvCxnSpPr>
-        <p:spPr>
-          <a:xfrm>
-            <a:off x="8366760" y="1828800"/>
-            <a:ext cx="0" cy="320040"/>
-          </a:xfrm>
-          <a:prstGeom prst="line">
-            <a:avLst/>
-          </a:prstGeom>
-          <a:ln w="19050">
-            <a:solidFill>
-              <a:srgbClr val="52606C"/>
-            </a:solidFill>
-            <a:tailEnd type="triangle"/>
-          </a:ln>
-        </p:spPr>
-        <p:style>
-          <a:lnRef idx="1">
-            <a:schemeClr val="accent1"/>
-          </a:lnRef>
-          <a:fillRef idx="0">
-            <a:schemeClr val="accent1"/>
-          </a:fillRef>
-          <a:effectRef idx="0">
-            <a:schemeClr val="accent1"/>
-          </a:effectRef>
-          <a:fontRef idx="minor">
-            <a:schemeClr val="tx1"/>
-          </a:fontRef>
-        </p:style>
-      </p:cxnSp>
-      <p:cxnSp>
-        <p:nvCxnSpPr>
           <p:cNvPr id="40" name="Arrow 40"/>
           <p:cNvCxnSpPr/>
           <p:nvPr/>
         </p:nvCxnSpPr>
         <p:spPr>
           <a:xfrm>
-            <a:off x="8366760" y="2651760"/>
+            <a:off x="8366760" y="1828800"/>
             <a:ext cx="0" cy="320040"/>
           </a:xfrm>
           <a:prstGeom prst="line">
@@ -2979,6 +3339,42 @@
       <p:cxnSp>
         <p:nvCxnSpPr>
           <p:cNvPr id="41" name="Arrow 41"/>
+          <p:cNvCxnSpPr/>
+          <p:nvPr/>
+        </p:nvCxnSpPr>
+        <p:spPr>
+          <a:xfrm>
+            <a:off x="8366760" y="2651760"/>
+            <a:ext cx="0" cy="320040"/>
+          </a:xfrm>
+          <a:prstGeom prst="line">
+            <a:avLst/>
+          </a:prstGeom>
+          <a:ln w="19050">
+            <a:solidFill>
+              <a:srgbClr val="52606C"/>
+            </a:solidFill>
+            <a:tailEnd type="triangle"/>
+          </a:ln>
+        </p:spPr>
+        <p:style>
+          <a:lnRef idx="1">
+            <a:schemeClr val="accent1"/>
+          </a:lnRef>
+          <a:fillRef idx="0">
+            <a:schemeClr val="accent1"/>
+          </a:fillRef>
+          <a:effectRef idx="0">
+            <a:schemeClr val="accent1"/>
+          </a:effectRef>
+          <a:fontRef idx="minor">
+            <a:schemeClr val="tx1"/>
+          </a:fontRef>
+        </p:style>
+      </p:cxnSp>
+      <p:cxnSp>
+        <p:nvCxnSpPr>
+          <p:cNvPr id="42" name="Arrow 42"/>
           <p:cNvCxnSpPr/>
           <p:nvPr/>
         </p:nvCxnSpPr>
@@ -3039,7 +3435,7 @@
       </p:grpSpPr>
       <p:sp>
         <p:nvSpPr>
-          <p:cNvPr id="42" name="Text 42"/>
+          <p:cNvPr id="43" name="Text 43"/>
           <p:cNvSpPr txBox="1"/>
           <p:nvPr/>
         </p:nvSpPr>
@@ -3077,7 +3473,7 @@
       </p:sp>
       <p:sp>
         <p:nvSpPr>
-          <p:cNvPr id="43" name="Text 43"/>
+          <p:cNvPr id="44" name="Text 44"/>
           <p:cNvSpPr txBox="1"/>
           <p:nvPr/>
         </p:nvSpPr>
@@ -3117,7 +3513,7 @@
       </p:sp>
       <p:sp>
         <p:nvSpPr>
-          <p:cNvPr id="44" name="Text 44"/>
+          <p:cNvPr id="45" name="Text 45"/>
           <p:cNvSpPr txBox="1"/>
           <p:nvPr/>
         </p:nvSpPr>
@@ -3157,7 +3553,7 @@
       </p:sp>
       <p:sp>
         <p:nvSpPr>
-          <p:cNvPr id="45" name="S(t)"/>
+          <p:cNvPr id="46" name="S(t)"/>
           <p:cNvSpPr/>
           <p:nvPr/>
         </p:nvSpPr>
@@ -3211,7 +3607,7 @@
       </p:sp>
       <p:sp>
         <p:nvSpPr>
-          <p:cNvPr id="46" name="I(t)"/>
+          <p:cNvPr id="47" name="I(t)"/>
           <p:cNvSpPr/>
           <p:nvPr/>
         </p:nvSpPr>
@@ -3265,7 +3661,7 @@
       </p:sp>
       <p:sp>
         <p:nvSpPr>
-          <p:cNvPr id="47" name="T(t)"/>
+          <p:cNvPr id="48" name="T(t)"/>
           <p:cNvSpPr/>
           <p:nvPr/>
         </p:nvSpPr>
@@ -3319,7 +3715,7 @@
       </p:sp>
       <p:sp>
         <p:nvSpPr>
-          <p:cNvPr id="48" name="A(t)"/>
+          <p:cNvPr id="49" name="A(t)"/>
           <p:cNvSpPr/>
           <p:nvPr/>
         </p:nvSpPr>
@@ -3373,49 +3769,13 @@
       </p:sp>
       <p:cxnSp>
         <p:nvCxnSpPr>
-          <p:cNvPr id="49" name="Arrow 49"/>
-          <p:cNvCxnSpPr/>
-          <p:nvPr/>
-        </p:nvCxnSpPr>
-        <p:spPr>
-          <a:xfrm>
-            <a:off x="2441448" y="2212848"/>
-            <a:ext cx="804671" cy="0"/>
-          </a:xfrm>
-          <a:prstGeom prst="line">
-            <a:avLst/>
-          </a:prstGeom>
-          <a:ln w="19050">
-            <a:solidFill>
-              <a:srgbClr val="142030"/>
-            </a:solidFill>
-            <a:tailEnd type="triangle"/>
-          </a:ln>
-        </p:spPr>
-        <p:style>
-          <a:lnRef idx="1">
-            <a:schemeClr val="accent1"/>
-          </a:lnRef>
-          <a:fillRef idx="0">
-            <a:schemeClr val="accent1"/>
-          </a:fillRef>
-          <a:effectRef idx="0">
-            <a:schemeClr val="accent1"/>
-          </a:effectRef>
-          <a:fontRef idx="minor">
-            <a:schemeClr val="tx1"/>
-          </a:fontRef>
-        </p:style>
-      </p:cxnSp>
-      <p:cxnSp>
-        <p:nvCxnSpPr>
           <p:cNvPr id="50" name="Arrow 50"/>
           <p:cNvCxnSpPr/>
           <p:nvPr/>
         </p:nvCxnSpPr>
         <p:spPr>
           <a:xfrm>
-            <a:off x="4937760" y="2212848"/>
+            <a:off x="2441448" y="2212848"/>
             <a:ext cx="804671" cy="0"/>
           </a:xfrm>
           <a:prstGeom prst="line">
@@ -3451,8 +3811,8 @@
         </p:nvCxnSpPr>
         <p:spPr>
           <a:xfrm>
-            <a:off x="7434072" y="2212848"/>
-            <a:ext cx="813815" cy="0"/>
+            <a:off x="4937760" y="2212848"/>
+            <a:ext cx="804671" cy="0"/>
           </a:xfrm>
           <a:prstGeom prst="line">
             <a:avLst/>
@@ -3479,9 +3839,45 @@
           </a:fontRef>
         </p:style>
       </p:cxnSp>
-      <p:sp>
-        <p:nvSpPr>
-          <p:cNvPr id="52" name="Text 52"/>
+      <p:cxnSp>
+        <p:nvCxnSpPr>
+          <p:cNvPr id="52" name="Arrow 52"/>
+          <p:cNvCxnSpPr/>
+          <p:nvPr/>
+        </p:nvCxnSpPr>
+        <p:spPr>
+          <a:xfrm>
+            <a:off x="7434072" y="2212848"/>
+            <a:ext cx="813815" cy="0"/>
+          </a:xfrm>
+          <a:prstGeom prst="line">
+            <a:avLst/>
+          </a:prstGeom>
+          <a:ln w="19050">
+            <a:solidFill>
+              <a:srgbClr val="142030"/>
+            </a:solidFill>
+            <a:tailEnd type="triangle"/>
+          </a:ln>
+        </p:spPr>
+        <p:style>
+          <a:lnRef idx="1">
+            <a:schemeClr val="accent1"/>
+          </a:lnRef>
+          <a:fillRef idx="0">
+            <a:schemeClr val="accent1"/>
+          </a:fillRef>
+          <a:effectRef idx="0">
+            <a:schemeClr val="accent1"/>
+          </a:effectRef>
+          <a:fontRef idx="minor">
+            <a:schemeClr val="tx1"/>
+          </a:fontRef>
+        </p:style>
+      </p:cxnSp>
+      <p:sp>
+        <p:nvSpPr>
+          <p:cNvPr id="53" name="Text 53"/>
           <p:cNvSpPr txBox="1"/>
           <p:nvPr/>
         </p:nvSpPr>
@@ -3519,7 +3915,7 @@
       </p:sp>
       <p:sp>
         <p:nvSpPr>
-          <p:cNvPr id="53" name="Text 53"/>
+          <p:cNvPr id="54" name="Text 54"/>
           <p:cNvSpPr txBox="1"/>
           <p:nvPr/>
         </p:nvSpPr>
@@ -3557,7 +3953,7 @@
       </p:sp>
       <p:sp>
         <p:nvSpPr>
-          <p:cNvPr id="54" name="Text 54"/>
+          <p:cNvPr id="55" name="Text 55"/>
           <p:cNvSpPr txBox="1"/>
           <p:nvPr/>
         </p:nvSpPr>
@@ -3595,7 +3991,7 @@
       </p:sp>
       <p:sp>
         <p:nvSpPr>
-          <p:cNvPr id="55" name="Text 55"/>
+          <p:cNvPr id="56" name="Text 56"/>
           <p:cNvSpPr txBox="1"/>
           <p:nvPr/>
         </p:nvSpPr>
@@ -3649,7 +4045,7 @@
       </p:sp>
       <p:sp>
         <p:nvSpPr>
-          <p:cNvPr id="56" name="Text 56"/>
+          <p:cNvPr id="57" name="Text 57"/>
           <p:cNvSpPr txBox="1"/>
           <p:nvPr/>
         </p:nvSpPr>
@@ -3728,7 +4124,7 @@
       </p:grpSpPr>
       <p:sp>
         <p:nvSpPr>
-          <p:cNvPr id="57" name="Text 57"/>
+          <p:cNvPr id="58" name="Text 58"/>
           <p:cNvSpPr txBox="1"/>
           <p:nvPr/>
         </p:nvSpPr>
@@ -3766,7 +4162,7 @@
       </p:sp>
       <p:sp>
         <p:nvSpPr>
-          <p:cNvPr id="58" name="Text 58"/>
+          <p:cNvPr id="59" name="Text 59"/>
           <p:cNvSpPr txBox="1"/>
           <p:nvPr/>
         </p:nvSpPr>
@@ -3806,7 +4202,7 @@
       </p:sp>
       <p:sp>
         <p:nvSpPr>
-          <p:cNvPr id="59" name="Text 59"/>
+          <p:cNvPr id="60" name="Text 60"/>
           <p:cNvSpPr txBox="1"/>
           <p:nvPr/>
         </p:nvSpPr>
@@ -3846,7 +4242,7 @@
       </p:sp>
       <p:sp>
         <p:nvSpPr>
-          <p:cNvPr id="60" name="Text 60"/>
+          <p:cNvPr id="61" name="Text 61"/>
           <p:cNvSpPr txBox="1"/>
           <p:nvPr/>
         </p:nvSpPr>
@@ -3884,7 +4280,7 @@
       </p:sp>
       <p:sp>
         <p:nvSpPr>
-          <p:cNvPr id="61" name="Text 61"/>
+          <p:cNvPr id="62" name="Text 62"/>
           <p:cNvSpPr txBox="1"/>
           <p:nvPr/>
         </p:nvSpPr>
@@ -3922,7 +4318,7 @@
       </p:sp>
       <p:sp>
         <p:nvSpPr>
-          <p:cNvPr id="62" name="Text 62"/>
+          <p:cNvPr id="63" name="Text 63"/>
           <p:cNvSpPr txBox="1"/>
           <p:nvPr/>
         </p:nvSpPr>
@@ -3996,7 +4392,7 @@
       </p:sp>
       <p:sp>
         <p:nvSpPr>
-          <p:cNvPr id="63" name="Text 63"/>
+          <p:cNvPr id="64" name="Text 64"/>
           <p:cNvSpPr txBox="1"/>
           <p:nvPr/>
         </p:nvSpPr>
@@ -4074,7 +4470,7 @@
       </p:sp>
       <p:sp>
         <p:nvSpPr>
-          <p:cNvPr id="64" name="Text 64"/>
+          <p:cNvPr id="65" name="Text 65"/>
           <p:cNvSpPr txBox="1"/>
           <p:nvPr/>
         </p:nvSpPr>
@@ -4153,7 +4549,7 @@
       </p:grpSpPr>
       <p:sp>
         <p:nvSpPr>
-          <p:cNvPr id="65" name="Text 65"/>
+          <p:cNvPr id="66" name="Text 66"/>
           <p:cNvSpPr txBox="1"/>
           <p:nvPr/>
         </p:nvSpPr>
@@ -4191,7 +4587,7 @@
       </p:sp>
       <p:sp>
         <p:nvSpPr>
-          <p:cNvPr id="66" name="Text 66"/>
+          <p:cNvPr id="67" name="Text 67"/>
           <p:cNvSpPr txBox="1"/>
           <p:nvPr/>
         </p:nvSpPr>
@@ -4231,7 +4627,7 @@
       </p:sp>
       <p:sp>
         <p:nvSpPr>
-          <p:cNvPr id="67" name="Text 67"/>
+          <p:cNvPr id="68" name="Text 68"/>
           <p:cNvSpPr txBox="1"/>
           <p:nvPr/>
         </p:nvSpPr>
@@ -4271,7 +4667,7 @@
       </p:sp>
       <p:sp>
         <p:nvSpPr>
-          <p:cNvPr id="68" name="Text 68"/>
+          <p:cNvPr id="69" name="Text 69"/>
           <p:cNvSpPr txBox="1"/>
           <p:nvPr/>
         </p:nvSpPr>
@@ -4309,7 +4705,7 @@
       </p:sp>
       <p:sp>
         <p:nvSpPr>
-          <p:cNvPr id="69" name="Text 69"/>
+          <p:cNvPr id="70" name="Text 70"/>
           <p:cNvSpPr txBox="1"/>
           <p:nvPr/>
         </p:nvSpPr>
@@ -4395,7 +4791,7 @@
       </p:sp>
       <p:sp>
         <p:nvSpPr>
-          <p:cNvPr id="70" name="Text 70"/>
+          <p:cNvPr id="71" name="Text 71"/>
           <p:cNvSpPr txBox="1"/>
           <p:nvPr/>
         </p:nvSpPr>
@@ -4449,7 +4845,7 @@
       </p:sp>
       <p:sp>
         <p:nvSpPr>
-          <p:cNvPr id="71" name="Text 71"/>
+          <p:cNvPr id="72" name="Text 72"/>
           <p:cNvSpPr txBox="1"/>
           <p:nvPr/>
         </p:nvSpPr>
@@ -4503,7 +4899,7 @@
       </p:sp>
       <p:sp>
         <p:nvSpPr>
-          <p:cNvPr id="72" name="Text 72"/>
+          <p:cNvPr id="73" name="Text 73"/>
           <p:cNvSpPr txBox="1"/>
           <p:nvPr/>
         </p:nvSpPr>
@@ -4557,7 +4953,7 @@
       </p:sp>
       <p:sp>
         <p:nvSpPr>
-          <p:cNvPr id="73" name="Text 73"/>
+          <p:cNvPr id="74" name="Text 74"/>
           <p:cNvSpPr txBox="1"/>
           <p:nvPr/>
         </p:nvSpPr>
@@ -4611,49 +5007,13 @@
       </p:sp>
       <p:cxnSp>
         <p:nvCxnSpPr>
-          <p:cNvPr id="74" name="Arrow 74"/>
-          <p:cNvCxnSpPr/>
-          <p:nvPr/>
-        </p:nvCxnSpPr>
-        <p:spPr>
-          <a:xfrm>
-            <a:off x="8503920" y="1920240"/>
-            <a:ext cx="0" cy="164591"/>
-          </a:xfrm>
-          <a:prstGeom prst="line">
-            <a:avLst/>
-          </a:prstGeom>
-          <a:ln w="19050">
-            <a:solidFill>
-              <a:srgbClr val="52606C"/>
-            </a:solidFill>
-            <a:tailEnd type="triangle"/>
-          </a:ln>
-        </p:spPr>
-        <p:style>
-          <a:lnRef idx="1">
-            <a:schemeClr val="accent1"/>
-          </a:lnRef>
-          <a:fillRef idx="0">
-            <a:schemeClr val="accent1"/>
-          </a:fillRef>
-          <a:effectRef idx="0">
-            <a:schemeClr val="accent1"/>
-          </a:effectRef>
-          <a:fontRef idx="minor">
-            <a:schemeClr val="tx1"/>
-          </a:fontRef>
-        </p:style>
-      </p:cxnSp>
-      <p:cxnSp>
-        <p:nvCxnSpPr>
           <p:cNvPr id="75" name="Arrow 75"/>
           <p:cNvCxnSpPr/>
           <p:nvPr/>
         </p:nvCxnSpPr>
         <p:spPr>
           <a:xfrm>
-            <a:off x="8503920" y="2834640"/>
+            <a:off x="8503920" y="1920240"/>
             <a:ext cx="0" cy="164591"/>
           </a:xfrm>
           <a:prstGeom prst="line">
@@ -4689,8 +5049,8 @@
         </p:nvCxnSpPr>
         <p:spPr>
           <a:xfrm>
-            <a:off x="8503920" y="3749039"/>
-            <a:ext cx="0" cy="164592"/>
+            <a:off x="8503920" y="2834640"/>
+            <a:ext cx="0" cy="164591"/>
           </a:xfrm>
           <a:prstGeom prst="line">
             <a:avLst/>
@@ -4717,9 +5077,45 @@
           </a:fontRef>
         </p:style>
       </p:cxnSp>
-      <p:sp>
-        <p:nvSpPr>
-          <p:cNvPr id="77" name="Text 77"/>
+      <p:cxnSp>
+        <p:nvCxnSpPr>
+          <p:cNvPr id="77" name="Arrow 77"/>
+          <p:cNvCxnSpPr/>
+          <p:nvPr/>
+        </p:nvCxnSpPr>
+        <p:spPr>
+          <a:xfrm>
+            <a:off x="8503920" y="3749039"/>
+            <a:ext cx="0" cy="164592"/>
+          </a:xfrm>
+          <a:prstGeom prst="line">
+            <a:avLst/>
+          </a:prstGeom>
+          <a:ln w="19050">
+            <a:solidFill>
+              <a:srgbClr val="52606C"/>
+            </a:solidFill>
+            <a:tailEnd type="triangle"/>
+          </a:ln>
+        </p:spPr>
+        <p:style>
+          <a:lnRef idx="1">
+            <a:schemeClr val="accent1"/>
+          </a:lnRef>
+          <a:fillRef idx="0">
+            <a:schemeClr val="accent1"/>
+          </a:fillRef>
+          <a:effectRef idx="0">
+            <a:schemeClr val="accent1"/>
+          </a:effectRef>
+          <a:fontRef idx="minor">
+            <a:schemeClr val="tx1"/>
+          </a:fontRef>
+        </p:style>
+      </p:cxnSp>
+      <p:sp>
+        <p:nvSpPr>
+          <p:cNvPr id="78" name="Text 78"/>
           <p:cNvSpPr txBox="1"/>
           <p:nvPr/>
         </p:nvSpPr>
@@ -4786,7 +5182,7 @@
       </p:grpSpPr>
       <p:sp>
         <p:nvSpPr>
-          <p:cNvPr id="79" name="Text 79"/>
+          <p:cNvPr id="80" name="Text 80"/>
           <p:cNvSpPr txBox="1"/>
           <p:nvPr/>
         </p:nvSpPr>
@@ -4824,7 +5220,7 @@
       </p:sp>
       <p:sp>
         <p:nvSpPr>
-          <p:cNvPr id="80" name="Text 80"/>
+          <p:cNvPr id="81" name="Text 81"/>
           <p:cNvSpPr txBox="1"/>
           <p:nvPr/>
         </p:nvSpPr>
@@ -4864,7 +5260,7 @@
       </p:sp>
       <p:sp>
         <p:nvSpPr>
-          <p:cNvPr id="81" name="Text 81"/>
+          <p:cNvPr id="82" name="Text 82"/>
           <p:cNvSpPr txBox="1"/>
           <p:nvPr/>
         </p:nvSpPr>
@@ -4904,7 +5300,7 @@
       </p:sp>
       <p:pic>
         <p:nvPicPr>
-          <p:cNvPr id="78" name="mainChartlinear.png"/>
+          <p:cNvPr id="79" name="mainChartlinear.png"/>
           <p:cNvPicPr/>
           <p:nvPr/>
         </p:nvPicPr>
@@ -4926,7 +5322,7 @@
       </p:pic>
       <p:sp>
         <p:nvSpPr>
-          <p:cNvPr id="82" name="Text 82"/>
+          <p:cNvPr id="83" name="Text 83"/>
           <p:cNvSpPr txBox="1"/>
           <p:nvPr/>
         </p:nvSpPr>
@@ -4964,7 +5360,7 @@
       </p:sp>
       <p:sp>
         <p:nvSpPr>
-          <p:cNvPr id="83" name="Text 83"/>
+          <p:cNvPr id="84" name="Text 84"/>
           <p:cNvSpPr txBox="1"/>
           <p:nvPr/>
         </p:nvSpPr>
@@ -5035,7 +5431,7 @@
       </p:sp>
       <p:sp>
         <p:nvSpPr>
-          <p:cNvPr id="84" name="Text 84"/>
+          <p:cNvPr id="85" name="Text 85"/>
           <p:cNvSpPr txBox="1"/>
           <p:nvPr/>
         </p:nvSpPr>
@@ -5089,7 +5485,7 @@
       </p:sp>
       <p:sp>
         <p:nvSpPr>
-          <p:cNvPr id="85" name="Text 85"/>
+          <p:cNvPr id="86" name="Text 86"/>
           <p:cNvSpPr txBox="1"/>
           <p:nvPr/>
         </p:nvSpPr>
@@ -5168,7 +5564,7 @@
       </p:grpSpPr>
       <p:sp>
         <p:nvSpPr>
-          <p:cNvPr id="87" name="Text 87"/>
+          <p:cNvPr id="88" name="Text 88"/>
           <p:cNvSpPr txBox="1"/>
           <p:nvPr/>
         </p:nvSpPr>
@@ -5206,7 +5602,7 @@
       </p:sp>
       <p:sp>
         <p:nvSpPr>
-          <p:cNvPr id="88" name="Text 88"/>
+          <p:cNvPr id="89" name="Text 89"/>
           <p:cNvSpPr txBox="1"/>
           <p:nvPr/>
         </p:nvSpPr>
@@ -5246,7 +5642,7 @@
       </p:sp>
       <p:sp>
         <p:nvSpPr>
-          <p:cNvPr id="89" name="Text 89"/>
+          <p:cNvPr id="90" name="Text 90"/>
           <p:cNvSpPr txBox="1"/>
           <p:nvPr/>
         </p:nvSpPr>
@@ -5286,7 +5682,7 @@
       </p:sp>
       <p:pic>
         <p:nvPicPr>
-          <p:cNvPr id="86" name="combinedInterventionsChart.png"/>
+          <p:cNvPr id="87" name="combinedInterventionsChart.png"/>
           <p:cNvPicPr/>
           <p:nvPr/>
         </p:nvPicPr>
@@ -5308,7 +5704,7 @@
       </p:pic>
       <p:sp>
         <p:nvSpPr>
-          <p:cNvPr id="90" name="Text 90"/>
+          <p:cNvPr id="91" name="Text 91"/>
           <p:cNvSpPr txBox="1"/>
           <p:nvPr/>
         </p:nvSpPr>
@@ -5346,7 +5742,7 @@
       </p:sp>
       <p:sp>
         <p:nvSpPr>
-          <p:cNvPr id="91" name="Text 91"/>
+          <p:cNvPr id="92" name="Text 92"/>
           <p:cNvSpPr txBox="1"/>
           <p:nvPr/>
         </p:nvSpPr>
@@ -5417,7 +5813,7 @@
       </p:sp>
       <p:sp>
         <p:nvSpPr>
-          <p:cNvPr id="92" name="Text 92"/>
+          <p:cNvPr id="93" name="Text 93"/>
           <p:cNvSpPr txBox="1"/>
           <p:nvPr/>
         </p:nvSpPr>

</xml_diff>

<commit_message>
Update thesis document to add a new page before the Parameter Description section
</commit_message>
<xml_diff>
--- a/presentation/FracHIV_SITA_Presentation.pptx
+++ b/presentation/FracHIV_SITA_Presentation.pptx
@@ -244,8 +244,8 @@
         </p:nvSpPr>
         <p:spPr>
           <a:xfrm>
-            <a:off x="749808" y="1901952"/>
-            <a:ext cx="6400800" cy="1298448"/>
+            <a:off x="749808" y="1755648"/>
+            <a:ext cx="6446520" cy="1627632"/>
           </a:xfrm>
           <a:prstGeom prst="rect">
             <a:avLst/>
@@ -263,25 +263,37 @@
           <a:p>
             <a:pPr algn="l"/>
             <a:r>
-              <a:rPr lang="en-US" sz="3200" b="1">
+              <a:rPr lang="en-US" sz="2500" b="1">
                 <a:solidFill>
                   <a:srgbClr val="FFFFFF"/>
                 </a:solidFill>
                 <a:latin typeface="Aptos"/>
               </a:rPr>
-              <a:t>Fractional-Order</a:t>
-            </a:r>
-          </a:p>
-          <a:p>
-            <a:pPr algn="l"/>
-            <a:r>
-              <a:rPr lang="en-US" sz="3200" b="1">
+              <a:t>A Fractional-Order Compartmental Model</a:t>
+            </a:r>
+          </a:p>
+          <a:p>
+            <a:pPr algn="l"/>
+            <a:r>
+              <a:rPr lang="en-US" sz="2500" b="1">
                 <a:solidFill>
                   <a:srgbClr val="FFFFFF"/>
                 </a:solidFill>
                 <a:latin typeface="Aptos"/>
               </a:rPr>
-              <a:t>HIV SITA Model</a:t>
+              <a:t>of HIV Transmission</a:t>
+            </a:r>
+          </a:p>
+          <a:p>
+            <a:pPr algn="l"/>
+            <a:r>
+              <a:rPr lang="en-US" sz="2500" b="1">
+                <a:solidFill>
+                  <a:srgbClr val="FFFFFF"/>
+                </a:solidFill>
+                <a:latin typeface="Aptos"/>
+              </a:rPr>
+              <a:t>with Social Behaviour Interventions</a:t>
             </a:r>
           </a:p>
         </p:txBody>
@@ -294,8 +306,8 @@
         </p:nvSpPr>
         <p:spPr>
           <a:xfrm>
-            <a:off x="786384" y="3310128"/>
-            <a:ext cx="6263640" cy="502920"/>
+            <a:off x="786384" y="3474720"/>
+            <a:ext cx="6263640" cy="411480"/>
           </a:xfrm>
           <a:prstGeom prst="rect">
             <a:avLst/>
@@ -313,13 +325,13 @@
           <a:p>
             <a:pPr algn="l"/>
             <a:r>
-              <a:rPr lang="en-US" sz="1700" b="0">
+              <a:rPr lang="en-US" sz="1500" b="0">
                 <a:solidFill>
                   <a:srgbClr val="FFFFFF"/>
                 </a:solidFill>
                 <a:latin typeface="Aptos"/>
               </a:rPr>
-              <a:t>Social Behaviour Interventions and Memory Effects</a:t>
+              <a:t>Fractional SITA dynamics and dashboard simulation</a:t>
             </a:r>
           </a:p>
         </p:txBody>
@@ -493,7 +505,7 @@
       </p:grpSpPr>
       <p:sp>
         <p:nvSpPr>
-          <p:cNvPr id="95" name="Text 95"/>
+          <p:cNvPr id="93" name="Text 93"/>
           <p:cNvSpPr txBox="1"/>
           <p:nvPr/>
         </p:nvSpPr>
@@ -531,7 +543,7 @@
       </p:sp>
       <p:sp>
         <p:nvSpPr>
-          <p:cNvPr id="96" name="Text 96"/>
+          <p:cNvPr id="94" name="Text 94"/>
           <p:cNvSpPr txBox="1"/>
           <p:nvPr/>
         </p:nvSpPr>
@@ -571,7 +583,7 @@
       </p:sp>
       <p:sp>
         <p:nvSpPr>
-          <p:cNvPr id="97" name="Text 97"/>
+          <p:cNvPr id="95" name="Text 95"/>
           <p:cNvSpPr txBox="1"/>
           <p:nvPr/>
         </p:nvSpPr>
@@ -611,7 +623,7 @@
       </p:sp>
       <p:pic>
         <p:nvPicPr>
-          <p:cNvPr id="94" name="memoryChart.png"/>
+          <p:cNvPr id="92" name="memoryChart.png"/>
           <p:cNvPicPr/>
           <p:nvPr/>
         </p:nvPicPr>
@@ -633,7 +645,7 @@
       </p:pic>
       <p:sp>
         <p:nvSpPr>
-          <p:cNvPr id="98" name="Text 98"/>
+          <p:cNvPr id="96" name="Text 96"/>
           <p:cNvSpPr txBox="1"/>
           <p:nvPr/>
         </p:nvSpPr>
@@ -671,7 +683,7 @@
       </p:sp>
       <p:sp>
         <p:nvSpPr>
-          <p:cNvPr id="99" name="Text 99"/>
+          <p:cNvPr id="97" name="Text 97"/>
           <p:cNvSpPr txBox="1"/>
           <p:nvPr/>
         </p:nvSpPr>
@@ -742,7 +754,7 @@
       </p:sp>
       <p:sp>
         <p:nvSpPr>
-          <p:cNvPr id="100" name="Text 100"/>
+          <p:cNvPr id="98" name="Text 98"/>
           <p:cNvSpPr txBox="1"/>
           <p:nvPr/>
         </p:nvSpPr>
@@ -821,7 +833,7 @@
       </p:grpSpPr>
       <p:sp>
         <p:nvSpPr>
-          <p:cNvPr id="103" name="Text 103"/>
+          <p:cNvPr id="101" name="Text 101"/>
           <p:cNvSpPr txBox="1"/>
           <p:nvPr/>
         </p:nvSpPr>
@@ -859,7 +871,7 @@
       </p:sp>
       <p:sp>
         <p:nvSpPr>
-          <p:cNvPr id="104" name="Text 104"/>
+          <p:cNvPr id="102" name="Text 102"/>
           <p:cNvSpPr txBox="1"/>
           <p:nvPr/>
         </p:nvSpPr>
@@ -899,7 +911,7 @@
       </p:sp>
       <p:sp>
         <p:nvSpPr>
-          <p:cNvPr id="105" name="Text 105"/>
+          <p:cNvPr id="103" name="Text 103"/>
           <p:cNvSpPr txBox="1"/>
           <p:nvPr/>
         </p:nvSpPr>
@@ -939,7 +951,7 @@
       </p:sp>
       <p:pic>
         <p:nvPicPr>
-          <p:cNvPr id="101" name="sensitivityChart.png"/>
+          <p:cNvPr id="99" name="sensitivityChart.png"/>
           <p:cNvPicPr/>
           <p:nvPr/>
         </p:nvPicPr>
@@ -961,7 +973,7 @@
       </p:pic>
       <p:sp>
         <p:nvSpPr>
-          <p:cNvPr id="106" name="Text 106"/>
+          <p:cNvPr id="104" name="Text 104"/>
           <p:cNvSpPr txBox="1"/>
           <p:nvPr/>
         </p:nvSpPr>
@@ -999,7 +1011,7 @@
       </p:sp>
       <p:sp>
         <p:nvSpPr>
-          <p:cNvPr id="107" name="Text 107"/>
+          <p:cNvPr id="105" name="Text 105"/>
           <p:cNvSpPr txBox="1"/>
           <p:nvPr/>
         </p:nvSpPr>
@@ -1070,7 +1082,7 @@
       </p:sp>
       <p:pic>
         <p:nvPicPr>
-          <p:cNvPr id="102" name="dashboardBaselineFigure.png"/>
+          <p:cNvPr id="100" name="dashboardBaselineFigure.png"/>
           <p:cNvPicPr/>
           <p:nvPr/>
         </p:nvPicPr>
@@ -1117,7 +1129,7 @@
       </p:grpSpPr>
       <p:sp>
         <p:nvSpPr>
-          <p:cNvPr id="109" name="Text 109"/>
+          <p:cNvPr id="107" name="Text 107"/>
           <p:cNvSpPr txBox="1"/>
           <p:nvPr/>
         </p:nvSpPr>
@@ -1155,7 +1167,7 @@
       </p:sp>
       <p:sp>
         <p:nvSpPr>
-          <p:cNvPr id="110" name="Text 110"/>
+          <p:cNvPr id="108" name="Text 108"/>
           <p:cNvSpPr txBox="1"/>
           <p:nvPr/>
         </p:nvSpPr>
@@ -1195,7 +1207,7 @@
       </p:sp>
       <p:sp>
         <p:nvSpPr>
-          <p:cNvPr id="111" name="Text 111"/>
+          <p:cNvPr id="109" name="Text 109"/>
           <p:cNvSpPr txBox="1"/>
           <p:nvPr/>
         </p:nvSpPr>
@@ -1235,7 +1247,7 @@
       </p:sp>
       <p:sp>
         <p:nvSpPr>
-          <p:cNvPr id="112" name="Text 112"/>
+          <p:cNvPr id="110" name="Text 110"/>
           <p:cNvSpPr txBox="1"/>
           <p:nvPr/>
         </p:nvSpPr>
@@ -1273,7 +1285,7 @@
       </p:sp>
       <p:sp>
         <p:nvSpPr>
-          <p:cNvPr id="113" name="Text 113"/>
+          <p:cNvPr id="111" name="Text 111"/>
           <p:cNvSpPr txBox="1"/>
           <p:nvPr/>
         </p:nvSpPr>
@@ -1327,7 +1339,7 @@
       </p:sp>
       <p:sp>
         <p:nvSpPr>
-          <p:cNvPr id="114" name="Text 114"/>
+          <p:cNvPr id="112" name="Text 112"/>
           <p:cNvSpPr txBox="1"/>
           <p:nvPr/>
         </p:nvSpPr>
@@ -1413,7 +1425,7 @@
       </p:sp>
       <p:pic>
         <p:nvPicPr>
-          <p:cNvPr id="108" name="dashboardBaselineFigure.png"/>
+          <p:cNvPr id="106" name="dashboardBaselineFigure.png"/>
           <p:cNvPicPr/>
           <p:nvPr/>
         </p:nvPicPr>
@@ -1435,7 +1447,7 @@
       </p:pic>
       <p:sp>
         <p:nvSpPr>
-          <p:cNvPr id="115" name="Text 115"/>
+          <p:cNvPr id="113" name="Text 113"/>
           <p:cNvSpPr txBox="1"/>
           <p:nvPr/>
         </p:nvSpPr>
@@ -1514,7 +1526,7 @@
       </p:grpSpPr>
       <p:sp>
         <p:nvSpPr>
-          <p:cNvPr id="116" name="Text 116"/>
+          <p:cNvPr id="114" name="Text 114"/>
           <p:cNvSpPr txBox="1"/>
           <p:nvPr/>
         </p:nvSpPr>
@@ -1552,7 +1564,7 @@
       </p:sp>
       <p:sp>
         <p:nvSpPr>
-          <p:cNvPr id="117" name="Text 117"/>
+          <p:cNvPr id="115" name="Text 115"/>
           <p:cNvSpPr txBox="1"/>
           <p:nvPr/>
         </p:nvSpPr>
@@ -1592,7 +1604,7 @@
       </p:sp>
       <p:sp>
         <p:nvSpPr>
-          <p:cNvPr id="118" name="Text 118"/>
+          <p:cNvPr id="116" name="Text 116"/>
           <p:cNvSpPr txBox="1"/>
           <p:nvPr/>
         </p:nvSpPr>
@@ -1632,7 +1644,7 @@
       </p:sp>
       <p:sp>
         <p:nvSpPr>
-          <p:cNvPr id="119" name="Text 119"/>
+          <p:cNvPr id="117" name="Text 117"/>
           <p:cNvSpPr txBox="1"/>
           <p:nvPr/>
         </p:nvSpPr>
@@ -1670,7 +1682,7 @@
       </p:sp>
       <p:sp>
         <p:nvSpPr>
-          <p:cNvPr id="120" name="Text 120"/>
+          <p:cNvPr id="118" name="Text 118"/>
           <p:cNvSpPr txBox="1"/>
           <p:nvPr/>
         </p:nvSpPr>
@@ -1741,7 +1753,7 @@
       </p:sp>
       <p:sp>
         <p:nvSpPr>
-          <p:cNvPr id="121" name="Text 121"/>
+          <p:cNvPr id="119" name="Text 119"/>
           <p:cNvSpPr txBox="1"/>
           <p:nvPr/>
         </p:nvSpPr>
@@ -1779,7 +1791,7 @@
       </p:sp>
       <p:sp>
         <p:nvSpPr>
-          <p:cNvPr id="122" name="Text 122"/>
+          <p:cNvPr id="120" name="Text 120"/>
           <p:cNvSpPr txBox="1"/>
           <p:nvPr/>
         </p:nvSpPr>
@@ -1865,7 +1877,7 @@
       </p:sp>
       <p:sp>
         <p:nvSpPr>
-          <p:cNvPr id="123" name="Text 123"/>
+          <p:cNvPr id="121" name="Text 121"/>
           <p:cNvSpPr txBox="1"/>
           <p:nvPr/>
         </p:nvSpPr>
@@ -2982,13 +2994,13 @@
           <a:p>
             <a:pPr algn="l"/>
             <a:r>
-              <a:rPr lang="en-US" sz="1800" b="0">
-                <a:solidFill>
-                  <a:srgbClr val="142030"/>
-                </a:solidFill>
-                <a:latin typeface="Aptos"/>
-              </a:rPr>
-              <a:t>To formulate, analyse, and simulate a fractional-order SITA HIV transmission model incorporating social behaviour interventions.</a:t>
+              <a:rPr lang="en-US" sz="1700" b="0">
+                <a:solidFill>
+                  <a:srgbClr val="142030"/>
+                </a:solidFill>
+                <a:latin typeface="Aptos"/>
+              </a:rPr>
+              <a:t>To formulate, analyse, and computationally simulate a fractional-order SITA model of HIV transmission incorporating social behaviour interventions.</a:t>
             </a:r>
           </a:p>
         </p:txBody>
@@ -3061,13 +3073,13 @@
               <a:buFont typeface="Arial"/>
             </a:pPr>
             <a:r>
-              <a:rPr lang="en-US" sz="1600" b="0">
-                <a:solidFill>
-                  <a:srgbClr val="142030"/>
-                </a:solidFill>
-                <a:latin typeface="Aptos"/>
-              </a:rPr>
-              <a:t>Formulate the SITA model with Caputo derivative.</a:t>
+              <a:rPr lang="en-US" sz="1500" b="0">
+                <a:solidFill>
+                  <a:srgbClr val="142030"/>
+                </a:solidFill>
+                <a:latin typeface="Aptos"/>
+              </a:rPr>
+              <a:t>Formulate a fractional-order SITA HIV model using the Caputo derivative and social behaviour interventions.</a:t>
             </a:r>
           </a:p>
           <a:p>
@@ -3076,13 +3088,13 @@
               <a:buFont typeface="Arial"/>
             </a:pPr>
             <a:r>
-              <a:rPr lang="en-US" sz="1600" b="0">
-                <a:solidFill>
-                  <a:srgbClr val="142030"/>
-                </a:solidFill>
-                <a:latin typeface="Aptos"/>
-              </a:rPr>
-              <a:t>Derive threshold quantities including R0.</a:t>
+              <a:rPr lang="en-US" sz="1500" b="0">
+                <a:solidFill>
+                  <a:srgbClr val="142030"/>
+                </a:solidFill>
+                <a:latin typeface="Aptos"/>
+              </a:rPr>
+              <a:t>Analyse positivity, boundedness, disease-free equilibrium, R0, and fractional stability.</a:t>
             </a:r>
           </a:p>
           <a:p>
@@ -3091,43 +3103,13 @@
               <a:buFont typeface="Arial"/>
             </a:pPr>
             <a:r>
-              <a:rPr lang="en-US" sz="1600" b="0">
-                <a:solidFill>
-                  <a:srgbClr val="142030"/>
-                </a:solidFill>
-                <a:latin typeface="Aptos"/>
-              </a:rPr>
-              <a:t>Establish core analytical properties.</a:t>
-            </a:r>
-          </a:p>
-          <a:p>
-            <a:pPr algn="l">
-              <a:buChar char="•"/>
-              <a:buFont typeface="Arial"/>
-            </a:pPr>
-            <a:r>
-              <a:rPr lang="en-US" sz="1600" b="0">
-                <a:solidFill>
-                  <a:srgbClr val="142030"/>
-                </a:solidFill>
-                <a:latin typeface="Aptos"/>
-              </a:rPr>
-              <a:t>Implement a numerical simulation scheme.</a:t>
-            </a:r>
-          </a:p>
-          <a:p>
-            <a:pPr algn="l">
-              <a:buChar char="•"/>
-              <a:buFont typeface="Arial"/>
-            </a:pPr>
-            <a:r>
-              <a:rPr lang="en-US" sz="1600" b="0">
-                <a:solidFill>
-                  <a:srgbClr val="142030"/>
-                </a:solidFill>
-                <a:latin typeface="Aptos"/>
-              </a:rPr>
-              <a:t>Compare interventions, memory effects, and sensitivity.</a:t>
+              <a:rPr lang="en-US" sz="1500" b="0">
+                <a:solidFill>
+                  <a:srgbClr val="142030"/>
+                </a:solidFill>
+                <a:latin typeface="Aptos"/>
+              </a:rPr>
+              <a:t>Implement simulations and a Python dashboard to study memory effects, interventions, sensitivity, and epidemic trajectories.</a:t>
             </a:r>
           </a:p>
         </p:txBody>
@@ -3140,8 +3122,8 @@
         </p:nvSpPr>
         <p:spPr>
           <a:xfrm>
-            <a:off x="6629400" y="1325880"/>
-            <a:ext cx="3474720" cy="502920"/>
+            <a:off x="6629400" y="1508760"/>
+            <a:ext cx="3474720" cy="594360"/>
           </a:xfrm>
           <a:prstGeom prst="rect">
             <a:avLst/>
@@ -3163,13 +3145,13 @@
           <a:p>
             <a:pPr algn="c"/>
             <a:r>
-              <a:rPr lang="en-US" sz="1700" b="1">
-                <a:solidFill>
-                  <a:srgbClr val="142030"/>
-                </a:solidFill>
-                <a:latin typeface="Aptos"/>
-              </a:rPr>
-              <a:t>Model formulation</a:t>
+              <a:rPr lang="en-US" sz="1600" b="1">
+                <a:solidFill>
+                  <a:srgbClr val="142030"/>
+                </a:solidFill>
+                <a:latin typeface="Aptos"/>
+              </a:rPr>
+              <a:t>1. Model formulation</a:t>
             </a:r>
           </a:p>
         </p:txBody>
@@ -3182,8 +3164,8 @@
         </p:nvSpPr>
         <p:spPr>
           <a:xfrm>
-            <a:off x="6629400" y="2148840"/>
-            <a:ext cx="3474720" cy="502920"/>
+            <a:off x="6629400" y="2514600"/>
+            <a:ext cx="3474720" cy="594360"/>
           </a:xfrm>
           <a:prstGeom prst="rect">
             <a:avLst/>
@@ -3205,13 +3187,13 @@
           <a:p>
             <a:pPr algn="c"/>
             <a:r>
-              <a:rPr lang="en-US" sz="1700" b="1">
-                <a:solidFill>
-                  <a:srgbClr val="142030"/>
-                </a:solidFill>
-                <a:latin typeface="Aptos"/>
-              </a:rPr>
-              <a:t>Mathematical analysis</a:t>
+              <a:rPr lang="en-US" sz="1600" b="1">
+                <a:solidFill>
+                  <a:srgbClr val="142030"/>
+                </a:solidFill>
+                <a:latin typeface="Aptos"/>
+              </a:rPr>
+              <a:t>2. Model analysis</a:t>
             </a:r>
           </a:p>
         </p:txBody>
@@ -3224,8 +3206,8 @@
         </p:nvSpPr>
         <p:spPr>
           <a:xfrm>
-            <a:off x="6629400" y="2971800"/>
-            <a:ext cx="3474720" cy="502920"/>
+            <a:off x="6629400" y="3520440"/>
+            <a:ext cx="3474720" cy="594360"/>
           </a:xfrm>
           <a:prstGeom prst="rect">
             <a:avLst/>
@@ -3247,69 +3229,27 @@
           <a:p>
             <a:pPr algn="c"/>
             <a:r>
-              <a:rPr lang="en-US" sz="1700" b="1">
-                <a:solidFill>
-                  <a:srgbClr val="142030"/>
-                </a:solidFill>
-                <a:latin typeface="Aptos"/>
-              </a:rPr>
-              <a:t>Numerical simulation</a:t>
-            </a:r>
-          </a:p>
-        </p:txBody>
-      </p:sp>
-      <p:sp>
-        <p:nvSpPr>
-          <p:cNvPr id="39" name="Text 39"/>
-          <p:cNvSpPr txBox="1"/>
-          <p:nvPr/>
-        </p:nvSpPr>
-        <p:spPr>
-          <a:xfrm>
-            <a:off x="6629400" y="3794760"/>
-            <a:ext cx="3474720" cy="502920"/>
-          </a:xfrm>
-          <a:prstGeom prst="rect">
-            <a:avLst/>
-          </a:prstGeom>
-          <a:solidFill>
-            <a:srgbClr val="FFFFFF"/>
-          </a:solidFill>
-          <a:ln w="9525">
-            <a:solidFill>
-              <a:srgbClr val="B44146"/>
-            </a:solidFill>
-          </a:ln>
-        </p:spPr>
-        <p:txBody>
-          <a:bodyPr wrap="square" lIns="91440" rIns="91440" tIns="45720" bIns="45720">
-            <a:normAutofit fontScale="85000" lnSpcReduction="20000"/>
-          </a:bodyPr>
-          <a:lstStyle/>
-          <a:p>
-            <a:pPr algn="c"/>
-            <a:r>
-              <a:rPr lang="en-US" sz="1700" b="1">
-                <a:solidFill>
-                  <a:srgbClr val="142030"/>
-                </a:solidFill>
-                <a:latin typeface="Aptos"/>
-              </a:rPr>
-              <a:t>Results interpretation</a:t>
+              <a:rPr lang="en-US" sz="1600" b="1">
+                <a:solidFill>
+                  <a:srgbClr val="142030"/>
+                </a:solidFill>
+                <a:latin typeface="Aptos"/>
+              </a:rPr>
+              <a:t>3. Simulation dashboard</a:t>
             </a:r>
           </a:p>
         </p:txBody>
       </p:sp>
       <p:cxnSp>
         <p:nvCxnSpPr>
-          <p:cNvPr id="40" name="Arrow 40"/>
+          <p:cNvPr id="39" name="Arrow 39"/>
           <p:cNvCxnSpPr/>
           <p:nvPr/>
         </p:nvCxnSpPr>
         <p:spPr>
           <a:xfrm>
-            <a:off x="8366760" y="1828800"/>
-            <a:ext cx="0" cy="320040"/>
+            <a:off x="8366760" y="2103120"/>
+            <a:ext cx="0" cy="411480"/>
           </a:xfrm>
           <a:prstGeom prst="line">
             <a:avLst/>
@@ -3338,50 +3278,14 @@
       </p:cxnSp>
       <p:cxnSp>
         <p:nvCxnSpPr>
-          <p:cNvPr id="41" name="Arrow 41"/>
+          <p:cNvPr id="40" name="Arrow 40"/>
           <p:cNvCxnSpPr/>
           <p:nvPr/>
         </p:nvCxnSpPr>
         <p:spPr>
           <a:xfrm>
-            <a:off x="8366760" y="2651760"/>
-            <a:ext cx="0" cy="320040"/>
-          </a:xfrm>
-          <a:prstGeom prst="line">
-            <a:avLst/>
-          </a:prstGeom>
-          <a:ln w="19050">
-            <a:solidFill>
-              <a:srgbClr val="52606C"/>
-            </a:solidFill>
-            <a:tailEnd type="triangle"/>
-          </a:ln>
-        </p:spPr>
-        <p:style>
-          <a:lnRef idx="1">
-            <a:schemeClr val="accent1"/>
-          </a:lnRef>
-          <a:fillRef idx="0">
-            <a:schemeClr val="accent1"/>
-          </a:fillRef>
-          <a:effectRef idx="0">
-            <a:schemeClr val="accent1"/>
-          </a:effectRef>
-          <a:fontRef idx="minor">
-            <a:schemeClr val="tx1"/>
-          </a:fontRef>
-        </p:style>
-      </p:cxnSp>
-      <p:cxnSp>
-        <p:nvCxnSpPr>
-          <p:cNvPr id="42" name="Arrow 42"/>
-          <p:cNvCxnSpPr/>
-          <p:nvPr/>
-        </p:nvCxnSpPr>
-        <p:spPr>
-          <a:xfrm>
-            <a:off x="8366760" y="3474720"/>
-            <a:ext cx="0" cy="320040"/>
+            <a:off x="8366760" y="3108960"/>
+            <a:ext cx="0" cy="411480"/>
           </a:xfrm>
           <a:prstGeom prst="line">
             <a:avLst/>
@@ -3435,7 +3339,7 @@
       </p:grpSpPr>
       <p:sp>
         <p:nvSpPr>
-          <p:cNvPr id="43" name="Text 43"/>
+          <p:cNvPr id="41" name="Text 41"/>
           <p:cNvSpPr txBox="1"/>
           <p:nvPr/>
         </p:nvSpPr>
@@ -3473,7 +3377,7 @@
       </p:sp>
       <p:sp>
         <p:nvSpPr>
-          <p:cNvPr id="44" name="Text 44"/>
+          <p:cNvPr id="42" name="Text 42"/>
           <p:cNvSpPr txBox="1"/>
           <p:nvPr/>
         </p:nvSpPr>
@@ -3513,7 +3417,7 @@
       </p:sp>
       <p:sp>
         <p:nvSpPr>
-          <p:cNvPr id="45" name="Text 45"/>
+          <p:cNvPr id="43" name="Text 43"/>
           <p:cNvSpPr txBox="1"/>
           <p:nvPr/>
         </p:nvSpPr>
@@ -3553,7 +3457,7 @@
       </p:sp>
       <p:sp>
         <p:nvSpPr>
-          <p:cNvPr id="46" name="S(t)"/>
+          <p:cNvPr id="44" name="S(t)"/>
           <p:cNvSpPr/>
           <p:nvPr/>
         </p:nvSpPr>
@@ -3607,7 +3511,7 @@
       </p:sp>
       <p:sp>
         <p:nvSpPr>
-          <p:cNvPr id="47" name="I(t)"/>
+          <p:cNvPr id="45" name="I(t)"/>
           <p:cNvSpPr/>
           <p:nvPr/>
         </p:nvSpPr>
@@ -3661,7 +3565,7 @@
       </p:sp>
       <p:sp>
         <p:nvSpPr>
-          <p:cNvPr id="48" name="T(t)"/>
+          <p:cNvPr id="46" name="T(t)"/>
           <p:cNvSpPr/>
           <p:nvPr/>
         </p:nvSpPr>
@@ -3715,7 +3619,7 @@
       </p:sp>
       <p:sp>
         <p:nvSpPr>
-          <p:cNvPr id="49" name="A(t)"/>
+          <p:cNvPr id="47" name="A(t)"/>
           <p:cNvSpPr/>
           <p:nvPr/>
         </p:nvSpPr>
@@ -3769,7 +3673,7 @@
       </p:sp>
       <p:cxnSp>
         <p:nvCxnSpPr>
-          <p:cNvPr id="50" name="Arrow 50"/>
+          <p:cNvPr id="48" name="Arrow 48"/>
           <p:cNvCxnSpPr/>
           <p:nvPr/>
         </p:nvCxnSpPr>
@@ -3805,7 +3709,7 @@
       </p:cxnSp>
       <p:cxnSp>
         <p:nvCxnSpPr>
-          <p:cNvPr id="51" name="Arrow 51"/>
+          <p:cNvPr id="49" name="Arrow 49"/>
           <p:cNvCxnSpPr/>
           <p:nvPr/>
         </p:nvCxnSpPr>
@@ -3841,7 +3745,7 @@
       </p:cxnSp>
       <p:cxnSp>
         <p:nvCxnSpPr>
-          <p:cNvPr id="52" name="Arrow 52"/>
+          <p:cNvPr id="50" name="Arrow 50"/>
           <p:cNvCxnSpPr/>
           <p:nvPr/>
         </p:nvCxnSpPr>
@@ -3877,7 +3781,7 @@
       </p:cxnSp>
       <p:sp>
         <p:nvSpPr>
-          <p:cNvPr id="53" name="Text 53"/>
+          <p:cNvPr id="51" name="Text 51"/>
           <p:cNvSpPr txBox="1"/>
           <p:nvPr/>
         </p:nvSpPr>
@@ -3915,7 +3819,7 @@
       </p:sp>
       <p:sp>
         <p:nvSpPr>
-          <p:cNvPr id="54" name="Text 54"/>
+          <p:cNvPr id="52" name="Text 52"/>
           <p:cNvSpPr txBox="1"/>
           <p:nvPr/>
         </p:nvSpPr>
@@ -3953,7 +3857,7 @@
       </p:sp>
       <p:sp>
         <p:nvSpPr>
-          <p:cNvPr id="55" name="Text 55"/>
+          <p:cNvPr id="53" name="Text 53"/>
           <p:cNvSpPr txBox="1"/>
           <p:nvPr/>
         </p:nvSpPr>
@@ -3991,7 +3895,7 @@
       </p:sp>
       <p:sp>
         <p:nvSpPr>
-          <p:cNvPr id="56" name="Text 56"/>
+          <p:cNvPr id="54" name="Text 54"/>
           <p:cNvSpPr txBox="1"/>
           <p:nvPr/>
         </p:nvSpPr>
@@ -4045,7 +3949,7 @@
       </p:sp>
       <p:sp>
         <p:nvSpPr>
-          <p:cNvPr id="57" name="Text 57"/>
+          <p:cNvPr id="55" name="Text 55"/>
           <p:cNvSpPr txBox="1"/>
           <p:nvPr/>
         </p:nvSpPr>
@@ -4124,7 +4028,7 @@
       </p:grpSpPr>
       <p:sp>
         <p:nvSpPr>
-          <p:cNvPr id="58" name="Text 58"/>
+          <p:cNvPr id="56" name="Text 56"/>
           <p:cNvSpPr txBox="1"/>
           <p:nvPr/>
         </p:nvSpPr>
@@ -4162,7 +4066,7 @@
       </p:sp>
       <p:sp>
         <p:nvSpPr>
-          <p:cNvPr id="59" name="Text 59"/>
+          <p:cNvPr id="57" name="Text 57"/>
           <p:cNvSpPr txBox="1"/>
           <p:nvPr/>
         </p:nvSpPr>
@@ -4202,7 +4106,7 @@
       </p:sp>
       <p:sp>
         <p:nvSpPr>
-          <p:cNvPr id="60" name="Text 60"/>
+          <p:cNvPr id="58" name="Text 58"/>
           <p:cNvSpPr txBox="1"/>
           <p:nvPr/>
         </p:nvSpPr>
@@ -4242,7 +4146,7 @@
       </p:sp>
       <p:sp>
         <p:nvSpPr>
-          <p:cNvPr id="61" name="Text 61"/>
+          <p:cNvPr id="59" name="Text 59"/>
           <p:cNvSpPr txBox="1"/>
           <p:nvPr/>
         </p:nvSpPr>
@@ -4280,7 +4184,7 @@
       </p:sp>
       <p:sp>
         <p:nvSpPr>
-          <p:cNvPr id="62" name="Text 62"/>
+          <p:cNvPr id="60" name="Text 60"/>
           <p:cNvSpPr txBox="1"/>
           <p:nvPr/>
         </p:nvSpPr>
@@ -4318,7 +4222,7 @@
       </p:sp>
       <p:sp>
         <p:nvSpPr>
-          <p:cNvPr id="63" name="Text 63"/>
+          <p:cNvPr id="61" name="Text 61"/>
           <p:cNvSpPr txBox="1"/>
           <p:nvPr/>
         </p:nvSpPr>
@@ -4392,7 +4296,7 @@
       </p:sp>
       <p:sp>
         <p:nvSpPr>
-          <p:cNvPr id="64" name="Text 64"/>
+          <p:cNvPr id="62" name="Text 62"/>
           <p:cNvSpPr txBox="1"/>
           <p:nvPr/>
         </p:nvSpPr>
@@ -4470,7 +4374,7 @@
       </p:sp>
       <p:sp>
         <p:nvSpPr>
-          <p:cNvPr id="65" name="Text 65"/>
+          <p:cNvPr id="63" name="Text 63"/>
           <p:cNvSpPr txBox="1"/>
           <p:nvPr/>
         </p:nvSpPr>
@@ -4549,7 +4453,7 @@
       </p:grpSpPr>
       <p:sp>
         <p:nvSpPr>
-          <p:cNvPr id="66" name="Text 66"/>
+          <p:cNvPr id="64" name="Text 64"/>
           <p:cNvSpPr txBox="1"/>
           <p:nvPr/>
         </p:nvSpPr>
@@ -4587,7 +4491,7 @@
       </p:sp>
       <p:sp>
         <p:nvSpPr>
-          <p:cNvPr id="67" name="Text 67"/>
+          <p:cNvPr id="65" name="Text 65"/>
           <p:cNvSpPr txBox="1"/>
           <p:nvPr/>
         </p:nvSpPr>
@@ -4627,7 +4531,7 @@
       </p:sp>
       <p:sp>
         <p:nvSpPr>
-          <p:cNvPr id="68" name="Text 68"/>
+          <p:cNvPr id="66" name="Text 66"/>
           <p:cNvSpPr txBox="1"/>
           <p:nvPr/>
         </p:nvSpPr>
@@ -4667,7 +4571,7 @@
       </p:sp>
       <p:sp>
         <p:nvSpPr>
-          <p:cNvPr id="69" name="Text 69"/>
+          <p:cNvPr id="67" name="Text 67"/>
           <p:cNvSpPr txBox="1"/>
           <p:nvPr/>
         </p:nvSpPr>
@@ -4705,7 +4609,7 @@
       </p:sp>
       <p:sp>
         <p:nvSpPr>
-          <p:cNvPr id="70" name="Text 70"/>
+          <p:cNvPr id="68" name="Text 68"/>
           <p:cNvSpPr txBox="1"/>
           <p:nvPr/>
         </p:nvSpPr>
@@ -4791,7 +4695,7 @@
       </p:sp>
       <p:sp>
         <p:nvSpPr>
-          <p:cNvPr id="71" name="Text 71"/>
+          <p:cNvPr id="69" name="Text 69"/>
           <p:cNvSpPr txBox="1"/>
           <p:nvPr/>
         </p:nvSpPr>
@@ -4845,7 +4749,7 @@
       </p:sp>
       <p:sp>
         <p:nvSpPr>
-          <p:cNvPr id="72" name="Text 72"/>
+          <p:cNvPr id="70" name="Text 70"/>
           <p:cNvSpPr txBox="1"/>
           <p:nvPr/>
         </p:nvSpPr>
@@ -4899,7 +4803,7 @@
       </p:sp>
       <p:sp>
         <p:nvSpPr>
-          <p:cNvPr id="73" name="Text 73"/>
+          <p:cNvPr id="71" name="Text 71"/>
           <p:cNvSpPr txBox="1"/>
           <p:nvPr/>
         </p:nvSpPr>
@@ -4953,7 +4857,7 @@
       </p:sp>
       <p:sp>
         <p:nvSpPr>
-          <p:cNvPr id="74" name="Text 74"/>
+          <p:cNvPr id="72" name="Text 72"/>
           <p:cNvSpPr txBox="1"/>
           <p:nvPr/>
         </p:nvSpPr>
@@ -5007,7 +4911,7 @@
       </p:sp>
       <p:cxnSp>
         <p:nvCxnSpPr>
-          <p:cNvPr id="75" name="Arrow 75"/>
+          <p:cNvPr id="73" name="Arrow 73"/>
           <p:cNvCxnSpPr/>
           <p:nvPr/>
         </p:nvCxnSpPr>
@@ -5043,7 +4947,7 @@
       </p:cxnSp>
       <p:cxnSp>
         <p:nvCxnSpPr>
-          <p:cNvPr id="76" name="Arrow 76"/>
+          <p:cNvPr id="74" name="Arrow 74"/>
           <p:cNvCxnSpPr/>
           <p:nvPr/>
         </p:nvCxnSpPr>
@@ -5079,7 +4983,7 @@
       </p:cxnSp>
       <p:cxnSp>
         <p:nvCxnSpPr>
-          <p:cNvPr id="77" name="Arrow 77"/>
+          <p:cNvPr id="75" name="Arrow 75"/>
           <p:cNvCxnSpPr/>
           <p:nvPr/>
         </p:nvCxnSpPr>
@@ -5115,7 +5019,7 @@
       </p:cxnSp>
       <p:sp>
         <p:nvSpPr>
-          <p:cNvPr id="78" name="Text 78"/>
+          <p:cNvPr id="76" name="Text 76"/>
           <p:cNvSpPr txBox="1"/>
           <p:nvPr/>
         </p:nvSpPr>
@@ -5182,7 +5086,7 @@
       </p:grpSpPr>
       <p:sp>
         <p:nvSpPr>
-          <p:cNvPr id="80" name="Text 80"/>
+          <p:cNvPr id="78" name="Text 78"/>
           <p:cNvSpPr txBox="1"/>
           <p:nvPr/>
         </p:nvSpPr>
@@ -5220,7 +5124,7 @@
       </p:sp>
       <p:sp>
         <p:nvSpPr>
-          <p:cNvPr id="81" name="Text 81"/>
+          <p:cNvPr id="79" name="Text 79"/>
           <p:cNvSpPr txBox="1"/>
           <p:nvPr/>
         </p:nvSpPr>
@@ -5260,7 +5164,7 @@
       </p:sp>
       <p:sp>
         <p:nvSpPr>
-          <p:cNvPr id="82" name="Text 82"/>
+          <p:cNvPr id="80" name="Text 80"/>
           <p:cNvSpPr txBox="1"/>
           <p:nvPr/>
         </p:nvSpPr>
@@ -5300,7 +5204,7 @@
       </p:sp>
       <p:pic>
         <p:nvPicPr>
-          <p:cNvPr id="79" name="mainChartlinear.png"/>
+          <p:cNvPr id="77" name="mainChartlinear.png"/>
           <p:cNvPicPr/>
           <p:nvPr/>
         </p:nvPicPr>
@@ -5322,7 +5226,7 @@
       </p:pic>
       <p:sp>
         <p:nvSpPr>
-          <p:cNvPr id="83" name="Text 83"/>
+          <p:cNvPr id="81" name="Text 81"/>
           <p:cNvSpPr txBox="1"/>
           <p:nvPr/>
         </p:nvSpPr>
@@ -5360,7 +5264,7 @@
       </p:sp>
       <p:sp>
         <p:nvSpPr>
-          <p:cNvPr id="84" name="Text 84"/>
+          <p:cNvPr id="82" name="Text 82"/>
           <p:cNvSpPr txBox="1"/>
           <p:nvPr/>
         </p:nvSpPr>
@@ -5431,7 +5335,7 @@
       </p:sp>
       <p:sp>
         <p:nvSpPr>
-          <p:cNvPr id="85" name="Text 85"/>
+          <p:cNvPr id="83" name="Text 83"/>
           <p:cNvSpPr txBox="1"/>
           <p:nvPr/>
         </p:nvSpPr>
@@ -5485,7 +5389,7 @@
       </p:sp>
       <p:sp>
         <p:nvSpPr>
-          <p:cNvPr id="86" name="Text 86"/>
+          <p:cNvPr id="84" name="Text 84"/>
           <p:cNvSpPr txBox="1"/>
           <p:nvPr/>
         </p:nvSpPr>
@@ -5564,7 +5468,7 @@
       </p:grpSpPr>
       <p:sp>
         <p:nvSpPr>
-          <p:cNvPr id="88" name="Text 88"/>
+          <p:cNvPr id="86" name="Text 86"/>
           <p:cNvSpPr txBox="1"/>
           <p:nvPr/>
         </p:nvSpPr>
@@ -5602,7 +5506,7 @@
       </p:sp>
       <p:sp>
         <p:nvSpPr>
-          <p:cNvPr id="89" name="Text 89"/>
+          <p:cNvPr id="87" name="Text 87"/>
           <p:cNvSpPr txBox="1"/>
           <p:nvPr/>
         </p:nvSpPr>
@@ -5642,7 +5546,7 @@
       </p:sp>
       <p:sp>
         <p:nvSpPr>
-          <p:cNvPr id="90" name="Text 90"/>
+          <p:cNvPr id="88" name="Text 88"/>
           <p:cNvSpPr txBox="1"/>
           <p:nvPr/>
         </p:nvSpPr>
@@ -5682,7 +5586,7 @@
       </p:sp>
       <p:pic>
         <p:nvPicPr>
-          <p:cNvPr id="87" name="combinedInterventionsChart.png"/>
+          <p:cNvPr id="85" name="combinedInterventionsChart.png"/>
           <p:cNvPicPr/>
           <p:nvPr/>
         </p:nvPicPr>
@@ -5704,7 +5608,7 @@
       </p:pic>
       <p:sp>
         <p:nvSpPr>
-          <p:cNvPr id="91" name="Text 91"/>
+          <p:cNvPr id="89" name="Text 89"/>
           <p:cNvSpPr txBox="1"/>
           <p:nvPr/>
         </p:nvSpPr>
@@ -5742,7 +5646,7 @@
       </p:sp>
       <p:sp>
         <p:nvSpPr>
-          <p:cNvPr id="92" name="Text 92"/>
+          <p:cNvPr id="90" name="Text 90"/>
           <p:cNvSpPr txBox="1"/>
           <p:nvPr/>
         </p:nvSpPr>
@@ -5813,7 +5717,7 @@
       </p:sp>
       <p:sp>
         <p:nvSpPr>
-          <p:cNvPr id="93" name="Text 93"/>
+          <p:cNvPr id="91" name="Text 91"/>
           <p:cNvSpPr txBox="1"/>
           <p:nvPr/>
         </p:nvSpPr>

</xml_diff>

<commit_message>
Update FracHIV SITA presentation and speaker notes to include Literature Review, Research Gap, and revised objectives
</commit_message>
<xml_diff>
--- a/presentation/FracHIV_SITA_Presentation.pptx
+++ b/presentation/FracHIV_SITA_Presentation.pptx
@@ -2,7 +2,7 @@
 <file path=ppt/presentation.xml><?xml version="1.0" encoding="utf-8"?>
 <p:presentation xmlns:a="http://schemas.openxmlformats.org/drawingml/2006/main" xmlns:r="http://schemas.openxmlformats.org/officeDocument/2006/relationships" xmlns:p="http://schemas.openxmlformats.org/presentationml/2006/main">
   <p:sldMasterIdLst>
-    <p:sldMasterId id="2147483648" r:id="rId14"/>
+    <p:sldMasterId id="2147483648" r:id="rId15"/>
   </p:sldMasterIdLst>
   <p:sldIdLst>
     <p:sldId id="256" r:id="rId1"/>
@@ -18,6 +18,7 @@
     <p:sldId id="266" r:id="rId11"/>
     <p:sldId id="267" r:id="rId12"/>
     <p:sldId id="268" r:id="rId13"/>
+    <p:sldId id="269" r:id="rId14"/>
   </p:sldIdLst>
   <p:sldSz cx="12191999" cy="6858000" type="screen16x9"/>
   <p:notesSz cx="6858000" cy="9144000"/>
@@ -505,7 +506,7 @@
       </p:grpSpPr>
       <p:sp>
         <p:nvSpPr>
-          <p:cNvPr id="93" name="Text 93"/>
+          <p:cNvPr id="94" name="Text 94"/>
           <p:cNvSpPr txBox="1"/>
           <p:nvPr/>
         </p:nvSpPr>
@@ -536,14 +537,14 @@
                 </a:solidFill>
                 <a:latin typeface="Aptos"/>
               </a:rPr>
-              <a:t>Simulation Results: Fractional Memory</a:t>
-            </a:r>
-          </a:p>
-        </p:txBody>
-      </p:sp>
-      <p:sp>
-        <p:nvSpPr>
-          <p:cNvPr id="94" name="Text 94"/>
+              <a:t>Simulation Results: Intervention Comparison</a:t>
+            </a:r>
+          </a:p>
+        </p:txBody>
+      </p:sp>
+      <p:sp>
+        <p:nvSpPr>
+          <p:cNvPr id="95" name="Text 95"/>
           <p:cNvSpPr txBox="1"/>
           <p:nvPr/>
         </p:nvSpPr>
@@ -583,7 +584,7 @@
       </p:sp>
       <p:sp>
         <p:nvSpPr>
-          <p:cNvPr id="95" name="Text 95"/>
+          <p:cNvPr id="96" name="Text 96"/>
           <p:cNvSpPr txBox="1"/>
           <p:nvPr/>
         </p:nvSpPr>
@@ -623,7 +624,7 @@
       </p:sp>
       <p:pic>
         <p:nvPicPr>
-          <p:cNvPr id="92" name="memoryChart.png"/>
+          <p:cNvPr id="93" name="combinedInterventionsChart.png"/>
           <p:cNvPicPr/>
           <p:nvPr/>
         </p:nvPicPr>
@@ -645,7 +646,7 @@
       </p:pic>
       <p:sp>
         <p:nvSpPr>
-          <p:cNvPr id="96" name="Text 96"/>
+          <p:cNvPr id="97" name="Text 97"/>
           <p:cNvSpPr txBox="1"/>
           <p:nvPr/>
         </p:nvSpPr>
@@ -676,21 +677,21 @@
                 </a:solidFill>
                 <a:latin typeface="Aptos"/>
               </a:rPr>
-              <a:t>Why q matters</a:t>
-            </a:r>
-          </a:p>
-        </p:txBody>
-      </p:sp>
-      <p:sp>
-        <p:nvSpPr>
-          <p:cNvPr id="97" name="Text 97"/>
+              <a:t>Main interpretation</a:t>
+            </a:r>
+          </a:p>
+        </p:txBody>
+      </p:sp>
+      <p:sp>
+        <p:nvSpPr>
+          <p:cNvPr id="98" name="Text 98"/>
           <p:cNvSpPr txBox="1"/>
           <p:nvPr/>
         </p:nvSpPr>
         <p:spPr>
           <a:xfrm>
             <a:off x="7406640" y="1719072"/>
-            <a:ext cx="3520440" cy="1691640"/>
+            <a:ext cx="3520440" cy="1920240"/>
           </a:xfrm>
           <a:prstGeom prst="rect">
             <a:avLst/>
@@ -717,7 +718,7 @@
                 </a:solidFill>
                 <a:latin typeface="Aptos"/>
               </a:rPr>
-              <a:t>q = 1 represents the ordinary model.</a:t>
+              <a:t>Single interventions help, but each targets only one mechanism.</a:t>
             </a:r>
           </a:p>
           <a:p>
@@ -732,7 +733,7 @@
                 </a:solidFill>
                 <a:latin typeface="Aptos"/>
               </a:rPr>
-              <a:t>Smaller q values strengthen the memory effect.</a:t>
+              <a:t>Combined intervention acts on transmission, treatment uptake, and progression.</a:t>
             </a:r>
           </a:p>
           <a:p>
@@ -747,31 +748,31 @@
                 </a:solidFill>
                 <a:latin typeface="Aptos"/>
               </a:rPr>
-              <a:t>Different q values produce visibly different trajectories.</a:t>
-            </a:r>
-          </a:p>
-        </p:txBody>
-      </p:sp>
-      <p:sp>
-        <p:nvSpPr>
-          <p:cNvPr id="98" name="Text 98"/>
-          <p:cNvSpPr txBox="1"/>
-          <p:nvPr/>
-        </p:nvSpPr>
-        <p:spPr>
-          <a:xfrm>
-            <a:off x="7360920" y="4005072"/>
-            <a:ext cx="3611880" cy="914400"/>
+              <a:t>The combined strategy gives stronger simulated control than isolated changes.</a:t>
+            </a:r>
+          </a:p>
+        </p:txBody>
+      </p:sp>
+      <p:sp>
+        <p:nvSpPr>
+          <p:cNvPr id="99" name="Text 99"/>
+          <p:cNvSpPr txBox="1"/>
+          <p:nvPr/>
+        </p:nvSpPr>
+        <p:spPr>
+          <a:xfrm>
+            <a:off x="7360920" y="4133087"/>
+            <a:ext cx="3611880" cy="868680"/>
           </a:xfrm>
           <a:prstGeom prst="rect">
             <a:avLst/>
           </a:prstGeom>
           <a:solidFill>
-            <a:srgbClr val="FFF7E0"/>
+            <a:srgbClr val="E6F7F4"/>
           </a:solidFill>
           <a:ln w="9525">
             <a:solidFill>
-              <a:srgbClr val="CC9900"/>
+              <a:srgbClr val="007E70"/>
             </a:solidFill>
           </a:ln>
         </p:spPr>
@@ -789,7 +790,7 @@
                 </a:solidFill>
                 <a:latin typeface="Aptos"/>
               </a:rPr>
-              <a:t>Defense point</a:t>
+              <a:t>Public-health meaning</a:t>
             </a:r>
           </a:p>
           <a:p>
@@ -801,7 +802,7 @@
                 </a:solidFill>
                 <a:latin typeface="Aptos"/>
               </a:rPr>
-              <a:t>Fractional calculus is not decorative; it changes the simulated dynamics.</a:t>
+              <a:t>Prevention and treatment support should work together.</a:t>
             </a:r>
           </a:p>
         </p:txBody>
@@ -864,7 +865,7 @@
                 </a:solidFill>
                 <a:latin typeface="Aptos"/>
               </a:rPr>
-              <a:t>Dashboard and Sensitivity Evidence</a:t>
+              <a:t>Simulation Results: Fractional Memory</a:t>
             </a:r>
           </a:p>
         </p:txBody>
@@ -951,7 +952,7 @@
       </p:sp>
       <p:pic>
         <p:nvPicPr>
-          <p:cNvPr id="99" name="sensitivityChart.png"/>
+          <p:cNvPr id="100" name="memoryChart.png"/>
           <p:cNvPicPr/>
           <p:nvPr/>
         </p:nvPicPr>
@@ -1004,7 +1005,7 @@
                 </a:solidFill>
                 <a:latin typeface="Aptos"/>
               </a:rPr>
-              <a:t>Main evidence</a:t>
+              <a:t>Why q matters</a:t>
             </a:r>
           </a:p>
         </p:txBody>
@@ -1018,7 +1019,7 @@
         <p:spPr>
           <a:xfrm>
             <a:off x="7406640" y="1719072"/>
-            <a:ext cx="3520440" cy="1600200"/>
+            <a:ext cx="3520440" cy="1691640"/>
           </a:xfrm>
           <a:prstGeom prst="rect">
             <a:avLst/>
@@ -1039,13 +1040,13 @@
               <a:buFont typeface="Arial"/>
             </a:pPr>
             <a:r>
-              <a:rPr lang="en-US" sz="1500" b="0">
-                <a:solidFill>
-                  <a:srgbClr val="142030"/>
-                </a:solidFill>
-                <a:latin typeface="Aptos"/>
-              </a:rPr>
-              <a:t>Transmission-related quantities dominate R0 sensitivity.</a:t>
+              <a:rPr lang="en-US" sz="1600" b="0">
+                <a:solidFill>
+                  <a:srgbClr val="142030"/>
+                </a:solidFill>
+                <a:latin typeface="Aptos"/>
+              </a:rPr>
+              <a:t>q = 1 represents the ordinary model.</a:t>
             </a:r>
           </a:p>
           <a:p>
@@ -1054,13 +1055,13 @@
               <a:buFont typeface="Arial"/>
             </a:pPr>
             <a:r>
-              <a:rPr lang="en-US" sz="1500" b="0">
-                <a:solidFill>
-                  <a:srgbClr val="142030"/>
-                </a:solidFill>
-                <a:latin typeface="Aptos"/>
-              </a:rPr>
-              <a:t>Safer behaviour and awareness reduce R0 strongly.</a:t>
+              <a:rPr lang="en-US" sz="1600" b="0">
+                <a:solidFill>
+                  <a:srgbClr val="142030"/>
+                </a:solidFill>
+                <a:latin typeface="Aptos"/>
+              </a:rPr>
+              <a:t>Smaller q values strengthen the memory effect.</a:t>
             </a:r>
           </a:p>
           <a:p>
@@ -1069,39 +1070,71 @@
               <a:buFont typeface="Arial"/>
             </a:pPr>
             <a:r>
+              <a:rPr lang="en-US" sz="1600" b="0">
+                <a:solidFill>
+                  <a:srgbClr val="142030"/>
+                </a:solidFill>
+                <a:latin typeface="Aptos"/>
+              </a:rPr>
+              <a:t>Different q values produce visibly different trajectories.</a:t>
+            </a:r>
+          </a:p>
+        </p:txBody>
+      </p:sp>
+      <p:sp>
+        <p:nvSpPr>
+          <p:cNvPr id="106" name="Text 106"/>
+          <p:cNvSpPr txBox="1"/>
+          <p:nvPr/>
+        </p:nvSpPr>
+        <p:spPr>
+          <a:xfrm>
+            <a:off x="7360920" y="4005072"/>
+            <a:ext cx="3611880" cy="914400"/>
+          </a:xfrm>
+          <a:prstGeom prst="rect">
+            <a:avLst/>
+          </a:prstGeom>
+          <a:solidFill>
+            <a:srgbClr val="FFF7E0"/>
+          </a:solidFill>
+          <a:ln w="9525">
+            <a:solidFill>
+              <a:srgbClr val="CC9900"/>
+            </a:solidFill>
+          </a:ln>
+        </p:spPr>
+        <p:txBody>
+          <a:bodyPr wrap="square" lIns="91440" rIns="91440" tIns="45720" bIns="45720">
+            <a:normAutofit fontScale="85000" lnSpcReduction="20000"/>
+          </a:bodyPr>
+          <a:lstStyle/>
+          <a:p>
+            <a:pPr algn="l"/>
+            <a:r>
               <a:rPr lang="en-US" sz="1500" b="0">
                 <a:solidFill>
                   <a:srgbClr val="142030"/>
                 </a:solidFill>
                 <a:latin typeface="Aptos"/>
               </a:rPr>
-              <a:t>Dashboard outputs support thesis discussion and live defense.</a:t>
-            </a:r>
-          </a:p>
-        </p:txBody>
-      </p:sp>
-      <p:pic>
-        <p:nvPicPr>
-          <p:cNvPr id="100" name="dashboardBaselineFigure.png"/>
-          <p:cNvPicPr/>
-          <p:nvPr/>
-        </p:nvPicPr>
-        <p:blipFill>
-          <a:blip r:embed="rId3"/>
-          <a:stretch>
-            <a:fillRect/>
-          </a:stretch>
-        </p:blipFill>
-        <p:spPr>
-          <a:xfrm>
-            <a:off x="7406640" y="3767328"/>
-            <a:ext cx="3383280" cy="1627632"/>
-          </a:xfrm>
-          <a:prstGeom prst="rect">
-            <a:avLst/>
-          </a:prstGeom>
-        </p:spPr>
-      </p:pic>
+              <a:t>Defense point</a:t>
+            </a:r>
+          </a:p>
+          <a:p>
+            <a:pPr algn="l"/>
+            <a:r>
+              <a:rPr lang="en-US" sz="1500" b="0">
+                <a:solidFill>
+                  <a:srgbClr val="142030"/>
+                </a:solidFill>
+                <a:latin typeface="Aptos"/>
+              </a:rPr>
+              <a:t>Fractional calculus is not decorative; it changes the simulated dynamics.</a:t>
+            </a:r>
+          </a:p>
+        </p:txBody>
+      </p:sp>
     </p:spTree>
   </p:cSld>
   <p:clrMapOvr>
@@ -1129,7 +1162,7 @@
       </p:grpSpPr>
       <p:sp>
         <p:nvSpPr>
-          <p:cNvPr id="107" name="Text 107"/>
+          <p:cNvPr id="109" name="Text 109"/>
           <p:cNvSpPr txBox="1"/>
           <p:nvPr/>
         </p:nvSpPr>
@@ -1160,14 +1193,14 @@
                 </a:solidFill>
                 <a:latin typeface="Aptos"/>
               </a:rPr>
-              <a:t>Live Dashboard Demonstration</a:t>
-            </a:r>
-          </a:p>
-        </p:txBody>
-      </p:sp>
-      <p:sp>
-        <p:nvSpPr>
-          <p:cNvPr id="108" name="Text 108"/>
+              <a:t>Dashboard and Sensitivity Evidence</a:t>
+            </a:r>
+          </a:p>
+        </p:txBody>
+      </p:sp>
+      <p:sp>
+        <p:nvSpPr>
+          <p:cNvPr id="110" name="Text 110"/>
           <p:cNvSpPr txBox="1"/>
           <p:nvPr/>
         </p:nvSpPr>
@@ -1207,7 +1240,7 @@
       </p:sp>
       <p:sp>
         <p:nvSpPr>
-          <p:cNvPr id="109" name="Text 109"/>
+          <p:cNvPr id="111" name="Text 111"/>
           <p:cNvSpPr txBox="1"/>
           <p:nvPr/>
         </p:nvSpPr>
@@ -1245,187 +1278,9 @@
           </a:p>
         </p:txBody>
       </p:sp>
-      <p:sp>
-        <p:nvSpPr>
-          <p:cNvPr id="110" name="Text 110"/>
-          <p:cNvSpPr txBox="1"/>
-          <p:nvPr/>
-        </p:nvSpPr>
-        <p:spPr>
-          <a:xfrm>
-            <a:off x="658368" y="1234440"/>
-            <a:ext cx="5074920" cy="320040"/>
-          </a:xfrm>
-          <a:prstGeom prst="rect">
-            <a:avLst/>
-          </a:prstGeom>
-          <a:noFill/>
-          <a:ln>
-            <a:noFill/>
-          </a:ln>
-        </p:spPr>
-        <p:txBody>
-          <a:bodyPr wrap="square" lIns="91440" rIns="91440" tIns="45720" bIns="45720">
-            <a:normAutofit fontScale="85000" lnSpcReduction="20000"/>
-          </a:bodyPr>
-          <a:lstStyle/>
-          <a:p>
-            <a:pPr algn="l"/>
-            <a:r>
-              <a:rPr lang="en-US" sz="1500" b="1">
-                <a:solidFill>
-                  <a:srgbClr val="CC9900"/>
-                </a:solidFill>
-                <a:latin typeface="Aptos"/>
-              </a:rPr>
-              <a:t>Open during the defense</a:t>
-            </a:r>
-          </a:p>
-        </p:txBody>
-      </p:sp>
-      <p:sp>
-        <p:nvSpPr>
-          <p:cNvPr id="111" name="Text 111"/>
-          <p:cNvSpPr txBox="1"/>
-          <p:nvPr/>
-        </p:nvSpPr>
-        <p:spPr>
-          <a:xfrm>
-            <a:off x="749808" y="1664208"/>
-            <a:ext cx="5029200" cy="731520"/>
-          </a:xfrm>
-          <a:prstGeom prst="rect">
-            <a:avLst/>
-          </a:prstGeom>
-          <a:solidFill>
-            <a:srgbClr val="E8F2FA"/>
-          </a:solidFill>
-          <a:ln w="9525">
-            <a:solidFill>
-              <a:srgbClr val="004A80"/>
-            </a:solidFill>
-          </a:ln>
-        </p:spPr>
-        <p:txBody>
-          <a:bodyPr wrap="square" lIns="91440" rIns="91440" tIns="45720" bIns="45720">
-            <a:normAutofit fontScale="85000" lnSpcReduction="20000"/>
-          </a:bodyPr>
-          <a:lstStyle/>
-          <a:p>
-            <a:pPr algn="l"/>
-            <a:r>
-              <a:rPr lang="en-US" sz="1800" b="0">
-                <a:solidFill>
-                  <a:srgbClr val="142030"/>
-                </a:solidFill>
-                <a:latin typeface="Aptos"/>
-              </a:rPr>
-              <a:t>Dashboard link</a:t>
-            </a:r>
-          </a:p>
-          <a:p>
-            <a:pPr algn="l"/>
-            <a:r>
-              <a:rPr lang="en-US" sz="1800" b="0">
-                <a:solidFill>
-                  <a:srgbClr val="142030"/>
-                </a:solidFill>
-                <a:latin typeface="Aptos"/>
-              </a:rPr>
-              <a:t>https://hiv-model.onrender.com/</a:t>
-            </a:r>
-          </a:p>
-        </p:txBody>
-      </p:sp>
-      <p:sp>
-        <p:nvSpPr>
-          <p:cNvPr id="112" name="Text 112"/>
-          <p:cNvSpPr txBox="1"/>
-          <p:nvPr/>
-        </p:nvSpPr>
-        <p:spPr>
-          <a:xfrm>
-            <a:off x="768096" y="2788920"/>
-            <a:ext cx="5120640" cy="1645920"/>
-          </a:xfrm>
-          <a:prstGeom prst="rect">
-            <a:avLst/>
-          </a:prstGeom>
-          <a:noFill/>
-          <a:ln>
-            <a:noFill/>
-          </a:ln>
-        </p:spPr>
-        <p:txBody>
-          <a:bodyPr wrap="square" lIns="91440" rIns="91440" tIns="45720" bIns="45720">
-            <a:normAutofit fontScale="85000" lnSpcReduction="20000"/>
-          </a:bodyPr>
-          <a:lstStyle/>
-          <a:p>
-            <a:pPr algn="l">
-              <a:buChar char="•"/>
-              <a:buFont typeface="Arial"/>
-            </a:pPr>
-            <a:r>
-              <a:rPr lang="en-US" sz="1600" b="0">
-                <a:solidFill>
-                  <a:srgbClr val="142030"/>
-                </a:solidFill>
-                <a:latin typeface="Aptos"/>
-              </a:rPr>
-              <a:t>Run the baseline simulation.</a:t>
-            </a:r>
-          </a:p>
-          <a:p>
-            <a:pPr algn="l">
-              <a:buChar char="•"/>
-              <a:buFont typeface="Arial"/>
-            </a:pPr>
-            <a:r>
-              <a:rPr lang="en-US" sz="1600" b="0">
-                <a:solidFill>
-                  <a:srgbClr val="142030"/>
-                </a:solidFill>
-                <a:latin typeface="Aptos"/>
-              </a:rPr>
-              <a:t>Show the final state summary and interpretation.</a:t>
-            </a:r>
-          </a:p>
-          <a:p>
-            <a:pPr algn="l">
-              <a:buChar char="•"/>
-              <a:buFont typeface="Arial"/>
-            </a:pPr>
-            <a:r>
-              <a:rPr lang="en-US" sz="1600" b="0">
-                <a:solidFill>
-                  <a:srgbClr val="142030"/>
-                </a:solidFill>
-                <a:latin typeface="Aptos"/>
-              </a:rPr>
-              <a:t>Compare no intervention with combined intervention.</a:t>
-            </a:r>
-          </a:p>
-          <a:p>
-            <a:pPr algn="l">
-              <a:buChar char="•"/>
-              <a:buFont typeface="Arial"/>
-            </a:pPr>
-            <a:r>
-              <a:rPr lang="en-US" sz="1600" b="0">
-                <a:solidFill>
-                  <a:srgbClr val="142030"/>
-                </a:solidFill>
-                <a:latin typeface="Aptos"/>
-              </a:rPr>
-              <a:t>Change q to show the fractional memory effect.</a:t>
-            </a:r>
-          </a:p>
-        </p:txBody>
-      </p:sp>
       <p:pic>
         <p:nvPicPr>
-          <p:cNvPr id="106" name="dashboardBaselineFigure.png"/>
+          <p:cNvPr id="107" name="sensitivityChart.png"/>
           <p:cNvPicPr/>
           <p:nvPr/>
         </p:nvPicPr>
@@ -1437,8 +1292,8 @@
         </p:blipFill>
         <p:spPr>
           <a:xfrm>
-            <a:off x="6583680" y="1417320"/>
-            <a:ext cx="4297680" cy="2331720"/>
+            <a:off x="658368" y="1298448"/>
+            <a:ext cx="6217920" cy="4206240"/>
           </a:xfrm>
           <a:prstGeom prst="rect">
             <a:avLst/>
@@ -1447,34 +1302,71 @@
       </p:pic>
       <p:sp>
         <p:nvSpPr>
+          <p:cNvPr id="112" name="Text 112"/>
+          <p:cNvSpPr txBox="1"/>
+          <p:nvPr/>
+        </p:nvSpPr>
+        <p:spPr>
+          <a:xfrm>
+            <a:off x="7360920" y="1325880"/>
+            <a:ext cx="3566160" cy="320040"/>
+          </a:xfrm>
+          <a:prstGeom prst="rect">
+            <a:avLst/>
+          </a:prstGeom>
+          <a:noFill/>
+          <a:ln>
+            <a:noFill/>
+          </a:ln>
+        </p:spPr>
+        <p:txBody>
+          <a:bodyPr wrap="square" lIns="91440" rIns="91440" tIns="45720" bIns="45720">
+            <a:normAutofit fontScale="85000" lnSpcReduction="20000"/>
+          </a:bodyPr>
+          <a:lstStyle/>
+          <a:p>
+            <a:pPr algn="l"/>
+            <a:r>
+              <a:rPr lang="en-US" sz="1500" b="1">
+                <a:solidFill>
+                  <a:srgbClr val="CC9900"/>
+                </a:solidFill>
+                <a:latin typeface="Aptos"/>
+              </a:rPr>
+              <a:t>Main evidence</a:t>
+            </a:r>
+          </a:p>
+        </p:txBody>
+      </p:sp>
+      <p:sp>
+        <p:nvSpPr>
           <p:cNvPr id="113" name="Text 113"/>
           <p:cNvSpPr txBox="1"/>
           <p:nvPr/>
         </p:nvSpPr>
         <p:spPr>
           <a:xfrm>
-            <a:off x="6601968" y="4160520"/>
-            <a:ext cx="4297680" cy="822960"/>
-          </a:xfrm>
-          <a:prstGeom prst="rect">
-            <a:avLst/>
-          </a:prstGeom>
-          <a:solidFill>
-            <a:srgbClr val="FFF7E0"/>
-          </a:solidFill>
-          <a:ln w="9525">
-            <a:solidFill>
-              <a:srgbClr val="CC9900"/>
-            </a:solidFill>
-          </a:ln>
-        </p:spPr>
-        <p:txBody>
-          <a:bodyPr wrap="square" lIns="91440" rIns="91440" tIns="45720" bIns="45720">
-            <a:normAutofit fontScale="85000" lnSpcReduction="20000"/>
-          </a:bodyPr>
-          <a:lstStyle/>
-          <a:p>
-            <a:pPr algn="l"/>
+            <a:off x="7406640" y="1719072"/>
+            <a:ext cx="3520440" cy="1600200"/>
+          </a:xfrm>
+          <a:prstGeom prst="rect">
+            <a:avLst/>
+          </a:prstGeom>
+          <a:noFill/>
+          <a:ln>
+            <a:noFill/>
+          </a:ln>
+        </p:spPr>
+        <p:txBody>
+          <a:bodyPr wrap="square" lIns="91440" rIns="91440" tIns="45720" bIns="45720">
+            <a:normAutofit fontScale="85000" lnSpcReduction="20000"/>
+          </a:bodyPr>
+          <a:lstStyle/>
+          <a:p>
+            <a:pPr algn="l">
+              <a:buChar char="•"/>
+              <a:buFont typeface="Arial"/>
+            </a:pPr>
             <a:r>
               <a:rPr lang="en-US" sz="1500" b="0">
                 <a:solidFill>
@@ -1482,11 +1374,14 @@
                 </a:solidFill>
                 <a:latin typeface="Aptos"/>
               </a:rPr>
-              <a:t>After the demo</a:t>
-            </a:r>
-          </a:p>
-          <a:p>
-            <a:pPr algn="l"/>
+              <a:t>Transmission-related quantities dominate R0 sensitivity.</a:t>
+            </a:r>
+          </a:p>
+          <a:p>
+            <a:pPr algn="l">
+              <a:buChar char="•"/>
+              <a:buFont typeface="Arial"/>
+            </a:pPr>
             <a:r>
               <a:rPr lang="en-US" sz="1500" b="0">
                 <a:solidFill>
@@ -1494,11 +1389,48 @@
                 </a:solidFill>
                 <a:latin typeface="Aptos"/>
               </a:rPr>
-              <a:t>Return to the next slide for conclusion and recommendations.</a:t>
-            </a:r>
-          </a:p>
-        </p:txBody>
-      </p:sp>
+              <a:t>Safer behaviour and awareness reduce R0 strongly.</a:t>
+            </a:r>
+          </a:p>
+          <a:p>
+            <a:pPr algn="l">
+              <a:buChar char="•"/>
+              <a:buFont typeface="Arial"/>
+            </a:pPr>
+            <a:r>
+              <a:rPr lang="en-US" sz="1500" b="0">
+                <a:solidFill>
+                  <a:srgbClr val="142030"/>
+                </a:solidFill>
+                <a:latin typeface="Aptos"/>
+              </a:rPr>
+              <a:t>Dashboard outputs support thesis discussion and live defense.</a:t>
+            </a:r>
+          </a:p>
+        </p:txBody>
+      </p:sp>
+      <p:pic>
+        <p:nvPicPr>
+          <p:cNvPr id="108" name="dashboardBaselineFigure.png"/>
+          <p:cNvPicPr/>
+          <p:nvPr/>
+        </p:nvPicPr>
+        <p:blipFill>
+          <a:blip r:embed="rId3"/>
+          <a:stretch>
+            <a:fillRect/>
+          </a:stretch>
+        </p:blipFill>
+        <p:spPr>
+          <a:xfrm>
+            <a:off x="7406640" y="3767328"/>
+            <a:ext cx="3383280" cy="1627632"/>
+          </a:xfrm>
+          <a:prstGeom prst="rect">
+            <a:avLst/>
+          </a:prstGeom>
+        </p:spPr>
+      </p:pic>
     </p:spTree>
   </p:cSld>
   <p:clrMapOvr>
@@ -1526,7 +1458,7 @@
       </p:grpSpPr>
       <p:sp>
         <p:nvSpPr>
-          <p:cNvPr id="114" name="Text 114"/>
+          <p:cNvPr id="115" name="Text 115"/>
           <p:cNvSpPr txBox="1"/>
           <p:nvPr/>
         </p:nvSpPr>
@@ -1557,14 +1489,14 @@
                 </a:solidFill>
                 <a:latin typeface="Aptos"/>
               </a:rPr>
-              <a:t>Conclusion + Recommendations</a:t>
-            </a:r>
-          </a:p>
-        </p:txBody>
-      </p:sp>
-      <p:sp>
-        <p:nvSpPr>
-          <p:cNvPr id="115" name="Text 115"/>
+              <a:t>Live Dashboard Demonstration</a:t>
+            </a:r>
+          </a:p>
+        </p:txBody>
+      </p:sp>
+      <p:sp>
+        <p:nvSpPr>
+          <p:cNvPr id="116" name="Text 116"/>
           <p:cNvSpPr txBox="1"/>
           <p:nvPr/>
         </p:nvSpPr>
@@ -1604,7 +1536,7 @@
       </p:sp>
       <p:sp>
         <p:nvSpPr>
-          <p:cNvPr id="116" name="Text 116"/>
+          <p:cNvPr id="117" name="Text 117"/>
           <p:cNvSpPr txBox="1"/>
           <p:nvPr/>
         </p:nvSpPr>
@@ -1644,14 +1576,14 @@
       </p:sp>
       <p:sp>
         <p:nvSpPr>
-          <p:cNvPr id="117" name="Text 117"/>
+          <p:cNvPr id="118" name="Text 118"/>
           <p:cNvSpPr txBox="1"/>
           <p:nvPr/>
         </p:nvSpPr>
         <p:spPr>
           <a:xfrm>
             <a:off x="658368" y="1234440"/>
-            <a:ext cx="4709160" cy="320040"/>
+            <a:ext cx="5074920" cy="320040"/>
           </a:xfrm>
           <a:prstGeom prst="rect">
             <a:avLst/>
@@ -1675,21 +1607,75 @@
                 </a:solidFill>
                 <a:latin typeface="Aptos"/>
               </a:rPr>
-              <a:t>Conclusion</a:t>
-            </a:r>
-          </a:p>
-        </p:txBody>
-      </p:sp>
-      <p:sp>
-        <p:nvSpPr>
-          <p:cNvPr id="118" name="Text 118"/>
-          <p:cNvSpPr txBox="1"/>
-          <p:nvPr/>
-        </p:nvSpPr>
-        <p:spPr>
-          <a:xfrm>
-            <a:off x="713232" y="1627632"/>
-            <a:ext cx="4800600" cy="2880360"/>
+              <a:t>Open during the defense</a:t>
+            </a:r>
+          </a:p>
+        </p:txBody>
+      </p:sp>
+      <p:sp>
+        <p:nvSpPr>
+          <p:cNvPr id="119" name="Text 119"/>
+          <p:cNvSpPr txBox="1"/>
+          <p:nvPr/>
+        </p:nvSpPr>
+        <p:spPr>
+          <a:xfrm>
+            <a:off x="749808" y="1664208"/>
+            <a:ext cx="5029200" cy="731520"/>
+          </a:xfrm>
+          <a:prstGeom prst="rect">
+            <a:avLst/>
+          </a:prstGeom>
+          <a:solidFill>
+            <a:srgbClr val="E8F2FA"/>
+          </a:solidFill>
+          <a:ln w="9525">
+            <a:solidFill>
+              <a:srgbClr val="004A80"/>
+            </a:solidFill>
+          </a:ln>
+        </p:spPr>
+        <p:txBody>
+          <a:bodyPr wrap="square" lIns="91440" rIns="91440" tIns="45720" bIns="45720">
+            <a:normAutofit fontScale="85000" lnSpcReduction="20000"/>
+          </a:bodyPr>
+          <a:lstStyle/>
+          <a:p>
+            <a:pPr algn="l"/>
+            <a:r>
+              <a:rPr lang="en-US" sz="1800" b="0">
+                <a:solidFill>
+                  <a:srgbClr val="142030"/>
+                </a:solidFill>
+                <a:latin typeface="Aptos"/>
+              </a:rPr>
+              <a:t>Dashboard link</a:t>
+            </a:r>
+          </a:p>
+          <a:p>
+            <a:pPr algn="l"/>
+            <a:r>
+              <a:rPr lang="en-US" sz="1800" b="0">
+                <a:solidFill>
+                  <a:srgbClr val="142030"/>
+                </a:solidFill>
+                <a:latin typeface="Aptos"/>
+              </a:rPr>
+              <a:t>https://hiv-model.onrender.com/</a:t>
+            </a:r>
+          </a:p>
+        </p:txBody>
+      </p:sp>
+      <p:sp>
+        <p:nvSpPr>
+          <p:cNvPr id="120" name="Text 120"/>
+          <p:cNvSpPr txBox="1"/>
+          <p:nvPr/>
+        </p:nvSpPr>
+        <p:spPr>
+          <a:xfrm>
+            <a:off x="768096" y="2788920"/>
+            <a:ext cx="5120640" cy="1645920"/>
           </a:xfrm>
           <a:prstGeom prst="rect">
             <a:avLst/>
@@ -1710,13 +1696,13 @@
               <a:buFont typeface="Arial"/>
             </a:pPr>
             <a:r>
-              <a:rPr lang="en-US" sz="1800" b="0">
-                <a:solidFill>
-                  <a:srgbClr val="142030"/>
-                </a:solidFill>
-                <a:latin typeface="Aptos"/>
-              </a:rPr>
-              <a:t>The SITA HIV model was extended using fractional memory.</a:t>
+              <a:rPr lang="en-US" sz="1600" b="0">
+                <a:solidFill>
+                  <a:srgbClr val="142030"/>
+                </a:solidFill>
+                <a:latin typeface="Aptos"/>
+              </a:rPr>
+              <a:t>Run the baseline simulation.</a:t>
             </a:r>
           </a:p>
           <a:p>
@@ -1725,13 +1711,13 @@
               <a:buFont typeface="Arial"/>
             </a:pPr>
             <a:r>
-              <a:rPr lang="en-US" sz="1800" b="0">
-                <a:solidFill>
-                  <a:srgbClr val="142030"/>
-                </a:solidFill>
-                <a:latin typeface="Aptos"/>
-              </a:rPr>
-              <a:t>Behavioural interventions were represented through effective rates.</a:t>
+              <a:rPr lang="en-US" sz="1600" b="0">
+                <a:solidFill>
+                  <a:srgbClr val="142030"/>
+                </a:solidFill>
+                <a:latin typeface="Aptos"/>
+              </a:rPr>
+              <a:t>Show the final state summary and interpretation.</a:t>
             </a:r>
           </a:p>
           <a:p>
@@ -1740,94 +1726,313 @@
               <a:buFont typeface="Arial"/>
             </a:pPr>
             <a:r>
-              <a:rPr lang="en-US" sz="1800" b="0">
-                <a:solidFill>
-                  <a:srgbClr val="142030"/>
-                </a:solidFill>
-                <a:latin typeface="Aptos"/>
-              </a:rPr>
-              <a:t>Numerical simulations support combined intervention strategies.</a:t>
-            </a:r>
-          </a:p>
-        </p:txBody>
-      </p:sp>
-      <p:sp>
-        <p:nvSpPr>
-          <p:cNvPr id="119" name="Text 119"/>
-          <p:cNvSpPr txBox="1"/>
-          <p:nvPr/>
-        </p:nvSpPr>
-        <p:spPr>
-          <a:xfrm>
-            <a:off x="6080760" y="1234440"/>
-            <a:ext cx="4663440" cy="320040"/>
-          </a:xfrm>
-          <a:prstGeom prst="rect">
-            <a:avLst/>
-          </a:prstGeom>
-          <a:noFill/>
-          <a:ln>
-            <a:noFill/>
-          </a:ln>
-        </p:spPr>
-        <p:txBody>
-          <a:bodyPr wrap="square" lIns="91440" rIns="91440" tIns="45720" bIns="45720">
-            <a:normAutofit fontScale="85000" lnSpcReduction="20000"/>
-          </a:bodyPr>
-          <a:lstStyle/>
-          <a:p>
-            <a:pPr algn="l"/>
-            <a:r>
-              <a:rPr lang="en-US" sz="1500" b="1">
-                <a:solidFill>
-                  <a:srgbClr val="CC9900"/>
-                </a:solidFill>
-                <a:latin typeface="Aptos"/>
-              </a:rPr>
-              <a:t>Recommendations</a:t>
-            </a:r>
-          </a:p>
-        </p:txBody>
-      </p:sp>
-      <p:sp>
-        <p:nvSpPr>
-          <p:cNvPr id="120" name="Text 120"/>
-          <p:cNvSpPr txBox="1"/>
-          <p:nvPr/>
-        </p:nvSpPr>
-        <p:spPr>
-          <a:xfrm>
-            <a:off x="6144768" y="1627632"/>
-            <a:ext cx="4800600" cy="2880360"/>
-          </a:xfrm>
-          <a:prstGeom prst="rect">
-            <a:avLst/>
-          </a:prstGeom>
-          <a:noFill/>
-          <a:ln>
-            <a:noFill/>
-          </a:ln>
-        </p:spPr>
-        <p:txBody>
-          <a:bodyPr wrap="square" lIns="91440" rIns="91440" tIns="45720" bIns="45720">
-            <a:normAutofit fontScale="85000" lnSpcReduction="20000"/>
-          </a:bodyPr>
-          <a:lstStyle/>
+              <a:rPr lang="en-US" sz="1600" b="0">
+                <a:solidFill>
+                  <a:srgbClr val="142030"/>
+                </a:solidFill>
+                <a:latin typeface="Aptos"/>
+              </a:rPr>
+              <a:t>Compare no intervention with combined intervention.</a:t>
+            </a:r>
+          </a:p>
           <a:p>
             <a:pPr algn="l">
               <a:buChar char="•"/>
               <a:buFont typeface="Arial"/>
             </a:pPr>
             <a:r>
-              <a:rPr lang="en-US" sz="1800" b="0">
-                <a:solidFill>
-                  <a:srgbClr val="142030"/>
-                </a:solidFill>
-                <a:latin typeface="Aptos"/>
-              </a:rPr>
-              <a:t>Calibrate parameters with Rwanda-specific data.</a:t>
-            </a:r>
-          </a:p>
+              <a:rPr lang="en-US" sz="1600" b="0">
+                <a:solidFill>
+                  <a:srgbClr val="142030"/>
+                </a:solidFill>
+                <a:latin typeface="Aptos"/>
+              </a:rPr>
+              <a:t>Change q to show the fractional memory effect.</a:t>
+            </a:r>
+          </a:p>
+        </p:txBody>
+      </p:sp>
+      <p:pic>
+        <p:nvPicPr>
+          <p:cNvPr id="114" name="dashboardBaselineFigure.png"/>
+          <p:cNvPicPr/>
+          <p:nvPr/>
+        </p:nvPicPr>
+        <p:blipFill>
+          <a:blip r:embed="rId2"/>
+          <a:stretch>
+            <a:fillRect/>
+          </a:stretch>
+        </p:blipFill>
+        <p:spPr>
+          <a:xfrm>
+            <a:off x="6583680" y="1417320"/>
+            <a:ext cx="4297680" cy="2331720"/>
+          </a:xfrm>
+          <a:prstGeom prst="rect">
+            <a:avLst/>
+          </a:prstGeom>
+        </p:spPr>
+      </p:pic>
+      <p:sp>
+        <p:nvSpPr>
+          <p:cNvPr id="121" name="Text 121"/>
+          <p:cNvSpPr txBox="1"/>
+          <p:nvPr/>
+        </p:nvSpPr>
+        <p:spPr>
+          <a:xfrm>
+            <a:off x="6601968" y="4160520"/>
+            <a:ext cx="4297680" cy="822960"/>
+          </a:xfrm>
+          <a:prstGeom prst="rect">
+            <a:avLst/>
+          </a:prstGeom>
+          <a:solidFill>
+            <a:srgbClr val="FFF7E0"/>
+          </a:solidFill>
+          <a:ln w="9525">
+            <a:solidFill>
+              <a:srgbClr val="CC9900"/>
+            </a:solidFill>
+          </a:ln>
+        </p:spPr>
+        <p:txBody>
+          <a:bodyPr wrap="square" lIns="91440" rIns="91440" tIns="45720" bIns="45720">
+            <a:normAutofit fontScale="85000" lnSpcReduction="20000"/>
+          </a:bodyPr>
+          <a:lstStyle/>
+          <a:p>
+            <a:pPr algn="l"/>
+            <a:r>
+              <a:rPr lang="en-US" sz="1500" b="0">
+                <a:solidFill>
+                  <a:srgbClr val="142030"/>
+                </a:solidFill>
+                <a:latin typeface="Aptos"/>
+              </a:rPr>
+              <a:t>After the demo</a:t>
+            </a:r>
+          </a:p>
+          <a:p>
+            <a:pPr algn="l"/>
+            <a:r>
+              <a:rPr lang="en-US" sz="1500" b="0">
+                <a:solidFill>
+                  <a:srgbClr val="142030"/>
+                </a:solidFill>
+                <a:latin typeface="Aptos"/>
+              </a:rPr>
+              <a:t>Return to the next slide for conclusion and recommendations.</a:t>
+            </a:r>
+          </a:p>
+        </p:txBody>
+      </p:sp>
+    </p:spTree>
+  </p:cSld>
+  <p:clrMapOvr>
+    <a:masterClrMapping/>
+  </p:clrMapOvr>
+</p:sld>
+</file>
+
+<file path=ppt/slides/slide14.xml><?xml version="1.0" encoding="utf-8"?>
+<p:sld xmlns:a="http://schemas.openxmlformats.org/drawingml/2006/main" xmlns:r="http://schemas.openxmlformats.org/officeDocument/2006/relationships" xmlns:p="http://schemas.openxmlformats.org/presentationml/2006/main">
+  <p:cSld>
+    <p:spTree>
+      <p:nvGrpSpPr>
+        <p:cNvPr id="1" name=""/>
+        <p:cNvGrpSpPr/>
+        <p:nvPr/>
+      </p:nvGrpSpPr>
+      <p:grpSpPr>
+        <a:xfrm>
+          <a:off x="0" y="0"/>
+          <a:ext cx="0" cy="0"/>
+          <a:chOff x="0" y="0"/>
+          <a:chExt cx="0" cy="0"/>
+        </a:xfrm>
+      </p:grpSpPr>
+      <p:sp>
+        <p:nvSpPr>
+          <p:cNvPr id="122" name="Text 122"/>
+          <p:cNvSpPr txBox="1"/>
+          <p:nvPr/>
+        </p:nvSpPr>
+        <p:spPr>
+          <a:xfrm>
+            <a:off x="502920" y="292608"/>
+            <a:ext cx="10058400" cy="384048"/>
+          </a:xfrm>
+          <a:prstGeom prst="rect">
+            <a:avLst/>
+          </a:prstGeom>
+          <a:noFill/>
+          <a:ln>
+            <a:noFill/>
+          </a:ln>
+        </p:spPr>
+        <p:txBody>
+          <a:bodyPr wrap="square" lIns="91440" rIns="91440" tIns="45720" bIns="45720">
+            <a:normAutofit fontScale="85000" lnSpcReduction="20000"/>
+          </a:bodyPr>
+          <a:lstStyle/>
+          <a:p>
+            <a:pPr algn="l"/>
+            <a:r>
+              <a:rPr lang="en-US" sz="2300" b="1">
+                <a:solidFill>
+                  <a:srgbClr val="0A1B30"/>
+                </a:solidFill>
+                <a:latin typeface="Aptos"/>
+              </a:rPr>
+              <a:t>Conclusion + Recommendations</a:t>
+            </a:r>
+          </a:p>
+        </p:txBody>
+      </p:sp>
+      <p:sp>
+        <p:nvSpPr>
+          <p:cNvPr id="123" name="Text 123"/>
+          <p:cNvSpPr txBox="1"/>
+          <p:nvPr/>
+        </p:nvSpPr>
+        <p:spPr>
+          <a:xfrm>
+            <a:off x="502920" y="868680"/>
+            <a:ext cx="1828800" cy="27432"/>
+          </a:xfrm>
+          <a:prstGeom prst="rect">
+            <a:avLst/>
+          </a:prstGeom>
+          <a:solidFill>
+            <a:srgbClr val="CC9900"/>
+          </a:solidFill>
+          <a:ln>
+            <a:noFill/>
+          </a:ln>
+        </p:spPr>
+        <p:txBody>
+          <a:bodyPr wrap="square" lIns="91440" rIns="91440" tIns="45720" bIns="45720">
+            <a:normAutofit fontScale="85000" lnSpcReduction="20000"/>
+          </a:bodyPr>
+          <a:lstStyle/>
+          <a:p>
+            <a:pPr algn="l"/>
+            <a:r>
+              <a:rPr lang="en-US" sz="2400" b="0">
+                <a:solidFill>
+                  <a:srgbClr val="142030"/>
+                </a:solidFill>
+                <a:latin typeface="Aptos"/>
+              </a:rPr>
+              <a:t/>
+            </a:r>
+          </a:p>
+        </p:txBody>
+      </p:sp>
+      <p:sp>
+        <p:nvSpPr>
+          <p:cNvPr id="124" name="Text 124"/>
+          <p:cNvSpPr txBox="1"/>
+          <p:nvPr/>
+        </p:nvSpPr>
+        <p:spPr>
+          <a:xfrm>
+            <a:off x="2331720" y="868680"/>
+            <a:ext cx="6949440" cy="27432"/>
+          </a:xfrm>
+          <a:prstGeom prst="rect">
+            <a:avLst/>
+          </a:prstGeom>
+          <a:solidFill>
+            <a:srgbClr val="007E70"/>
+          </a:solidFill>
+          <a:ln>
+            <a:noFill/>
+          </a:ln>
+        </p:spPr>
+        <p:txBody>
+          <a:bodyPr wrap="square" lIns="91440" rIns="91440" tIns="45720" bIns="45720">
+            <a:normAutofit fontScale="85000" lnSpcReduction="20000"/>
+          </a:bodyPr>
+          <a:lstStyle/>
+          <a:p>
+            <a:pPr algn="l"/>
+            <a:r>
+              <a:rPr lang="en-US" sz="2400" b="0">
+                <a:solidFill>
+                  <a:srgbClr val="142030"/>
+                </a:solidFill>
+                <a:latin typeface="Aptos"/>
+              </a:rPr>
+              <a:t/>
+            </a:r>
+          </a:p>
+        </p:txBody>
+      </p:sp>
+      <p:sp>
+        <p:nvSpPr>
+          <p:cNvPr id="125" name="Text 125"/>
+          <p:cNvSpPr txBox="1"/>
+          <p:nvPr/>
+        </p:nvSpPr>
+        <p:spPr>
+          <a:xfrm>
+            <a:off x="658368" y="1234440"/>
+            <a:ext cx="4709160" cy="320040"/>
+          </a:xfrm>
+          <a:prstGeom prst="rect">
+            <a:avLst/>
+          </a:prstGeom>
+          <a:noFill/>
+          <a:ln>
+            <a:noFill/>
+          </a:ln>
+        </p:spPr>
+        <p:txBody>
+          <a:bodyPr wrap="square" lIns="91440" rIns="91440" tIns="45720" bIns="45720">
+            <a:normAutofit fontScale="85000" lnSpcReduction="20000"/>
+          </a:bodyPr>
+          <a:lstStyle/>
+          <a:p>
+            <a:pPr algn="l"/>
+            <a:r>
+              <a:rPr lang="en-US" sz="1500" b="1">
+                <a:solidFill>
+                  <a:srgbClr val="CC9900"/>
+                </a:solidFill>
+                <a:latin typeface="Aptos"/>
+              </a:rPr>
+              <a:t>Conclusion</a:t>
+            </a:r>
+          </a:p>
+        </p:txBody>
+      </p:sp>
+      <p:sp>
+        <p:nvSpPr>
+          <p:cNvPr id="126" name="Text 126"/>
+          <p:cNvSpPr txBox="1"/>
+          <p:nvPr/>
+        </p:nvSpPr>
+        <p:spPr>
+          <a:xfrm>
+            <a:off x="713232" y="1627632"/>
+            <a:ext cx="4800600" cy="2880360"/>
+          </a:xfrm>
+          <a:prstGeom prst="rect">
+            <a:avLst/>
+          </a:prstGeom>
+          <a:noFill/>
+          <a:ln>
+            <a:noFill/>
+          </a:ln>
+        </p:spPr>
+        <p:txBody>
+          <a:bodyPr wrap="square" lIns="91440" rIns="91440" tIns="45720" bIns="45720">
+            <a:normAutofit fontScale="85000" lnSpcReduction="20000"/>
+          </a:bodyPr>
+          <a:lstStyle/>
           <a:p>
             <a:pPr algn="l">
               <a:buChar char="•"/>
@@ -1840,7 +2045,7 @@
                 </a:solidFill>
                 <a:latin typeface="Aptos"/>
               </a:rPr>
-              <a:t>Extend the model using age, gender, or stochastic structure.</a:t>
+              <a:t>The SITA HIV model was extended using fractional memory.</a:t>
             </a:r>
           </a:p>
           <a:p>
@@ -1855,7 +2060,7 @@
                 </a:solidFill>
                 <a:latin typeface="Aptos"/>
               </a:rPr>
-              <a:t>Compare other fractional operators.</a:t>
+              <a:t>Behavioural interventions were represented through effective rates.</a:t>
             </a:r>
           </a:p>
           <a:p>
@@ -1870,6 +2075,130 @@
                 </a:solidFill>
                 <a:latin typeface="Aptos"/>
               </a:rPr>
+              <a:t>Numerical simulations support combined intervention strategies.</a:t>
+            </a:r>
+          </a:p>
+        </p:txBody>
+      </p:sp>
+      <p:sp>
+        <p:nvSpPr>
+          <p:cNvPr id="127" name="Text 127"/>
+          <p:cNvSpPr txBox="1"/>
+          <p:nvPr/>
+        </p:nvSpPr>
+        <p:spPr>
+          <a:xfrm>
+            <a:off x="6080760" y="1234440"/>
+            <a:ext cx="4663440" cy="320040"/>
+          </a:xfrm>
+          <a:prstGeom prst="rect">
+            <a:avLst/>
+          </a:prstGeom>
+          <a:noFill/>
+          <a:ln>
+            <a:noFill/>
+          </a:ln>
+        </p:spPr>
+        <p:txBody>
+          <a:bodyPr wrap="square" lIns="91440" rIns="91440" tIns="45720" bIns="45720">
+            <a:normAutofit fontScale="85000" lnSpcReduction="20000"/>
+          </a:bodyPr>
+          <a:lstStyle/>
+          <a:p>
+            <a:pPr algn="l"/>
+            <a:r>
+              <a:rPr lang="en-US" sz="1500" b="1">
+                <a:solidFill>
+                  <a:srgbClr val="CC9900"/>
+                </a:solidFill>
+                <a:latin typeface="Aptos"/>
+              </a:rPr>
+              <a:t>Recommendations</a:t>
+            </a:r>
+          </a:p>
+        </p:txBody>
+      </p:sp>
+      <p:sp>
+        <p:nvSpPr>
+          <p:cNvPr id="128" name="Text 128"/>
+          <p:cNvSpPr txBox="1"/>
+          <p:nvPr/>
+        </p:nvSpPr>
+        <p:spPr>
+          <a:xfrm>
+            <a:off x="6144768" y="1627632"/>
+            <a:ext cx="4800600" cy="2880360"/>
+          </a:xfrm>
+          <a:prstGeom prst="rect">
+            <a:avLst/>
+          </a:prstGeom>
+          <a:noFill/>
+          <a:ln>
+            <a:noFill/>
+          </a:ln>
+        </p:spPr>
+        <p:txBody>
+          <a:bodyPr wrap="square" lIns="91440" rIns="91440" tIns="45720" bIns="45720">
+            <a:normAutofit fontScale="85000" lnSpcReduction="20000"/>
+          </a:bodyPr>
+          <a:lstStyle/>
+          <a:p>
+            <a:pPr algn="l">
+              <a:buChar char="•"/>
+              <a:buFont typeface="Arial"/>
+            </a:pPr>
+            <a:r>
+              <a:rPr lang="en-US" sz="1800" b="0">
+                <a:solidFill>
+                  <a:srgbClr val="142030"/>
+                </a:solidFill>
+                <a:latin typeface="Aptos"/>
+              </a:rPr>
+              <a:t>Calibrate parameters with Rwanda-specific data.</a:t>
+            </a:r>
+          </a:p>
+          <a:p>
+            <a:pPr algn="l">
+              <a:buChar char="•"/>
+              <a:buFont typeface="Arial"/>
+            </a:pPr>
+            <a:r>
+              <a:rPr lang="en-US" sz="1800" b="0">
+                <a:solidFill>
+                  <a:srgbClr val="142030"/>
+                </a:solidFill>
+                <a:latin typeface="Aptos"/>
+              </a:rPr>
+              <a:t>Extend the model using age, gender, or stochastic structure.</a:t>
+            </a:r>
+          </a:p>
+          <a:p>
+            <a:pPr algn="l">
+              <a:buChar char="•"/>
+              <a:buFont typeface="Arial"/>
+            </a:pPr>
+            <a:r>
+              <a:rPr lang="en-US" sz="1800" b="0">
+                <a:solidFill>
+                  <a:srgbClr val="142030"/>
+                </a:solidFill>
+                <a:latin typeface="Aptos"/>
+              </a:rPr>
+              <a:t>Compare other fractional operators.</a:t>
+            </a:r>
+          </a:p>
+          <a:p>
+            <a:pPr algn="l">
+              <a:buChar char="•"/>
+              <a:buFont typeface="Arial"/>
+            </a:pPr>
+            <a:r>
+              <a:rPr lang="en-US" sz="1800" b="0">
+                <a:solidFill>
+                  <a:srgbClr val="142030"/>
+                </a:solidFill>
+                <a:latin typeface="Aptos"/>
+              </a:rPr>
               <a:t>Improve the dashboard into an educational decision-support tool.</a:t>
             </a:r>
           </a:p>
@@ -1877,7 +2206,7 @@
       </p:sp>
       <p:sp>
         <p:nvSpPr>
-          <p:cNvPr id="121" name="Text 121"/>
+          <p:cNvPr id="129" name="Text 129"/>
           <p:cNvSpPr txBox="1"/>
           <p:nvPr/>
         </p:nvSpPr>
@@ -2844,7 +3173,7 @@
                 </a:solidFill>
                 <a:latin typeface="Aptos"/>
               </a:rPr>
-              <a:t>Objectives</a:t>
+              <a:t>Literature Review and Research Gap</a:t>
             </a:r>
           </a:p>
         </p:txBody>
@@ -2937,8 +3266,8 @@
         </p:nvSpPr>
         <p:spPr>
           <a:xfrm>
-            <a:off x="685800" y="1207008"/>
-            <a:ext cx="5212080" cy="347472"/>
+            <a:off x="658368" y="1234440"/>
+            <a:ext cx="4709160" cy="320040"/>
           </a:xfrm>
           <a:prstGeom prst="rect">
             <a:avLst/>
@@ -2962,7 +3291,7 @@
                 </a:solidFill>
                 <a:latin typeface="Aptos"/>
               </a:rPr>
-              <a:t>Main objective</a:t>
+              <a:t>What existing studies show</a:t>
             </a:r>
           </a:p>
         </p:txBody>
@@ -2976,83 +3305,7 @@
         <p:spPr>
           <a:xfrm>
             <a:off x="713232" y="1627632"/>
-            <a:ext cx="5257800" cy="868680"/>
-          </a:xfrm>
-          <a:prstGeom prst="rect">
-            <a:avLst/>
-          </a:prstGeom>
-          <a:noFill/>
-          <a:ln>
-            <a:noFill/>
-          </a:ln>
-        </p:spPr>
-        <p:txBody>
-          <a:bodyPr wrap="square" lIns="91440" rIns="91440" tIns="45720" bIns="45720">
-            <a:normAutofit fontScale="85000" lnSpcReduction="20000"/>
-          </a:bodyPr>
-          <a:lstStyle/>
-          <a:p>
-            <a:pPr algn="l"/>
-            <a:r>
-              <a:rPr lang="en-US" sz="1700" b="0">
-                <a:solidFill>
-                  <a:srgbClr val="142030"/>
-                </a:solidFill>
-                <a:latin typeface="Aptos"/>
-              </a:rPr>
-              <a:t>To formulate, analyse, and computationally simulate a fractional-order SITA model of HIV transmission incorporating social behaviour interventions.</a:t>
-            </a:r>
-          </a:p>
-        </p:txBody>
-      </p:sp>
-      <p:sp>
-        <p:nvSpPr>
-          <p:cNvPr id="34" name="Text 34"/>
-          <p:cNvSpPr txBox="1"/>
-          <p:nvPr/>
-        </p:nvSpPr>
-        <p:spPr>
-          <a:xfrm>
-            <a:off x="685800" y="2788920"/>
-            <a:ext cx="5212080" cy="347472"/>
-          </a:xfrm>
-          <a:prstGeom prst="rect">
-            <a:avLst/>
-          </a:prstGeom>
-          <a:noFill/>
-          <a:ln>
-            <a:noFill/>
-          </a:ln>
-        </p:spPr>
-        <p:txBody>
-          <a:bodyPr wrap="square" lIns="91440" rIns="91440" tIns="45720" bIns="45720">
-            <a:normAutofit fontScale="85000" lnSpcReduction="20000"/>
-          </a:bodyPr>
-          <a:lstStyle/>
-          <a:p>
-            <a:pPr algn="l"/>
-            <a:r>
-              <a:rPr lang="en-US" sz="1500" b="1">
-                <a:solidFill>
-                  <a:srgbClr val="CC9900"/>
-                </a:solidFill>
-                <a:latin typeface="Aptos"/>
-              </a:rPr>
-              <a:t>Specific objectives</a:t>
-            </a:r>
-          </a:p>
-        </p:txBody>
-      </p:sp>
-      <p:sp>
-        <p:nvSpPr>
-          <p:cNvPr id="35" name="Text 35"/>
-          <p:cNvSpPr txBox="1"/>
-          <p:nvPr/>
-        </p:nvSpPr>
-        <p:spPr>
-          <a:xfrm>
-            <a:off x="768096" y="3182112"/>
-            <a:ext cx="5303520" cy="1965960"/>
+            <a:ext cx="4800600" cy="2880360"/>
           </a:xfrm>
           <a:prstGeom prst="rect">
             <a:avLst/>
@@ -3073,13 +3326,13 @@
               <a:buFont typeface="Arial"/>
             </a:pPr>
             <a:r>
-              <a:rPr lang="en-US" sz="1500" b="0">
-                <a:solidFill>
-                  <a:srgbClr val="142030"/>
-                </a:solidFill>
-                <a:latin typeface="Aptos"/>
-              </a:rPr>
-              <a:t>Formulate a fractional-order SITA HIV model using the Caputo derivative and social behaviour interventions.</a:t>
+              <a:rPr lang="en-US" sz="1800" b="0">
+                <a:solidFill>
+                  <a:srgbClr val="142030"/>
+                </a:solidFill>
+                <a:latin typeface="Aptos"/>
+              </a:rPr>
+              <a:t>Classical HIV models commonly use ordinary differential equations and treatment compartments such as SICA/SITA.</a:t>
             </a:r>
           </a:p>
           <a:p>
@@ -3088,13 +3341,13 @@
               <a:buFont typeface="Arial"/>
             </a:pPr>
             <a:r>
-              <a:rPr lang="en-US" sz="1500" b="0">
-                <a:solidFill>
-                  <a:srgbClr val="142030"/>
-                </a:solidFill>
-                <a:latin typeface="Aptos"/>
-              </a:rPr>
-              <a:t>Analyse positivity, boundedness, disease-free equilibrium, R0, and fractional stability.</a:t>
+              <a:rPr lang="en-US" sz="1800" b="0">
+                <a:solidFill>
+                  <a:srgbClr val="142030"/>
+                </a:solidFill>
+                <a:latin typeface="Aptos"/>
+              </a:rPr>
+              <a:t>Previous studies show that social behaviour, testing, safer sexual practices, stigma, and adherence influence HIV transmission.</a:t>
             </a:r>
           </a:p>
           <a:p>
@@ -3103,13 +3356,107 @@
               <a:buFont typeface="Arial"/>
             </a:pPr>
             <a:r>
-              <a:rPr lang="en-US" sz="1500" b="0">
-                <a:solidFill>
-                  <a:srgbClr val="142030"/>
-                </a:solidFill>
-                <a:latin typeface="Aptos"/>
-              </a:rPr>
-              <a:t>Implement simulations and a Python dashboard to study memory effects, interventions, sensitivity, and epidemic trajectories.</a:t>
+              <a:rPr lang="en-US" sz="1800" b="0">
+                <a:solidFill>
+                  <a:srgbClr val="142030"/>
+                </a:solidFill>
+                <a:latin typeface="Aptos"/>
+              </a:rPr>
+              <a:t>Fractional-order epidemic models use Caputo derivatives to capture memory and hereditary effects.</a:t>
+            </a:r>
+          </a:p>
+        </p:txBody>
+      </p:sp>
+      <p:sp>
+        <p:nvSpPr>
+          <p:cNvPr id="34" name="Text 34"/>
+          <p:cNvSpPr txBox="1"/>
+          <p:nvPr/>
+        </p:nvSpPr>
+        <p:spPr>
+          <a:xfrm>
+            <a:off x="6080760" y="1234440"/>
+            <a:ext cx="4663440" cy="320040"/>
+          </a:xfrm>
+          <a:prstGeom prst="rect">
+            <a:avLst/>
+          </a:prstGeom>
+          <a:noFill/>
+          <a:ln>
+            <a:noFill/>
+          </a:ln>
+        </p:spPr>
+        <p:txBody>
+          <a:bodyPr wrap="square" lIns="91440" rIns="91440" tIns="45720" bIns="45720">
+            <a:normAutofit fontScale="85000" lnSpcReduction="20000"/>
+          </a:bodyPr>
+          <a:lstStyle/>
+          <a:p>
+            <a:pPr algn="l"/>
+            <a:r>
+              <a:rPr lang="en-US" sz="1500" b="1">
+                <a:solidFill>
+                  <a:srgbClr val="CC9900"/>
+                </a:solidFill>
+                <a:latin typeface="Aptos"/>
+              </a:rPr>
+              <a:t>Research gap</a:t>
+            </a:r>
+          </a:p>
+        </p:txBody>
+      </p:sp>
+      <p:sp>
+        <p:nvSpPr>
+          <p:cNvPr id="35" name="Text 35"/>
+          <p:cNvSpPr txBox="1"/>
+          <p:nvPr/>
+        </p:nvSpPr>
+        <p:spPr>
+          <a:xfrm>
+            <a:off x="6144768" y="1627632"/>
+            <a:ext cx="4800600" cy="2880360"/>
+          </a:xfrm>
+          <a:prstGeom prst="rect">
+            <a:avLst/>
+          </a:prstGeom>
+          <a:noFill/>
+          <a:ln>
+            <a:noFill/>
+          </a:ln>
+        </p:spPr>
+        <p:txBody>
+          <a:bodyPr wrap="square" lIns="91440" rIns="91440" tIns="45720" bIns="45720">
+            <a:normAutofit fontScale="85000" lnSpcReduction="20000"/>
+          </a:bodyPr>
+          <a:lstStyle/>
+          <a:p>
+            <a:pPr algn="l">
+              <a:buChar char="•"/>
+              <a:buFont typeface="Arial"/>
+            </a:pPr>
+            <a:r>
+              <a:rPr lang="en-US" sz="1800" b="0">
+                <a:solidFill>
+                  <a:srgbClr val="142030"/>
+                </a:solidFill>
+                <a:latin typeface="Aptos"/>
+              </a:rPr>
+              <a:t>Existing work does not commonly combine fractional HIV dynamics.</a:t>
+            </a:r>
+          </a:p>
+          <a:p>
+            <a:pPr algn="l">
+              <a:buChar char="•"/>
+              <a:buFont typeface="Arial"/>
+            </a:pPr>
+            <a:r>
+              <a:rPr lang="en-US" sz="1800" b="0">
+                <a:solidFill>
+                  <a:srgbClr val="142030"/>
+                </a:solidFill>
+                <a:latin typeface="Aptos"/>
+              </a:rPr>
+              <a:t>It also does not commonly combine social behaviour intervention functions with an interactive simulation dashboard.</a:t>
             </a:r>
           </a:p>
         </p:txBody>
@@ -3122,50 +3469,8 @@
         </p:nvSpPr>
         <p:spPr>
           <a:xfrm>
-            <a:off x="6629400" y="1508760"/>
-            <a:ext cx="3474720" cy="594360"/>
-          </a:xfrm>
-          <a:prstGeom prst="rect">
-            <a:avLst/>
-          </a:prstGeom>
-          <a:solidFill>
-            <a:srgbClr val="E8F2FA"/>
-          </a:solidFill>
-          <a:ln w="9525">
-            <a:solidFill>
-              <a:srgbClr val="004A80"/>
-            </a:solidFill>
-          </a:ln>
-        </p:spPr>
-        <p:txBody>
-          <a:bodyPr wrap="square" lIns="91440" rIns="91440" tIns="45720" bIns="45720">
-            <a:normAutofit fontScale="85000" lnSpcReduction="20000"/>
-          </a:bodyPr>
-          <a:lstStyle/>
-          <a:p>
-            <a:pPr algn="c"/>
-            <a:r>
-              <a:rPr lang="en-US" sz="1600" b="1">
-                <a:solidFill>
-                  <a:srgbClr val="142030"/>
-                </a:solidFill>
-                <a:latin typeface="Aptos"/>
-              </a:rPr>
-              <a:t>1. Model formulation</a:t>
-            </a:r>
-          </a:p>
-        </p:txBody>
-      </p:sp>
-      <p:sp>
-        <p:nvSpPr>
-          <p:cNvPr id="37" name="Text 37"/>
-          <p:cNvSpPr txBox="1"/>
-          <p:nvPr/>
-        </p:nvSpPr>
-        <p:spPr>
-          <a:xfrm>
-            <a:off x="6629400" y="2514600"/>
-            <a:ext cx="3474720" cy="594360"/>
+            <a:off x="868680" y="5349240"/>
+            <a:ext cx="10195560" cy="640080"/>
           </a:xfrm>
           <a:prstGeom prst="rect">
             <a:avLst/>
@@ -3185,133 +3490,19 @@
           </a:bodyPr>
           <a:lstStyle/>
           <a:p>
-            <a:pPr algn="c"/>
-            <a:r>
-              <a:rPr lang="en-US" sz="1600" b="1">
-                <a:solidFill>
-                  <a:srgbClr val="142030"/>
-                </a:solidFill>
-                <a:latin typeface="Aptos"/>
-              </a:rPr>
-              <a:t>2. Model analysis</a:t>
-            </a:r>
-          </a:p>
-        </p:txBody>
-      </p:sp>
-      <p:sp>
-        <p:nvSpPr>
-          <p:cNvPr id="38" name="Text 38"/>
-          <p:cNvSpPr txBox="1"/>
-          <p:nvPr/>
-        </p:nvSpPr>
-        <p:spPr>
-          <a:xfrm>
-            <a:off x="6629400" y="3520440"/>
-            <a:ext cx="3474720" cy="594360"/>
-          </a:xfrm>
-          <a:prstGeom prst="rect">
-            <a:avLst/>
-          </a:prstGeom>
-          <a:solidFill>
-            <a:srgbClr val="FFF7E0"/>
-          </a:solidFill>
-          <a:ln w="9525">
-            <a:solidFill>
-              <a:srgbClr val="CC9900"/>
-            </a:solidFill>
-          </a:ln>
-        </p:spPr>
-        <p:txBody>
-          <a:bodyPr wrap="square" lIns="91440" rIns="91440" tIns="45720" bIns="45720">
-            <a:normAutofit fontScale="85000" lnSpcReduction="20000"/>
-          </a:bodyPr>
-          <a:lstStyle/>
-          <a:p>
-            <a:pPr algn="c"/>
-            <a:r>
-              <a:rPr lang="en-US" sz="1600" b="1">
-                <a:solidFill>
-                  <a:srgbClr val="142030"/>
-                </a:solidFill>
-                <a:latin typeface="Aptos"/>
-              </a:rPr>
-              <a:t>3. Simulation dashboard</a:t>
-            </a:r>
-          </a:p>
-        </p:txBody>
-      </p:sp>
-      <p:cxnSp>
-        <p:nvCxnSpPr>
-          <p:cNvPr id="39" name="Arrow 39"/>
-          <p:cNvCxnSpPr/>
-          <p:nvPr/>
-        </p:nvCxnSpPr>
-        <p:spPr>
-          <a:xfrm>
-            <a:off x="8366760" y="2103120"/>
-            <a:ext cx="0" cy="411480"/>
-          </a:xfrm>
-          <a:prstGeom prst="line">
-            <a:avLst/>
-          </a:prstGeom>
-          <a:ln w="19050">
-            <a:solidFill>
-              <a:srgbClr val="52606C"/>
-            </a:solidFill>
-            <a:tailEnd type="triangle"/>
-          </a:ln>
-        </p:spPr>
-        <p:style>
-          <a:lnRef idx="1">
-            <a:schemeClr val="accent1"/>
-          </a:lnRef>
-          <a:fillRef idx="0">
-            <a:schemeClr val="accent1"/>
-          </a:fillRef>
-          <a:effectRef idx="0">
-            <a:schemeClr val="accent1"/>
-          </a:effectRef>
-          <a:fontRef idx="minor">
-            <a:schemeClr val="tx1"/>
-          </a:fontRef>
-        </p:style>
-      </p:cxnSp>
-      <p:cxnSp>
-        <p:nvCxnSpPr>
-          <p:cNvPr id="40" name="Arrow 40"/>
-          <p:cNvCxnSpPr/>
-          <p:nvPr/>
-        </p:nvCxnSpPr>
-        <p:spPr>
-          <a:xfrm>
-            <a:off x="8366760" y="3108960"/>
-            <a:ext cx="0" cy="411480"/>
-          </a:xfrm>
-          <a:prstGeom prst="line">
-            <a:avLst/>
-          </a:prstGeom>
-          <a:ln w="19050">
-            <a:solidFill>
-              <a:srgbClr val="52606C"/>
-            </a:solidFill>
-            <a:tailEnd type="triangle"/>
-          </a:ln>
-        </p:spPr>
-        <p:style>
-          <a:lnRef idx="1">
-            <a:schemeClr val="accent1"/>
-          </a:lnRef>
-          <a:fillRef idx="0">
-            <a:schemeClr val="accent1"/>
-          </a:fillRef>
-          <a:effectRef idx="0">
-            <a:schemeClr val="accent1"/>
-          </a:effectRef>
-          <a:fontRef idx="minor">
-            <a:schemeClr val="tx1"/>
-          </a:fontRef>
-        </p:style>
-      </p:cxnSp>
+            <a:pPr algn="l"/>
+            <a:r>
+              <a:rPr lang="en-US" sz="1700" b="0">
+                <a:solidFill>
+                  <a:srgbClr val="142030"/>
+                </a:solidFill>
+                <a:latin typeface="Aptos"/>
+              </a:rPr>
+              <a:t>Gap addressed: a fractional-order SITA model that connects memory effects, social behaviour interventions, numerical simulation, and dashboard exploration.</a:t>
+            </a:r>
+          </a:p>
+        </p:txBody>
+      </p:sp>
     </p:spTree>
   </p:cSld>
   <p:clrMapOvr>
@@ -3339,7 +3530,7 @@
       </p:grpSpPr>
       <p:sp>
         <p:nvSpPr>
-          <p:cNvPr id="41" name="Text 41"/>
+          <p:cNvPr id="37" name="Text 37"/>
           <p:cNvSpPr txBox="1"/>
           <p:nvPr/>
         </p:nvSpPr>
@@ -3370,14 +3561,14 @@
                 </a:solidFill>
                 <a:latin typeface="Aptos"/>
               </a:rPr>
-              <a:t>Model Diagram: SITA</a:t>
-            </a:r>
-          </a:p>
-        </p:txBody>
-      </p:sp>
-      <p:sp>
-        <p:nvSpPr>
-          <p:cNvPr id="42" name="Text 42"/>
+              <a:t>Objectives</a:t>
+            </a:r>
+          </a:p>
+        </p:txBody>
+      </p:sp>
+      <p:sp>
+        <p:nvSpPr>
+          <p:cNvPr id="38" name="Text 38"/>
           <p:cNvSpPr txBox="1"/>
           <p:nvPr/>
         </p:nvSpPr>
@@ -3417,7 +3608,7 @@
       </p:sp>
       <p:sp>
         <p:nvSpPr>
-          <p:cNvPr id="43" name="Text 43"/>
+          <p:cNvPr id="39" name="Text 39"/>
           <p:cNvSpPr txBox="1"/>
           <p:nvPr/>
         </p:nvSpPr>
@@ -3457,237 +3648,332 @@
       </p:sp>
       <p:sp>
         <p:nvSpPr>
-          <p:cNvPr id="44" name="S(t)"/>
-          <p:cNvSpPr/>
-          <p:nvPr/>
-        </p:nvSpPr>
-        <p:spPr>
-          <a:xfrm>
-            <a:off x="749808" y="1856231"/>
-            <a:ext cx="1691640" cy="713232"/>
-          </a:xfrm>
-          <a:prstGeom prst="roundRect">
+          <p:cNvPr id="40" name="Text 40"/>
+          <p:cNvSpPr txBox="1"/>
+          <p:nvPr/>
+        </p:nvSpPr>
+        <p:spPr>
+          <a:xfrm>
+            <a:off x="685800" y="1207008"/>
+            <a:ext cx="5212080" cy="347472"/>
+          </a:xfrm>
+          <a:prstGeom prst="rect">
+            <a:avLst/>
+          </a:prstGeom>
+          <a:noFill/>
+          <a:ln>
+            <a:noFill/>
+          </a:ln>
+        </p:spPr>
+        <p:txBody>
+          <a:bodyPr wrap="square" lIns="91440" rIns="91440" tIns="45720" bIns="45720">
+            <a:normAutofit fontScale="85000" lnSpcReduction="20000"/>
+          </a:bodyPr>
+          <a:lstStyle/>
+          <a:p>
+            <a:pPr algn="l"/>
+            <a:r>
+              <a:rPr lang="en-US" sz="1500" b="1">
+                <a:solidFill>
+                  <a:srgbClr val="CC9900"/>
+                </a:solidFill>
+                <a:latin typeface="Aptos"/>
+              </a:rPr>
+              <a:t>Main objective</a:t>
+            </a:r>
+          </a:p>
+        </p:txBody>
+      </p:sp>
+      <p:sp>
+        <p:nvSpPr>
+          <p:cNvPr id="41" name="Text 41"/>
+          <p:cNvSpPr txBox="1"/>
+          <p:nvPr/>
+        </p:nvSpPr>
+        <p:spPr>
+          <a:xfrm>
+            <a:off x="713232" y="1627632"/>
+            <a:ext cx="5257800" cy="868680"/>
+          </a:xfrm>
+          <a:prstGeom prst="rect">
+            <a:avLst/>
+          </a:prstGeom>
+          <a:noFill/>
+          <a:ln>
+            <a:noFill/>
+          </a:ln>
+        </p:spPr>
+        <p:txBody>
+          <a:bodyPr wrap="square" lIns="91440" rIns="91440" tIns="45720" bIns="45720">
+            <a:normAutofit fontScale="85000" lnSpcReduction="20000"/>
+          </a:bodyPr>
+          <a:lstStyle/>
+          <a:p>
+            <a:pPr algn="l"/>
+            <a:r>
+              <a:rPr lang="en-US" sz="1700" b="0">
+                <a:solidFill>
+                  <a:srgbClr val="142030"/>
+                </a:solidFill>
+                <a:latin typeface="Aptos"/>
+              </a:rPr>
+              <a:t>To formulate, analyse, and computationally simulate a fractional-order SITA model of HIV transmission incorporating social behaviour interventions.</a:t>
+            </a:r>
+          </a:p>
+        </p:txBody>
+      </p:sp>
+      <p:sp>
+        <p:nvSpPr>
+          <p:cNvPr id="42" name="Text 42"/>
+          <p:cNvSpPr txBox="1"/>
+          <p:nvPr/>
+        </p:nvSpPr>
+        <p:spPr>
+          <a:xfrm>
+            <a:off x="685800" y="2788920"/>
+            <a:ext cx="5212080" cy="347472"/>
+          </a:xfrm>
+          <a:prstGeom prst="rect">
+            <a:avLst/>
+          </a:prstGeom>
+          <a:noFill/>
+          <a:ln>
+            <a:noFill/>
+          </a:ln>
+        </p:spPr>
+        <p:txBody>
+          <a:bodyPr wrap="square" lIns="91440" rIns="91440" tIns="45720" bIns="45720">
+            <a:normAutofit fontScale="85000" lnSpcReduction="20000"/>
+          </a:bodyPr>
+          <a:lstStyle/>
+          <a:p>
+            <a:pPr algn="l"/>
+            <a:r>
+              <a:rPr lang="en-US" sz="1500" b="1">
+                <a:solidFill>
+                  <a:srgbClr val="CC9900"/>
+                </a:solidFill>
+                <a:latin typeface="Aptos"/>
+              </a:rPr>
+              <a:t>Specific objectives</a:t>
+            </a:r>
+          </a:p>
+        </p:txBody>
+      </p:sp>
+      <p:sp>
+        <p:nvSpPr>
+          <p:cNvPr id="43" name="Text 43"/>
+          <p:cNvSpPr txBox="1"/>
+          <p:nvPr/>
+        </p:nvSpPr>
+        <p:spPr>
+          <a:xfrm>
+            <a:off x="768096" y="3182112"/>
+            <a:ext cx="5303520" cy="1965960"/>
+          </a:xfrm>
+          <a:prstGeom prst="rect">
+            <a:avLst/>
+          </a:prstGeom>
+          <a:noFill/>
+          <a:ln>
+            <a:noFill/>
+          </a:ln>
+        </p:spPr>
+        <p:txBody>
+          <a:bodyPr wrap="square" lIns="91440" rIns="91440" tIns="45720" bIns="45720">
+            <a:normAutofit fontScale="85000" lnSpcReduction="20000"/>
+          </a:bodyPr>
+          <a:lstStyle/>
+          <a:p>
+            <a:pPr algn="l">
+              <a:buChar char="•"/>
+              <a:buFont typeface="Arial"/>
+            </a:pPr>
+            <a:r>
+              <a:rPr lang="en-US" sz="1500" b="0">
+                <a:solidFill>
+                  <a:srgbClr val="142030"/>
+                </a:solidFill>
+                <a:latin typeface="Aptos"/>
+              </a:rPr>
+              <a:t>Formulate a fractional-order SITA HIV model using the Caputo derivative and social behaviour interventions.</a:t>
+            </a:r>
+          </a:p>
+          <a:p>
+            <a:pPr algn="l">
+              <a:buChar char="•"/>
+              <a:buFont typeface="Arial"/>
+            </a:pPr>
+            <a:r>
+              <a:rPr lang="en-US" sz="1500" b="0">
+                <a:solidFill>
+                  <a:srgbClr val="142030"/>
+                </a:solidFill>
+                <a:latin typeface="Aptos"/>
+              </a:rPr>
+              <a:t>Analyse positivity, boundedness, disease-free equilibrium, R0, and fractional stability.</a:t>
+            </a:r>
+          </a:p>
+          <a:p>
+            <a:pPr algn="l">
+              <a:buChar char="•"/>
+              <a:buFont typeface="Arial"/>
+            </a:pPr>
+            <a:r>
+              <a:rPr lang="en-US" sz="1500" b="0">
+                <a:solidFill>
+                  <a:srgbClr val="142030"/>
+                </a:solidFill>
+                <a:latin typeface="Aptos"/>
+              </a:rPr>
+              <a:t>Implement simulations and a Python dashboard to study memory effects, interventions, sensitivity, and epidemic trajectories.</a:t>
+            </a:r>
+          </a:p>
+        </p:txBody>
+      </p:sp>
+      <p:sp>
+        <p:nvSpPr>
+          <p:cNvPr id="44" name="Text 44"/>
+          <p:cNvSpPr txBox="1"/>
+          <p:nvPr/>
+        </p:nvSpPr>
+        <p:spPr>
+          <a:xfrm>
+            <a:off x="6629400" y="1508760"/>
+            <a:ext cx="3474720" cy="594360"/>
+          </a:xfrm>
+          <a:prstGeom prst="rect">
             <a:avLst/>
           </a:prstGeom>
           <a:solidFill>
             <a:srgbClr val="E8F2FA"/>
           </a:solidFill>
-          <a:ln w="12700">
+          <a:ln w="9525">
             <a:solidFill>
               <a:srgbClr val="004A80"/>
             </a:solidFill>
           </a:ln>
         </p:spPr>
         <p:txBody>
-          <a:bodyPr wrap="square" anchor="mid" lIns="91440" rIns="91440" tIns="45720" bIns="45720">
-            <a:normAutofit fontScale="85000" lnSpcReduction="15000"/>
-          </a:bodyPr>
-          <a:lstStyle/>
-          <a:p>
-            <a:pPr algn="ctr"/>
-            <a:r>
-              <a:rPr lang="en-US" sz="2000" b="1">
-                <a:solidFill>
-                  <a:srgbClr val="004A80"/>
-                </a:solidFill>
-                <a:latin typeface="Aptos Display"/>
-              </a:rPr>
-              <a:t>S(t)</a:t>
-            </a:r>
-          </a:p>
-          <a:p>
-            <a:pPr algn="ctr"/>
-            <a:r>
-              <a:rPr lang="en-US" sz="1500" b="1">
-                <a:solidFill>
-                  <a:srgbClr val="004A80"/>
-                </a:solidFill>
-                <a:latin typeface="Aptos"/>
-              </a:rPr>
-              <a:t>Susceptible</a:t>
-            </a:r>
-          </a:p>
-        </p:txBody>
-      </p:sp>
-      <p:sp>
-        <p:nvSpPr>
-          <p:cNvPr id="45" name="I(t)"/>
-          <p:cNvSpPr/>
-          <p:nvPr/>
-        </p:nvSpPr>
-        <p:spPr>
-          <a:xfrm>
-            <a:off x="3246120" y="1856231"/>
-            <a:ext cx="1691640" cy="713232"/>
-          </a:xfrm>
-          <a:prstGeom prst="roundRect">
+          <a:bodyPr wrap="square" lIns="91440" rIns="91440" tIns="45720" bIns="45720">
+            <a:normAutofit fontScale="85000" lnSpcReduction="20000"/>
+          </a:bodyPr>
+          <a:lstStyle/>
+          <a:p>
+            <a:pPr algn="c"/>
+            <a:r>
+              <a:rPr lang="en-US" sz="1600" b="1">
+                <a:solidFill>
+                  <a:srgbClr val="142030"/>
+                </a:solidFill>
+                <a:latin typeface="Aptos"/>
+              </a:rPr>
+              <a:t>1. Model formulation</a:t>
+            </a:r>
+          </a:p>
+        </p:txBody>
+      </p:sp>
+      <p:sp>
+        <p:nvSpPr>
+          <p:cNvPr id="45" name="Text 45"/>
+          <p:cNvSpPr txBox="1"/>
+          <p:nvPr/>
+        </p:nvSpPr>
+        <p:spPr>
+          <a:xfrm>
+            <a:off x="6629400" y="2514600"/>
+            <a:ext cx="3474720" cy="594360"/>
+          </a:xfrm>
+          <a:prstGeom prst="rect">
             <a:avLst/>
           </a:prstGeom>
           <a:solidFill>
-            <a:srgbClr val="FFFFFF"/>
+            <a:srgbClr val="E6F7F4"/>
           </a:solidFill>
-          <a:ln w="12700">
+          <a:ln w="9525">
             <a:solidFill>
-              <a:srgbClr val="B44146"/>
+              <a:srgbClr val="007E70"/>
             </a:solidFill>
           </a:ln>
         </p:spPr>
         <p:txBody>
-          <a:bodyPr wrap="square" anchor="mid" lIns="91440" rIns="91440" tIns="45720" bIns="45720">
-            <a:normAutofit fontScale="85000" lnSpcReduction="15000"/>
-          </a:bodyPr>
-          <a:lstStyle/>
-          <a:p>
-            <a:pPr algn="ctr"/>
-            <a:r>
-              <a:rPr lang="en-US" sz="2000" b="1">
-                <a:solidFill>
-                  <a:srgbClr val="B44146"/>
-                </a:solidFill>
-                <a:latin typeface="Aptos Display"/>
-              </a:rPr>
-              <a:t>I(t)</a:t>
-            </a:r>
-          </a:p>
-          <a:p>
-            <a:pPr algn="ctr"/>
-            <a:r>
-              <a:rPr lang="en-US" sz="1500" b="1">
-                <a:solidFill>
-                  <a:srgbClr val="B44146"/>
-                </a:solidFill>
-                <a:latin typeface="Aptos"/>
-              </a:rPr>
-              <a:t>Infected</a:t>
-            </a:r>
-          </a:p>
-        </p:txBody>
-      </p:sp>
-      <p:sp>
-        <p:nvSpPr>
-          <p:cNvPr id="46" name="T(t)"/>
-          <p:cNvSpPr/>
-          <p:nvPr/>
-        </p:nvSpPr>
-        <p:spPr>
-          <a:xfrm>
-            <a:off x="5742432" y="1856231"/>
-            <a:ext cx="1691640" cy="713232"/>
-          </a:xfrm>
-          <a:prstGeom prst="roundRect">
+          <a:bodyPr wrap="square" lIns="91440" rIns="91440" tIns="45720" bIns="45720">
+            <a:normAutofit fontScale="85000" lnSpcReduction="20000"/>
+          </a:bodyPr>
+          <a:lstStyle/>
+          <a:p>
+            <a:pPr algn="c"/>
+            <a:r>
+              <a:rPr lang="en-US" sz="1600" b="1">
+                <a:solidFill>
+                  <a:srgbClr val="142030"/>
+                </a:solidFill>
+                <a:latin typeface="Aptos"/>
+              </a:rPr>
+              <a:t>2. Model analysis</a:t>
+            </a:r>
+          </a:p>
+        </p:txBody>
+      </p:sp>
+      <p:sp>
+        <p:nvSpPr>
+          <p:cNvPr id="46" name="Text 46"/>
+          <p:cNvSpPr txBox="1"/>
+          <p:nvPr/>
+        </p:nvSpPr>
+        <p:spPr>
+          <a:xfrm>
+            <a:off x="6629400" y="3520440"/>
+            <a:ext cx="3474720" cy="594360"/>
+          </a:xfrm>
+          <a:prstGeom prst="rect">
             <a:avLst/>
           </a:prstGeom>
           <a:solidFill>
             <a:srgbClr val="FFF7E0"/>
           </a:solidFill>
-          <a:ln w="12700">
+          <a:ln w="9525">
             <a:solidFill>
               <a:srgbClr val="CC9900"/>
             </a:solidFill>
           </a:ln>
         </p:spPr>
         <p:txBody>
-          <a:bodyPr wrap="square" anchor="mid" lIns="91440" rIns="91440" tIns="45720" bIns="45720">
-            <a:normAutofit fontScale="85000" lnSpcReduction="15000"/>
-          </a:bodyPr>
-          <a:lstStyle/>
-          <a:p>
-            <a:pPr algn="ctr"/>
-            <a:r>
-              <a:rPr lang="en-US" sz="2000" b="1">
-                <a:solidFill>
-                  <a:srgbClr val="CC9900"/>
-                </a:solidFill>
-                <a:latin typeface="Aptos Display"/>
-              </a:rPr>
-              <a:t>T(t)</a:t>
-            </a:r>
-          </a:p>
-          <a:p>
-            <a:pPr algn="ctr"/>
-            <a:r>
-              <a:rPr lang="en-US" sz="1500" b="1">
-                <a:solidFill>
-                  <a:srgbClr val="CC9900"/>
-                </a:solidFill>
-                <a:latin typeface="Aptos"/>
-              </a:rPr>
-              <a:t>Treated</a:t>
-            </a:r>
-          </a:p>
-        </p:txBody>
-      </p:sp>
-      <p:sp>
-        <p:nvSpPr>
-          <p:cNvPr id="47" name="A(t)"/>
-          <p:cNvSpPr/>
-          <p:nvPr/>
-        </p:nvSpPr>
-        <p:spPr>
-          <a:xfrm>
-            <a:off x="8247888" y="1856231"/>
-            <a:ext cx="1691640" cy="713232"/>
-          </a:xfrm>
-          <a:prstGeom prst="roundRect">
-            <a:avLst/>
-          </a:prstGeom>
-          <a:solidFill>
-            <a:srgbClr val="E6F7F4"/>
-          </a:solidFill>
-          <a:ln w="12700">
-            <a:solidFill>
-              <a:srgbClr val="007E70"/>
-            </a:solidFill>
-          </a:ln>
-        </p:spPr>
-        <p:txBody>
-          <a:bodyPr wrap="square" anchor="mid" lIns="91440" rIns="91440" tIns="45720" bIns="45720">
-            <a:normAutofit fontScale="85000" lnSpcReduction="15000"/>
-          </a:bodyPr>
-          <a:lstStyle/>
-          <a:p>
-            <a:pPr algn="ctr"/>
-            <a:r>
-              <a:rPr lang="en-US" sz="2000" b="1">
-                <a:solidFill>
-                  <a:srgbClr val="007E70"/>
-                </a:solidFill>
-                <a:latin typeface="Aptos Display"/>
-              </a:rPr>
-              <a:t>A(t)</a:t>
-            </a:r>
-          </a:p>
-          <a:p>
-            <a:pPr algn="ctr"/>
-            <a:r>
-              <a:rPr lang="en-US" sz="1500" b="1">
-                <a:solidFill>
-                  <a:srgbClr val="007E70"/>
-                </a:solidFill>
-                <a:latin typeface="Aptos"/>
-              </a:rPr>
-              <a:t>AIDS stage</a:t>
+          <a:bodyPr wrap="square" lIns="91440" rIns="91440" tIns="45720" bIns="45720">
+            <a:normAutofit fontScale="85000" lnSpcReduction="20000"/>
+          </a:bodyPr>
+          <a:lstStyle/>
+          <a:p>
+            <a:pPr algn="c"/>
+            <a:r>
+              <a:rPr lang="en-US" sz="1600" b="1">
+                <a:solidFill>
+                  <a:srgbClr val="142030"/>
+                </a:solidFill>
+                <a:latin typeface="Aptos"/>
+              </a:rPr>
+              <a:t>3. Simulation dashboard</a:t>
             </a:r>
           </a:p>
         </p:txBody>
       </p:sp>
       <p:cxnSp>
         <p:nvCxnSpPr>
-          <p:cNvPr id="48" name="Arrow 48"/>
+          <p:cNvPr id="47" name="Arrow 47"/>
           <p:cNvCxnSpPr/>
           <p:nvPr/>
         </p:nvCxnSpPr>
         <p:spPr>
           <a:xfrm>
-            <a:off x="2441448" y="2212848"/>
-            <a:ext cx="804671" cy="0"/>
+            <a:off x="8366760" y="2103120"/>
+            <a:ext cx="0" cy="411480"/>
           </a:xfrm>
           <a:prstGeom prst="line">
             <a:avLst/>
           </a:prstGeom>
           <a:ln w="19050">
             <a:solidFill>
-              <a:srgbClr val="142030"/>
+              <a:srgbClr val="52606C"/>
             </a:solidFill>
             <a:tailEnd type="triangle"/>
           </a:ln>
@@ -3709,21 +3995,21 @@
       </p:cxnSp>
       <p:cxnSp>
         <p:nvCxnSpPr>
-          <p:cNvPr id="49" name="Arrow 49"/>
+          <p:cNvPr id="48" name="Arrow 48"/>
           <p:cNvCxnSpPr/>
           <p:nvPr/>
         </p:nvCxnSpPr>
         <p:spPr>
           <a:xfrm>
-            <a:off x="4937760" y="2212848"/>
-            <a:ext cx="804671" cy="0"/>
+            <a:off x="8366760" y="3108960"/>
+            <a:ext cx="0" cy="411480"/>
           </a:xfrm>
           <a:prstGeom prst="line">
             <a:avLst/>
           </a:prstGeom>
           <a:ln w="19050">
             <a:solidFill>
-              <a:srgbClr val="142030"/>
+              <a:srgbClr val="52606C"/>
             </a:solidFill>
             <a:tailEnd type="triangle"/>
           </a:ln>
@@ -3743,264 +4029,6 @@
           </a:fontRef>
         </p:style>
       </p:cxnSp>
-      <p:cxnSp>
-        <p:nvCxnSpPr>
-          <p:cNvPr id="50" name="Arrow 50"/>
-          <p:cNvCxnSpPr/>
-          <p:nvPr/>
-        </p:nvCxnSpPr>
-        <p:spPr>
-          <a:xfrm>
-            <a:off x="7434072" y="2212848"/>
-            <a:ext cx="813815" cy="0"/>
-          </a:xfrm>
-          <a:prstGeom prst="line">
-            <a:avLst/>
-          </a:prstGeom>
-          <a:ln w="19050">
-            <a:solidFill>
-              <a:srgbClr val="142030"/>
-            </a:solidFill>
-            <a:tailEnd type="triangle"/>
-          </a:ln>
-        </p:spPr>
-        <p:style>
-          <a:lnRef idx="1">
-            <a:schemeClr val="accent1"/>
-          </a:lnRef>
-          <a:fillRef idx="0">
-            <a:schemeClr val="accent1"/>
-          </a:fillRef>
-          <a:effectRef idx="0">
-            <a:schemeClr val="accent1"/>
-          </a:effectRef>
-          <a:fontRef idx="minor">
-            <a:schemeClr val="tx1"/>
-          </a:fontRef>
-        </p:style>
-      </p:cxnSp>
-      <p:sp>
-        <p:nvSpPr>
-          <p:cNvPr id="51" name="Text 51"/>
-          <p:cNvSpPr txBox="1"/>
-          <p:nvPr/>
-        </p:nvSpPr>
-        <p:spPr>
-          <a:xfrm>
-            <a:off x="2267712" y="1353312"/>
-            <a:ext cx="1143000" cy="320040"/>
-          </a:xfrm>
-          <a:prstGeom prst="rect">
-            <a:avLst/>
-          </a:prstGeom>
-          <a:noFill/>
-          <a:ln>
-            <a:noFill/>
-          </a:ln>
-        </p:spPr>
-        <p:txBody>
-          <a:bodyPr wrap="square" lIns="91440" rIns="91440" tIns="45720" bIns="45720">
-            <a:normAutofit fontScale="85000" lnSpcReduction="20000"/>
-          </a:bodyPr>
-          <a:lstStyle/>
-          <a:p>
-            <a:pPr algn="c"/>
-            <a:r>
-              <a:rPr lang="en-US" sz="1000" b="0">
-                <a:solidFill>
-                  <a:srgbClr val="52606C"/>
-                </a:solidFill>
-                <a:latin typeface="Aptos"/>
-              </a:rPr>
-              <a:t>effective transmission</a:t>
-            </a:r>
-          </a:p>
-        </p:txBody>
-      </p:sp>
-      <p:sp>
-        <p:nvSpPr>
-          <p:cNvPr id="52" name="Text 52"/>
-          <p:cNvSpPr txBox="1"/>
-          <p:nvPr/>
-        </p:nvSpPr>
-        <p:spPr>
-          <a:xfrm>
-            <a:off x="4700016" y="1353312"/>
-            <a:ext cx="1143000" cy="320040"/>
-          </a:xfrm>
-          <a:prstGeom prst="rect">
-            <a:avLst/>
-          </a:prstGeom>
-          <a:noFill/>
-          <a:ln>
-            <a:noFill/>
-          </a:ln>
-        </p:spPr>
-        <p:txBody>
-          <a:bodyPr wrap="square" lIns="91440" rIns="91440" tIns="45720" bIns="45720">
-            <a:normAutofit fontScale="85000" lnSpcReduction="20000"/>
-          </a:bodyPr>
-          <a:lstStyle/>
-          <a:p>
-            <a:pPr algn="c"/>
-            <a:r>
-              <a:rPr lang="en-US" sz="1000" b="0">
-                <a:solidFill>
-                  <a:srgbClr val="52606C"/>
-                </a:solidFill>
-                <a:latin typeface="Aptos"/>
-              </a:rPr>
-              <a:t>testing and treatment</a:t>
-            </a:r>
-          </a:p>
-        </p:txBody>
-      </p:sp>
-      <p:sp>
-        <p:nvSpPr>
-          <p:cNvPr id="53" name="Text 53"/>
-          <p:cNvSpPr txBox="1"/>
-          <p:nvPr/>
-        </p:nvSpPr>
-        <p:spPr>
-          <a:xfrm>
-            <a:off x="7059168" y="2779776"/>
-            <a:ext cx="1280160" cy="320040"/>
-          </a:xfrm>
-          <a:prstGeom prst="rect">
-            <a:avLst/>
-          </a:prstGeom>
-          <a:noFill/>
-          <a:ln>
-            <a:noFill/>
-          </a:ln>
-        </p:spPr>
-        <p:txBody>
-          <a:bodyPr wrap="square" lIns="91440" rIns="91440" tIns="45720" bIns="45720">
-            <a:normAutofit fontScale="85000" lnSpcReduction="20000"/>
-          </a:bodyPr>
-          <a:lstStyle/>
-          <a:p>
-            <a:pPr algn="c"/>
-            <a:r>
-              <a:rPr lang="en-US" sz="1000" b="0">
-                <a:solidFill>
-                  <a:srgbClr val="52606C"/>
-                </a:solidFill>
-                <a:latin typeface="Aptos"/>
-              </a:rPr>
-              <a:t>reduced progression</a:t>
-            </a:r>
-          </a:p>
-        </p:txBody>
-      </p:sp>
-      <p:sp>
-        <p:nvSpPr>
-          <p:cNvPr id="54" name="Text 54"/>
-          <p:cNvSpPr txBox="1"/>
-          <p:nvPr/>
-        </p:nvSpPr>
-        <p:spPr>
-          <a:xfrm>
-            <a:off x="914400" y="4224528"/>
-            <a:ext cx="4846320" cy="960120"/>
-          </a:xfrm>
-          <a:prstGeom prst="rect">
-            <a:avLst/>
-          </a:prstGeom>
-          <a:solidFill>
-            <a:srgbClr val="E8F2FA"/>
-          </a:solidFill>
-          <a:ln w="9525">
-            <a:solidFill>
-              <a:srgbClr val="004A80"/>
-            </a:solidFill>
-          </a:ln>
-        </p:spPr>
-        <p:txBody>
-          <a:bodyPr wrap="square" lIns="91440" rIns="91440" tIns="45720" bIns="45720">
-            <a:normAutofit fontScale="85000" lnSpcReduction="20000"/>
-          </a:bodyPr>
-          <a:lstStyle/>
-          <a:p>
-            <a:pPr algn="l"/>
-            <a:r>
-              <a:rPr lang="en-US" sz="1500" b="0">
-                <a:solidFill>
-                  <a:srgbClr val="142030"/>
-                </a:solidFill>
-                <a:latin typeface="Aptos"/>
-              </a:rPr>
-              <a:t>State variables</a:t>
-            </a:r>
-          </a:p>
-          <a:p>
-            <a:pPr algn="l"/>
-            <a:r>
-              <a:rPr lang="en-US" sz="1500" b="0">
-                <a:solidFill>
-                  <a:srgbClr val="142030"/>
-                </a:solidFill>
-                <a:latin typeface="Aptos"/>
-              </a:rPr>
-              <a:t>S susceptible, I infected, T treated, A AIDS-stage population.</a:t>
-            </a:r>
-          </a:p>
-        </p:txBody>
-      </p:sp>
-      <p:sp>
-        <p:nvSpPr>
-          <p:cNvPr id="55" name="Text 55"/>
-          <p:cNvSpPr txBox="1"/>
-          <p:nvPr/>
-        </p:nvSpPr>
-        <p:spPr>
-          <a:xfrm>
-            <a:off x="6355080" y="4224528"/>
-            <a:ext cx="4709160" cy="960120"/>
-          </a:xfrm>
-          <a:prstGeom prst="rect">
-            <a:avLst/>
-          </a:prstGeom>
-          <a:solidFill>
-            <a:srgbClr val="FFF7E0"/>
-          </a:solidFill>
-          <a:ln w="9525">
-            <a:solidFill>
-              <a:srgbClr val="CC9900"/>
-            </a:solidFill>
-          </a:ln>
-        </p:spPr>
-        <p:txBody>
-          <a:bodyPr wrap="square" lIns="91440" rIns="91440" tIns="45720" bIns="45720">
-            <a:normAutofit fontScale="85000" lnSpcReduction="20000"/>
-          </a:bodyPr>
-          <a:lstStyle/>
-          <a:p>
-            <a:pPr algn="l"/>
-            <a:r>
-              <a:rPr lang="en-US" sz="1500" b="0">
-                <a:solidFill>
-                  <a:srgbClr val="142030"/>
-                </a:solidFill>
-                <a:latin typeface="Aptos"/>
-              </a:rPr>
-              <a:t>Controls</a:t>
-            </a:r>
-          </a:p>
-          <a:p>
-            <a:pPr algn="l"/>
-            <a:r>
-              <a:rPr lang="en-US" sz="1500" b="0">
-                <a:solidFill>
-                  <a:srgbClr val="142030"/>
-                </a:solidFill>
-                <a:latin typeface="Aptos"/>
-              </a:rPr>
-              <a:t>u1 awareness, u2 safer behaviour, u3 testing, u4 adherence.</a:t>
-            </a:r>
-          </a:p>
-        </p:txBody>
-      </p:sp>
     </p:spTree>
   </p:cSld>
   <p:clrMapOvr>
@@ -4028,7 +4056,7 @@
       </p:grpSpPr>
       <p:sp>
         <p:nvSpPr>
-          <p:cNvPr id="56" name="Text 56"/>
+          <p:cNvPr id="49" name="Text 49"/>
           <p:cNvSpPr txBox="1"/>
           <p:nvPr/>
         </p:nvSpPr>
@@ -4059,14 +4087,14 @@
                 </a:solidFill>
                 <a:latin typeface="Aptos"/>
               </a:rPr>
-              <a:t>Fractional-Order Model</a:t>
-            </a:r>
-          </a:p>
-        </p:txBody>
-      </p:sp>
-      <p:sp>
-        <p:nvSpPr>
-          <p:cNvPr id="57" name="Text 57"/>
+              <a:t>Model Diagram: SITA</a:t>
+            </a:r>
+          </a:p>
+        </p:txBody>
+      </p:sp>
+      <p:sp>
+        <p:nvSpPr>
+          <p:cNvPr id="50" name="Text 50"/>
           <p:cNvSpPr txBox="1"/>
           <p:nvPr/>
         </p:nvSpPr>
@@ -4106,7 +4134,7 @@
       </p:sp>
       <p:sp>
         <p:nvSpPr>
-          <p:cNvPr id="58" name="Text 58"/>
+          <p:cNvPr id="51" name="Text 51"/>
           <p:cNvSpPr txBox="1"/>
           <p:nvPr/>
         </p:nvSpPr>
@@ -4146,14 +4174,338 @@
       </p:sp>
       <p:sp>
         <p:nvSpPr>
+          <p:cNvPr id="52" name="S(t)"/>
+          <p:cNvSpPr/>
+          <p:nvPr/>
+        </p:nvSpPr>
+        <p:spPr>
+          <a:xfrm>
+            <a:off x="749808" y="1856231"/>
+            <a:ext cx="1691640" cy="713232"/>
+          </a:xfrm>
+          <a:prstGeom prst="roundRect">
+            <a:avLst/>
+          </a:prstGeom>
+          <a:solidFill>
+            <a:srgbClr val="E8F2FA"/>
+          </a:solidFill>
+          <a:ln w="12700">
+            <a:solidFill>
+              <a:srgbClr val="004A80"/>
+            </a:solidFill>
+          </a:ln>
+        </p:spPr>
+        <p:txBody>
+          <a:bodyPr wrap="square" anchor="mid" lIns="91440" rIns="91440" tIns="45720" bIns="45720">
+            <a:normAutofit fontScale="85000" lnSpcReduction="15000"/>
+          </a:bodyPr>
+          <a:lstStyle/>
+          <a:p>
+            <a:pPr algn="ctr"/>
+            <a:r>
+              <a:rPr lang="en-US" sz="2000" b="1">
+                <a:solidFill>
+                  <a:srgbClr val="004A80"/>
+                </a:solidFill>
+                <a:latin typeface="Aptos Display"/>
+              </a:rPr>
+              <a:t>S(t)</a:t>
+            </a:r>
+          </a:p>
+          <a:p>
+            <a:pPr algn="ctr"/>
+            <a:r>
+              <a:rPr lang="en-US" sz="1500" b="1">
+                <a:solidFill>
+                  <a:srgbClr val="004A80"/>
+                </a:solidFill>
+                <a:latin typeface="Aptos"/>
+              </a:rPr>
+              <a:t>Susceptible</a:t>
+            </a:r>
+          </a:p>
+        </p:txBody>
+      </p:sp>
+      <p:sp>
+        <p:nvSpPr>
+          <p:cNvPr id="53" name="I(t)"/>
+          <p:cNvSpPr/>
+          <p:nvPr/>
+        </p:nvSpPr>
+        <p:spPr>
+          <a:xfrm>
+            <a:off x="3246120" y="1856231"/>
+            <a:ext cx="1691640" cy="713232"/>
+          </a:xfrm>
+          <a:prstGeom prst="roundRect">
+            <a:avLst/>
+          </a:prstGeom>
+          <a:solidFill>
+            <a:srgbClr val="FFFFFF"/>
+          </a:solidFill>
+          <a:ln w="12700">
+            <a:solidFill>
+              <a:srgbClr val="B44146"/>
+            </a:solidFill>
+          </a:ln>
+        </p:spPr>
+        <p:txBody>
+          <a:bodyPr wrap="square" anchor="mid" lIns="91440" rIns="91440" tIns="45720" bIns="45720">
+            <a:normAutofit fontScale="85000" lnSpcReduction="15000"/>
+          </a:bodyPr>
+          <a:lstStyle/>
+          <a:p>
+            <a:pPr algn="ctr"/>
+            <a:r>
+              <a:rPr lang="en-US" sz="2000" b="1">
+                <a:solidFill>
+                  <a:srgbClr val="B44146"/>
+                </a:solidFill>
+                <a:latin typeface="Aptos Display"/>
+              </a:rPr>
+              <a:t>I(t)</a:t>
+            </a:r>
+          </a:p>
+          <a:p>
+            <a:pPr algn="ctr"/>
+            <a:r>
+              <a:rPr lang="en-US" sz="1500" b="1">
+                <a:solidFill>
+                  <a:srgbClr val="B44146"/>
+                </a:solidFill>
+                <a:latin typeface="Aptos"/>
+              </a:rPr>
+              <a:t>Infected</a:t>
+            </a:r>
+          </a:p>
+        </p:txBody>
+      </p:sp>
+      <p:sp>
+        <p:nvSpPr>
+          <p:cNvPr id="54" name="T(t)"/>
+          <p:cNvSpPr/>
+          <p:nvPr/>
+        </p:nvSpPr>
+        <p:spPr>
+          <a:xfrm>
+            <a:off x="5742432" y="1856231"/>
+            <a:ext cx="1691640" cy="713232"/>
+          </a:xfrm>
+          <a:prstGeom prst="roundRect">
+            <a:avLst/>
+          </a:prstGeom>
+          <a:solidFill>
+            <a:srgbClr val="FFF7E0"/>
+          </a:solidFill>
+          <a:ln w="12700">
+            <a:solidFill>
+              <a:srgbClr val="CC9900"/>
+            </a:solidFill>
+          </a:ln>
+        </p:spPr>
+        <p:txBody>
+          <a:bodyPr wrap="square" anchor="mid" lIns="91440" rIns="91440" tIns="45720" bIns="45720">
+            <a:normAutofit fontScale="85000" lnSpcReduction="15000"/>
+          </a:bodyPr>
+          <a:lstStyle/>
+          <a:p>
+            <a:pPr algn="ctr"/>
+            <a:r>
+              <a:rPr lang="en-US" sz="2000" b="1">
+                <a:solidFill>
+                  <a:srgbClr val="CC9900"/>
+                </a:solidFill>
+                <a:latin typeface="Aptos Display"/>
+              </a:rPr>
+              <a:t>T(t)</a:t>
+            </a:r>
+          </a:p>
+          <a:p>
+            <a:pPr algn="ctr"/>
+            <a:r>
+              <a:rPr lang="en-US" sz="1500" b="1">
+                <a:solidFill>
+                  <a:srgbClr val="CC9900"/>
+                </a:solidFill>
+                <a:latin typeface="Aptos"/>
+              </a:rPr>
+              <a:t>Treated</a:t>
+            </a:r>
+          </a:p>
+        </p:txBody>
+      </p:sp>
+      <p:sp>
+        <p:nvSpPr>
+          <p:cNvPr id="55" name="A(t)"/>
+          <p:cNvSpPr/>
+          <p:nvPr/>
+        </p:nvSpPr>
+        <p:spPr>
+          <a:xfrm>
+            <a:off x="8247888" y="1856231"/>
+            <a:ext cx="1691640" cy="713232"/>
+          </a:xfrm>
+          <a:prstGeom prst="roundRect">
+            <a:avLst/>
+          </a:prstGeom>
+          <a:solidFill>
+            <a:srgbClr val="E6F7F4"/>
+          </a:solidFill>
+          <a:ln w="12700">
+            <a:solidFill>
+              <a:srgbClr val="007E70"/>
+            </a:solidFill>
+          </a:ln>
+        </p:spPr>
+        <p:txBody>
+          <a:bodyPr wrap="square" anchor="mid" lIns="91440" rIns="91440" tIns="45720" bIns="45720">
+            <a:normAutofit fontScale="85000" lnSpcReduction="15000"/>
+          </a:bodyPr>
+          <a:lstStyle/>
+          <a:p>
+            <a:pPr algn="ctr"/>
+            <a:r>
+              <a:rPr lang="en-US" sz="2000" b="1">
+                <a:solidFill>
+                  <a:srgbClr val="007E70"/>
+                </a:solidFill>
+                <a:latin typeface="Aptos Display"/>
+              </a:rPr>
+              <a:t>A(t)</a:t>
+            </a:r>
+          </a:p>
+          <a:p>
+            <a:pPr algn="ctr"/>
+            <a:r>
+              <a:rPr lang="en-US" sz="1500" b="1">
+                <a:solidFill>
+                  <a:srgbClr val="007E70"/>
+                </a:solidFill>
+                <a:latin typeface="Aptos"/>
+              </a:rPr>
+              <a:t>AIDS stage</a:t>
+            </a:r>
+          </a:p>
+        </p:txBody>
+      </p:sp>
+      <p:cxnSp>
+        <p:nvCxnSpPr>
+          <p:cNvPr id="56" name="Arrow 56"/>
+          <p:cNvCxnSpPr/>
+          <p:nvPr/>
+        </p:nvCxnSpPr>
+        <p:spPr>
+          <a:xfrm>
+            <a:off x="2441448" y="2212848"/>
+            <a:ext cx="804671" cy="0"/>
+          </a:xfrm>
+          <a:prstGeom prst="line">
+            <a:avLst/>
+          </a:prstGeom>
+          <a:ln w="19050">
+            <a:solidFill>
+              <a:srgbClr val="142030"/>
+            </a:solidFill>
+            <a:tailEnd type="triangle"/>
+          </a:ln>
+        </p:spPr>
+        <p:style>
+          <a:lnRef idx="1">
+            <a:schemeClr val="accent1"/>
+          </a:lnRef>
+          <a:fillRef idx="0">
+            <a:schemeClr val="accent1"/>
+          </a:fillRef>
+          <a:effectRef idx="0">
+            <a:schemeClr val="accent1"/>
+          </a:effectRef>
+          <a:fontRef idx="minor">
+            <a:schemeClr val="tx1"/>
+          </a:fontRef>
+        </p:style>
+      </p:cxnSp>
+      <p:cxnSp>
+        <p:nvCxnSpPr>
+          <p:cNvPr id="57" name="Arrow 57"/>
+          <p:cNvCxnSpPr/>
+          <p:nvPr/>
+        </p:nvCxnSpPr>
+        <p:spPr>
+          <a:xfrm>
+            <a:off x="4937760" y="2212848"/>
+            <a:ext cx="804671" cy="0"/>
+          </a:xfrm>
+          <a:prstGeom prst="line">
+            <a:avLst/>
+          </a:prstGeom>
+          <a:ln w="19050">
+            <a:solidFill>
+              <a:srgbClr val="142030"/>
+            </a:solidFill>
+            <a:tailEnd type="triangle"/>
+          </a:ln>
+        </p:spPr>
+        <p:style>
+          <a:lnRef idx="1">
+            <a:schemeClr val="accent1"/>
+          </a:lnRef>
+          <a:fillRef idx="0">
+            <a:schemeClr val="accent1"/>
+          </a:fillRef>
+          <a:effectRef idx="0">
+            <a:schemeClr val="accent1"/>
+          </a:effectRef>
+          <a:fontRef idx="minor">
+            <a:schemeClr val="tx1"/>
+          </a:fontRef>
+        </p:style>
+      </p:cxnSp>
+      <p:cxnSp>
+        <p:nvCxnSpPr>
+          <p:cNvPr id="58" name="Arrow 58"/>
+          <p:cNvCxnSpPr/>
+          <p:nvPr/>
+        </p:nvCxnSpPr>
+        <p:spPr>
+          <a:xfrm>
+            <a:off x="7434072" y="2212848"/>
+            <a:ext cx="813815" cy="0"/>
+          </a:xfrm>
+          <a:prstGeom prst="line">
+            <a:avLst/>
+          </a:prstGeom>
+          <a:ln w="19050">
+            <a:solidFill>
+              <a:srgbClr val="142030"/>
+            </a:solidFill>
+            <a:tailEnd type="triangle"/>
+          </a:ln>
+        </p:spPr>
+        <p:style>
+          <a:lnRef idx="1">
+            <a:schemeClr val="accent1"/>
+          </a:lnRef>
+          <a:fillRef idx="0">
+            <a:schemeClr val="accent1"/>
+          </a:fillRef>
+          <a:effectRef idx="0">
+            <a:schemeClr val="accent1"/>
+          </a:effectRef>
+          <a:fontRef idx="minor">
+            <a:schemeClr val="tx1"/>
+          </a:fontRef>
+        </p:style>
+      </p:cxnSp>
+      <p:sp>
+        <p:nvSpPr>
           <p:cNvPr id="59" name="Text 59"/>
           <p:cNvSpPr txBox="1"/>
           <p:nvPr/>
         </p:nvSpPr>
         <p:spPr>
           <a:xfrm>
-            <a:off x="658368" y="1234440"/>
-            <a:ext cx="5303520" cy="320040"/>
+            <a:off x="2267712" y="1353312"/>
+            <a:ext cx="1143000" cy="320040"/>
           </a:xfrm>
           <a:prstGeom prst="rect">
             <a:avLst/>
@@ -4169,15 +4521,15 @@
           </a:bodyPr>
           <a:lstStyle/>
           <a:p>
-            <a:pPr algn="l"/>
-            <a:r>
-              <a:rPr lang="en-US" sz="1500" b="1">
-                <a:solidFill>
-                  <a:srgbClr val="CC9900"/>
-                </a:solidFill>
-                <a:latin typeface="Aptos"/>
-              </a:rPr>
-              <a:t>Caputo memory form</a:t>
+            <a:pPr algn="c"/>
+            <a:r>
+              <a:rPr lang="en-US" sz="1000" b="0">
+                <a:solidFill>
+                  <a:srgbClr val="52606C"/>
+                </a:solidFill>
+                <a:latin typeface="Aptos"/>
+              </a:rPr>
+              <a:t>effective transmission</a:t>
             </a:r>
           </a:p>
         </p:txBody>
@@ -4190,8 +4542,8 @@
         </p:nvSpPr>
         <p:spPr>
           <a:xfrm>
-            <a:off x="694944" y="1664208"/>
-            <a:ext cx="5303520" cy="566928"/>
+            <a:off x="4700016" y="1353312"/>
+            <a:ext cx="1143000" cy="320040"/>
           </a:xfrm>
           <a:prstGeom prst="rect">
             <a:avLst/>
@@ -4207,15 +4559,15 @@
           </a:bodyPr>
           <a:lstStyle/>
           <a:p>
-            <a:pPr algn="l"/>
-            <a:r>
-              <a:rPr lang="en-US" sz="2400" b="1">
-                <a:solidFill>
-                  <a:srgbClr val="142030"/>
-                </a:solidFill>
-                <a:latin typeface="Aptos"/>
-              </a:rPr>
-              <a:t>D_C^q X(t) = F(t, X(t)),    0 &lt; q &lt;= 1</a:t>
+            <a:pPr algn="c"/>
+            <a:r>
+              <a:rPr lang="en-US" sz="1000" b="0">
+                <a:solidFill>
+                  <a:srgbClr val="52606C"/>
+                </a:solidFill>
+                <a:latin typeface="Aptos"/>
+              </a:rPr>
+              <a:t>testing and treatment</a:t>
             </a:r>
           </a:p>
         </p:txBody>
@@ -4228,8 +4580,8 @@
         </p:nvSpPr>
         <p:spPr>
           <a:xfrm>
-            <a:off x="749808" y="2542032"/>
-            <a:ext cx="5623560" cy="1737360"/>
+            <a:off x="7059168" y="2779776"/>
+            <a:ext cx="1280160" cy="320040"/>
           </a:xfrm>
           <a:prstGeom prst="rect">
             <a:avLst/>
@@ -4245,51 +4597,15 @@
           </a:bodyPr>
           <a:lstStyle/>
           <a:p>
-            <a:pPr algn="l"/>
-            <a:r>
-              <a:rPr lang="en-US" sz="1600" b="0">
-                <a:solidFill>
-                  <a:srgbClr val="142030"/>
-                </a:solidFill>
-                <a:latin typeface="Aptos"/>
-              </a:rPr>
-              <a:t>D_C^q S = Lambda - beta_eff S(I + eta T) - mu S</a:t>
-            </a:r>
-          </a:p>
-          <a:p>
-            <a:pPr algn="l"/>
-            <a:r>
-              <a:rPr lang="en-US" sz="1600" b="0">
-                <a:solidFill>
-                  <a:srgbClr val="142030"/>
-                </a:solidFill>
-                <a:latin typeface="Aptos"/>
-              </a:rPr>
-              <a:t>D_C^q I = beta_eff S(I + eta T) - (tau_eff + delta + mu)I</a:t>
-            </a:r>
-          </a:p>
-          <a:p>
-            <a:pPr algn="l"/>
-            <a:r>
-              <a:rPr lang="en-US" sz="1600" b="0">
-                <a:solidFill>
-                  <a:srgbClr val="142030"/>
-                </a:solidFill>
-                <a:latin typeface="Aptos"/>
-              </a:rPr>
-              <a:t>D_C^q T = tau_eff I - (rho_eff + mu)T</a:t>
-            </a:r>
-          </a:p>
-          <a:p>
-            <a:pPr algn="l"/>
-            <a:r>
-              <a:rPr lang="en-US" sz="1600" b="0">
-                <a:solidFill>
-                  <a:srgbClr val="142030"/>
-                </a:solidFill>
-                <a:latin typeface="Aptos"/>
-              </a:rPr>
-              <a:t>D_C^q A = delta I + rho_eff T - (d + mu)A</a:t>
+            <a:pPr algn="c"/>
+            <a:r>
+              <a:rPr lang="en-US" sz="1000" b="0">
+                <a:solidFill>
+                  <a:srgbClr val="52606C"/>
+                </a:solidFill>
+                <a:latin typeface="Aptos"/>
+              </a:rPr>
+              <a:t>reduced progression</a:t>
             </a:r>
           </a:p>
         </p:txBody>
@@ -4302,8 +4618,62 @@
         </p:nvSpPr>
         <p:spPr>
           <a:xfrm>
-            <a:off x="6812280" y="1417320"/>
-            <a:ext cx="4206240" cy="1325880"/>
+            <a:off x="914400" y="4224528"/>
+            <a:ext cx="4846320" cy="960120"/>
+          </a:xfrm>
+          <a:prstGeom prst="rect">
+            <a:avLst/>
+          </a:prstGeom>
+          <a:solidFill>
+            <a:srgbClr val="E8F2FA"/>
+          </a:solidFill>
+          <a:ln w="9525">
+            <a:solidFill>
+              <a:srgbClr val="004A80"/>
+            </a:solidFill>
+          </a:ln>
+        </p:spPr>
+        <p:txBody>
+          <a:bodyPr wrap="square" lIns="91440" rIns="91440" tIns="45720" bIns="45720">
+            <a:normAutofit fontScale="85000" lnSpcReduction="20000"/>
+          </a:bodyPr>
+          <a:lstStyle/>
+          <a:p>
+            <a:pPr algn="l"/>
+            <a:r>
+              <a:rPr lang="en-US" sz="1500" b="0">
+                <a:solidFill>
+                  <a:srgbClr val="142030"/>
+                </a:solidFill>
+                <a:latin typeface="Aptos"/>
+              </a:rPr>
+              <a:t>State variables</a:t>
+            </a:r>
+          </a:p>
+          <a:p>
+            <a:pPr algn="l"/>
+            <a:r>
+              <a:rPr lang="en-US" sz="1500" b="0">
+                <a:solidFill>
+                  <a:srgbClr val="142030"/>
+                </a:solidFill>
+                <a:latin typeface="Aptos"/>
+              </a:rPr>
+              <a:t>S susceptible, I infected, T treated, A AIDS-stage population.</a:t>
+            </a:r>
+          </a:p>
+        </p:txBody>
+      </p:sp>
+      <p:sp>
+        <p:nvSpPr>
+          <p:cNvPr id="63" name="Text 63"/>
+          <p:cNvSpPr txBox="1"/>
+          <p:nvPr/>
+        </p:nvSpPr>
+        <p:spPr>
+          <a:xfrm>
+            <a:off x="6355080" y="4224528"/>
+            <a:ext cx="4709160" cy="960120"/>
           </a:xfrm>
           <a:prstGeom prst="rect">
             <a:avLst/>
@@ -4325,103 +4695,25 @@
           <a:p>
             <a:pPr algn="l"/>
             <a:r>
-              <a:rPr lang="en-US" sz="1600" b="0">
-                <a:solidFill>
-                  <a:srgbClr val="142030"/>
-                </a:solidFill>
-                <a:latin typeface="Aptos"/>
-              </a:rPr>
-              <a:t>Intervention-adjusted rates</a:t>
-            </a:r>
-          </a:p>
-          <a:p>
-            <a:pPr algn="l"/>
-            <a:r>
-              <a:rPr lang="en-US" sz="1600" b="0">
-                <a:solidFill>
-                  <a:srgbClr val="142030"/>
-                </a:solidFill>
-                <a:latin typeface="Aptos"/>
-              </a:rPr>
-              <a:t>beta_eff = beta0(1-u1)(1-u2)</a:t>
-            </a:r>
-          </a:p>
-          <a:p>
-            <a:pPr algn="l"/>
-            <a:r>
-              <a:rPr lang="en-US" sz="1600" b="0">
-                <a:solidFill>
-                  <a:srgbClr val="142030"/>
-                </a:solidFill>
-                <a:latin typeface="Aptos"/>
-              </a:rPr>
-              <a:t>tau_eff = tau(1+u3)</a:t>
-            </a:r>
-          </a:p>
-          <a:p>
-            <a:pPr algn="l"/>
-            <a:r>
-              <a:rPr lang="en-US" sz="1600" b="0">
-                <a:solidFill>
-                  <a:srgbClr val="142030"/>
-                </a:solidFill>
-                <a:latin typeface="Aptos"/>
-              </a:rPr>
-              <a:t>rho_eff = rho(1-u4)</a:t>
-            </a:r>
-          </a:p>
-        </p:txBody>
-      </p:sp>
-      <p:sp>
-        <p:nvSpPr>
-          <p:cNvPr id="63" name="Text 63"/>
-          <p:cNvSpPr txBox="1"/>
-          <p:nvPr/>
-        </p:nvSpPr>
-        <p:spPr>
-          <a:xfrm>
-            <a:off x="6812280" y="3474720"/>
-            <a:ext cx="4206240" cy="960120"/>
-          </a:xfrm>
-          <a:prstGeom prst="rect">
-            <a:avLst/>
-          </a:prstGeom>
-          <a:solidFill>
-            <a:srgbClr val="E6F7F4"/>
-          </a:solidFill>
-          <a:ln w="9525">
-            <a:solidFill>
-              <a:srgbClr val="007E70"/>
-            </a:solidFill>
-          </a:ln>
-        </p:spPr>
-        <p:txBody>
-          <a:bodyPr wrap="square" lIns="91440" rIns="91440" tIns="45720" bIns="45720">
-            <a:normAutofit fontScale="85000" lnSpcReduction="20000"/>
-          </a:bodyPr>
-          <a:lstStyle/>
-          <a:p>
-            <a:pPr algn="l"/>
-            <a:r>
-              <a:rPr lang="en-US" sz="1600" b="0">
-                <a:solidFill>
-                  <a:srgbClr val="142030"/>
-                </a:solidFill>
-                <a:latin typeface="Aptos"/>
-              </a:rPr>
-              <a:t>Meaning of q</a:t>
-            </a:r>
-          </a:p>
-          <a:p>
-            <a:pPr algn="l"/>
-            <a:r>
-              <a:rPr lang="en-US" sz="1600" b="0">
-                <a:solidFill>
-                  <a:srgbClr val="142030"/>
-                </a:solidFill>
-                <a:latin typeface="Aptos"/>
-              </a:rPr>
-              <a:t>q = 1 gives the ordinary model. q &lt; 1 carries memory of past states.</a:t>
+              <a:rPr lang="en-US" sz="1500" b="0">
+                <a:solidFill>
+                  <a:srgbClr val="142030"/>
+                </a:solidFill>
+                <a:latin typeface="Aptos"/>
+              </a:rPr>
+              <a:t>Controls</a:t>
+            </a:r>
+          </a:p>
+          <a:p>
+            <a:pPr algn="l"/>
+            <a:r>
+              <a:rPr lang="en-US" sz="1500" b="0">
+                <a:solidFill>
+                  <a:srgbClr val="142030"/>
+                </a:solidFill>
+                <a:latin typeface="Aptos"/>
+              </a:rPr>
+              <a:t>u1 awareness, u2 safer behaviour, u3 testing, u4 adherence.</a:t>
             </a:r>
           </a:p>
         </p:txBody>
@@ -4484,7 +4776,7 @@
                 </a:solidFill>
                 <a:latin typeface="Aptos"/>
               </a:rPr>
-              <a:t>Numerical Scheme + Implementation</a:t>
+              <a:t>Fractional-Order Model</a:t>
             </a:r>
           </a:p>
         </p:txBody>
@@ -4578,7 +4870,7 @@
         <p:spPr>
           <a:xfrm>
             <a:off x="658368" y="1234440"/>
-            <a:ext cx="4709160" cy="320040"/>
+            <a:ext cx="5303520" cy="320040"/>
           </a:xfrm>
           <a:prstGeom prst="rect">
             <a:avLst/>
@@ -4602,7 +4894,7 @@
                 </a:solidFill>
                 <a:latin typeface="Aptos"/>
               </a:rPr>
-              <a:t>Numerical idea</a:t>
+              <a:t>Caputo memory form</a:t>
             </a:r>
           </a:p>
         </p:txBody>
@@ -4615,8 +4907,8 @@
         </p:nvSpPr>
         <p:spPr>
           <a:xfrm>
-            <a:off x="749808" y="1627632"/>
-            <a:ext cx="4937760" cy="2423160"/>
+            <a:off x="694944" y="1664208"/>
+            <a:ext cx="5303520" cy="566928"/>
           </a:xfrm>
           <a:prstGeom prst="rect">
             <a:avLst/>
@@ -4632,63 +4924,15 @@
           </a:bodyPr>
           <a:lstStyle/>
           <a:p>
-            <a:pPr algn="l">
-              <a:buChar char="•"/>
-              <a:buFont typeface="Arial"/>
-            </a:pPr>
-            <a:r>
-              <a:rPr lang="en-US" sz="1800" b="0">
-                <a:solidFill>
-                  <a:srgbClr val="142030"/>
-                </a:solidFill>
-                <a:latin typeface="Aptos"/>
-              </a:rPr>
-              <a:t>Time interval is divided into discrete steps.</a:t>
-            </a:r>
-          </a:p>
-          <a:p>
-            <a:pPr algn="l">
-              <a:buChar char="•"/>
-              <a:buFont typeface="Arial"/>
-            </a:pPr>
-            <a:r>
-              <a:rPr lang="en-US" sz="1800" b="0">
-                <a:solidFill>
-                  <a:srgbClr val="142030"/>
-                </a:solidFill>
-                <a:latin typeface="Aptos"/>
-              </a:rPr>
-              <a:t>A predictor estimates the next state.</a:t>
-            </a:r>
-          </a:p>
-          <a:p>
-            <a:pPr algn="l">
-              <a:buChar char="•"/>
-              <a:buFont typeface="Arial"/>
-            </a:pPr>
-            <a:r>
-              <a:rPr lang="en-US" sz="1800" b="0">
-                <a:solidFill>
-                  <a:srgbClr val="142030"/>
-                </a:solidFill>
-                <a:latin typeface="Aptos"/>
-              </a:rPr>
-              <a:t>A corrector updates the state using fractional-memory weights.</a:t>
-            </a:r>
-          </a:p>
-          <a:p>
-            <a:pPr algn="l">
-              <a:buChar char="•"/>
-              <a:buFont typeface="Arial"/>
-            </a:pPr>
-            <a:r>
-              <a:rPr lang="en-US" sz="1800" b="0">
-                <a:solidFill>
-                  <a:srgbClr val="142030"/>
-                </a:solidFill>
-                <a:latin typeface="Aptos"/>
-              </a:rPr>
-              <a:t>The same engine is used for baseline, memory, intervention, and sensitivity experiments.</a:t>
+            <a:pPr algn="l"/>
+            <a:r>
+              <a:rPr lang="en-US" sz="2400" b="1">
+                <a:solidFill>
+                  <a:srgbClr val="142030"/>
+                </a:solidFill>
+                <a:latin typeface="Aptos"/>
+              </a:rPr>
+              <a:t>D_C^q X(t) = F(t, X(t)),    0 &lt; q &lt;= 1</a:t>
             </a:r>
           </a:p>
         </p:txBody>
@@ -4701,18 +4945,92 @@
         </p:nvSpPr>
         <p:spPr>
           <a:xfrm>
-            <a:off x="6355080" y="1170432"/>
-            <a:ext cx="4297680" cy="749808"/>
+            <a:off x="749808" y="2542032"/>
+            <a:ext cx="5623560" cy="1737360"/>
+          </a:xfrm>
+          <a:prstGeom prst="rect">
+            <a:avLst/>
+          </a:prstGeom>
+          <a:noFill/>
+          <a:ln>
+            <a:noFill/>
+          </a:ln>
+        </p:spPr>
+        <p:txBody>
+          <a:bodyPr wrap="square" lIns="91440" rIns="91440" tIns="45720" bIns="45720">
+            <a:normAutofit fontScale="85000" lnSpcReduction="20000"/>
+          </a:bodyPr>
+          <a:lstStyle/>
+          <a:p>
+            <a:pPr algn="l"/>
+            <a:r>
+              <a:rPr lang="en-US" sz="1600" b="0">
+                <a:solidFill>
+                  <a:srgbClr val="142030"/>
+                </a:solidFill>
+                <a:latin typeface="Aptos"/>
+              </a:rPr>
+              <a:t>D_C^q S = Lambda - beta_eff S(I + eta T) - mu S</a:t>
+            </a:r>
+          </a:p>
+          <a:p>
+            <a:pPr algn="l"/>
+            <a:r>
+              <a:rPr lang="en-US" sz="1600" b="0">
+                <a:solidFill>
+                  <a:srgbClr val="142030"/>
+                </a:solidFill>
+                <a:latin typeface="Aptos"/>
+              </a:rPr>
+              <a:t>D_C^q I = beta_eff S(I + eta T) - (tau_eff + delta + mu)I</a:t>
+            </a:r>
+          </a:p>
+          <a:p>
+            <a:pPr algn="l"/>
+            <a:r>
+              <a:rPr lang="en-US" sz="1600" b="0">
+                <a:solidFill>
+                  <a:srgbClr val="142030"/>
+                </a:solidFill>
+                <a:latin typeface="Aptos"/>
+              </a:rPr>
+              <a:t>D_C^q T = tau_eff I - (rho_eff + mu)T</a:t>
+            </a:r>
+          </a:p>
+          <a:p>
+            <a:pPr algn="l"/>
+            <a:r>
+              <a:rPr lang="en-US" sz="1600" b="0">
+                <a:solidFill>
+                  <a:srgbClr val="142030"/>
+                </a:solidFill>
+                <a:latin typeface="Aptos"/>
+              </a:rPr>
+              <a:t>D_C^q A = delta I + rho_eff T - (d + mu)A</a:t>
+            </a:r>
+          </a:p>
+        </p:txBody>
+      </p:sp>
+      <p:sp>
+        <p:nvSpPr>
+          <p:cNvPr id="70" name="Text 70"/>
+          <p:cNvSpPr txBox="1"/>
+          <p:nvPr/>
+        </p:nvSpPr>
+        <p:spPr>
+          <a:xfrm>
+            <a:off x="6812280" y="1417320"/>
+            <a:ext cx="4206240" cy="1325880"/>
           </a:xfrm>
           <a:prstGeom prst="rect">
             <a:avLst/>
           </a:prstGeom>
           <a:solidFill>
-            <a:srgbClr val="E8F2FA"/>
+            <a:srgbClr val="FFF7E0"/>
           </a:solidFill>
           <a:ln w="9525">
             <a:solidFill>
-              <a:srgbClr val="004A80"/>
+              <a:srgbClr val="CC9900"/>
             </a:solidFill>
           </a:ln>
         </p:spPr>
@@ -4724,39 +5042,63 @@
           <a:p>
             <a:pPr algn="l"/>
             <a:r>
-              <a:rPr lang="en-US" sz="1400" b="0">
-                <a:solidFill>
-                  <a:srgbClr val="142030"/>
-                </a:solidFill>
-                <a:latin typeface="Aptos"/>
-              </a:rPr>
-              <a:t>Inputs</a:t>
-            </a:r>
-          </a:p>
-          <a:p>
-            <a:pPr algn="l"/>
-            <a:r>
-              <a:rPr lang="en-US" sz="1400" b="0">
-                <a:solidFill>
-                  <a:srgbClr val="142030"/>
-                </a:solidFill>
-                <a:latin typeface="Aptos"/>
-              </a:rPr>
-              <a:t>parameters, initial conditions, q, controls</a:t>
-            </a:r>
-          </a:p>
-        </p:txBody>
-      </p:sp>
-      <p:sp>
-        <p:nvSpPr>
-          <p:cNvPr id="70" name="Text 70"/>
-          <p:cNvSpPr txBox="1"/>
-          <p:nvPr/>
-        </p:nvSpPr>
-        <p:spPr>
-          <a:xfrm>
-            <a:off x="6355080" y="2084831"/>
-            <a:ext cx="4297680" cy="749808"/>
+              <a:rPr lang="en-US" sz="1600" b="0">
+                <a:solidFill>
+                  <a:srgbClr val="142030"/>
+                </a:solidFill>
+                <a:latin typeface="Aptos"/>
+              </a:rPr>
+              <a:t>Intervention-adjusted rates</a:t>
+            </a:r>
+          </a:p>
+          <a:p>
+            <a:pPr algn="l"/>
+            <a:r>
+              <a:rPr lang="en-US" sz="1600" b="0">
+                <a:solidFill>
+                  <a:srgbClr val="142030"/>
+                </a:solidFill>
+                <a:latin typeface="Aptos"/>
+              </a:rPr>
+              <a:t>beta_eff = beta0(1-u1)(1-u2)</a:t>
+            </a:r>
+          </a:p>
+          <a:p>
+            <a:pPr algn="l"/>
+            <a:r>
+              <a:rPr lang="en-US" sz="1600" b="0">
+                <a:solidFill>
+                  <a:srgbClr val="142030"/>
+                </a:solidFill>
+                <a:latin typeface="Aptos"/>
+              </a:rPr>
+              <a:t>tau_eff = tau(1+u3)</a:t>
+            </a:r>
+          </a:p>
+          <a:p>
+            <a:pPr algn="l"/>
+            <a:r>
+              <a:rPr lang="en-US" sz="1600" b="0">
+                <a:solidFill>
+                  <a:srgbClr val="142030"/>
+                </a:solidFill>
+                <a:latin typeface="Aptos"/>
+              </a:rPr>
+              <a:t>rho_eff = rho(1-u4)</a:t>
+            </a:r>
+          </a:p>
+        </p:txBody>
+      </p:sp>
+      <p:sp>
+        <p:nvSpPr>
+          <p:cNvPr id="71" name="Text 71"/>
+          <p:cNvSpPr txBox="1"/>
+          <p:nvPr/>
+        </p:nvSpPr>
+        <p:spPr>
+          <a:xfrm>
+            <a:off x="6812280" y="3474720"/>
+            <a:ext cx="4206240" cy="960120"/>
           </a:xfrm>
           <a:prstGeom prst="rect">
             <a:avLst/>
@@ -4778,283 +5120,25 @@
           <a:p>
             <a:pPr algn="l"/>
             <a:r>
-              <a:rPr lang="en-US" sz="1400" b="0">
-                <a:solidFill>
-                  <a:srgbClr val="142030"/>
-                </a:solidFill>
-                <a:latin typeface="Aptos"/>
-              </a:rPr>
-              <a:t>Solver</a:t>
-            </a:r>
-          </a:p>
-          <a:p>
-            <a:pPr algn="l"/>
-            <a:r>
-              <a:rPr lang="en-US" sz="1400" b="0">
-                <a:solidFill>
-                  <a:srgbClr val="142030"/>
-                </a:solidFill>
-                <a:latin typeface="Aptos"/>
-              </a:rPr>
-              <a:t>fractional ABM-type numerical method</a:t>
-            </a:r>
-          </a:p>
-        </p:txBody>
-      </p:sp>
-      <p:sp>
-        <p:nvSpPr>
-          <p:cNvPr id="71" name="Text 71"/>
-          <p:cNvSpPr txBox="1"/>
-          <p:nvPr/>
-        </p:nvSpPr>
-        <p:spPr>
-          <a:xfrm>
-            <a:off x="6355080" y="2999232"/>
-            <a:ext cx="4297680" cy="749808"/>
-          </a:xfrm>
-          <a:prstGeom prst="rect">
-            <a:avLst/>
-          </a:prstGeom>
-          <a:solidFill>
-            <a:srgbClr val="FFF7E0"/>
-          </a:solidFill>
-          <a:ln w="9525">
-            <a:solidFill>
-              <a:srgbClr val="CC9900"/>
-            </a:solidFill>
-          </a:ln>
-        </p:spPr>
-        <p:txBody>
-          <a:bodyPr wrap="square" lIns="91440" rIns="91440" tIns="45720" bIns="45720">
-            <a:normAutofit fontScale="85000" lnSpcReduction="20000"/>
-          </a:bodyPr>
-          <a:lstStyle/>
-          <a:p>
-            <a:pPr algn="l"/>
-            <a:r>
-              <a:rPr lang="en-US" sz="1400" b="0">
-                <a:solidFill>
-                  <a:srgbClr val="142030"/>
-                </a:solidFill>
-                <a:latin typeface="Aptos"/>
-              </a:rPr>
-              <a:t>Outputs</a:t>
-            </a:r>
-          </a:p>
-          <a:p>
-            <a:pPr algn="l"/>
-            <a:r>
-              <a:rPr lang="en-US" sz="1400" b="0">
-                <a:solidFill>
-                  <a:srgbClr val="142030"/>
-                </a:solidFill>
-                <a:latin typeface="Aptos"/>
-              </a:rPr>
-              <a:t>trajectories, R0, scenarios, sensitivity</a:t>
-            </a:r>
-          </a:p>
-        </p:txBody>
-      </p:sp>
-      <p:sp>
-        <p:nvSpPr>
-          <p:cNvPr id="72" name="Text 72"/>
-          <p:cNvSpPr txBox="1"/>
-          <p:nvPr/>
-        </p:nvSpPr>
-        <p:spPr>
-          <a:xfrm>
-            <a:off x="6355080" y="3913632"/>
-            <a:ext cx="4297680" cy="749808"/>
-          </a:xfrm>
-          <a:prstGeom prst="rect">
-            <a:avLst/>
-          </a:prstGeom>
-          <a:solidFill>
-            <a:srgbClr val="FFFFFF"/>
-          </a:solidFill>
-          <a:ln w="9525">
-            <a:solidFill>
-              <a:srgbClr val="B44146"/>
-            </a:solidFill>
-          </a:ln>
-        </p:spPr>
-        <p:txBody>
-          <a:bodyPr wrap="square" lIns="91440" rIns="91440" tIns="45720" bIns="45720">
-            <a:normAutofit fontScale="85000" lnSpcReduction="20000"/>
-          </a:bodyPr>
-          <a:lstStyle/>
-          <a:p>
-            <a:pPr algn="l"/>
-            <a:r>
-              <a:rPr lang="en-US" sz="1400" b="0">
-                <a:solidFill>
-                  <a:srgbClr val="142030"/>
-                </a:solidFill>
-                <a:latin typeface="Aptos"/>
-              </a:rPr>
-              <a:t>Presentation</a:t>
-            </a:r>
-          </a:p>
-          <a:p>
-            <a:pPr algn="l"/>
-            <a:r>
-              <a:rPr lang="en-US" sz="1400" b="0">
-                <a:solidFill>
-                  <a:srgbClr val="142030"/>
-                </a:solidFill>
-                <a:latin typeface="Aptos"/>
-              </a:rPr>
-              <a:t>moving graphs during the live demo</a:t>
-            </a:r>
-          </a:p>
-        </p:txBody>
-      </p:sp>
-      <p:cxnSp>
-        <p:nvCxnSpPr>
-          <p:cNvPr id="73" name="Arrow 73"/>
-          <p:cNvCxnSpPr/>
-          <p:nvPr/>
-        </p:nvCxnSpPr>
-        <p:spPr>
-          <a:xfrm>
-            <a:off x="8503920" y="1920240"/>
-            <a:ext cx="0" cy="164591"/>
-          </a:xfrm>
-          <a:prstGeom prst="line">
-            <a:avLst/>
-          </a:prstGeom>
-          <a:ln w="19050">
-            <a:solidFill>
-              <a:srgbClr val="52606C"/>
-            </a:solidFill>
-            <a:tailEnd type="triangle"/>
-          </a:ln>
-        </p:spPr>
-        <p:style>
-          <a:lnRef idx="1">
-            <a:schemeClr val="accent1"/>
-          </a:lnRef>
-          <a:fillRef idx="0">
-            <a:schemeClr val="accent1"/>
-          </a:fillRef>
-          <a:effectRef idx="0">
-            <a:schemeClr val="accent1"/>
-          </a:effectRef>
-          <a:fontRef idx="minor">
-            <a:schemeClr val="tx1"/>
-          </a:fontRef>
-        </p:style>
-      </p:cxnSp>
-      <p:cxnSp>
-        <p:nvCxnSpPr>
-          <p:cNvPr id="74" name="Arrow 74"/>
-          <p:cNvCxnSpPr/>
-          <p:nvPr/>
-        </p:nvCxnSpPr>
-        <p:spPr>
-          <a:xfrm>
-            <a:off x="8503920" y="2834640"/>
-            <a:ext cx="0" cy="164591"/>
-          </a:xfrm>
-          <a:prstGeom prst="line">
-            <a:avLst/>
-          </a:prstGeom>
-          <a:ln w="19050">
-            <a:solidFill>
-              <a:srgbClr val="52606C"/>
-            </a:solidFill>
-            <a:tailEnd type="triangle"/>
-          </a:ln>
-        </p:spPr>
-        <p:style>
-          <a:lnRef idx="1">
-            <a:schemeClr val="accent1"/>
-          </a:lnRef>
-          <a:fillRef idx="0">
-            <a:schemeClr val="accent1"/>
-          </a:fillRef>
-          <a:effectRef idx="0">
-            <a:schemeClr val="accent1"/>
-          </a:effectRef>
-          <a:fontRef idx="minor">
-            <a:schemeClr val="tx1"/>
-          </a:fontRef>
-        </p:style>
-      </p:cxnSp>
-      <p:cxnSp>
-        <p:nvCxnSpPr>
-          <p:cNvPr id="75" name="Arrow 75"/>
-          <p:cNvCxnSpPr/>
-          <p:nvPr/>
-        </p:nvCxnSpPr>
-        <p:spPr>
-          <a:xfrm>
-            <a:off x="8503920" y="3749039"/>
-            <a:ext cx="0" cy="164592"/>
-          </a:xfrm>
-          <a:prstGeom prst="line">
-            <a:avLst/>
-          </a:prstGeom>
-          <a:ln w="19050">
-            <a:solidFill>
-              <a:srgbClr val="52606C"/>
-            </a:solidFill>
-            <a:tailEnd type="triangle"/>
-          </a:ln>
-        </p:spPr>
-        <p:style>
-          <a:lnRef idx="1">
-            <a:schemeClr val="accent1"/>
-          </a:lnRef>
-          <a:fillRef idx="0">
-            <a:schemeClr val="accent1"/>
-          </a:fillRef>
-          <a:effectRef idx="0">
-            <a:schemeClr val="accent1"/>
-          </a:effectRef>
-          <a:fontRef idx="minor">
-            <a:schemeClr val="tx1"/>
-          </a:fontRef>
-        </p:style>
-      </p:cxnSp>
-      <p:sp>
-        <p:nvSpPr>
-          <p:cNvPr id="76" name="Text 76"/>
-          <p:cNvSpPr txBox="1"/>
-          <p:nvPr/>
-        </p:nvSpPr>
-        <p:spPr>
-          <a:xfrm>
-            <a:off x="896112" y="5166360"/>
-            <a:ext cx="9921240" cy="658368"/>
-          </a:xfrm>
-          <a:prstGeom prst="rect">
-            <a:avLst/>
-          </a:prstGeom>
-          <a:solidFill>
-            <a:srgbClr val="FFF7E0"/>
-          </a:solidFill>
-          <a:ln w="9525">
-            <a:solidFill>
-              <a:srgbClr val="CC9900"/>
-            </a:solidFill>
-          </a:ln>
-        </p:spPr>
-        <p:txBody>
-          <a:bodyPr wrap="square" lIns="91440" rIns="91440" tIns="45720" bIns="45720">
-            <a:normAutofit fontScale="85000" lnSpcReduction="20000"/>
-          </a:bodyPr>
-          <a:lstStyle/>
-          <a:p>
-            <a:pPr algn="l"/>
-            <a:r>
               <a:rPr lang="en-US" sz="1600" b="0">
                 <a:solidFill>
                   <a:srgbClr val="142030"/>
                 </a:solidFill>
                 <a:latin typeface="Aptos"/>
               </a:rPr>
-              <a:t>Presentation link: the mathematical model is explained in the slides; moving graphs are shown separately during the live demonstration.</a:t>
+              <a:t>Meaning of q</a:t>
+            </a:r>
+          </a:p>
+          <a:p>
+            <a:pPr algn="l"/>
+            <a:r>
+              <a:rPr lang="en-US" sz="1600" b="0">
+                <a:solidFill>
+                  <a:srgbClr val="142030"/>
+                </a:solidFill>
+                <a:latin typeface="Aptos"/>
+              </a:rPr>
+              <a:t>q = 1 gives the ordinary model. q &lt; 1 carries memory of past states.</a:t>
             </a:r>
           </a:p>
         </p:txBody>
@@ -5086,7 +5170,7 @@
       </p:grpSpPr>
       <p:sp>
         <p:nvSpPr>
-          <p:cNvPr id="78" name="Text 78"/>
+          <p:cNvPr id="72" name="Text 72"/>
           <p:cNvSpPr txBox="1"/>
           <p:nvPr/>
         </p:nvSpPr>
@@ -5117,14 +5201,14 @@
                 </a:solidFill>
                 <a:latin typeface="Aptos"/>
               </a:rPr>
-              <a:t>Baseline Simulation Result</a:t>
-            </a:r>
-          </a:p>
-        </p:txBody>
-      </p:sp>
-      <p:sp>
-        <p:nvSpPr>
-          <p:cNvPr id="79" name="Text 79"/>
+              <a:t>Numerical Scheme + Implementation</a:t>
+            </a:r>
+          </a:p>
+        </p:txBody>
+      </p:sp>
+      <p:sp>
+        <p:nvSpPr>
+          <p:cNvPr id="73" name="Text 73"/>
           <p:cNvSpPr txBox="1"/>
           <p:nvPr/>
         </p:nvSpPr>
@@ -5164,7 +5248,7 @@
       </p:sp>
       <p:sp>
         <p:nvSpPr>
-          <p:cNvPr id="80" name="Text 80"/>
+          <p:cNvPr id="74" name="Text 74"/>
           <p:cNvSpPr txBox="1"/>
           <p:nvPr/>
         </p:nvSpPr>
@@ -5202,38 +5286,16 @@
           </a:p>
         </p:txBody>
       </p:sp>
-      <p:pic>
-        <p:nvPicPr>
-          <p:cNvPr id="77" name="mainChartlinear.png"/>
-          <p:cNvPicPr/>
-          <p:nvPr/>
-        </p:nvPicPr>
-        <p:blipFill>
-          <a:blip r:embed="rId2"/>
-          <a:stretch>
-            <a:fillRect/>
-          </a:stretch>
-        </p:blipFill>
-        <p:spPr>
-          <a:xfrm>
-            <a:off x="640080" y="1261872"/>
-            <a:ext cx="6309360" cy="4251960"/>
-          </a:xfrm>
-          <a:prstGeom prst="rect">
-            <a:avLst/>
-          </a:prstGeom>
-        </p:spPr>
-      </p:pic>
-      <p:sp>
-        <p:nvSpPr>
-          <p:cNvPr id="81" name="Text 81"/>
-          <p:cNvSpPr txBox="1"/>
-          <p:nvPr/>
-        </p:nvSpPr>
-        <p:spPr>
-          <a:xfrm>
-            <a:off x="7360920" y="1234440"/>
-            <a:ext cx="3566160" cy="320040"/>
+      <p:sp>
+        <p:nvSpPr>
+          <p:cNvPr id="75" name="Text 75"/>
+          <p:cNvSpPr txBox="1"/>
+          <p:nvPr/>
+        </p:nvSpPr>
+        <p:spPr>
+          <a:xfrm>
+            <a:off x="658368" y="1234440"/>
+            <a:ext cx="4709160" cy="320040"/>
           </a:xfrm>
           <a:prstGeom prst="rect">
             <a:avLst/>
@@ -5257,21 +5319,21 @@
                 </a:solidFill>
                 <a:latin typeface="Aptos"/>
               </a:rPr>
-              <a:t>Computed baseline</a:t>
-            </a:r>
-          </a:p>
-        </p:txBody>
-      </p:sp>
-      <p:sp>
-        <p:nvSpPr>
-          <p:cNvPr id="82" name="Text 82"/>
-          <p:cNvSpPr txBox="1"/>
-          <p:nvPr/>
-        </p:nvSpPr>
-        <p:spPr>
-          <a:xfrm>
-            <a:off x="7406640" y="1627632"/>
-            <a:ext cx="3566160" cy="1234440"/>
+              <a:t>Numerical idea</a:t>
+            </a:r>
+          </a:p>
+        </p:txBody>
+      </p:sp>
+      <p:sp>
+        <p:nvSpPr>
+          <p:cNvPr id="76" name="Text 76"/>
+          <p:cNvSpPr txBox="1"/>
+          <p:nvPr/>
+        </p:nvSpPr>
+        <p:spPr>
+          <a:xfrm>
+            <a:off x="749808" y="1627632"/>
+            <a:ext cx="4937760" cy="2423160"/>
           </a:xfrm>
           <a:prstGeom prst="rect">
             <a:avLst/>
@@ -5292,13 +5354,13 @@
               <a:buFont typeface="Arial"/>
             </a:pPr>
             <a:r>
-              <a:rPr lang="en-US" sz="1500" b="0">
-                <a:solidFill>
-                  <a:srgbClr val="142030"/>
-                </a:solidFill>
-                <a:latin typeface="Aptos"/>
-              </a:rPr>
-              <a:t>R0 = 0.430, below the epidemic threshold.</a:t>
+              <a:rPr lang="en-US" sz="1800" b="0">
+                <a:solidFill>
+                  <a:srgbClr val="142030"/>
+                </a:solidFill>
+                <a:latin typeface="Aptos"/>
+              </a:rPr>
+              <a:t>Time interval is divided into discrete steps.</a:t>
             </a:r>
           </a:p>
           <a:p>
@@ -5307,13 +5369,13 @@
               <a:buFont typeface="Arial"/>
             </a:pPr>
             <a:r>
-              <a:rPr lang="en-US" sz="1500" b="0">
-                <a:solidFill>
-                  <a:srgbClr val="142030"/>
-                </a:solidFill>
-                <a:latin typeface="Aptos"/>
-              </a:rPr>
-              <a:t>Peak infected population is 150 at t = 0 years.</a:t>
+              <a:rPr lang="en-US" sz="1800" b="0">
+                <a:solidFill>
+                  <a:srgbClr val="142030"/>
+                </a:solidFill>
+                <a:latin typeface="Aptos"/>
+              </a:rPr>
+              <a:t>A predictor estimates the next state.</a:t>
             </a:r>
           </a:p>
           <a:p>
@@ -5322,27 +5384,96 @@
               <a:buFont typeface="Arial"/>
             </a:pPr>
             <a:r>
-              <a:rPr lang="en-US" sz="1500" b="0">
-                <a:solidFill>
-                  <a:srgbClr val="142030"/>
-                </a:solidFill>
-                <a:latin typeface="Aptos"/>
-              </a:rPr>
-              <a:t>Final values after 50 years: I = 3.1, T = 94.3, A = 3.6.</a:t>
-            </a:r>
-          </a:p>
-        </p:txBody>
-      </p:sp>
-      <p:sp>
-        <p:nvSpPr>
-          <p:cNvPr id="83" name="Text 83"/>
-          <p:cNvSpPr txBox="1"/>
-          <p:nvPr/>
-        </p:nvSpPr>
-        <p:spPr>
-          <a:xfrm>
-            <a:off x="7360920" y="3310128"/>
-            <a:ext cx="3657600" cy="1024128"/>
+              <a:rPr lang="en-US" sz="1800" b="0">
+                <a:solidFill>
+                  <a:srgbClr val="142030"/>
+                </a:solidFill>
+                <a:latin typeface="Aptos"/>
+              </a:rPr>
+              <a:t>A corrector updates the state using fractional-memory weights.</a:t>
+            </a:r>
+          </a:p>
+          <a:p>
+            <a:pPr algn="l">
+              <a:buChar char="•"/>
+              <a:buFont typeface="Arial"/>
+            </a:pPr>
+            <a:r>
+              <a:rPr lang="en-US" sz="1800" b="0">
+                <a:solidFill>
+                  <a:srgbClr val="142030"/>
+                </a:solidFill>
+                <a:latin typeface="Aptos"/>
+              </a:rPr>
+              <a:t>The same engine is used for baseline, memory, intervention, and sensitivity experiments.</a:t>
+            </a:r>
+          </a:p>
+        </p:txBody>
+      </p:sp>
+      <p:sp>
+        <p:nvSpPr>
+          <p:cNvPr id="77" name="Text 77"/>
+          <p:cNvSpPr txBox="1"/>
+          <p:nvPr/>
+        </p:nvSpPr>
+        <p:spPr>
+          <a:xfrm>
+            <a:off x="6355080" y="1170432"/>
+            <a:ext cx="4297680" cy="749808"/>
+          </a:xfrm>
+          <a:prstGeom prst="rect">
+            <a:avLst/>
+          </a:prstGeom>
+          <a:solidFill>
+            <a:srgbClr val="E8F2FA"/>
+          </a:solidFill>
+          <a:ln w="9525">
+            <a:solidFill>
+              <a:srgbClr val="004A80"/>
+            </a:solidFill>
+          </a:ln>
+        </p:spPr>
+        <p:txBody>
+          <a:bodyPr wrap="square" lIns="91440" rIns="91440" tIns="45720" bIns="45720">
+            <a:normAutofit fontScale="85000" lnSpcReduction="20000"/>
+          </a:bodyPr>
+          <a:lstStyle/>
+          <a:p>
+            <a:pPr algn="l"/>
+            <a:r>
+              <a:rPr lang="en-US" sz="1400" b="0">
+                <a:solidFill>
+                  <a:srgbClr val="142030"/>
+                </a:solidFill>
+                <a:latin typeface="Aptos"/>
+              </a:rPr>
+              <a:t>Inputs</a:t>
+            </a:r>
+          </a:p>
+          <a:p>
+            <a:pPr algn="l"/>
+            <a:r>
+              <a:rPr lang="en-US" sz="1400" b="0">
+                <a:solidFill>
+                  <a:srgbClr val="142030"/>
+                </a:solidFill>
+                <a:latin typeface="Aptos"/>
+              </a:rPr>
+              <a:t>parameters, initial conditions, q, controls</a:t>
+            </a:r>
+          </a:p>
+        </p:txBody>
+      </p:sp>
+      <p:sp>
+        <p:nvSpPr>
+          <p:cNvPr id="78" name="Text 78"/>
+          <p:cNvSpPr txBox="1"/>
+          <p:nvPr/>
+        </p:nvSpPr>
+        <p:spPr>
+          <a:xfrm>
+            <a:off x="6355080" y="2084831"/>
+            <a:ext cx="4297680" cy="749808"/>
           </a:xfrm>
           <a:prstGeom prst="rect">
             <a:avLst/>
@@ -5370,7 +5501,7 @@
                 </a:solidFill>
                 <a:latin typeface="Aptos"/>
               </a:rPr>
-              <a:t>Interpretation</a:t>
+              <a:t>Solver</a:t>
             </a:r>
           </a:p>
           <a:p>
@@ -5382,21 +5513,21 @@
                 </a:solidFill>
                 <a:latin typeface="Aptos"/>
               </a:rPr>
-              <a:t>The baseline intervention-adjusted configuration leads toward disease-free behaviour in the simulation.</a:t>
-            </a:r>
-          </a:p>
-        </p:txBody>
-      </p:sp>
-      <p:sp>
-        <p:nvSpPr>
-          <p:cNvPr id="84" name="Text 84"/>
-          <p:cNvSpPr txBox="1"/>
-          <p:nvPr/>
-        </p:nvSpPr>
-        <p:spPr>
-          <a:xfrm>
-            <a:off x="7360920" y="4645152"/>
-            <a:ext cx="3657600" cy="694944"/>
+              <a:t>fractional ABM-type numerical method</a:t>
+            </a:r>
+          </a:p>
+        </p:txBody>
+      </p:sp>
+      <p:sp>
+        <p:nvSpPr>
+          <p:cNvPr id="79" name="Text 79"/>
+          <p:cNvSpPr txBox="1"/>
+          <p:nvPr/>
+        </p:nvSpPr>
+        <p:spPr>
+          <a:xfrm>
+            <a:off x="6355080" y="2999232"/>
+            <a:ext cx="4297680" cy="749808"/>
           </a:xfrm>
           <a:prstGeom prst="rect">
             <a:avLst/>
@@ -5418,25 +5549,229 @@
           <a:p>
             <a:pPr algn="l"/>
             <a:r>
-              <a:rPr lang="en-US" sz="1300" b="0">
-                <a:solidFill>
-                  <a:srgbClr val="142030"/>
-                </a:solidFill>
-                <a:latin typeface="Aptos"/>
-              </a:rPr>
-              <a:t>Defense point</a:t>
-            </a:r>
-          </a:p>
-          <a:p>
-            <a:pPr algn="l"/>
-            <a:r>
-              <a:rPr lang="en-US" sz="1300" b="0">
-                <a:solidFill>
-                  <a:srgbClr val="142030"/>
-                </a:solidFill>
-                <a:latin typeface="Aptos"/>
-              </a:rPr>
-              <a:t>These numbers come from the Python simulation engine and match the dashboard summary table.</a:t>
+              <a:rPr lang="en-US" sz="1400" b="0">
+                <a:solidFill>
+                  <a:srgbClr val="142030"/>
+                </a:solidFill>
+                <a:latin typeface="Aptos"/>
+              </a:rPr>
+              <a:t>Outputs</a:t>
+            </a:r>
+          </a:p>
+          <a:p>
+            <a:pPr algn="l"/>
+            <a:r>
+              <a:rPr lang="en-US" sz="1400" b="0">
+                <a:solidFill>
+                  <a:srgbClr val="142030"/>
+                </a:solidFill>
+                <a:latin typeface="Aptos"/>
+              </a:rPr>
+              <a:t>trajectories, R0, scenarios, sensitivity</a:t>
+            </a:r>
+          </a:p>
+        </p:txBody>
+      </p:sp>
+      <p:sp>
+        <p:nvSpPr>
+          <p:cNvPr id="80" name="Text 80"/>
+          <p:cNvSpPr txBox="1"/>
+          <p:nvPr/>
+        </p:nvSpPr>
+        <p:spPr>
+          <a:xfrm>
+            <a:off x="6355080" y="3913632"/>
+            <a:ext cx="4297680" cy="749808"/>
+          </a:xfrm>
+          <a:prstGeom prst="rect">
+            <a:avLst/>
+          </a:prstGeom>
+          <a:solidFill>
+            <a:srgbClr val="FFFFFF"/>
+          </a:solidFill>
+          <a:ln w="9525">
+            <a:solidFill>
+              <a:srgbClr val="B44146"/>
+            </a:solidFill>
+          </a:ln>
+        </p:spPr>
+        <p:txBody>
+          <a:bodyPr wrap="square" lIns="91440" rIns="91440" tIns="45720" bIns="45720">
+            <a:normAutofit fontScale="85000" lnSpcReduction="20000"/>
+          </a:bodyPr>
+          <a:lstStyle/>
+          <a:p>
+            <a:pPr algn="l"/>
+            <a:r>
+              <a:rPr lang="en-US" sz="1400" b="0">
+                <a:solidFill>
+                  <a:srgbClr val="142030"/>
+                </a:solidFill>
+                <a:latin typeface="Aptos"/>
+              </a:rPr>
+              <a:t>Presentation</a:t>
+            </a:r>
+          </a:p>
+          <a:p>
+            <a:pPr algn="l"/>
+            <a:r>
+              <a:rPr lang="en-US" sz="1400" b="0">
+                <a:solidFill>
+                  <a:srgbClr val="142030"/>
+                </a:solidFill>
+                <a:latin typeface="Aptos"/>
+              </a:rPr>
+              <a:t>moving graphs during the live demo</a:t>
+            </a:r>
+          </a:p>
+        </p:txBody>
+      </p:sp>
+      <p:cxnSp>
+        <p:nvCxnSpPr>
+          <p:cNvPr id="81" name="Arrow 81"/>
+          <p:cNvCxnSpPr/>
+          <p:nvPr/>
+        </p:nvCxnSpPr>
+        <p:spPr>
+          <a:xfrm>
+            <a:off x="8503920" y="1920240"/>
+            <a:ext cx="0" cy="164591"/>
+          </a:xfrm>
+          <a:prstGeom prst="line">
+            <a:avLst/>
+          </a:prstGeom>
+          <a:ln w="19050">
+            <a:solidFill>
+              <a:srgbClr val="52606C"/>
+            </a:solidFill>
+            <a:tailEnd type="triangle"/>
+          </a:ln>
+        </p:spPr>
+        <p:style>
+          <a:lnRef idx="1">
+            <a:schemeClr val="accent1"/>
+          </a:lnRef>
+          <a:fillRef idx="0">
+            <a:schemeClr val="accent1"/>
+          </a:fillRef>
+          <a:effectRef idx="0">
+            <a:schemeClr val="accent1"/>
+          </a:effectRef>
+          <a:fontRef idx="minor">
+            <a:schemeClr val="tx1"/>
+          </a:fontRef>
+        </p:style>
+      </p:cxnSp>
+      <p:cxnSp>
+        <p:nvCxnSpPr>
+          <p:cNvPr id="82" name="Arrow 82"/>
+          <p:cNvCxnSpPr/>
+          <p:nvPr/>
+        </p:nvCxnSpPr>
+        <p:spPr>
+          <a:xfrm>
+            <a:off x="8503920" y="2834640"/>
+            <a:ext cx="0" cy="164591"/>
+          </a:xfrm>
+          <a:prstGeom prst="line">
+            <a:avLst/>
+          </a:prstGeom>
+          <a:ln w="19050">
+            <a:solidFill>
+              <a:srgbClr val="52606C"/>
+            </a:solidFill>
+            <a:tailEnd type="triangle"/>
+          </a:ln>
+        </p:spPr>
+        <p:style>
+          <a:lnRef idx="1">
+            <a:schemeClr val="accent1"/>
+          </a:lnRef>
+          <a:fillRef idx="0">
+            <a:schemeClr val="accent1"/>
+          </a:fillRef>
+          <a:effectRef idx="0">
+            <a:schemeClr val="accent1"/>
+          </a:effectRef>
+          <a:fontRef idx="minor">
+            <a:schemeClr val="tx1"/>
+          </a:fontRef>
+        </p:style>
+      </p:cxnSp>
+      <p:cxnSp>
+        <p:nvCxnSpPr>
+          <p:cNvPr id="83" name="Arrow 83"/>
+          <p:cNvCxnSpPr/>
+          <p:nvPr/>
+        </p:nvCxnSpPr>
+        <p:spPr>
+          <a:xfrm>
+            <a:off x="8503920" y="3749039"/>
+            <a:ext cx="0" cy="164592"/>
+          </a:xfrm>
+          <a:prstGeom prst="line">
+            <a:avLst/>
+          </a:prstGeom>
+          <a:ln w="19050">
+            <a:solidFill>
+              <a:srgbClr val="52606C"/>
+            </a:solidFill>
+            <a:tailEnd type="triangle"/>
+          </a:ln>
+        </p:spPr>
+        <p:style>
+          <a:lnRef idx="1">
+            <a:schemeClr val="accent1"/>
+          </a:lnRef>
+          <a:fillRef idx="0">
+            <a:schemeClr val="accent1"/>
+          </a:fillRef>
+          <a:effectRef idx="0">
+            <a:schemeClr val="accent1"/>
+          </a:effectRef>
+          <a:fontRef idx="minor">
+            <a:schemeClr val="tx1"/>
+          </a:fontRef>
+        </p:style>
+      </p:cxnSp>
+      <p:sp>
+        <p:nvSpPr>
+          <p:cNvPr id="84" name="Text 84"/>
+          <p:cNvSpPr txBox="1"/>
+          <p:nvPr/>
+        </p:nvSpPr>
+        <p:spPr>
+          <a:xfrm>
+            <a:off x="896112" y="5166360"/>
+            <a:ext cx="9921240" cy="658368"/>
+          </a:xfrm>
+          <a:prstGeom prst="rect">
+            <a:avLst/>
+          </a:prstGeom>
+          <a:solidFill>
+            <a:srgbClr val="FFF7E0"/>
+          </a:solidFill>
+          <a:ln w="9525">
+            <a:solidFill>
+              <a:srgbClr val="CC9900"/>
+            </a:solidFill>
+          </a:ln>
+        </p:spPr>
+        <p:txBody>
+          <a:bodyPr wrap="square" lIns="91440" rIns="91440" tIns="45720" bIns="45720">
+            <a:normAutofit fontScale="85000" lnSpcReduction="20000"/>
+          </a:bodyPr>
+          <a:lstStyle/>
+          <a:p>
+            <a:pPr algn="l"/>
+            <a:r>
+              <a:rPr lang="en-US" sz="1600" b="0">
+                <a:solidFill>
+                  <a:srgbClr val="142030"/>
+                </a:solidFill>
+                <a:latin typeface="Aptos"/>
+              </a:rPr>
+              <a:t>Presentation link: the mathematical model is explained in the slides; moving graphs are shown separately during the live demonstration.</a:t>
             </a:r>
           </a:p>
         </p:txBody>
@@ -5499,7 +5834,7 @@
                 </a:solidFill>
                 <a:latin typeface="Aptos"/>
               </a:rPr>
-              <a:t>Simulation Results: Intervention Comparison</a:t>
+              <a:t>Baseline Simulation Result</a:t>
             </a:r>
           </a:p>
         </p:txBody>
@@ -5586,7 +5921,7 @@
       </p:sp>
       <p:pic>
         <p:nvPicPr>
-          <p:cNvPr id="85" name="combinedInterventionsChart.png"/>
+          <p:cNvPr id="85" name="mainChartlinear.png"/>
           <p:cNvPicPr/>
           <p:nvPr/>
         </p:nvPicPr>
@@ -5598,8 +5933,8 @@
         </p:blipFill>
         <p:spPr>
           <a:xfrm>
-            <a:off x="658368" y="1298448"/>
-            <a:ext cx="6217920" cy="4206240"/>
+            <a:off x="640080" y="1261872"/>
+            <a:ext cx="6309360" cy="4251960"/>
           </a:xfrm>
           <a:prstGeom prst="rect">
             <a:avLst/>
@@ -5614,7 +5949,7 @@
         </p:nvSpPr>
         <p:spPr>
           <a:xfrm>
-            <a:off x="7360920" y="1325880"/>
+            <a:off x="7360920" y="1234440"/>
             <a:ext cx="3566160" cy="320040"/>
           </a:xfrm>
           <a:prstGeom prst="rect">
@@ -5639,7 +5974,7 @@
                 </a:solidFill>
                 <a:latin typeface="Aptos"/>
               </a:rPr>
-              <a:t>Main interpretation</a:t>
+              <a:t>Computed baseline</a:t>
             </a:r>
           </a:p>
         </p:txBody>
@@ -5652,8 +5987,8 @@
         </p:nvSpPr>
         <p:spPr>
           <a:xfrm>
-            <a:off x="7406640" y="1719072"/>
-            <a:ext cx="3520440" cy="1920240"/>
+            <a:off x="7406640" y="1627632"/>
+            <a:ext cx="3566160" cy="1234440"/>
           </a:xfrm>
           <a:prstGeom prst="rect">
             <a:avLst/>
@@ -5674,13 +6009,13 @@
               <a:buFont typeface="Arial"/>
             </a:pPr>
             <a:r>
-              <a:rPr lang="en-US" sz="1600" b="0">
-                <a:solidFill>
-                  <a:srgbClr val="142030"/>
-                </a:solidFill>
-                <a:latin typeface="Aptos"/>
-              </a:rPr>
-              <a:t>Single interventions help, but each targets only one mechanism.</a:t>
+              <a:rPr lang="en-US" sz="1500" b="0">
+                <a:solidFill>
+                  <a:srgbClr val="142030"/>
+                </a:solidFill>
+                <a:latin typeface="Aptos"/>
+              </a:rPr>
+              <a:t>R0 = 0.430, below the epidemic threshold.</a:t>
             </a:r>
           </a:p>
           <a:p>
@@ -5689,13 +6024,13 @@
               <a:buFont typeface="Arial"/>
             </a:pPr>
             <a:r>
-              <a:rPr lang="en-US" sz="1600" b="0">
-                <a:solidFill>
-                  <a:srgbClr val="142030"/>
-                </a:solidFill>
-                <a:latin typeface="Aptos"/>
-              </a:rPr>
-              <a:t>Combined intervention acts on transmission, treatment uptake, and progression.</a:t>
+              <a:rPr lang="en-US" sz="1500" b="0">
+                <a:solidFill>
+                  <a:srgbClr val="142030"/>
+                </a:solidFill>
+                <a:latin typeface="Aptos"/>
+              </a:rPr>
+              <a:t>Peak infected population is 150 at t = 0 years.</a:t>
             </a:r>
           </a:p>
           <a:p>
@@ -5704,13 +6039,13 @@
               <a:buFont typeface="Arial"/>
             </a:pPr>
             <a:r>
-              <a:rPr lang="en-US" sz="1600" b="0">
-                <a:solidFill>
-                  <a:srgbClr val="142030"/>
-                </a:solidFill>
-                <a:latin typeface="Aptos"/>
-              </a:rPr>
-              <a:t>The combined strategy gives stronger simulated control than isolated changes.</a:t>
+              <a:rPr lang="en-US" sz="1500" b="0">
+                <a:solidFill>
+                  <a:srgbClr val="142030"/>
+                </a:solidFill>
+                <a:latin typeface="Aptos"/>
+              </a:rPr>
+              <a:t>Final values after 50 years: I = 3.1, T = 94.3, A = 3.6.</a:t>
             </a:r>
           </a:p>
         </p:txBody>
@@ -5723,8 +6058,8 @@
         </p:nvSpPr>
         <p:spPr>
           <a:xfrm>
-            <a:off x="7360920" y="4133087"/>
-            <a:ext cx="3611880" cy="868680"/>
+            <a:off x="7360920" y="3310128"/>
+            <a:ext cx="3657600" cy="1024128"/>
           </a:xfrm>
           <a:prstGeom prst="rect">
             <a:avLst/>
@@ -5746,25 +6081,79 @@
           <a:p>
             <a:pPr algn="l"/>
             <a:r>
-              <a:rPr lang="en-US" sz="1500" b="0">
-                <a:solidFill>
-                  <a:srgbClr val="142030"/>
-                </a:solidFill>
-                <a:latin typeface="Aptos"/>
-              </a:rPr>
-              <a:t>Public-health meaning</a:t>
-            </a:r>
-          </a:p>
-          <a:p>
-            <a:pPr algn="l"/>
-            <a:r>
-              <a:rPr lang="en-US" sz="1500" b="0">
-                <a:solidFill>
-                  <a:srgbClr val="142030"/>
-                </a:solidFill>
-                <a:latin typeface="Aptos"/>
-              </a:rPr>
-              <a:t>Prevention and treatment support should work together.</a:t>
+              <a:rPr lang="en-US" sz="1400" b="0">
+                <a:solidFill>
+                  <a:srgbClr val="142030"/>
+                </a:solidFill>
+                <a:latin typeface="Aptos"/>
+              </a:rPr>
+              <a:t>Interpretation</a:t>
+            </a:r>
+          </a:p>
+          <a:p>
+            <a:pPr algn="l"/>
+            <a:r>
+              <a:rPr lang="en-US" sz="1400" b="0">
+                <a:solidFill>
+                  <a:srgbClr val="142030"/>
+                </a:solidFill>
+                <a:latin typeface="Aptos"/>
+              </a:rPr>
+              <a:t>The baseline intervention-adjusted configuration leads toward disease-free behaviour in the simulation.</a:t>
+            </a:r>
+          </a:p>
+        </p:txBody>
+      </p:sp>
+      <p:sp>
+        <p:nvSpPr>
+          <p:cNvPr id="92" name="Text 92"/>
+          <p:cNvSpPr txBox="1"/>
+          <p:nvPr/>
+        </p:nvSpPr>
+        <p:spPr>
+          <a:xfrm>
+            <a:off x="7360920" y="4645152"/>
+            <a:ext cx="3657600" cy="694944"/>
+          </a:xfrm>
+          <a:prstGeom prst="rect">
+            <a:avLst/>
+          </a:prstGeom>
+          <a:solidFill>
+            <a:srgbClr val="FFF7E0"/>
+          </a:solidFill>
+          <a:ln w="9525">
+            <a:solidFill>
+              <a:srgbClr val="CC9900"/>
+            </a:solidFill>
+          </a:ln>
+        </p:spPr>
+        <p:txBody>
+          <a:bodyPr wrap="square" lIns="91440" rIns="91440" tIns="45720" bIns="45720">
+            <a:normAutofit fontScale="85000" lnSpcReduction="20000"/>
+          </a:bodyPr>
+          <a:lstStyle/>
+          <a:p>
+            <a:pPr algn="l"/>
+            <a:r>
+              <a:rPr lang="en-US" sz="1300" b="0">
+                <a:solidFill>
+                  <a:srgbClr val="142030"/>
+                </a:solidFill>
+                <a:latin typeface="Aptos"/>
+              </a:rPr>
+              <a:t>Defense point</a:t>
+            </a:r>
+          </a:p>
+          <a:p>
+            <a:pPr algn="l"/>
+            <a:r>
+              <a:rPr lang="en-US" sz="1300" b="0">
+                <a:solidFill>
+                  <a:srgbClr val="142030"/>
+                </a:solidFill>
+                <a:latin typeface="Aptos"/>
+              </a:rPr>
+              <a:t>These numbers come from the Python simulation engine and match the dashboard summary table.</a:t>
             </a:r>
           </a:p>
         </p:txBody>

</xml_diff>

<commit_message>
Update FracHIV SITA presentation files to reflect recent revisions
</commit_message>
<xml_diff>
--- a/presentation/FracHIV_SITA_Presentation.pptx
+++ b/presentation/FracHIV_SITA_Presentation.pptx
@@ -2,7 +2,7 @@
 <file path=ppt/presentation.xml><?xml version="1.0" encoding="utf-8"?>
 <p:presentation xmlns:a="http://schemas.openxmlformats.org/drawingml/2006/main" xmlns:r="http://schemas.openxmlformats.org/officeDocument/2006/relationships" xmlns:p="http://schemas.openxmlformats.org/presentationml/2006/main">
   <p:sldMasterIdLst>
-    <p:sldMasterId id="2147483648" r:id="rId15"/>
+    <p:sldMasterId id="2147483648" r:id="rId16"/>
   </p:sldMasterIdLst>
   <p:sldIdLst>
     <p:sldId id="256" r:id="rId1"/>
@@ -19,6 +19,7 @@
     <p:sldId id="267" r:id="rId12"/>
     <p:sldId id="268" r:id="rId13"/>
     <p:sldId id="269" r:id="rId14"/>
+    <p:sldId id="270" r:id="rId15"/>
   </p:sldIdLst>
   <p:sldSz cx="12191999" cy="6858000" type="screen16x9"/>
   <p:notesSz cx="6858000" cy="9144000"/>
@@ -506,7 +507,7 @@
       </p:grpSpPr>
       <p:sp>
         <p:nvSpPr>
-          <p:cNvPr id="94" name="Text 94"/>
+          <p:cNvPr id="96" name="Text 96"/>
           <p:cNvSpPr txBox="1"/>
           <p:nvPr/>
         </p:nvSpPr>
@@ -537,14 +538,14 @@
                 </a:solidFill>
                 <a:latin typeface="Aptos"/>
               </a:rPr>
-              <a:t>Simulation Results: Intervention Comparison</a:t>
-            </a:r>
-          </a:p>
-        </p:txBody>
-      </p:sp>
-      <p:sp>
-        <p:nvSpPr>
-          <p:cNvPr id="95" name="Text 95"/>
+              <a:t>Baseline Simulation Result</a:t>
+            </a:r>
+          </a:p>
+        </p:txBody>
+      </p:sp>
+      <p:sp>
+        <p:nvSpPr>
+          <p:cNvPr id="97" name="Text 97"/>
           <p:cNvSpPr txBox="1"/>
           <p:nvPr/>
         </p:nvSpPr>
@@ -584,7 +585,7 @@
       </p:sp>
       <p:sp>
         <p:nvSpPr>
-          <p:cNvPr id="96" name="Text 96"/>
+          <p:cNvPr id="98" name="Text 98"/>
           <p:cNvSpPr txBox="1"/>
           <p:nvPr/>
         </p:nvSpPr>
@@ -624,7 +625,7 @@
       </p:sp>
       <p:pic>
         <p:nvPicPr>
-          <p:cNvPr id="93" name="combinedInterventionsChart.png"/>
+          <p:cNvPr id="95" name="mainChartlinear.png"/>
           <p:cNvPicPr/>
           <p:nvPr/>
         </p:nvPicPr>
@@ -636,8 +637,8 @@
         </p:blipFill>
         <p:spPr>
           <a:xfrm>
-            <a:off x="658368" y="1298448"/>
-            <a:ext cx="6217920" cy="4206240"/>
+            <a:off x="640080" y="1261872"/>
+            <a:ext cx="6309360" cy="4251960"/>
           </a:xfrm>
           <a:prstGeom prst="rect">
             <a:avLst/>
@@ -646,13 +647,13 @@
       </p:pic>
       <p:sp>
         <p:nvSpPr>
-          <p:cNvPr id="97" name="Text 97"/>
-          <p:cNvSpPr txBox="1"/>
-          <p:nvPr/>
-        </p:nvSpPr>
-        <p:spPr>
-          <a:xfrm>
-            <a:off x="7360920" y="1325880"/>
+          <p:cNvPr id="99" name="Text 99"/>
+          <p:cNvSpPr txBox="1"/>
+          <p:nvPr/>
+        </p:nvSpPr>
+        <p:spPr>
+          <a:xfrm>
+            <a:off x="7360920" y="1234440"/>
             <a:ext cx="3566160" cy="320040"/>
           </a:xfrm>
           <a:prstGeom prst="rect">
@@ -677,21 +678,21 @@
                 </a:solidFill>
                 <a:latin typeface="Aptos"/>
               </a:rPr>
-              <a:t>Main interpretation</a:t>
-            </a:r>
-          </a:p>
-        </p:txBody>
-      </p:sp>
-      <p:sp>
-        <p:nvSpPr>
-          <p:cNvPr id="98" name="Text 98"/>
-          <p:cNvSpPr txBox="1"/>
-          <p:nvPr/>
-        </p:nvSpPr>
-        <p:spPr>
-          <a:xfrm>
-            <a:off x="7406640" y="1719072"/>
-            <a:ext cx="3520440" cy="1920240"/>
+              <a:t>Computed baseline</a:t>
+            </a:r>
+          </a:p>
+        </p:txBody>
+      </p:sp>
+      <p:sp>
+        <p:nvSpPr>
+          <p:cNvPr id="100" name="Text 100"/>
+          <p:cNvSpPr txBox="1"/>
+          <p:nvPr/>
+        </p:nvSpPr>
+        <p:spPr>
+          <a:xfrm>
+            <a:off x="7406640" y="1627632"/>
+            <a:ext cx="3566160" cy="1234440"/>
           </a:xfrm>
           <a:prstGeom prst="rect">
             <a:avLst/>
@@ -712,13 +713,13 @@
               <a:buFont typeface="Arial"/>
             </a:pPr>
             <a:r>
-              <a:rPr lang="en-US" sz="1600" b="0">
-                <a:solidFill>
-                  <a:srgbClr val="142030"/>
-                </a:solidFill>
-                <a:latin typeface="Aptos"/>
-              </a:rPr>
-              <a:t>Single interventions help, but each targets only one mechanism.</a:t>
+              <a:rPr lang="en-US" sz="1500" b="0">
+                <a:solidFill>
+                  <a:srgbClr val="142030"/>
+                </a:solidFill>
+                <a:latin typeface="Aptos"/>
+              </a:rPr>
+              <a:t>R0 = 0.430, below the epidemic threshold.</a:t>
             </a:r>
           </a:p>
           <a:p>
@@ -727,13 +728,13 @@
               <a:buFont typeface="Arial"/>
             </a:pPr>
             <a:r>
-              <a:rPr lang="en-US" sz="1600" b="0">
-                <a:solidFill>
-                  <a:srgbClr val="142030"/>
-                </a:solidFill>
-                <a:latin typeface="Aptos"/>
-              </a:rPr>
-              <a:t>Combined intervention acts on transmission, treatment uptake, and progression.</a:t>
+              <a:rPr lang="en-US" sz="1500" b="0">
+                <a:solidFill>
+                  <a:srgbClr val="142030"/>
+                </a:solidFill>
+                <a:latin typeface="Aptos"/>
+              </a:rPr>
+              <a:t>Peak infected population is 150 at t = 0 years.</a:t>
             </a:r>
           </a:p>
           <a:p>
@@ -742,27 +743,27 @@
               <a:buFont typeface="Arial"/>
             </a:pPr>
             <a:r>
-              <a:rPr lang="en-US" sz="1600" b="0">
-                <a:solidFill>
-                  <a:srgbClr val="142030"/>
-                </a:solidFill>
-                <a:latin typeface="Aptos"/>
-              </a:rPr>
-              <a:t>The combined strategy gives stronger simulated control than isolated changes.</a:t>
-            </a:r>
-          </a:p>
-        </p:txBody>
-      </p:sp>
-      <p:sp>
-        <p:nvSpPr>
-          <p:cNvPr id="99" name="Text 99"/>
-          <p:cNvSpPr txBox="1"/>
-          <p:nvPr/>
-        </p:nvSpPr>
-        <p:spPr>
-          <a:xfrm>
-            <a:off x="7360920" y="4133087"/>
-            <a:ext cx="3611880" cy="868680"/>
+              <a:rPr lang="en-US" sz="1500" b="0">
+                <a:solidFill>
+                  <a:srgbClr val="142030"/>
+                </a:solidFill>
+                <a:latin typeface="Aptos"/>
+              </a:rPr>
+              <a:t>Final values after 50 years: I = 3.1, T = 94.3, A = 3.6.</a:t>
+            </a:r>
+          </a:p>
+        </p:txBody>
+      </p:sp>
+      <p:sp>
+        <p:nvSpPr>
+          <p:cNvPr id="101" name="Text 101"/>
+          <p:cNvSpPr txBox="1"/>
+          <p:nvPr/>
+        </p:nvSpPr>
+        <p:spPr>
+          <a:xfrm>
+            <a:off x="7360920" y="3310128"/>
+            <a:ext cx="3657600" cy="1024128"/>
           </a:xfrm>
           <a:prstGeom prst="rect">
             <a:avLst/>
@@ -784,25 +785,79 @@
           <a:p>
             <a:pPr algn="l"/>
             <a:r>
-              <a:rPr lang="en-US" sz="1500" b="0">
-                <a:solidFill>
-                  <a:srgbClr val="142030"/>
-                </a:solidFill>
-                <a:latin typeface="Aptos"/>
-              </a:rPr>
-              <a:t>Public-health meaning</a:t>
-            </a:r>
-          </a:p>
-          <a:p>
-            <a:pPr algn="l"/>
-            <a:r>
-              <a:rPr lang="en-US" sz="1500" b="0">
-                <a:solidFill>
-                  <a:srgbClr val="142030"/>
-                </a:solidFill>
-                <a:latin typeface="Aptos"/>
-              </a:rPr>
-              <a:t>Prevention and treatment support should work together.</a:t>
+              <a:rPr lang="en-US" sz="1400" b="0">
+                <a:solidFill>
+                  <a:srgbClr val="142030"/>
+                </a:solidFill>
+                <a:latin typeface="Aptos"/>
+              </a:rPr>
+              <a:t>Interpretation</a:t>
+            </a:r>
+          </a:p>
+          <a:p>
+            <a:pPr algn="l"/>
+            <a:r>
+              <a:rPr lang="en-US" sz="1400" b="0">
+                <a:solidFill>
+                  <a:srgbClr val="142030"/>
+                </a:solidFill>
+                <a:latin typeface="Aptos"/>
+              </a:rPr>
+              <a:t>The baseline intervention-adjusted configuration leads toward disease-free behaviour in the simulation.</a:t>
+            </a:r>
+          </a:p>
+        </p:txBody>
+      </p:sp>
+      <p:sp>
+        <p:nvSpPr>
+          <p:cNvPr id="102" name="Text 102"/>
+          <p:cNvSpPr txBox="1"/>
+          <p:nvPr/>
+        </p:nvSpPr>
+        <p:spPr>
+          <a:xfrm>
+            <a:off x="7360920" y="4645152"/>
+            <a:ext cx="3657600" cy="694944"/>
+          </a:xfrm>
+          <a:prstGeom prst="rect">
+            <a:avLst/>
+          </a:prstGeom>
+          <a:solidFill>
+            <a:srgbClr val="FFF7E0"/>
+          </a:solidFill>
+          <a:ln w="9525">
+            <a:solidFill>
+              <a:srgbClr val="CC9900"/>
+            </a:solidFill>
+          </a:ln>
+        </p:spPr>
+        <p:txBody>
+          <a:bodyPr wrap="square" lIns="91440" rIns="91440" tIns="45720" bIns="45720">
+            <a:normAutofit fontScale="85000" lnSpcReduction="20000"/>
+          </a:bodyPr>
+          <a:lstStyle/>
+          <a:p>
+            <a:pPr algn="l"/>
+            <a:r>
+              <a:rPr lang="en-US" sz="1300" b="0">
+                <a:solidFill>
+                  <a:srgbClr val="142030"/>
+                </a:solidFill>
+                <a:latin typeface="Aptos"/>
+              </a:rPr>
+              <a:t>Defense point</a:t>
+            </a:r>
+          </a:p>
+          <a:p>
+            <a:pPr algn="l"/>
+            <a:r>
+              <a:rPr lang="en-US" sz="1300" b="0">
+                <a:solidFill>
+                  <a:srgbClr val="142030"/>
+                </a:solidFill>
+                <a:latin typeface="Aptos"/>
+              </a:rPr>
+              <a:t>These numbers come from the Python simulation engine and match the dashboard summary table.</a:t>
             </a:r>
           </a:p>
         </p:txBody>
@@ -834,7 +889,7 @@
       </p:grpSpPr>
       <p:sp>
         <p:nvSpPr>
-          <p:cNvPr id="101" name="Text 101"/>
+          <p:cNvPr id="104" name="Text 104"/>
           <p:cNvSpPr txBox="1"/>
           <p:nvPr/>
         </p:nvSpPr>
@@ -865,14 +920,14 @@
                 </a:solidFill>
                 <a:latin typeface="Aptos"/>
               </a:rPr>
-              <a:t>Simulation Results: Fractional Memory</a:t>
-            </a:r>
-          </a:p>
-        </p:txBody>
-      </p:sp>
-      <p:sp>
-        <p:nvSpPr>
-          <p:cNvPr id="102" name="Text 102"/>
+              <a:t>Simulation Results: Intervention Comparison</a:t>
+            </a:r>
+          </a:p>
+        </p:txBody>
+      </p:sp>
+      <p:sp>
+        <p:nvSpPr>
+          <p:cNvPr id="105" name="Text 105"/>
           <p:cNvSpPr txBox="1"/>
           <p:nvPr/>
         </p:nvSpPr>
@@ -912,7 +967,7 @@
       </p:sp>
       <p:sp>
         <p:nvSpPr>
-          <p:cNvPr id="103" name="Text 103"/>
+          <p:cNvPr id="106" name="Text 106"/>
           <p:cNvSpPr txBox="1"/>
           <p:nvPr/>
         </p:nvSpPr>
@@ -952,7 +1007,7 @@
       </p:sp>
       <p:pic>
         <p:nvPicPr>
-          <p:cNvPr id="100" name="memoryChart.png"/>
+          <p:cNvPr id="103" name="combinedInterventionsChart.png"/>
           <p:cNvPicPr/>
           <p:nvPr/>
         </p:nvPicPr>
@@ -974,7 +1029,7 @@
       </p:pic>
       <p:sp>
         <p:nvSpPr>
-          <p:cNvPr id="104" name="Text 104"/>
+          <p:cNvPr id="107" name="Text 107"/>
           <p:cNvSpPr txBox="1"/>
           <p:nvPr/>
         </p:nvSpPr>
@@ -1005,21 +1060,21 @@
                 </a:solidFill>
                 <a:latin typeface="Aptos"/>
               </a:rPr>
-              <a:t>Why q matters</a:t>
-            </a:r>
-          </a:p>
-        </p:txBody>
-      </p:sp>
-      <p:sp>
-        <p:nvSpPr>
-          <p:cNvPr id="105" name="Text 105"/>
+              <a:t>Main interpretation</a:t>
+            </a:r>
+          </a:p>
+        </p:txBody>
+      </p:sp>
+      <p:sp>
+        <p:nvSpPr>
+          <p:cNvPr id="108" name="Text 108"/>
           <p:cNvSpPr txBox="1"/>
           <p:nvPr/>
         </p:nvSpPr>
         <p:spPr>
           <a:xfrm>
             <a:off x="7406640" y="1719072"/>
-            <a:ext cx="3520440" cy="1691640"/>
+            <a:ext cx="3520440" cy="1920240"/>
           </a:xfrm>
           <a:prstGeom prst="rect">
             <a:avLst/>
@@ -1046,7 +1101,7 @@
                 </a:solidFill>
                 <a:latin typeface="Aptos"/>
               </a:rPr>
-              <a:t>q = 1 represents the ordinary model.</a:t>
+              <a:t>Single interventions help, but each targets only one mechanism.</a:t>
             </a:r>
           </a:p>
           <a:p>
@@ -1061,7 +1116,7 @@
                 </a:solidFill>
                 <a:latin typeface="Aptos"/>
               </a:rPr>
-              <a:t>Smaller q values strengthen the memory effect.</a:t>
+              <a:t>Combined intervention acts on transmission, treatment uptake, and progression.</a:t>
             </a:r>
           </a:p>
           <a:p>
@@ -1076,31 +1131,31 @@
                 </a:solidFill>
                 <a:latin typeface="Aptos"/>
               </a:rPr>
-              <a:t>Different q values produce visibly different trajectories.</a:t>
-            </a:r>
-          </a:p>
-        </p:txBody>
-      </p:sp>
-      <p:sp>
-        <p:nvSpPr>
-          <p:cNvPr id="106" name="Text 106"/>
-          <p:cNvSpPr txBox="1"/>
-          <p:nvPr/>
-        </p:nvSpPr>
-        <p:spPr>
-          <a:xfrm>
-            <a:off x="7360920" y="4005072"/>
-            <a:ext cx="3611880" cy="914400"/>
+              <a:t>The combined strategy gives stronger simulated control than isolated changes.</a:t>
+            </a:r>
+          </a:p>
+        </p:txBody>
+      </p:sp>
+      <p:sp>
+        <p:nvSpPr>
+          <p:cNvPr id="109" name="Text 109"/>
+          <p:cNvSpPr txBox="1"/>
+          <p:nvPr/>
+        </p:nvSpPr>
+        <p:spPr>
+          <a:xfrm>
+            <a:off x="7360920" y="4133087"/>
+            <a:ext cx="3611880" cy="868680"/>
           </a:xfrm>
           <a:prstGeom prst="rect">
             <a:avLst/>
           </a:prstGeom>
           <a:solidFill>
-            <a:srgbClr val="FFF7E0"/>
+            <a:srgbClr val="E6F7F4"/>
           </a:solidFill>
           <a:ln w="9525">
             <a:solidFill>
-              <a:srgbClr val="CC9900"/>
+              <a:srgbClr val="007E70"/>
             </a:solidFill>
           </a:ln>
         </p:spPr>
@@ -1118,7 +1173,7 @@
                 </a:solidFill>
                 <a:latin typeface="Aptos"/>
               </a:rPr>
-              <a:t>Defense point</a:t>
+              <a:t>Public-health meaning</a:t>
             </a:r>
           </a:p>
           <a:p>
@@ -1130,7 +1185,7 @@
                 </a:solidFill>
                 <a:latin typeface="Aptos"/>
               </a:rPr>
-              <a:t>Fractional calculus is not decorative; it changes the simulated dynamics.</a:t>
+              <a:t>Prevention and treatment support should work together.</a:t>
             </a:r>
           </a:p>
         </p:txBody>
@@ -1162,7 +1217,7 @@
       </p:grpSpPr>
       <p:sp>
         <p:nvSpPr>
-          <p:cNvPr id="109" name="Text 109"/>
+          <p:cNvPr id="111" name="Text 111"/>
           <p:cNvSpPr txBox="1"/>
           <p:nvPr/>
         </p:nvSpPr>
@@ -1193,14 +1248,14 @@
                 </a:solidFill>
                 <a:latin typeface="Aptos"/>
               </a:rPr>
-              <a:t>Dashboard and Sensitivity Evidence</a:t>
-            </a:r>
-          </a:p>
-        </p:txBody>
-      </p:sp>
-      <p:sp>
-        <p:nvSpPr>
-          <p:cNvPr id="110" name="Text 110"/>
+              <a:t>Simulation Results: Fractional Memory</a:t>
+            </a:r>
+          </a:p>
+        </p:txBody>
+      </p:sp>
+      <p:sp>
+        <p:nvSpPr>
+          <p:cNvPr id="112" name="Text 112"/>
           <p:cNvSpPr txBox="1"/>
           <p:nvPr/>
         </p:nvSpPr>
@@ -1240,7 +1295,7 @@
       </p:sp>
       <p:sp>
         <p:nvSpPr>
-          <p:cNvPr id="111" name="Text 111"/>
+          <p:cNvPr id="113" name="Text 113"/>
           <p:cNvSpPr txBox="1"/>
           <p:nvPr/>
         </p:nvSpPr>
@@ -1280,7 +1335,7 @@
       </p:sp>
       <p:pic>
         <p:nvPicPr>
-          <p:cNvPr id="107" name="sensitivityChart.png"/>
+          <p:cNvPr id="110" name="memoryChart.png"/>
           <p:cNvPicPr/>
           <p:nvPr/>
         </p:nvPicPr>
@@ -1302,7 +1357,7 @@
       </p:pic>
       <p:sp>
         <p:nvSpPr>
-          <p:cNvPr id="112" name="Text 112"/>
+          <p:cNvPr id="114" name="Text 114"/>
           <p:cNvSpPr txBox="1"/>
           <p:nvPr/>
         </p:nvSpPr>
@@ -1333,21 +1388,21 @@
                 </a:solidFill>
                 <a:latin typeface="Aptos"/>
               </a:rPr>
-              <a:t>Main evidence</a:t>
-            </a:r>
-          </a:p>
-        </p:txBody>
-      </p:sp>
-      <p:sp>
-        <p:nvSpPr>
-          <p:cNvPr id="113" name="Text 113"/>
+              <a:t>Why q matters</a:t>
+            </a:r>
+          </a:p>
+        </p:txBody>
+      </p:sp>
+      <p:sp>
+        <p:nvSpPr>
+          <p:cNvPr id="115" name="Text 115"/>
           <p:cNvSpPr txBox="1"/>
           <p:nvPr/>
         </p:nvSpPr>
         <p:spPr>
           <a:xfrm>
             <a:off x="7406640" y="1719072"/>
-            <a:ext cx="3520440" cy="1600200"/>
+            <a:ext cx="3520440" cy="1691640"/>
           </a:xfrm>
           <a:prstGeom prst="rect">
             <a:avLst/>
@@ -1368,13 +1423,13 @@
               <a:buFont typeface="Arial"/>
             </a:pPr>
             <a:r>
-              <a:rPr lang="en-US" sz="1500" b="0">
-                <a:solidFill>
-                  <a:srgbClr val="142030"/>
-                </a:solidFill>
-                <a:latin typeface="Aptos"/>
-              </a:rPr>
-              <a:t>Transmission-related quantities dominate R0 sensitivity.</a:t>
+              <a:rPr lang="en-US" sz="1600" b="0">
+                <a:solidFill>
+                  <a:srgbClr val="142030"/>
+                </a:solidFill>
+                <a:latin typeface="Aptos"/>
+              </a:rPr>
+              <a:t>q = 1 represents the ordinary model.</a:t>
             </a:r>
           </a:p>
           <a:p>
@@ -1383,13 +1438,13 @@
               <a:buFont typeface="Arial"/>
             </a:pPr>
             <a:r>
-              <a:rPr lang="en-US" sz="1500" b="0">
-                <a:solidFill>
-                  <a:srgbClr val="142030"/>
-                </a:solidFill>
-                <a:latin typeface="Aptos"/>
-              </a:rPr>
-              <a:t>Safer behaviour and awareness reduce R0 strongly.</a:t>
+              <a:rPr lang="en-US" sz="1600" b="0">
+                <a:solidFill>
+                  <a:srgbClr val="142030"/>
+                </a:solidFill>
+                <a:latin typeface="Aptos"/>
+              </a:rPr>
+              <a:t>Smaller q values strengthen the memory effect.</a:t>
             </a:r>
           </a:p>
           <a:p>
@@ -1398,39 +1453,71 @@
               <a:buFont typeface="Arial"/>
             </a:pPr>
             <a:r>
+              <a:rPr lang="en-US" sz="1600" b="0">
+                <a:solidFill>
+                  <a:srgbClr val="142030"/>
+                </a:solidFill>
+                <a:latin typeface="Aptos"/>
+              </a:rPr>
+              <a:t>Different q values produce visibly different trajectories.</a:t>
+            </a:r>
+          </a:p>
+        </p:txBody>
+      </p:sp>
+      <p:sp>
+        <p:nvSpPr>
+          <p:cNvPr id="116" name="Text 116"/>
+          <p:cNvSpPr txBox="1"/>
+          <p:nvPr/>
+        </p:nvSpPr>
+        <p:spPr>
+          <a:xfrm>
+            <a:off x="7360920" y="4005072"/>
+            <a:ext cx="3611880" cy="914400"/>
+          </a:xfrm>
+          <a:prstGeom prst="rect">
+            <a:avLst/>
+          </a:prstGeom>
+          <a:solidFill>
+            <a:srgbClr val="FFF7E0"/>
+          </a:solidFill>
+          <a:ln w="9525">
+            <a:solidFill>
+              <a:srgbClr val="CC9900"/>
+            </a:solidFill>
+          </a:ln>
+        </p:spPr>
+        <p:txBody>
+          <a:bodyPr wrap="square" lIns="91440" rIns="91440" tIns="45720" bIns="45720">
+            <a:normAutofit fontScale="85000" lnSpcReduction="20000"/>
+          </a:bodyPr>
+          <a:lstStyle/>
+          <a:p>
+            <a:pPr algn="l"/>
+            <a:r>
               <a:rPr lang="en-US" sz="1500" b="0">
                 <a:solidFill>
                   <a:srgbClr val="142030"/>
                 </a:solidFill>
                 <a:latin typeface="Aptos"/>
               </a:rPr>
-              <a:t>Dashboard outputs support thesis discussion and live defense.</a:t>
-            </a:r>
-          </a:p>
-        </p:txBody>
-      </p:sp>
-      <p:pic>
-        <p:nvPicPr>
-          <p:cNvPr id="108" name="dashboardBaselineFigure.png"/>
-          <p:cNvPicPr/>
-          <p:nvPr/>
-        </p:nvPicPr>
-        <p:blipFill>
-          <a:blip r:embed="rId3"/>
-          <a:stretch>
-            <a:fillRect/>
-          </a:stretch>
-        </p:blipFill>
-        <p:spPr>
-          <a:xfrm>
-            <a:off x="7406640" y="3767328"/>
-            <a:ext cx="3383280" cy="1627632"/>
-          </a:xfrm>
-          <a:prstGeom prst="rect">
-            <a:avLst/>
-          </a:prstGeom>
-        </p:spPr>
-      </p:pic>
+              <a:t>Defense point</a:t>
+            </a:r>
+          </a:p>
+          <a:p>
+            <a:pPr algn="l"/>
+            <a:r>
+              <a:rPr lang="en-US" sz="1500" b="0">
+                <a:solidFill>
+                  <a:srgbClr val="142030"/>
+                </a:solidFill>
+                <a:latin typeface="Aptos"/>
+              </a:rPr>
+              <a:t>Fractional calculus is not decorative; it changes the simulated dynamics.</a:t>
+            </a:r>
+          </a:p>
+        </p:txBody>
+      </p:sp>
     </p:spTree>
   </p:cSld>
   <p:clrMapOvr>
@@ -1458,7 +1545,7 @@
       </p:grpSpPr>
       <p:sp>
         <p:nvSpPr>
-          <p:cNvPr id="115" name="Text 115"/>
+          <p:cNvPr id="119" name="Text 119"/>
           <p:cNvSpPr txBox="1"/>
           <p:nvPr/>
         </p:nvSpPr>
@@ -1489,14 +1576,14 @@
                 </a:solidFill>
                 <a:latin typeface="Aptos"/>
               </a:rPr>
-              <a:t>Live Dashboard Demonstration</a:t>
-            </a:r>
-          </a:p>
-        </p:txBody>
-      </p:sp>
-      <p:sp>
-        <p:nvSpPr>
-          <p:cNvPr id="116" name="Text 116"/>
+              <a:t>Dashboard and Sensitivity Evidence</a:t>
+            </a:r>
+          </a:p>
+        </p:txBody>
+      </p:sp>
+      <p:sp>
+        <p:nvSpPr>
+          <p:cNvPr id="120" name="Text 120"/>
           <p:cNvSpPr txBox="1"/>
           <p:nvPr/>
         </p:nvSpPr>
@@ -1536,7 +1623,7 @@
       </p:sp>
       <p:sp>
         <p:nvSpPr>
-          <p:cNvPr id="117" name="Text 117"/>
+          <p:cNvPr id="121" name="Text 121"/>
           <p:cNvSpPr txBox="1"/>
           <p:nvPr/>
         </p:nvSpPr>
@@ -1574,187 +1661,9 @@
           </a:p>
         </p:txBody>
       </p:sp>
-      <p:sp>
-        <p:nvSpPr>
-          <p:cNvPr id="118" name="Text 118"/>
-          <p:cNvSpPr txBox="1"/>
-          <p:nvPr/>
-        </p:nvSpPr>
-        <p:spPr>
-          <a:xfrm>
-            <a:off x="658368" y="1234440"/>
-            <a:ext cx="5074920" cy="320040"/>
-          </a:xfrm>
-          <a:prstGeom prst="rect">
-            <a:avLst/>
-          </a:prstGeom>
-          <a:noFill/>
-          <a:ln>
-            <a:noFill/>
-          </a:ln>
-        </p:spPr>
-        <p:txBody>
-          <a:bodyPr wrap="square" lIns="91440" rIns="91440" tIns="45720" bIns="45720">
-            <a:normAutofit fontScale="85000" lnSpcReduction="20000"/>
-          </a:bodyPr>
-          <a:lstStyle/>
-          <a:p>
-            <a:pPr algn="l"/>
-            <a:r>
-              <a:rPr lang="en-US" sz="1500" b="1">
-                <a:solidFill>
-                  <a:srgbClr val="CC9900"/>
-                </a:solidFill>
-                <a:latin typeface="Aptos"/>
-              </a:rPr>
-              <a:t>Open during the defense</a:t>
-            </a:r>
-          </a:p>
-        </p:txBody>
-      </p:sp>
-      <p:sp>
-        <p:nvSpPr>
-          <p:cNvPr id="119" name="Text 119"/>
-          <p:cNvSpPr txBox="1"/>
-          <p:nvPr/>
-        </p:nvSpPr>
-        <p:spPr>
-          <a:xfrm>
-            <a:off x="749808" y="1664208"/>
-            <a:ext cx="5029200" cy="731520"/>
-          </a:xfrm>
-          <a:prstGeom prst="rect">
-            <a:avLst/>
-          </a:prstGeom>
-          <a:solidFill>
-            <a:srgbClr val="E8F2FA"/>
-          </a:solidFill>
-          <a:ln w="9525">
-            <a:solidFill>
-              <a:srgbClr val="004A80"/>
-            </a:solidFill>
-          </a:ln>
-        </p:spPr>
-        <p:txBody>
-          <a:bodyPr wrap="square" lIns="91440" rIns="91440" tIns="45720" bIns="45720">
-            <a:normAutofit fontScale="85000" lnSpcReduction="20000"/>
-          </a:bodyPr>
-          <a:lstStyle/>
-          <a:p>
-            <a:pPr algn="l"/>
-            <a:r>
-              <a:rPr lang="en-US" sz="1800" b="0">
-                <a:solidFill>
-                  <a:srgbClr val="142030"/>
-                </a:solidFill>
-                <a:latin typeface="Aptos"/>
-              </a:rPr>
-              <a:t>Dashboard link</a:t>
-            </a:r>
-          </a:p>
-          <a:p>
-            <a:pPr algn="l"/>
-            <a:r>
-              <a:rPr lang="en-US" sz="1800" b="0">
-                <a:solidFill>
-                  <a:srgbClr val="142030"/>
-                </a:solidFill>
-                <a:latin typeface="Aptos"/>
-              </a:rPr>
-              <a:t>https://hiv-model.onrender.com/</a:t>
-            </a:r>
-          </a:p>
-        </p:txBody>
-      </p:sp>
-      <p:sp>
-        <p:nvSpPr>
-          <p:cNvPr id="120" name="Text 120"/>
-          <p:cNvSpPr txBox="1"/>
-          <p:nvPr/>
-        </p:nvSpPr>
-        <p:spPr>
-          <a:xfrm>
-            <a:off x="768096" y="2788920"/>
-            <a:ext cx="5120640" cy="1645920"/>
-          </a:xfrm>
-          <a:prstGeom prst="rect">
-            <a:avLst/>
-          </a:prstGeom>
-          <a:noFill/>
-          <a:ln>
-            <a:noFill/>
-          </a:ln>
-        </p:spPr>
-        <p:txBody>
-          <a:bodyPr wrap="square" lIns="91440" rIns="91440" tIns="45720" bIns="45720">
-            <a:normAutofit fontScale="85000" lnSpcReduction="20000"/>
-          </a:bodyPr>
-          <a:lstStyle/>
-          <a:p>
-            <a:pPr algn="l">
-              <a:buChar char="•"/>
-              <a:buFont typeface="Arial"/>
-            </a:pPr>
-            <a:r>
-              <a:rPr lang="en-US" sz="1600" b="0">
-                <a:solidFill>
-                  <a:srgbClr val="142030"/>
-                </a:solidFill>
-                <a:latin typeface="Aptos"/>
-              </a:rPr>
-              <a:t>Run the baseline simulation.</a:t>
-            </a:r>
-          </a:p>
-          <a:p>
-            <a:pPr algn="l">
-              <a:buChar char="•"/>
-              <a:buFont typeface="Arial"/>
-            </a:pPr>
-            <a:r>
-              <a:rPr lang="en-US" sz="1600" b="0">
-                <a:solidFill>
-                  <a:srgbClr val="142030"/>
-                </a:solidFill>
-                <a:latin typeface="Aptos"/>
-              </a:rPr>
-              <a:t>Show the final state summary and interpretation.</a:t>
-            </a:r>
-          </a:p>
-          <a:p>
-            <a:pPr algn="l">
-              <a:buChar char="•"/>
-              <a:buFont typeface="Arial"/>
-            </a:pPr>
-            <a:r>
-              <a:rPr lang="en-US" sz="1600" b="0">
-                <a:solidFill>
-                  <a:srgbClr val="142030"/>
-                </a:solidFill>
-                <a:latin typeface="Aptos"/>
-              </a:rPr>
-              <a:t>Compare no intervention with combined intervention.</a:t>
-            </a:r>
-          </a:p>
-          <a:p>
-            <a:pPr algn="l">
-              <a:buChar char="•"/>
-              <a:buFont typeface="Arial"/>
-            </a:pPr>
-            <a:r>
-              <a:rPr lang="en-US" sz="1600" b="0">
-                <a:solidFill>
-                  <a:srgbClr val="142030"/>
-                </a:solidFill>
-                <a:latin typeface="Aptos"/>
-              </a:rPr>
-              <a:t>Change q to show the fractional memory effect.</a:t>
-            </a:r>
-          </a:p>
-        </p:txBody>
-      </p:sp>
       <p:pic>
         <p:nvPicPr>
-          <p:cNvPr id="114" name="dashboardBaselineFigure.png"/>
+          <p:cNvPr id="117" name="sensitivityChart.png"/>
           <p:cNvPicPr/>
           <p:nvPr/>
         </p:nvPicPr>
@@ -1766,8 +1675,8 @@
         </p:blipFill>
         <p:spPr>
           <a:xfrm>
-            <a:off x="6583680" y="1417320"/>
-            <a:ext cx="4297680" cy="2331720"/>
+            <a:off x="658368" y="1298448"/>
+            <a:ext cx="6217920" cy="4206240"/>
           </a:xfrm>
           <a:prstGeom prst="rect">
             <a:avLst/>
@@ -1776,34 +1685,71 @@
       </p:pic>
       <p:sp>
         <p:nvSpPr>
-          <p:cNvPr id="121" name="Text 121"/>
-          <p:cNvSpPr txBox="1"/>
-          <p:nvPr/>
-        </p:nvSpPr>
-        <p:spPr>
-          <a:xfrm>
-            <a:off x="6601968" y="4160520"/>
-            <a:ext cx="4297680" cy="822960"/>
-          </a:xfrm>
-          <a:prstGeom prst="rect">
-            <a:avLst/>
-          </a:prstGeom>
-          <a:solidFill>
-            <a:srgbClr val="FFF7E0"/>
-          </a:solidFill>
-          <a:ln w="9525">
-            <a:solidFill>
-              <a:srgbClr val="CC9900"/>
-            </a:solidFill>
-          </a:ln>
-        </p:spPr>
-        <p:txBody>
-          <a:bodyPr wrap="square" lIns="91440" rIns="91440" tIns="45720" bIns="45720">
-            <a:normAutofit fontScale="85000" lnSpcReduction="20000"/>
-          </a:bodyPr>
-          <a:lstStyle/>
-          <a:p>
-            <a:pPr algn="l"/>
+          <p:cNvPr id="122" name="Text 122"/>
+          <p:cNvSpPr txBox="1"/>
+          <p:nvPr/>
+        </p:nvSpPr>
+        <p:spPr>
+          <a:xfrm>
+            <a:off x="7360920" y="1325880"/>
+            <a:ext cx="3566160" cy="320040"/>
+          </a:xfrm>
+          <a:prstGeom prst="rect">
+            <a:avLst/>
+          </a:prstGeom>
+          <a:noFill/>
+          <a:ln>
+            <a:noFill/>
+          </a:ln>
+        </p:spPr>
+        <p:txBody>
+          <a:bodyPr wrap="square" lIns="91440" rIns="91440" tIns="45720" bIns="45720">
+            <a:normAutofit fontScale="85000" lnSpcReduction="20000"/>
+          </a:bodyPr>
+          <a:lstStyle/>
+          <a:p>
+            <a:pPr algn="l"/>
+            <a:r>
+              <a:rPr lang="en-US" sz="1500" b="1">
+                <a:solidFill>
+                  <a:srgbClr val="CC9900"/>
+                </a:solidFill>
+                <a:latin typeface="Aptos"/>
+              </a:rPr>
+              <a:t>Main evidence</a:t>
+            </a:r>
+          </a:p>
+        </p:txBody>
+      </p:sp>
+      <p:sp>
+        <p:nvSpPr>
+          <p:cNvPr id="123" name="Text 123"/>
+          <p:cNvSpPr txBox="1"/>
+          <p:nvPr/>
+        </p:nvSpPr>
+        <p:spPr>
+          <a:xfrm>
+            <a:off x="7406640" y="1719072"/>
+            <a:ext cx="3520440" cy="1600200"/>
+          </a:xfrm>
+          <a:prstGeom prst="rect">
+            <a:avLst/>
+          </a:prstGeom>
+          <a:noFill/>
+          <a:ln>
+            <a:noFill/>
+          </a:ln>
+        </p:spPr>
+        <p:txBody>
+          <a:bodyPr wrap="square" lIns="91440" rIns="91440" tIns="45720" bIns="45720">
+            <a:normAutofit fontScale="85000" lnSpcReduction="20000"/>
+          </a:bodyPr>
+          <a:lstStyle/>
+          <a:p>
+            <a:pPr algn="l">
+              <a:buChar char="•"/>
+              <a:buFont typeface="Arial"/>
+            </a:pPr>
             <a:r>
               <a:rPr lang="en-US" sz="1500" b="0">
                 <a:solidFill>
@@ -1811,11 +1757,14 @@
                 </a:solidFill>
                 <a:latin typeface="Aptos"/>
               </a:rPr>
-              <a:t>After the demo</a:t>
-            </a:r>
-          </a:p>
-          <a:p>
-            <a:pPr algn="l"/>
+              <a:t>Transmission-related quantities dominate R0 sensitivity.</a:t>
+            </a:r>
+          </a:p>
+          <a:p>
+            <a:pPr algn="l">
+              <a:buChar char="•"/>
+              <a:buFont typeface="Arial"/>
+            </a:pPr>
             <a:r>
               <a:rPr lang="en-US" sz="1500" b="0">
                 <a:solidFill>
@@ -1823,11 +1772,48 @@
                 </a:solidFill>
                 <a:latin typeface="Aptos"/>
               </a:rPr>
-              <a:t>Return to the next slide for conclusion and recommendations.</a:t>
-            </a:r>
-          </a:p>
-        </p:txBody>
-      </p:sp>
+              <a:t>Safer behaviour and awareness reduce R0 strongly.</a:t>
+            </a:r>
+          </a:p>
+          <a:p>
+            <a:pPr algn="l">
+              <a:buChar char="•"/>
+              <a:buFont typeface="Arial"/>
+            </a:pPr>
+            <a:r>
+              <a:rPr lang="en-US" sz="1500" b="0">
+                <a:solidFill>
+                  <a:srgbClr val="142030"/>
+                </a:solidFill>
+                <a:latin typeface="Aptos"/>
+              </a:rPr>
+              <a:t>Dashboard outputs support thesis discussion and live defense.</a:t>
+            </a:r>
+          </a:p>
+        </p:txBody>
+      </p:sp>
+      <p:pic>
+        <p:nvPicPr>
+          <p:cNvPr id="118" name="dashboardBaselineFigure.png"/>
+          <p:cNvPicPr/>
+          <p:nvPr/>
+        </p:nvPicPr>
+        <p:blipFill>
+          <a:blip r:embed="rId3"/>
+          <a:stretch>
+            <a:fillRect/>
+          </a:stretch>
+        </p:blipFill>
+        <p:spPr>
+          <a:xfrm>
+            <a:off x="7406640" y="3767328"/>
+            <a:ext cx="3383280" cy="1627632"/>
+          </a:xfrm>
+          <a:prstGeom prst="rect">
+            <a:avLst/>
+          </a:prstGeom>
+        </p:spPr>
+      </p:pic>
     </p:spTree>
   </p:cSld>
   <p:clrMapOvr>
@@ -1855,7 +1841,7 @@
       </p:grpSpPr>
       <p:sp>
         <p:nvSpPr>
-          <p:cNvPr id="122" name="Text 122"/>
+          <p:cNvPr id="125" name="Text 125"/>
           <p:cNvSpPr txBox="1"/>
           <p:nvPr/>
         </p:nvSpPr>
@@ -1886,14 +1872,14 @@
                 </a:solidFill>
                 <a:latin typeface="Aptos"/>
               </a:rPr>
-              <a:t>Conclusion + Recommendations</a:t>
-            </a:r>
-          </a:p>
-        </p:txBody>
-      </p:sp>
-      <p:sp>
-        <p:nvSpPr>
-          <p:cNvPr id="123" name="Text 123"/>
+              <a:t>Live Dashboard Demonstration</a:t>
+            </a:r>
+          </a:p>
+        </p:txBody>
+      </p:sp>
+      <p:sp>
+        <p:nvSpPr>
+          <p:cNvPr id="126" name="Text 126"/>
           <p:cNvSpPr txBox="1"/>
           <p:nvPr/>
         </p:nvSpPr>
@@ -1933,7 +1919,7 @@
       </p:sp>
       <p:sp>
         <p:nvSpPr>
-          <p:cNvPr id="124" name="Text 124"/>
+          <p:cNvPr id="127" name="Text 127"/>
           <p:cNvSpPr txBox="1"/>
           <p:nvPr/>
         </p:nvSpPr>
@@ -1973,14 +1959,14 @@
       </p:sp>
       <p:sp>
         <p:nvSpPr>
-          <p:cNvPr id="125" name="Text 125"/>
+          <p:cNvPr id="128" name="Text 128"/>
           <p:cNvSpPr txBox="1"/>
           <p:nvPr/>
         </p:nvSpPr>
         <p:spPr>
           <a:xfrm>
             <a:off x="658368" y="1234440"/>
-            <a:ext cx="4709160" cy="320040"/>
+            <a:ext cx="5074920" cy="320040"/>
           </a:xfrm>
           <a:prstGeom prst="rect">
             <a:avLst/>
@@ -2004,21 +1990,75 @@
                 </a:solidFill>
                 <a:latin typeface="Aptos"/>
               </a:rPr>
-              <a:t>Conclusion</a:t>
-            </a:r>
-          </a:p>
-        </p:txBody>
-      </p:sp>
-      <p:sp>
-        <p:nvSpPr>
-          <p:cNvPr id="126" name="Text 126"/>
-          <p:cNvSpPr txBox="1"/>
-          <p:nvPr/>
-        </p:nvSpPr>
-        <p:spPr>
-          <a:xfrm>
-            <a:off x="713232" y="1627632"/>
-            <a:ext cx="4800600" cy="2880360"/>
+              <a:t>Open during the defense</a:t>
+            </a:r>
+          </a:p>
+        </p:txBody>
+      </p:sp>
+      <p:sp>
+        <p:nvSpPr>
+          <p:cNvPr id="129" name="Text 129"/>
+          <p:cNvSpPr txBox="1"/>
+          <p:nvPr/>
+        </p:nvSpPr>
+        <p:spPr>
+          <a:xfrm>
+            <a:off x="749808" y="1664208"/>
+            <a:ext cx="5029200" cy="731520"/>
+          </a:xfrm>
+          <a:prstGeom prst="rect">
+            <a:avLst/>
+          </a:prstGeom>
+          <a:solidFill>
+            <a:srgbClr val="E8F2FA"/>
+          </a:solidFill>
+          <a:ln w="9525">
+            <a:solidFill>
+              <a:srgbClr val="004A80"/>
+            </a:solidFill>
+          </a:ln>
+        </p:spPr>
+        <p:txBody>
+          <a:bodyPr wrap="square" lIns="91440" rIns="91440" tIns="45720" bIns="45720">
+            <a:normAutofit fontScale="85000" lnSpcReduction="20000"/>
+          </a:bodyPr>
+          <a:lstStyle/>
+          <a:p>
+            <a:pPr algn="l"/>
+            <a:r>
+              <a:rPr lang="en-US" sz="1800" b="0">
+                <a:solidFill>
+                  <a:srgbClr val="142030"/>
+                </a:solidFill>
+                <a:latin typeface="Aptos"/>
+              </a:rPr>
+              <a:t>Dashboard link</a:t>
+            </a:r>
+          </a:p>
+          <a:p>
+            <a:pPr algn="l"/>
+            <a:r>
+              <a:rPr lang="en-US" sz="1800" b="0">
+                <a:solidFill>
+                  <a:srgbClr val="142030"/>
+                </a:solidFill>
+                <a:latin typeface="Aptos"/>
+              </a:rPr>
+              <a:t>https://hiv-model.onrender.com/</a:t>
+            </a:r>
+          </a:p>
+        </p:txBody>
+      </p:sp>
+      <p:sp>
+        <p:nvSpPr>
+          <p:cNvPr id="130" name="Text 130"/>
+          <p:cNvSpPr txBox="1"/>
+          <p:nvPr/>
+        </p:nvSpPr>
+        <p:spPr>
+          <a:xfrm>
+            <a:off x="768096" y="2788920"/>
+            <a:ext cx="5120640" cy="1645920"/>
           </a:xfrm>
           <a:prstGeom prst="rect">
             <a:avLst/>
@@ -2039,13 +2079,13 @@
               <a:buFont typeface="Arial"/>
             </a:pPr>
             <a:r>
-              <a:rPr lang="en-US" sz="1800" b="0">
-                <a:solidFill>
-                  <a:srgbClr val="142030"/>
-                </a:solidFill>
-                <a:latin typeface="Aptos"/>
-              </a:rPr>
-              <a:t>The SITA HIV model was extended using fractional memory.</a:t>
+              <a:rPr lang="en-US" sz="1600" b="0">
+                <a:solidFill>
+                  <a:srgbClr val="142030"/>
+                </a:solidFill>
+                <a:latin typeface="Aptos"/>
+              </a:rPr>
+              <a:t>Run the baseline simulation.</a:t>
             </a:r>
           </a:p>
           <a:p>
@@ -2054,13 +2094,13 @@
               <a:buFont typeface="Arial"/>
             </a:pPr>
             <a:r>
-              <a:rPr lang="en-US" sz="1800" b="0">
-                <a:solidFill>
-                  <a:srgbClr val="142030"/>
-                </a:solidFill>
-                <a:latin typeface="Aptos"/>
-              </a:rPr>
-              <a:t>Behavioural interventions were represented through effective rates.</a:t>
+              <a:rPr lang="en-US" sz="1600" b="0">
+                <a:solidFill>
+                  <a:srgbClr val="142030"/>
+                </a:solidFill>
+                <a:latin typeface="Aptos"/>
+              </a:rPr>
+              <a:t>Show the final state summary and interpretation.</a:t>
             </a:r>
           </a:p>
           <a:p>
@@ -2069,94 +2109,313 @@
               <a:buFont typeface="Arial"/>
             </a:pPr>
             <a:r>
-              <a:rPr lang="en-US" sz="1800" b="0">
-                <a:solidFill>
-                  <a:srgbClr val="142030"/>
-                </a:solidFill>
-                <a:latin typeface="Aptos"/>
-              </a:rPr>
-              <a:t>Numerical simulations support combined intervention strategies.</a:t>
-            </a:r>
-          </a:p>
-        </p:txBody>
-      </p:sp>
-      <p:sp>
-        <p:nvSpPr>
-          <p:cNvPr id="127" name="Text 127"/>
-          <p:cNvSpPr txBox="1"/>
-          <p:nvPr/>
-        </p:nvSpPr>
-        <p:spPr>
-          <a:xfrm>
-            <a:off x="6080760" y="1234440"/>
-            <a:ext cx="4663440" cy="320040"/>
-          </a:xfrm>
-          <a:prstGeom prst="rect">
-            <a:avLst/>
-          </a:prstGeom>
-          <a:noFill/>
-          <a:ln>
-            <a:noFill/>
-          </a:ln>
-        </p:spPr>
-        <p:txBody>
-          <a:bodyPr wrap="square" lIns="91440" rIns="91440" tIns="45720" bIns="45720">
-            <a:normAutofit fontScale="85000" lnSpcReduction="20000"/>
-          </a:bodyPr>
-          <a:lstStyle/>
-          <a:p>
-            <a:pPr algn="l"/>
-            <a:r>
-              <a:rPr lang="en-US" sz="1500" b="1">
-                <a:solidFill>
-                  <a:srgbClr val="CC9900"/>
-                </a:solidFill>
-                <a:latin typeface="Aptos"/>
-              </a:rPr>
-              <a:t>Recommendations</a:t>
-            </a:r>
-          </a:p>
-        </p:txBody>
-      </p:sp>
-      <p:sp>
-        <p:nvSpPr>
-          <p:cNvPr id="128" name="Text 128"/>
-          <p:cNvSpPr txBox="1"/>
-          <p:nvPr/>
-        </p:nvSpPr>
-        <p:spPr>
-          <a:xfrm>
-            <a:off x="6144768" y="1627632"/>
-            <a:ext cx="4800600" cy="2880360"/>
-          </a:xfrm>
-          <a:prstGeom prst="rect">
-            <a:avLst/>
-          </a:prstGeom>
-          <a:noFill/>
-          <a:ln>
-            <a:noFill/>
-          </a:ln>
-        </p:spPr>
-        <p:txBody>
-          <a:bodyPr wrap="square" lIns="91440" rIns="91440" tIns="45720" bIns="45720">
-            <a:normAutofit fontScale="85000" lnSpcReduction="20000"/>
-          </a:bodyPr>
-          <a:lstStyle/>
+              <a:rPr lang="en-US" sz="1600" b="0">
+                <a:solidFill>
+                  <a:srgbClr val="142030"/>
+                </a:solidFill>
+                <a:latin typeface="Aptos"/>
+              </a:rPr>
+              <a:t>Compare no intervention with combined intervention.</a:t>
+            </a:r>
+          </a:p>
           <a:p>
             <a:pPr algn="l">
               <a:buChar char="•"/>
               <a:buFont typeface="Arial"/>
             </a:pPr>
             <a:r>
-              <a:rPr lang="en-US" sz="1800" b="0">
-                <a:solidFill>
-                  <a:srgbClr val="142030"/>
-                </a:solidFill>
-                <a:latin typeface="Aptos"/>
-              </a:rPr>
-              <a:t>Calibrate parameters with Rwanda-specific data.</a:t>
-            </a:r>
-          </a:p>
+              <a:rPr lang="en-US" sz="1600" b="0">
+                <a:solidFill>
+                  <a:srgbClr val="142030"/>
+                </a:solidFill>
+                <a:latin typeface="Aptos"/>
+              </a:rPr>
+              <a:t>Change q to show the fractional memory effect.</a:t>
+            </a:r>
+          </a:p>
+        </p:txBody>
+      </p:sp>
+      <p:pic>
+        <p:nvPicPr>
+          <p:cNvPr id="124" name="dashboardBaselineFigure.png"/>
+          <p:cNvPicPr/>
+          <p:nvPr/>
+        </p:nvPicPr>
+        <p:blipFill>
+          <a:blip r:embed="rId2"/>
+          <a:stretch>
+            <a:fillRect/>
+          </a:stretch>
+        </p:blipFill>
+        <p:spPr>
+          <a:xfrm>
+            <a:off x="6583680" y="1417320"/>
+            <a:ext cx="4297680" cy="2331720"/>
+          </a:xfrm>
+          <a:prstGeom prst="rect">
+            <a:avLst/>
+          </a:prstGeom>
+        </p:spPr>
+      </p:pic>
+      <p:sp>
+        <p:nvSpPr>
+          <p:cNvPr id="131" name="Text 131"/>
+          <p:cNvSpPr txBox="1"/>
+          <p:nvPr/>
+        </p:nvSpPr>
+        <p:spPr>
+          <a:xfrm>
+            <a:off x="6601968" y="4160520"/>
+            <a:ext cx="4297680" cy="822960"/>
+          </a:xfrm>
+          <a:prstGeom prst="rect">
+            <a:avLst/>
+          </a:prstGeom>
+          <a:solidFill>
+            <a:srgbClr val="FFF7E0"/>
+          </a:solidFill>
+          <a:ln w="9525">
+            <a:solidFill>
+              <a:srgbClr val="CC9900"/>
+            </a:solidFill>
+          </a:ln>
+        </p:spPr>
+        <p:txBody>
+          <a:bodyPr wrap="square" lIns="91440" rIns="91440" tIns="45720" bIns="45720">
+            <a:normAutofit fontScale="85000" lnSpcReduction="20000"/>
+          </a:bodyPr>
+          <a:lstStyle/>
+          <a:p>
+            <a:pPr algn="l"/>
+            <a:r>
+              <a:rPr lang="en-US" sz="1500" b="0">
+                <a:solidFill>
+                  <a:srgbClr val="142030"/>
+                </a:solidFill>
+                <a:latin typeface="Aptos"/>
+              </a:rPr>
+              <a:t>After the demo</a:t>
+            </a:r>
+          </a:p>
+          <a:p>
+            <a:pPr algn="l"/>
+            <a:r>
+              <a:rPr lang="en-US" sz="1500" b="0">
+                <a:solidFill>
+                  <a:srgbClr val="142030"/>
+                </a:solidFill>
+                <a:latin typeface="Aptos"/>
+              </a:rPr>
+              <a:t>Return to the next slide for conclusion and recommendations.</a:t>
+            </a:r>
+          </a:p>
+        </p:txBody>
+      </p:sp>
+    </p:spTree>
+  </p:cSld>
+  <p:clrMapOvr>
+    <a:masterClrMapping/>
+  </p:clrMapOvr>
+</p:sld>
+</file>
+
+<file path=ppt/slides/slide15.xml><?xml version="1.0" encoding="utf-8"?>
+<p:sld xmlns:a="http://schemas.openxmlformats.org/drawingml/2006/main" xmlns:r="http://schemas.openxmlformats.org/officeDocument/2006/relationships" xmlns:p="http://schemas.openxmlformats.org/presentationml/2006/main">
+  <p:cSld>
+    <p:spTree>
+      <p:nvGrpSpPr>
+        <p:cNvPr id="1" name=""/>
+        <p:cNvGrpSpPr/>
+        <p:nvPr/>
+      </p:nvGrpSpPr>
+      <p:grpSpPr>
+        <a:xfrm>
+          <a:off x="0" y="0"/>
+          <a:ext cx="0" cy="0"/>
+          <a:chOff x="0" y="0"/>
+          <a:chExt cx="0" cy="0"/>
+        </a:xfrm>
+      </p:grpSpPr>
+      <p:sp>
+        <p:nvSpPr>
+          <p:cNvPr id="132" name="Text 132"/>
+          <p:cNvSpPr txBox="1"/>
+          <p:nvPr/>
+        </p:nvSpPr>
+        <p:spPr>
+          <a:xfrm>
+            <a:off x="502920" y="292608"/>
+            <a:ext cx="10058400" cy="384048"/>
+          </a:xfrm>
+          <a:prstGeom prst="rect">
+            <a:avLst/>
+          </a:prstGeom>
+          <a:noFill/>
+          <a:ln>
+            <a:noFill/>
+          </a:ln>
+        </p:spPr>
+        <p:txBody>
+          <a:bodyPr wrap="square" lIns="91440" rIns="91440" tIns="45720" bIns="45720">
+            <a:normAutofit fontScale="85000" lnSpcReduction="20000"/>
+          </a:bodyPr>
+          <a:lstStyle/>
+          <a:p>
+            <a:pPr algn="l"/>
+            <a:r>
+              <a:rPr lang="en-US" sz="2300" b="1">
+                <a:solidFill>
+                  <a:srgbClr val="0A1B30"/>
+                </a:solidFill>
+                <a:latin typeface="Aptos"/>
+              </a:rPr>
+              <a:t>Conclusion + Recommendations</a:t>
+            </a:r>
+          </a:p>
+        </p:txBody>
+      </p:sp>
+      <p:sp>
+        <p:nvSpPr>
+          <p:cNvPr id="133" name="Text 133"/>
+          <p:cNvSpPr txBox="1"/>
+          <p:nvPr/>
+        </p:nvSpPr>
+        <p:spPr>
+          <a:xfrm>
+            <a:off x="502920" y="868680"/>
+            <a:ext cx="1828800" cy="27432"/>
+          </a:xfrm>
+          <a:prstGeom prst="rect">
+            <a:avLst/>
+          </a:prstGeom>
+          <a:solidFill>
+            <a:srgbClr val="CC9900"/>
+          </a:solidFill>
+          <a:ln>
+            <a:noFill/>
+          </a:ln>
+        </p:spPr>
+        <p:txBody>
+          <a:bodyPr wrap="square" lIns="91440" rIns="91440" tIns="45720" bIns="45720">
+            <a:normAutofit fontScale="85000" lnSpcReduction="20000"/>
+          </a:bodyPr>
+          <a:lstStyle/>
+          <a:p>
+            <a:pPr algn="l"/>
+            <a:r>
+              <a:rPr lang="en-US" sz="2400" b="0">
+                <a:solidFill>
+                  <a:srgbClr val="142030"/>
+                </a:solidFill>
+                <a:latin typeface="Aptos"/>
+              </a:rPr>
+              <a:t/>
+            </a:r>
+          </a:p>
+        </p:txBody>
+      </p:sp>
+      <p:sp>
+        <p:nvSpPr>
+          <p:cNvPr id="134" name="Text 134"/>
+          <p:cNvSpPr txBox="1"/>
+          <p:nvPr/>
+        </p:nvSpPr>
+        <p:spPr>
+          <a:xfrm>
+            <a:off x="2331720" y="868680"/>
+            <a:ext cx="6949440" cy="27432"/>
+          </a:xfrm>
+          <a:prstGeom prst="rect">
+            <a:avLst/>
+          </a:prstGeom>
+          <a:solidFill>
+            <a:srgbClr val="007E70"/>
+          </a:solidFill>
+          <a:ln>
+            <a:noFill/>
+          </a:ln>
+        </p:spPr>
+        <p:txBody>
+          <a:bodyPr wrap="square" lIns="91440" rIns="91440" tIns="45720" bIns="45720">
+            <a:normAutofit fontScale="85000" lnSpcReduction="20000"/>
+          </a:bodyPr>
+          <a:lstStyle/>
+          <a:p>
+            <a:pPr algn="l"/>
+            <a:r>
+              <a:rPr lang="en-US" sz="2400" b="0">
+                <a:solidFill>
+                  <a:srgbClr val="142030"/>
+                </a:solidFill>
+                <a:latin typeface="Aptos"/>
+              </a:rPr>
+              <a:t/>
+            </a:r>
+          </a:p>
+        </p:txBody>
+      </p:sp>
+      <p:sp>
+        <p:nvSpPr>
+          <p:cNvPr id="135" name="Text 135"/>
+          <p:cNvSpPr txBox="1"/>
+          <p:nvPr/>
+        </p:nvSpPr>
+        <p:spPr>
+          <a:xfrm>
+            <a:off x="658368" y="1234440"/>
+            <a:ext cx="4709160" cy="320040"/>
+          </a:xfrm>
+          <a:prstGeom prst="rect">
+            <a:avLst/>
+          </a:prstGeom>
+          <a:noFill/>
+          <a:ln>
+            <a:noFill/>
+          </a:ln>
+        </p:spPr>
+        <p:txBody>
+          <a:bodyPr wrap="square" lIns="91440" rIns="91440" tIns="45720" bIns="45720">
+            <a:normAutofit fontScale="85000" lnSpcReduction="20000"/>
+          </a:bodyPr>
+          <a:lstStyle/>
+          <a:p>
+            <a:pPr algn="l"/>
+            <a:r>
+              <a:rPr lang="en-US" sz="1500" b="1">
+                <a:solidFill>
+                  <a:srgbClr val="CC9900"/>
+                </a:solidFill>
+                <a:latin typeface="Aptos"/>
+              </a:rPr>
+              <a:t>Conclusion</a:t>
+            </a:r>
+          </a:p>
+        </p:txBody>
+      </p:sp>
+      <p:sp>
+        <p:nvSpPr>
+          <p:cNvPr id="136" name="Text 136"/>
+          <p:cNvSpPr txBox="1"/>
+          <p:nvPr/>
+        </p:nvSpPr>
+        <p:spPr>
+          <a:xfrm>
+            <a:off x="713232" y="1627632"/>
+            <a:ext cx="4800600" cy="2880360"/>
+          </a:xfrm>
+          <a:prstGeom prst="rect">
+            <a:avLst/>
+          </a:prstGeom>
+          <a:noFill/>
+          <a:ln>
+            <a:noFill/>
+          </a:ln>
+        </p:spPr>
+        <p:txBody>
+          <a:bodyPr wrap="square" lIns="91440" rIns="91440" tIns="45720" bIns="45720">
+            <a:normAutofit fontScale="85000" lnSpcReduction="20000"/>
+          </a:bodyPr>
+          <a:lstStyle/>
           <a:p>
             <a:pPr algn="l">
               <a:buChar char="•"/>
@@ -2169,7 +2428,7 @@
                 </a:solidFill>
                 <a:latin typeface="Aptos"/>
               </a:rPr>
-              <a:t>Extend the model using age, gender, or stochastic structure.</a:t>
+              <a:t>The SITA HIV model was extended using fractional memory.</a:t>
             </a:r>
           </a:p>
           <a:p>
@@ -2184,7 +2443,7 @@
                 </a:solidFill>
                 <a:latin typeface="Aptos"/>
               </a:rPr>
-              <a:t>Compare other fractional operators.</a:t>
+              <a:t>Behavioural interventions were represented through effective rates.</a:t>
             </a:r>
           </a:p>
           <a:p>
@@ -2199,6 +2458,130 @@
                 </a:solidFill>
                 <a:latin typeface="Aptos"/>
               </a:rPr>
+              <a:t>Numerical simulations support combined intervention strategies.</a:t>
+            </a:r>
+          </a:p>
+        </p:txBody>
+      </p:sp>
+      <p:sp>
+        <p:nvSpPr>
+          <p:cNvPr id="137" name="Text 137"/>
+          <p:cNvSpPr txBox="1"/>
+          <p:nvPr/>
+        </p:nvSpPr>
+        <p:spPr>
+          <a:xfrm>
+            <a:off x="6080760" y="1234440"/>
+            <a:ext cx="4663440" cy="320040"/>
+          </a:xfrm>
+          <a:prstGeom prst="rect">
+            <a:avLst/>
+          </a:prstGeom>
+          <a:noFill/>
+          <a:ln>
+            <a:noFill/>
+          </a:ln>
+        </p:spPr>
+        <p:txBody>
+          <a:bodyPr wrap="square" lIns="91440" rIns="91440" tIns="45720" bIns="45720">
+            <a:normAutofit fontScale="85000" lnSpcReduction="20000"/>
+          </a:bodyPr>
+          <a:lstStyle/>
+          <a:p>
+            <a:pPr algn="l"/>
+            <a:r>
+              <a:rPr lang="en-US" sz="1500" b="1">
+                <a:solidFill>
+                  <a:srgbClr val="CC9900"/>
+                </a:solidFill>
+                <a:latin typeface="Aptos"/>
+              </a:rPr>
+              <a:t>Recommendations</a:t>
+            </a:r>
+          </a:p>
+        </p:txBody>
+      </p:sp>
+      <p:sp>
+        <p:nvSpPr>
+          <p:cNvPr id="138" name="Text 138"/>
+          <p:cNvSpPr txBox="1"/>
+          <p:nvPr/>
+        </p:nvSpPr>
+        <p:spPr>
+          <a:xfrm>
+            <a:off x="6144768" y="1627632"/>
+            <a:ext cx="4800600" cy="2880360"/>
+          </a:xfrm>
+          <a:prstGeom prst="rect">
+            <a:avLst/>
+          </a:prstGeom>
+          <a:noFill/>
+          <a:ln>
+            <a:noFill/>
+          </a:ln>
+        </p:spPr>
+        <p:txBody>
+          <a:bodyPr wrap="square" lIns="91440" rIns="91440" tIns="45720" bIns="45720">
+            <a:normAutofit fontScale="85000" lnSpcReduction="20000"/>
+          </a:bodyPr>
+          <a:lstStyle/>
+          <a:p>
+            <a:pPr algn="l">
+              <a:buChar char="•"/>
+              <a:buFont typeface="Arial"/>
+            </a:pPr>
+            <a:r>
+              <a:rPr lang="en-US" sz="1800" b="0">
+                <a:solidFill>
+                  <a:srgbClr val="142030"/>
+                </a:solidFill>
+                <a:latin typeface="Aptos"/>
+              </a:rPr>
+              <a:t>Calibrate parameters with Rwanda-specific data.</a:t>
+            </a:r>
+          </a:p>
+          <a:p>
+            <a:pPr algn="l">
+              <a:buChar char="•"/>
+              <a:buFont typeface="Arial"/>
+            </a:pPr>
+            <a:r>
+              <a:rPr lang="en-US" sz="1800" b="0">
+                <a:solidFill>
+                  <a:srgbClr val="142030"/>
+                </a:solidFill>
+                <a:latin typeface="Aptos"/>
+              </a:rPr>
+              <a:t>Extend the model using age, gender, or stochastic structure.</a:t>
+            </a:r>
+          </a:p>
+          <a:p>
+            <a:pPr algn="l">
+              <a:buChar char="•"/>
+              <a:buFont typeface="Arial"/>
+            </a:pPr>
+            <a:r>
+              <a:rPr lang="en-US" sz="1800" b="0">
+                <a:solidFill>
+                  <a:srgbClr val="142030"/>
+                </a:solidFill>
+                <a:latin typeface="Aptos"/>
+              </a:rPr>
+              <a:t>Compare other fractional operators.</a:t>
+            </a:r>
+          </a:p>
+          <a:p>
+            <a:pPr algn="l">
+              <a:buChar char="•"/>
+              <a:buFont typeface="Arial"/>
+            </a:pPr>
+            <a:r>
+              <a:rPr lang="en-US" sz="1800" b="0">
+                <a:solidFill>
+                  <a:srgbClr val="142030"/>
+                </a:solidFill>
+                <a:latin typeface="Aptos"/>
+              </a:rPr>
               <a:t>Improve the dashboard into an educational decision-support tool.</a:t>
             </a:r>
           </a:p>
@@ -2206,7 +2589,7 @@
       </p:sp>
       <p:sp>
         <p:nvSpPr>
-          <p:cNvPr id="129" name="Text 129"/>
+          <p:cNvPr id="139" name="Text 139"/>
           <p:cNvSpPr txBox="1"/>
           <p:nvPr/>
         </p:nvSpPr>
@@ -3796,7 +4179,7 @@
                 </a:solidFill>
                 <a:latin typeface="Aptos"/>
               </a:rPr>
-              <a:t>Formulate a fractional-order SITA HIV model using the Caputo derivative and social behaviour interventions.</a:t>
+              <a:t>Formulate a fractional-order SITA HIV transmission model using the Caputo derivative and social behaviour intervention functions.</a:t>
             </a:r>
           </a:p>
           <a:p>
@@ -3811,7 +4194,7 @@
                 </a:solidFill>
                 <a:latin typeface="Aptos"/>
               </a:rPr>
-              <a:t>Analyse positivity, boundedness, disease-free equilibrium, R0, and fractional stability.</a:t>
+              <a:t>Analyse the main mathematical properties: positivity, boundedness, disease-free equilibrium, R0, and fractional-order stability.</a:t>
             </a:r>
           </a:p>
           <a:p>
@@ -3826,7 +4209,7 @@
                 </a:solidFill>
                 <a:latin typeface="Aptos"/>
               </a:rPr>
-              <a:t>Implement simulations and a Python dashboard to study memory effects, interventions, sensitivity, and epidemic trajectories.</a:t>
+              <a:t>Implement numerical simulations and a Python dashboard for studying memory effects, intervention scenarios, sensitivity, and epidemic trajectories.</a:t>
             </a:r>
           </a:p>
         </p:txBody>
@@ -4087,7 +4470,7 @@
                 </a:solidFill>
                 <a:latin typeface="Aptos"/>
               </a:rPr>
-              <a:t>Model Diagram: SITA</a:t>
+              <a:t>How the Objectives Are Addressed</a:t>
             </a:r>
           </a:p>
         </p:txBody>
@@ -4174,452 +4557,52 @@
       </p:sp>
       <p:sp>
         <p:nvSpPr>
-          <p:cNvPr id="52" name="S(t)"/>
-          <p:cNvSpPr/>
-          <p:nvPr/>
-        </p:nvSpPr>
-        <p:spPr>
-          <a:xfrm>
-            <a:off x="749808" y="1856231"/>
-            <a:ext cx="1691640" cy="713232"/>
-          </a:xfrm>
-          <a:prstGeom prst="roundRect">
-            <a:avLst/>
-          </a:prstGeom>
-          <a:solidFill>
-            <a:srgbClr val="E8F2FA"/>
-          </a:solidFill>
-          <a:ln w="12700">
-            <a:solidFill>
-              <a:srgbClr val="004A80"/>
-            </a:solidFill>
-          </a:ln>
-        </p:spPr>
-        <p:txBody>
-          <a:bodyPr wrap="square" anchor="mid" lIns="91440" rIns="91440" tIns="45720" bIns="45720">
-            <a:normAutofit fontScale="85000" lnSpcReduction="15000"/>
-          </a:bodyPr>
-          <a:lstStyle/>
-          <a:p>
-            <a:pPr algn="ctr"/>
-            <a:r>
-              <a:rPr lang="en-US" sz="2000" b="1">
-                <a:solidFill>
-                  <a:srgbClr val="004A80"/>
-                </a:solidFill>
-                <a:latin typeface="Aptos Display"/>
-              </a:rPr>
-              <a:t>S(t)</a:t>
-            </a:r>
-          </a:p>
-          <a:p>
-            <a:pPr algn="ctr"/>
-            <a:r>
-              <a:rPr lang="en-US" sz="1500" b="1">
-                <a:solidFill>
-                  <a:srgbClr val="004A80"/>
-                </a:solidFill>
-                <a:latin typeface="Aptos"/>
-              </a:rPr>
-              <a:t>Susceptible</a:t>
-            </a:r>
-          </a:p>
-        </p:txBody>
-      </p:sp>
-      <p:sp>
-        <p:nvSpPr>
-          <p:cNvPr id="53" name="I(t)"/>
-          <p:cNvSpPr/>
-          <p:nvPr/>
-        </p:nvSpPr>
-        <p:spPr>
-          <a:xfrm>
-            <a:off x="3246120" y="1856231"/>
-            <a:ext cx="1691640" cy="713232"/>
-          </a:xfrm>
-          <a:prstGeom prst="roundRect">
-            <a:avLst/>
-          </a:prstGeom>
-          <a:solidFill>
-            <a:srgbClr val="FFFFFF"/>
-          </a:solidFill>
-          <a:ln w="12700">
-            <a:solidFill>
-              <a:srgbClr val="B44146"/>
-            </a:solidFill>
-          </a:ln>
-        </p:spPr>
-        <p:txBody>
-          <a:bodyPr wrap="square" anchor="mid" lIns="91440" rIns="91440" tIns="45720" bIns="45720">
-            <a:normAutofit fontScale="85000" lnSpcReduction="15000"/>
-          </a:bodyPr>
-          <a:lstStyle/>
-          <a:p>
-            <a:pPr algn="ctr"/>
-            <a:r>
-              <a:rPr lang="en-US" sz="2000" b="1">
-                <a:solidFill>
-                  <a:srgbClr val="B44146"/>
-                </a:solidFill>
-                <a:latin typeface="Aptos Display"/>
-              </a:rPr>
-              <a:t>I(t)</a:t>
-            </a:r>
-          </a:p>
-          <a:p>
-            <a:pPr algn="ctr"/>
-            <a:r>
-              <a:rPr lang="en-US" sz="1500" b="1">
-                <a:solidFill>
-                  <a:srgbClr val="B44146"/>
-                </a:solidFill>
-                <a:latin typeface="Aptos"/>
-              </a:rPr>
-              <a:t>Infected</a:t>
-            </a:r>
-          </a:p>
-        </p:txBody>
-      </p:sp>
-      <p:sp>
-        <p:nvSpPr>
-          <p:cNvPr id="54" name="T(t)"/>
-          <p:cNvSpPr/>
-          <p:nvPr/>
-        </p:nvSpPr>
-        <p:spPr>
-          <a:xfrm>
-            <a:off x="5742432" y="1856231"/>
-            <a:ext cx="1691640" cy="713232"/>
-          </a:xfrm>
-          <a:prstGeom prst="roundRect">
-            <a:avLst/>
-          </a:prstGeom>
-          <a:solidFill>
-            <a:srgbClr val="FFF7E0"/>
-          </a:solidFill>
-          <a:ln w="12700">
-            <a:solidFill>
-              <a:srgbClr val="CC9900"/>
-            </a:solidFill>
-          </a:ln>
-        </p:spPr>
-        <p:txBody>
-          <a:bodyPr wrap="square" anchor="mid" lIns="91440" rIns="91440" tIns="45720" bIns="45720">
-            <a:normAutofit fontScale="85000" lnSpcReduction="15000"/>
-          </a:bodyPr>
-          <a:lstStyle/>
-          <a:p>
-            <a:pPr algn="ctr"/>
-            <a:r>
-              <a:rPr lang="en-US" sz="2000" b="1">
+          <p:cNvPr id="52" name="Text 52"/>
+          <p:cNvSpPr txBox="1"/>
+          <p:nvPr/>
+        </p:nvSpPr>
+        <p:spPr>
+          <a:xfrm>
+            <a:off x="777240" y="1417320"/>
+            <a:ext cx="3017520" cy="347472"/>
+          </a:xfrm>
+          <a:prstGeom prst="rect">
+            <a:avLst/>
+          </a:prstGeom>
+          <a:noFill/>
+          <a:ln>
+            <a:noFill/>
+          </a:ln>
+        </p:spPr>
+        <p:txBody>
+          <a:bodyPr wrap="square" lIns="91440" rIns="91440" tIns="45720" bIns="45720">
+            <a:normAutofit fontScale="85000" lnSpcReduction="20000"/>
+          </a:bodyPr>
+          <a:lstStyle/>
+          <a:p>
+            <a:pPr algn="l"/>
+            <a:r>
+              <a:rPr lang="en-US" sz="1400" b="1">
                 <a:solidFill>
                   <a:srgbClr val="CC9900"/>
                 </a:solidFill>
-                <a:latin typeface="Aptos Display"/>
-              </a:rPr>
-              <a:t>T(t)</a:t>
-            </a:r>
-          </a:p>
-          <a:p>
-            <a:pPr algn="ctr"/>
-            <a:r>
-              <a:rPr lang="en-US" sz="1500" b="1">
-                <a:solidFill>
-                  <a:srgbClr val="CC9900"/>
-                </a:solidFill>
-                <a:latin typeface="Aptos"/>
-              </a:rPr>
-              <a:t>Treated</a:t>
-            </a:r>
-          </a:p>
-        </p:txBody>
-      </p:sp>
-      <p:sp>
-        <p:nvSpPr>
-          <p:cNvPr id="55" name="A(t)"/>
-          <p:cNvSpPr/>
-          <p:nvPr/>
-        </p:nvSpPr>
-        <p:spPr>
-          <a:xfrm>
-            <a:off x="8247888" y="1856231"/>
-            <a:ext cx="1691640" cy="713232"/>
-          </a:xfrm>
-          <a:prstGeom prst="roundRect">
-            <a:avLst/>
-          </a:prstGeom>
-          <a:solidFill>
-            <a:srgbClr val="E6F7F4"/>
-          </a:solidFill>
-          <a:ln w="12700">
-            <a:solidFill>
-              <a:srgbClr val="007E70"/>
-            </a:solidFill>
-          </a:ln>
-        </p:spPr>
-        <p:txBody>
-          <a:bodyPr wrap="square" anchor="mid" lIns="91440" rIns="91440" tIns="45720" bIns="45720">
-            <a:normAutofit fontScale="85000" lnSpcReduction="15000"/>
-          </a:bodyPr>
-          <a:lstStyle/>
-          <a:p>
-            <a:pPr algn="ctr"/>
-            <a:r>
-              <a:rPr lang="en-US" sz="2000" b="1">
-                <a:solidFill>
-                  <a:srgbClr val="007E70"/>
-                </a:solidFill>
-                <a:latin typeface="Aptos Display"/>
-              </a:rPr>
-              <a:t>A(t)</a:t>
-            </a:r>
-          </a:p>
-          <a:p>
-            <a:pPr algn="ctr"/>
-            <a:r>
-              <a:rPr lang="en-US" sz="1500" b="1">
-                <a:solidFill>
-                  <a:srgbClr val="007E70"/>
-                </a:solidFill>
-                <a:latin typeface="Aptos"/>
-              </a:rPr>
-              <a:t>AIDS stage</a:t>
-            </a:r>
-          </a:p>
-        </p:txBody>
-      </p:sp>
-      <p:cxnSp>
-        <p:nvCxnSpPr>
-          <p:cNvPr id="56" name="Arrow 56"/>
-          <p:cNvCxnSpPr/>
-          <p:nvPr/>
-        </p:nvCxnSpPr>
-        <p:spPr>
-          <a:xfrm>
-            <a:off x="2441448" y="2212848"/>
-            <a:ext cx="804671" cy="0"/>
-          </a:xfrm>
-          <a:prstGeom prst="line">
-            <a:avLst/>
-          </a:prstGeom>
-          <a:ln w="19050">
-            <a:solidFill>
-              <a:srgbClr val="142030"/>
-            </a:solidFill>
-            <a:tailEnd type="triangle"/>
-          </a:ln>
-        </p:spPr>
-        <p:style>
-          <a:lnRef idx="1">
-            <a:schemeClr val="accent1"/>
-          </a:lnRef>
-          <a:fillRef idx="0">
-            <a:schemeClr val="accent1"/>
-          </a:fillRef>
-          <a:effectRef idx="0">
-            <a:schemeClr val="accent1"/>
-          </a:effectRef>
-          <a:fontRef idx="minor">
-            <a:schemeClr val="tx1"/>
-          </a:fontRef>
-        </p:style>
-      </p:cxnSp>
-      <p:cxnSp>
-        <p:nvCxnSpPr>
-          <p:cNvPr id="57" name="Arrow 57"/>
-          <p:cNvCxnSpPr/>
-          <p:nvPr/>
-        </p:nvCxnSpPr>
-        <p:spPr>
-          <a:xfrm>
-            <a:off x="4937760" y="2212848"/>
-            <a:ext cx="804671" cy="0"/>
-          </a:xfrm>
-          <a:prstGeom prst="line">
-            <a:avLst/>
-          </a:prstGeom>
-          <a:ln w="19050">
-            <a:solidFill>
-              <a:srgbClr val="142030"/>
-            </a:solidFill>
-            <a:tailEnd type="triangle"/>
-          </a:ln>
-        </p:spPr>
-        <p:style>
-          <a:lnRef idx="1">
-            <a:schemeClr val="accent1"/>
-          </a:lnRef>
-          <a:fillRef idx="0">
-            <a:schemeClr val="accent1"/>
-          </a:fillRef>
-          <a:effectRef idx="0">
-            <a:schemeClr val="accent1"/>
-          </a:effectRef>
-          <a:fontRef idx="minor">
-            <a:schemeClr val="tx1"/>
-          </a:fontRef>
-        </p:style>
-      </p:cxnSp>
-      <p:cxnSp>
-        <p:nvCxnSpPr>
-          <p:cNvPr id="58" name="Arrow 58"/>
-          <p:cNvCxnSpPr/>
-          <p:nvPr/>
-        </p:nvCxnSpPr>
-        <p:spPr>
-          <a:xfrm>
-            <a:off x="7434072" y="2212848"/>
-            <a:ext cx="813815" cy="0"/>
-          </a:xfrm>
-          <a:prstGeom prst="line">
-            <a:avLst/>
-          </a:prstGeom>
-          <a:ln w="19050">
-            <a:solidFill>
-              <a:srgbClr val="142030"/>
-            </a:solidFill>
-            <a:tailEnd type="triangle"/>
-          </a:ln>
-        </p:spPr>
-        <p:style>
-          <a:lnRef idx="1">
-            <a:schemeClr val="accent1"/>
-          </a:lnRef>
-          <a:fillRef idx="0">
-            <a:schemeClr val="accent1"/>
-          </a:fillRef>
-          <a:effectRef idx="0">
-            <a:schemeClr val="accent1"/>
-          </a:effectRef>
-          <a:fontRef idx="minor">
-            <a:schemeClr val="tx1"/>
-          </a:fontRef>
-        </p:style>
-      </p:cxnSp>
-      <p:sp>
-        <p:nvSpPr>
-          <p:cNvPr id="59" name="Text 59"/>
-          <p:cNvSpPr txBox="1"/>
-          <p:nvPr/>
-        </p:nvSpPr>
-        <p:spPr>
-          <a:xfrm>
-            <a:off x="2267712" y="1353312"/>
-            <a:ext cx="1143000" cy="320040"/>
-          </a:xfrm>
-          <a:prstGeom prst="rect">
-            <a:avLst/>
-          </a:prstGeom>
-          <a:noFill/>
-          <a:ln>
-            <a:noFill/>
-          </a:ln>
-        </p:spPr>
-        <p:txBody>
-          <a:bodyPr wrap="square" lIns="91440" rIns="91440" tIns="45720" bIns="45720">
-            <a:normAutofit fontScale="85000" lnSpcReduction="20000"/>
-          </a:bodyPr>
-          <a:lstStyle/>
-          <a:p>
-            <a:pPr algn="c"/>
-            <a:r>
-              <a:rPr lang="en-US" sz="1000" b="0">
-                <a:solidFill>
-                  <a:srgbClr val="52606C"/>
-                </a:solidFill>
-                <a:latin typeface="Aptos"/>
-              </a:rPr>
-              <a:t>effective transmission</a:t>
-            </a:r>
-          </a:p>
-        </p:txBody>
-      </p:sp>
-      <p:sp>
-        <p:nvSpPr>
-          <p:cNvPr id="60" name="Text 60"/>
-          <p:cNvSpPr txBox="1"/>
-          <p:nvPr/>
-        </p:nvSpPr>
-        <p:spPr>
-          <a:xfrm>
-            <a:off x="4700016" y="1353312"/>
-            <a:ext cx="1143000" cy="320040"/>
-          </a:xfrm>
-          <a:prstGeom prst="rect">
-            <a:avLst/>
-          </a:prstGeom>
-          <a:noFill/>
-          <a:ln>
-            <a:noFill/>
-          </a:ln>
-        </p:spPr>
-        <p:txBody>
-          <a:bodyPr wrap="square" lIns="91440" rIns="91440" tIns="45720" bIns="45720">
-            <a:normAutofit fontScale="85000" lnSpcReduction="20000"/>
-          </a:bodyPr>
-          <a:lstStyle/>
-          <a:p>
-            <a:pPr algn="c"/>
-            <a:r>
-              <a:rPr lang="en-US" sz="1000" b="0">
-                <a:solidFill>
-                  <a:srgbClr val="52606C"/>
-                </a:solidFill>
-                <a:latin typeface="Aptos"/>
-              </a:rPr>
-              <a:t>testing and treatment</a:t>
-            </a:r>
-          </a:p>
-        </p:txBody>
-      </p:sp>
-      <p:sp>
-        <p:nvSpPr>
-          <p:cNvPr id="61" name="Text 61"/>
-          <p:cNvSpPr txBox="1"/>
-          <p:nvPr/>
-        </p:nvSpPr>
-        <p:spPr>
-          <a:xfrm>
-            <a:off x="7059168" y="2779776"/>
-            <a:ext cx="1280160" cy="320040"/>
-          </a:xfrm>
-          <a:prstGeom prst="rect">
-            <a:avLst/>
-          </a:prstGeom>
-          <a:noFill/>
-          <a:ln>
-            <a:noFill/>
-          </a:ln>
-        </p:spPr>
-        <p:txBody>
-          <a:bodyPr wrap="square" lIns="91440" rIns="91440" tIns="45720" bIns="45720">
-            <a:normAutofit fontScale="85000" lnSpcReduction="20000"/>
-          </a:bodyPr>
-          <a:lstStyle/>
-          <a:p>
-            <a:pPr algn="c"/>
-            <a:r>
-              <a:rPr lang="en-US" sz="1000" b="0">
-                <a:solidFill>
-                  <a:srgbClr val="52606C"/>
-                </a:solidFill>
-                <a:latin typeface="Aptos"/>
-              </a:rPr>
-              <a:t>reduced progression</a:t>
-            </a:r>
-          </a:p>
-        </p:txBody>
-      </p:sp>
-      <p:sp>
-        <p:nvSpPr>
-          <p:cNvPr id="62" name="Text 62"/>
-          <p:cNvSpPr txBox="1"/>
-          <p:nvPr/>
-        </p:nvSpPr>
-        <p:spPr>
-          <a:xfrm>
-            <a:off x="914400" y="4224528"/>
-            <a:ext cx="4846320" cy="960120"/>
+                <a:latin typeface="Aptos"/>
+              </a:rPr>
+              <a:t>Objective 1</a:t>
+            </a:r>
+          </a:p>
+        </p:txBody>
+      </p:sp>
+      <p:sp>
+        <p:nvSpPr>
+          <p:cNvPr id="53" name="Text 53"/>
+          <p:cNvSpPr txBox="1"/>
+          <p:nvPr/>
+        </p:nvSpPr>
+        <p:spPr>
+          <a:xfrm>
+            <a:off x="804672" y="1874519"/>
+            <a:ext cx="2971800" cy="1874519"/>
           </a:xfrm>
           <a:prstGeom prst="rect">
             <a:avLst/>
@@ -4641,39 +4624,169 @@
           <a:p>
             <a:pPr algn="l"/>
             <a:r>
-              <a:rPr lang="en-US" sz="1500" b="0">
-                <a:solidFill>
-                  <a:srgbClr val="142030"/>
-                </a:solidFill>
-                <a:latin typeface="Aptos"/>
-              </a:rPr>
-              <a:t>State variables</a:t>
-            </a:r>
-          </a:p>
-          <a:p>
-            <a:pPr algn="l"/>
-            <a:r>
-              <a:rPr lang="en-US" sz="1500" b="0">
-                <a:solidFill>
-                  <a:srgbClr val="142030"/>
-                </a:solidFill>
-                <a:latin typeface="Aptos"/>
-              </a:rPr>
-              <a:t>S susceptible, I infected, T treated, A AIDS-stage population.</a:t>
-            </a:r>
-          </a:p>
-        </p:txBody>
-      </p:sp>
-      <p:sp>
-        <p:nvSpPr>
-          <p:cNvPr id="63" name="Text 63"/>
-          <p:cNvSpPr txBox="1"/>
-          <p:nvPr/>
-        </p:nvSpPr>
-        <p:spPr>
-          <a:xfrm>
-            <a:off x="6355080" y="4224528"/>
-            <a:ext cx="4709160" cy="960120"/>
+              <a:rPr lang="en-US" sz="1400" b="0">
+                <a:solidFill>
+                  <a:srgbClr val="142030"/>
+                </a:solidFill>
+                <a:latin typeface="Aptos"/>
+              </a:rPr>
+              <a:t>Formulation</a:t>
+            </a:r>
+          </a:p>
+          <a:p>
+            <a:pPr algn="l"/>
+            <a:r>
+              <a:rPr lang="en-US" sz="1400" b="0">
+                <a:solidFill>
+                  <a:srgbClr val="142030"/>
+                </a:solidFill>
+                <a:latin typeface="Aptos"/>
+              </a:rPr>
+              <a:t>Caputo fractional SITA system with S, I, T, A compartments and intervention functions beta_eff, tau_eff, rho_eff.</a:t>
+            </a:r>
+          </a:p>
+        </p:txBody>
+      </p:sp>
+      <p:sp>
+        <p:nvSpPr>
+          <p:cNvPr id="54" name="Text 54"/>
+          <p:cNvSpPr txBox="1"/>
+          <p:nvPr/>
+        </p:nvSpPr>
+        <p:spPr>
+          <a:xfrm>
+            <a:off x="4343400" y="1417320"/>
+            <a:ext cx="3017520" cy="347472"/>
+          </a:xfrm>
+          <a:prstGeom prst="rect">
+            <a:avLst/>
+          </a:prstGeom>
+          <a:noFill/>
+          <a:ln>
+            <a:noFill/>
+          </a:ln>
+        </p:spPr>
+        <p:txBody>
+          <a:bodyPr wrap="square" lIns="91440" rIns="91440" tIns="45720" bIns="45720">
+            <a:normAutofit fontScale="85000" lnSpcReduction="20000"/>
+          </a:bodyPr>
+          <a:lstStyle/>
+          <a:p>
+            <a:pPr algn="l"/>
+            <a:r>
+              <a:rPr lang="en-US" sz="1400" b="1">
+                <a:solidFill>
+                  <a:srgbClr val="CC9900"/>
+                </a:solidFill>
+                <a:latin typeface="Aptos"/>
+              </a:rPr>
+              <a:t>Objective 2</a:t>
+            </a:r>
+          </a:p>
+        </p:txBody>
+      </p:sp>
+      <p:sp>
+        <p:nvSpPr>
+          <p:cNvPr id="55" name="Text 55"/>
+          <p:cNvSpPr txBox="1"/>
+          <p:nvPr/>
+        </p:nvSpPr>
+        <p:spPr>
+          <a:xfrm>
+            <a:off x="4370832" y="1874519"/>
+            <a:ext cx="2971800" cy="1874519"/>
+          </a:xfrm>
+          <a:prstGeom prst="rect">
+            <a:avLst/>
+          </a:prstGeom>
+          <a:solidFill>
+            <a:srgbClr val="E6F7F4"/>
+          </a:solidFill>
+          <a:ln w="9525">
+            <a:solidFill>
+              <a:srgbClr val="007E70"/>
+            </a:solidFill>
+          </a:ln>
+        </p:spPr>
+        <p:txBody>
+          <a:bodyPr wrap="square" lIns="91440" rIns="91440" tIns="45720" bIns="45720">
+            <a:normAutofit fontScale="85000" lnSpcReduction="20000"/>
+          </a:bodyPr>
+          <a:lstStyle/>
+          <a:p>
+            <a:pPr algn="l"/>
+            <a:r>
+              <a:rPr lang="en-US" sz="1400" b="0">
+                <a:solidFill>
+                  <a:srgbClr val="142030"/>
+                </a:solidFill>
+                <a:latin typeface="Aptos"/>
+              </a:rPr>
+              <a:t>Analysis</a:t>
+            </a:r>
+          </a:p>
+          <a:p>
+            <a:pPr algn="l"/>
+            <a:r>
+              <a:rPr lang="en-US" sz="1400" b="0">
+                <a:solidFill>
+                  <a:srgbClr val="142030"/>
+                </a:solidFill>
+                <a:latin typeface="Aptos"/>
+              </a:rPr>
+              <a:t>Positivity, boundedness, disease-free equilibrium, R0, and fractional-order local stability are presented in the report.</a:t>
+            </a:r>
+          </a:p>
+        </p:txBody>
+      </p:sp>
+      <p:sp>
+        <p:nvSpPr>
+          <p:cNvPr id="56" name="Text 56"/>
+          <p:cNvSpPr txBox="1"/>
+          <p:nvPr/>
+        </p:nvSpPr>
+        <p:spPr>
+          <a:xfrm>
+            <a:off x="7909560" y="1417320"/>
+            <a:ext cx="3017520" cy="347472"/>
+          </a:xfrm>
+          <a:prstGeom prst="rect">
+            <a:avLst/>
+          </a:prstGeom>
+          <a:noFill/>
+          <a:ln>
+            <a:noFill/>
+          </a:ln>
+        </p:spPr>
+        <p:txBody>
+          <a:bodyPr wrap="square" lIns="91440" rIns="91440" tIns="45720" bIns="45720">
+            <a:normAutofit fontScale="85000" lnSpcReduction="20000"/>
+          </a:bodyPr>
+          <a:lstStyle/>
+          <a:p>
+            <a:pPr algn="l"/>
+            <a:r>
+              <a:rPr lang="en-US" sz="1400" b="1">
+                <a:solidFill>
+                  <a:srgbClr val="CC9900"/>
+                </a:solidFill>
+                <a:latin typeface="Aptos"/>
+              </a:rPr>
+              <a:t>Objective 3</a:t>
+            </a:r>
+          </a:p>
+        </p:txBody>
+      </p:sp>
+      <p:sp>
+        <p:nvSpPr>
+          <p:cNvPr id="57" name="Text 57"/>
+          <p:cNvSpPr txBox="1"/>
+          <p:nvPr/>
+        </p:nvSpPr>
+        <p:spPr>
+          <a:xfrm>
+            <a:off x="7936992" y="1874519"/>
+            <a:ext cx="2971800" cy="1874519"/>
           </a:xfrm>
           <a:prstGeom prst="rect">
             <a:avLst/>
@@ -4695,25 +4808,79 @@
           <a:p>
             <a:pPr algn="l"/>
             <a:r>
-              <a:rPr lang="en-US" sz="1500" b="0">
-                <a:solidFill>
-                  <a:srgbClr val="142030"/>
-                </a:solidFill>
-                <a:latin typeface="Aptos"/>
-              </a:rPr>
-              <a:t>Controls</a:t>
-            </a:r>
-          </a:p>
-          <a:p>
-            <a:pPr algn="l"/>
-            <a:r>
-              <a:rPr lang="en-US" sz="1500" b="0">
-                <a:solidFill>
-                  <a:srgbClr val="142030"/>
-                </a:solidFill>
-                <a:latin typeface="Aptos"/>
-              </a:rPr>
-              <a:t>u1 awareness, u2 safer behaviour, u3 testing, u4 adherence.</a:t>
+              <a:rPr lang="en-US" sz="1400" b="0">
+                <a:solidFill>
+                  <a:srgbClr val="142030"/>
+                </a:solidFill>
+                <a:latin typeface="Aptos"/>
+              </a:rPr>
+              <a:t>Implementation</a:t>
+            </a:r>
+          </a:p>
+          <a:p>
+            <a:pPr algn="l"/>
+            <a:r>
+              <a:rPr lang="en-US" sz="1400" b="0">
+                <a:solidFill>
+                  <a:srgbClr val="142030"/>
+                </a:solidFill>
+                <a:latin typeface="Aptos"/>
+              </a:rPr>
+              <a:t>Python simulations and dashboard views show trajectories, memory effects, intervention scenarios, and sensitivity.</a:t>
+            </a:r>
+          </a:p>
+        </p:txBody>
+      </p:sp>
+      <p:sp>
+        <p:nvSpPr>
+          <p:cNvPr id="58" name="Text 58"/>
+          <p:cNvSpPr txBox="1"/>
+          <p:nvPr/>
+        </p:nvSpPr>
+        <p:spPr>
+          <a:xfrm>
+            <a:off x="960120" y="4709160"/>
+            <a:ext cx="9875520" cy="713232"/>
+          </a:xfrm>
+          <a:prstGeom prst="rect">
+            <a:avLst/>
+          </a:prstGeom>
+          <a:solidFill>
+            <a:srgbClr val="FDEBEC"/>
+          </a:solidFill>
+          <a:ln w="9525">
+            <a:solidFill>
+              <a:srgbClr val="B44146"/>
+            </a:solidFill>
+          </a:ln>
+        </p:spPr>
+        <p:txBody>
+          <a:bodyPr wrap="square" lIns="91440" rIns="91440" tIns="45720" bIns="45720">
+            <a:normAutofit fontScale="85000" lnSpcReduction="20000"/>
+          </a:bodyPr>
+          <a:lstStyle/>
+          <a:p>
+            <a:pPr algn="l"/>
+            <a:r>
+              <a:rPr lang="en-US" sz="1600" b="0">
+                <a:solidFill>
+                  <a:srgbClr val="142030"/>
+                </a:solidFill>
+                <a:latin typeface="Aptos"/>
+              </a:rPr>
+              <a:t>Defense point</a:t>
+            </a:r>
+          </a:p>
+          <a:p>
+            <a:pPr algn="l"/>
+            <a:r>
+              <a:rPr lang="en-US" sz="1600" b="0">
+                <a:solidFill>
+                  <a:srgbClr val="142030"/>
+                </a:solidFill>
+                <a:latin typeface="Aptos"/>
+              </a:rPr>
+              <a:t>Each objective is represented in the thesis, the generated figures, and the live dashboard demonstration.</a:t>
             </a:r>
           </a:p>
         </p:txBody>
@@ -4745,7 +4912,7 @@
       </p:grpSpPr>
       <p:sp>
         <p:nvSpPr>
-          <p:cNvPr id="64" name="Text 64"/>
+          <p:cNvPr id="59" name="Text 59"/>
           <p:cNvSpPr txBox="1"/>
           <p:nvPr/>
         </p:nvSpPr>
@@ -4776,14 +4943,14 @@
                 </a:solidFill>
                 <a:latin typeface="Aptos"/>
               </a:rPr>
-              <a:t>Fractional-Order Model</a:t>
-            </a:r>
-          </a:p>
-        </p:txBody>
-      </p:sp>
-      <p:sp>
-        <p:nvSpPr>
-          <p:cNvPr id="65" name="Text 65"/>
+              <a:t>Model Diagram: SITA</a:t>
+            </a:r>
+          </a:p>
+        </p:txBody>
+      </p:sp>
+      <p:sp>
+        <p:nvSpPr>
+          <p:cNvPr id="60" name="Text 60"/>
           <p:cNvSpPr txBox="1"/>
           <p:nvPr/>
         </p:nvSpPr>
@@ -4823,7 +4990,7 @@
       </p:sp>
       <p:sp>
         <p:nvSpPr>
-          <p:cNvPr id="66" name="Text 66"/>
+          <p:cNvPr id="61" name="Text 61"/>
           <p:cNvSpPr txBox="1"/>
           <p:nvPr/>
         </p:nvSpPr>
@@ -4863,14 +5030,338 @@
       </p:sp>
       <p:sp>
         <p:nvSpPr>
-          <p:cNvPr id="67" name="Text 67"/>
-          <p:cNvSpPr txBox="1"/>
-          <p:nvPr/>
-        </p:nvSpPr>
-        <p:spPr>
-          <a:xfrm>
-            <a:off x="658368" y="1234440"/>
-            <a:ext cx="5303520" cy="320040"/>
+          <p:cNvPr id="62" name="S(t)"/>
+          <p:cNvSpPr/>
+          <p:nvPr/>
+        </p:nvSpPr>
+        <p:spPr>
+          <a:xfrm>
+            <a:off x="749808" y="1856231"/>
+            <a:ext cx="1691640" cy="713232"/>
+          </a:xfrm>
+          <a:prstGeom prst="roundRect">
+            <a:avLst/>
+          </a:prstGeom>
+          <a:solidFill>
+            <a:srgbClr val="E8F2FA"/>
+          </a:solidFill>
+          <a:ln w="12700">
+            <a:solidFill>
+              <a:srgbClr val="004A80"/>
+            </a:solidFill>
+          </a:ln>
+        </p:spPr>
+        <p:txBody>
+          <a:bodyPr wrap="square" anchor="mid" lIns="91440" rIns="91440" tIns="45720" bIns="45720">
+            <a:normAutofit fontScale="85000" lnSpcReduction="15000"/>
+          </a:bodyPr>
+          <a:lstStyle/>
+          <a:p>
+            <a:pPr algn="ctr"/>
+            <a:r>
+              <a:rPr lang="en-US" sz="2000" b="1">
+                <a:solidFill>
+                  <a:srgbClr val="004A80"/>
+                </a:solidFill>
+                <a:latin typeface="Aptos Display"/>
+              </a:rPr>
+              <a:t>S(t)</a:t>
+            </a:r>
+          </a:p>
+          <a:p>
+            <a:pPr algn="ctr"/>
+            <a:r>
+              <a:rPr lang="en-US" sz="1500" b="1">
+                <a:solidFill>
+                  <a:srgbClr val="004A80"/>
+                </a:solidFill>
+                <a:latin typeface="Aptos"/>
+              </a:rPr>
+              <a:t>Susceptible</a:t>
+            </a:r>
+          </a:p>
+        </p:txBody>
+      </p:sp>
+      <p:sp>
+        <p:nvSpPr>
+          <p:cNvPr id="63" name="I(t)"/>
+          <p:cNvSpPr/>
+          <p:nvPr/>
+        </p:nvSpPr>
+        <p:spPr>
+          <a:xfrm>
+            <a:off x="3246120" y="1856231"/>
+            <a:ext cx="1691640" cy="713232"/>
+          </a:xfrm>
+          <a:prstGeom prst="roundRect">
+            <a:avLst/>
+          </a:prstGeom>
+          <a:solidFill>
+            <a:srgbClr val="FFFFFF"/>
+          </a:solidFill>
+          <a:ln w="12700">
+            <a:solidFill>
+              <a:srgbClr val="B44146"/>
+            </a:solidFill>
+          </a:ln>
+        </p:spPr>
+        <p:txBody>
+          <a:bodyPr wrap="square" anchor="mid" lIns="91440" rIns="91440" tIns="45720" bIns="45720">
+            <a:normAutofit fontScale="85000" lnSpcReduction="15000"/>
+          </a:bodyPr>
+          <a:lstStyle/>
+          <a:p>
+            <a:pPr algn="ctr"/>
+            <a:r>
+              <a:rPr lang="en-US" sz="2000" b="1">
+                <a:solidFill>
+                  <a:srgbClr val="B44146"/>
+                </a:solidFill>
+                <a:latin typeface="Aptos Display"/>
+              </a:rPr>
+              <a:t>I(t)</a:t>
+            </a:r>
+          </a:p>
+          <a:p>
+            <a:pPr algn="ctr"/>
+            <a:r>
+              <a:rPr lang="en-US" sz="1500" b="1">
+                <a:solidFill>
+                  <a:srgbClr val="B44146"/>
+                </a:solidFill>
+                <a:latin typeface="Aptos"/>
+              </a:rPr>
+              <a:t>Infected</a:t>
+            </a:r>
+          </a:p>
+        </p:txBody>
+      </p:sp>
+      <p:sp>
+        <p:nvSpPr>
+          <p:cNvPr id="64" name="T(t)"/>
+          <p:cNvSpPr/>
+          <p:nvPr/>
+        </p:nvSpPr>
+        <p:spPr>
+          <a:xfrm>
+            <a:off x="5742432" y="1856231"/>
+            <a:ext cx="1691640" cy="713232"/>
+          </a:xfrm>
+          <a:prstGeom prst="roundRect">
+            <a:avLst/>
+          </a:prstGeom>
+          <a:solidFill>
+            <a:srgbClr val="FFF7E0"/>
+          </a:solidFill>
+          <a:ln w="12700">
+            <a:solidFill>
+              <a:srgbClr val="CC9900"/>
+            </a:solidFill>
+          </a:ln>
+        </p:spPr>
+        <p:txBody>
+          <a:bodyPr wrap="square" anchor="mid" lIns="91440" rIns="91440" tIns="45720" bIns="45720">
+            <a:normAutofit fontScale="85000" lnSpcReduction="15000"/>
+          </a:bodyPr>
+          <a:lstStyle/>
+          <a:p>
+            <a:pPr algn="ctr"/>
+            <a:r>
+              <a:rPr lang="en-US" sz="2000" b="1">
+                <a:solidFill>
+                  <a:srgbClr val="CC9900"/>
+                </a:solidFill>
+                <a:latin typeface="Aptos Display"/>
+              </a:rPr>
+              <a:t>T(t)</a:t>
+            </a:r>
+          </a:p>
+          <a:p>
+            <a:pPr algn="ctr"/>
+            <a:r>
+              <a:rPr lang="en-US" sz="1500" b="1">
+                <a:solidFill>
+                  <a:srgbClr val="CC9900"/>
+                </a:solidFill>
+                <a:latin typeface="Aptos"/>
+              </a:rPr>
+              <a:t>Treated</a:t>
+            </a:r>
+          </a:p>
+        </p:txBody>
+      </p:sp>
+      <p:sp>
+        <p:nvSpPr>
+          <p:cNvPr id="65" name="A(t)"/>
+          <p:cNvSpPr/>
+          <p:nvPr/>
+        </p:nvSpPr>
+        <p:spPr>
+          <a:xfrm>
+            <a:off x="8247888" y="1856231"/>
+            <a:ext cx="1691640" cy="713232"/>
+          </a:xfrm>
+          <a:prstGeom prst="roundRect">
+            <a:avLst/>
+          </a:prstGeom>
+          <a:solidFill>
+            <a:srgbClr val="E6F7F4"/>
+          </a:solidFill>
+          <a:ln w="12700">
+            <a:solidFill>
+              <a:srgbClr val="007E70"/>
+            </a:solidFill>
+          </a:ln>
+        </p:spPr>
+        <p:txBody>
+          <a:bodyPr wrap="square" anchor="mid" lIns="91440" rIns="91440" tIns="45720" bIns="45720">
+            <a:normAutofit fontScale="85000" lnSpcReduction="15000"/>
+          </a:bodyPr>
+          <a:lstStyle/>
+          <a:p>
+            <a:pPr algn="ctr"/>
+            <a:r>
+              <a:rPr lang="en-US" sz="2000" b="1">
+                <a:solidFill>
+                  <a:srgbClr val="007E70"/>
+                </a:solidFill>
+                <a:latin typeface="Aptos Display"/>
+              </a:rPr>
+              <a:t>A(t)</a:t>
+            </a:r>
+          </a:p>
+          <a:p>
+            <a:pPr algn="ctr"/>
+            <a:r>
+              <a:rPr lang="en-US" sz="1500" b="1">
+                <a:solidFill>
+                  <a:srgbClr val="007E70"/>
+                </a:solidFill>
+                <a:latin typeface="Aptos"/>
+              </a:rPr>
+              <a:t>AIDS stage</a:t>
+            </a:r>
+          </a:p>
+        </p:txBody>
+      </p:sp>
+      <p:cxnSp>
+        <p:nvCxnSpPr>
+          <p:cNvPr id="66" name="Arrow 66"/>
+          <p:cNvCxnSpPr/>
+          <p:nvPr/>
+        </p:nvCxnSpPr>
+        <p:spPr>
+          <a:xfrm>
+            <a:off x="2441448" y="2212848"/>
+            <a:ext cx="804671" cy="0"/>
+          </a:xfrm>
+          <a:prstGeom prst="line">
+            <a:avLst/>
+          </a:prstGeom>
+          <a:ln w="19050">
+            <a:solidFill>
+              <a:srgbClr val="142030"/>
+            </a:solidFill>
+            <a:tailEnd type="triangle"/>
+          </a:ln>
+        </p:spPr>
+        <p:style>
+          <a:lnRef idx="1">
+            <a:schemeClr val="accent1"/>
+          </a:lnRef>
+          <a:fillRef idx="0">
+            <a:schemeClr val="accent1"/>
+          </a:fillRef>
+          <a:effectRef idx="0">
+            <a:schemeClr val="accent1"/>
+          </a:effectRef>
+          <a:fontRef idx="minor">
+            <a:schemeClr val="tx1"/>
+          </a:fontRef>
+        </p:style>
+      </p:cxnSp>
+      <p:cxnSp>
+        <p:nvCxnSpPr>
+          <p:cNvPr id="67" name="Arrow 67"/>
+          <p:cNvCxnSpPr/>
+          <p:nvPr/>
+        </p:nvCxnSpPr>
+        <p:spPr>
+          <a:xfrm>
+            <a:off x="4937760" y="2212848"/>
+            <a:ext cx="804671" cy="0"/>
+          </a:xfrm>
+          <a:prstGeom prst="line">
+            <a:avLst/>
+          </a:prstGeom>
+          <a:ln w="19050">
+            <a:solidFill>
+              <a:srgbClr val="142030"/>
+            </a:solidFill>
+            <a:tailEnd type="triangle"/>
+          </a:ln>
+        </p:spPr>
+        <p:style>
+          <a:lnRef idx="1">
+            <a:schemeClr val="accent1"/>
+          </a:lnRef>
+          <a:fillRef idx="0">
+            <a:schemeClr val="accent1"/>
+          </a:fillRef>
+          <a:effectRef idx="0">
+            <a:schemeClr val="accent1"/>
+          </a:effectRef>
+          <a:fontRef idx="minor">
+            <a:schemeClr val="tx1"/>
+          </a:fontRef>
+        </p:style>
+      </p:cxnSp>
+      <p:cxnSp>
+        <p:nvCxnSpPr>
+          <p:cNvPr id="68" name="Arrow 68"/>
+          <p:cNvCxnSpPr/>
+          <p:nvPr/>
+        </p:nvCxnSpPr>
+        <p:spPr>
+          <a:xfrm>
+            <a:off x="7434072" y="2212848"/>
+            <a:ext cx="813815" cy="0"/>
+          </a:xfrm>
+          <a:prstGeom prst="line">
+            <a:avLst/>
+          </a:prstGeom>
+          <a:ln w="19050">
+            <a:solidFill>
+              <a:srgbClr val="142030"/>
+            </a:solidFill>
+            <a:tailEnd type="triangle"/>
+          </a:ln>
+        </p:spPr>
+        <p:style>
+          <a:lnRef idx="1">
+            <a:schemeClr val="accent1"/>
+          </a:lnRef>
+          <a:fillRef idx="0">
+            <a:schemeClr val="accent1"/>
+          </a:fillRef>
+          <a:effectRef idx="0">
+            <a:schemeClr val="accent1"/>
+          </a:effectRef>
+          <a:fontRef idx="minor">
+            <a:schemeClr val="tx1"/>
+          </a:fontRef>
+        </p:style>
+      </p:cxnSp>
+      <p:sp>
+        <p:nvSpPr>
+          <p:cNvPr id="69" name="Text 69"/>
+          <p:cNvSpPr txBox="1"/>
+          <p:nvPr/>
+        </p:nvSpPr>
+        <p:spPr>
+          <a:xfrm>
+            <a:off x="2267712" y="1353312"/>
+            <a:ext cx="1143000" cy="320040"/>
           </a:xfrm>
           <a:prstGeom prst="rect">
             <a:avLst/>
@@ -4886,29 +5377,29 @@
           </a:bodyPr>
           <a:lstStyle/>
           <a:p>
-            <a:pPr algn="l"/>
-            <a:r>
-              <a:rPr lang="en-US" sz="1500" b="1">
-                <a:solidFill>
-                  <a:srgbClr val="CC9900"/>
-                </a:solidFill>
-                <a:latin typeface="Aptos"/>
-              </a:rPr>
-              <a:t>Caputo memory form</a:t>
-            </a:r>
-          </a:p>
-        </p:txBody>
-      </p:sp>
-      <p:sp>
-        <p:nvSpPr>
-          <p:cNvPr id="68" name="Text 68"/>
-          <p:cNvSpPr txBox="1"/>
-          <p:nvPr/>
-        </p:nvSpPr>
-        <p:spPr>
-          <a:xfrm>
-            <a:off x="694944" y="1664208"/>
-            <a:ext cx="5303520" cy="566928"/>
+            <a:pPr algn="c"/>
+            <a:r>
+              <a:rPr lang="en-US" sz="1000" b="0">
+                <a:solidFill>
+                  <a:srgbClr val="52606C"/>
+                </a:solidFill>
+                <a:latin typeface="Aptos"/>
+              </a:rPr>
+              <a:t>effective transmission</a:t>
+            </a:r>
+          </a:p>
+        </p:txBody>
+      </p:sp>
+      <p:sp>
+        <p:nvSpPr>
+          <p:cNvPr id="70" name="Text 70"/>
+          <p:cNvSpPr txBox="1"/>
+          <p:nvPr/>
+        </p:nvSpPr>
+        <p:spPr>
+          <a:xfrm>
+            <a:off x="4700016" y="1353312"/>
+            <a:ext cx="1143000" cy="320040"/>
           </a:xfrm>
           <a:prstGeom prst="rect">
             <a:avLst/>
@@ -4924,29 +5415,29 @@
           </a:bodyPr>
           <a:lstStyle/>
           <a:p>
-            <a:pPr algn="l"/>
-            <a:r>
-              <a:rPr lang="en-US" sz="2400" b="1">
-                <a:solidFill>
-                  <a:srgbClr val="142030"/>
-                </a:solidFill>
-                <a:latin typeface="Aptos"/>
-              </a:rPr>
-              <a:t>D_C^q X(t) = F(t, X(t)),    0 &lt; q &lt;= 1</a:t>
-            </a:r>
-          </a:p>
-        </p:txBody>
-      </p:sp>
-      <p:sp>
-        <p:nvSpPr>
-          <p:cNvPr id="69" name="Text 69"/>
-          <p:cNvSpPr txBox="1"/>
-          <p:nvPr/>
-        </p:nvSpPr>
-        <p:spPr>
-          <a:xfrm>
-            <a:off x="749808" y="2542032"/>
-            <a:ext cx="5623560" cy="1737360"/>
+            <a:pPr algn="c"/>
+            <a:r>
+              <a:rPr lang="en-US" sz="1000" b="0">
+                <a:solidFill>
+                  <a:srgbClr val="52606C"/>
+                </a:solidFill>
+                <a:latin typeface="Aptos"/>
+              </a:rPr>
+              <a:t>testing and treatment</a:t>
+            </a:r>
+          </a:p>
+        </p:txBody>
+      </p:sp>
+      <p:sp>
+        <p:nvSpPr>
+          <p:cNvPr id="71" name="Text 71"/>
+          <p:cNvSpPr txBox="1"/>
+          <p:nvPr/>
+        </p:nvSpPr>
+        <p:spPr>
+          <a:xfrm>
+            <a:off x="7059168" y="2779776"/>
+            <a:ext cx="1280160" cy="320040"/>
           </a:xfrm>
           <a:prstGeom prst="rect">
             <a:avLst/>
@@ -4962,65 +5453,83 @@
           </a:bodyPr>
           <a:lstStyle/>
           <a:p>
-            <a:pPr algn="l"/>
-            <a:r>
-              <a:rPr lang="en-US" sz="1600" b="0">
-                <a:solidFill>
-                  <a:srgbClr val="142030"/>
-                </a:solidFill>
-                <a:latin typeface="Aptos"/>
-              </a:rPr>
-              <a:t>D_C^q S = Lambda - beta_eff S(I + eta T) - mu S</a:t>
-            </a:r>
-          </a:p>
-          <a:p>
-            <a:pPr algn="l"/>
-            <a:r>
-              <a:rPr lang="en-US" sz="1600" b="0">
-                <a:solidFill>
-                  <a:srgbClr val="142030"/>
-                </a:solidFill>
-                <a:latin typeface="Aptos"/>
-              </a:rPr>
-              <a:t>D_C^q I = beta_eff S(I + eta T) - (tau_eff + delta + mu)I</a:t>
-            </a:r>
-          </a:p>
-          <a:p>
-            <a:pPr algn="l"/>
-            <a:r>
-              <a:rPr lang="en-US" sz="1600" b="0">
-                <a:solidFill>
-                  <a:srgbClr val="142030"/>
-                </a:solidFill>
-                <a:latin typeface="Aptos"/>
-              </a:rPr>
-              <a:t>D_C^q T = tau_eff I - (rho_eff + mu)T</a:t>
-            </a:r>
-          </a:p>
-          <a:p>
-            <a:pPr algn="l"/>
-            <a:r>
-              <a:rPr lang="en-US" sz="1600" b="0">
-                <a:solidFill>
-                  <a:srgbClr val="142030"/>
-                </a:solidFill>
-                <a:latin typeface="Aptos"/>
-              </a:rPr>
-              <a:t>D_C^q A = delta I + rho_eff T - (d + mu)A</a:t>
-            </a:r>
-          </a:p>
-        </p:txBody>
-      </p:sp>
-      <p:sp>
-        <p:nvSpPr>
-          <p:cNvPr id="70" name="Text 70"/>
-          <p:cNvSpPr txBox="1"/>
-          <p:nvPr/>
-        </p:nvSpPr>
-        <p:spPr>
-          <a:xfrm>
-            <a:off x="6812280" y="1417320"/>
-            <a:ext cx="4206240" cy="1325880"/>
+            <a:pPr algn="c"/>
+            <a:r>
+              <a:rPr lang="en-US" sz="1000" b="0">
+                <a:solidFill>
+                  <a:srgbClr val="52606C"/>
+                </a:solidFill>
+                <a:latin typeface="Aptos"/>
+              </a:rPr>
+              <a:t>reduced progression</a:t>
+            </a:r>
+          </a:p>
+        </p:txBody>
+      </p:sp>
+      <p:sp>
+        <p:nvSpPr>
+          <p:cNvPr id="72" name="Text 72"/>
+          <p:cNvSpPr txBox="1"/>
+          <p:nvPr/>
+        </p:nvSpPr>
+        <p:spPr>
+          <a:xfrm>
+            <a:off x="914400" y="4224528"/>
+            <a:ext cx="4846320" cy="960120"/>
+          </a:xfrm>
+          <a:prstGeom prst="rect">
+            <a:avLst/>
+          </a:prstGeom>
+          <a:solidFill>
+            <a:srgbClr val="E8F2FA"/>
+          </a:solidFill>
+          <a:ln w="9525">
+            <a:solidFill>
+              <a:srgbClr val="004A80"/>
+            </a:solidFill>
+          </a:ln>
+        </p:spPr>
+        <p:txBody>
+          <a:bodyPr wrap="square" lIns="91440" rIns="91440" tIns="45720" bIns="45720">
+            <a:normAutofit fontScale="85000" lnSpcReduction="20000"/>
+          </a:bodyPr>
+          <a:lstStyle/>
+          <a:p>
+            <a:pPr algn="l"/>
+            <a:r>
+              <a:rPr lang="en-US" sz="1500" b="0">
+                <a:solidFill>
+                  <a:srgbClr val="142030"/>
+                </a:solidFill>
+                <a:latin typeface="Aptos"/>
+              </a:rPr>
+              <a:t>State variables</a:t>
+            </a:r>
+          </a:p>
+          <a:p>
+            <a:pPr algn="l"/>
+            <a:r>
+              <a:rPr lang="en-US" sz="1500" b="0">
+                <a:solidFill>
+                  <a:srgbClr val="142030"/>
+                </a:solidFill>
+                <a:latin typeface="Aptos"/>
+              </a:rPr>
+              <a:t>S susceptible, I infected, T treated, A AIDS-stage population.</a:t>
+            </a:r>
+          </a:p>
+        </p:txBody>
+      </p:sp>
+      <p:sp>
+        <p:nvSpPr>
+          <p:cNvPr id="73" name="Text 73"/>
+          <p:cNvSpPr txBox="1"/>
+          <p:nvPr/>
+        </p:nvSpPr>
+        <p:spPr>
+          <a:xfrm>
+            <a:off x="6355080" y="4224528"/>
+            <a:ext cx="4709160" cy="960120"/>
           </a:xfrm>
           <a:prstGeom prst="rect">
             <a:avLst/>
@@ -5042,103 +5551,25 @@
           <a:p>
             <a:pPr algn="l"/>
             <a:r>
-              <a:rPr lang="en-US" sz="1600" b="0">
-                <a:solidFill>
-                  <a:srgbClr val="142030"/>
-                </a:solidFill>
-                <a:latin typeface="Aptos"/>
-              </a:rPr>
-              <a:t>Intervention-adjusted rates</a:t>
-            </a:r>
-          </a:p>
-          <a:p>
-            <a:pPr algn="l"/>
-            <a:r>
-              <a:rPr lang="en-US" sz="1600" b="0">
-                <a:solidFill>
-                  <a:srgbClr val="142030"/>
-                </a:solidFill>
-                <a:latin typeface="Aptos"/>
-              </a:rPr>
-              <a:t>beta_eff = beta0(1-u1)(1-u2)</a:t>
-            </a:r>
-          </a:p>
-          <a:p>
-            <a:pPr algn="l"/>
-            <a:r>
-              <a:rPr lang="en-US" sz="1600" b="0">
-                <a:solidFill>
-                  <a:srgbClr val="142030"/>
-                </a:solidFill>
-                <a:latin typeface="Aptos"/>
-              </a:rPr>
-              <a:t>tau_eff = tau(1+u3)</a:t>
-            </a:r>
-          </a:p>
-          <a:p>
-            <a:pPr algn="l"/>
-            <a:r>
-              <a:rPr lang="en-US" sz="1600" b="0">
-                <a:solidFill>
-                  <a:srgbClr val="142030"/>
-                </a:solidFill>
-                <a:latin typeface="Aptos"/>
-              </a:rPr>
-              <a:t>rho_eff = rho(1-u4)</a:t>
-            </a:r>
-          </a:p>
-        </p:txBody>
-      </p:sp>
-      <p:sp>
-        <p:nvSpPr>
-          <p:cNvPr id="71" name="Text 71"/>
-          <p:cNvSpPr txBox="1"/>
-          <p:nvPr/>
-        </p:nvSpPr>
-        <p:spPr>
-          <a:xfrm>
-            <a:off x="6812280" y="3474720"/>
-            <a:ext cx="4206240" cy="960120"/>
-          </a:xfrm>
-          <a:prstGeom prst="rect">
-            <a:avLst/>
-          </a:prstGeom>
-          <a:solidFill>
-            <a:srgbClr val="E6F7F4"/>
-          </a:solidFill>
-          <a:ln w="9525">
-            <a:solidFill>
-              <a:srgbClr val="007E70"/>
-            </a:solidFill>
-          </a:ln>
-        </p:spPr>
-        <p:txBody>
-          <a:bodyPr wrap="square" lIns="91440" rIns="91440" tIns="45720" bIns="45720">
-            <a:normAutofit fontScale="85000" lnSpcReduction="20000"/>
-          </a:bodyPr>
-          <a:lstStyle/>
-          <a:p>
-            <a:pPr algn="l"/>
-            <a:r>
-              <a:rPr lang="en-US" sz="1600" b="0">
-                <a:solidFill>
-                  <a:srgbClr val="142030"/>
-                </a:solidFill>
-                <a:latin typeface="Aptos"/>
-              </a:rPr>
-              <a:t>Meaning of q</a:t>
-            </a:r>
-          </a:p>
-          <a:p>
-            <a:pPr algn="l"/>
-            <a:r>
-              <a:rPr lang="en-US" sz="1600" b="0">
-                <a:solidFill>
-                  <a:srgbClr val="142030"/>
-                </a:solidFill>
-                <a:latin typeface="Aptos"/>
-              </a:rPr>
-              <a:t>q = 1 gives the ordinary model. q &lt; 1 carries memory of past states.</a:t>
+              <a:rPr lang="en-US" sz="1500" b="0">
+                <a:solidFill>
+                  <a:srgbClr val="142030"/>
+                </a:solidFill>
+                <a:latin typeface="Aptos"/>
+              </a:rPr>
+              <a:t>Controls</a:t>
+            </a:r>
+          </a:p>
+          <a:p>
+            <a:pPr algn="l"/>
+            <a:r>
+              <a:rPr lang="en-US" sz="1500" b="0">
+                <a:solidFill>
+                  <a:srgbClr val="142030"/>
+                </a:solidFill>
+                <a:latin typeface="Aptos"/>
+              </a:rPr>
+              <a:t>u1 awareness, u2 safer behaviour, u3 testing, u4 adherence.</a:t>
             </a:r>
           </a:p>
         </p:txBody>
@@ -5170,7 +5601,7 @@
       </p:grpSpPr>
       <p:sp>
         <p:nvSpPr>
-          <p:cNvPr id="72" name="Text 72"/>
+          <p:cNvPr id="74" name="Text 74"/>
           <p:cNvSpPr txBox="1"/>
           <p:nvPr/>
         </p:nvSpPr>
@@ -5201,14 +5632,14 @@
                 </a:solidFill>
                 <a:latin typeface="Aptos"/>
               </a:rPr>
-              <a:t>Numerical Scheme + Implementation</a:t>
-            </a:r>
-          </a:p>
-        </p:txBody>
-      </p:sp>
-      <p:sp>
-        <p:nvSpPr>
-          <p:cNvPr id="73" name="Text 73"/>
+              <a:t>Fractional-Order Model</a:t>
+            </a:r>
+          </a:p>
+        </p:txBody>
+      </p:sp>
+      <p:sp>
+        <p:nvSpPr>
+          <p:cNvPr id="75" name="Text 75"/>
           <p:cNvSpPr txBox="1"/>
           <p:nvPr/>
         </p:nvSpPr>
@@ -5248,7 +5679,7 @@
       </p:sp>
       <p:sp>
         <p:nvSpPr>
-          <p:cNvPr id="74" name="Text 74"/>
+          <p:cNvPr id="76" name="Text 76"/>
           <p:cNvSpPr txBox="1"/>
           <p:nvPr/>
         </p:nvSpPr>
@@ -5288,14 +5719,14 @@
       </p:sp>
       <p:sp>
         <p:nvSpPr>
-          <p:cNvPr id="75" name="Text 75"/>
+          <p:cNvPr id="77" name="Text 77"/>
           <p:cNvSpPr txBox="1"/>
           <p:nvPr/>
         </p:nvSpPr>
         <p:spPr>
           <a:xfrm>
             <a:off x="658368" y="1234440"/>
-            <a:ext cx="4709160" cy="320040"/>
+            <a:ext cx="5303520" cy="320040"/>
           </a:xfrm>
           <a:prstGeom prst="rect">
             <a:avLst/>
@@ -5319,21 +5750,21 @@
                 </a:solidFill>
                 <a:latin typeface="Aptos"/>
               </a:rPr>
-              <a:t>Numerical idea</a:t>
-            </a:r>
-          </a:p>
-        </p:txBody>
-      </p:sp>
-      <p:sp>
-        <p:nvSpPr>
-          <p:cNvPr id="76" name="Text 76"/>
-          <p:cNvSpPr txBox="1"/>
-          <p:nvPr/>
-        </p:nvSpPr>
-        <p:spPr>
-          <a:xfrm>
-            <a:off x="749808" y="1627632"/>
-            <a:ext cx="4937760" cy="2423160"/>
+              <a:t>Caputo memory form</a:t>
+            </a:r>
+          </a:p>
+        </p:txBody>
+      </p:sp>
+      <p:sp>
+        <p:nvSpPr>
+          <p:cNvPr id="78" name="Text 78"/>
+          <p:cNvSpPr txBox="1"/>
+          <p:nvPr/>
+        </p:nvSpPr>
+        <p:spPr>
+          <a:xfrm>
+            <a:off x="694944" y="1664208"/>
+            <a:ext cx="5303520" cy="566928"/>
           </a:xfrm>
           <a:prstGeom prst="rect">
             <a:avLst/>
@@ -5349,87 +5780,113 @@
           </a:bodyPr>
           <a:lstStyle/>
           <a:p>
-            <a:pPr algn="l">
-              <a:buChar char="•"/>
-              <a:buFont typeface="Arial"/>
-            </a:pPr>
-            <a:r>
-              <a:rPr lang="en-US" sz="1800" b="0">
-                <a:solidFill>
-                  <a:srgbClr val="142030"/>
-                </a:solidFill>
-                <a:latin typeface="Aptos"/>
-              </a:rPr>
-              <a:t>Time interval is divided into discrete steps.</a:t>
-            </a:r>
-          </a:p>
-          <a:p>
-            <a:pPr algn="l">
-              <a:buChar char="•"/>
-              <a:buFont typeface="Arial"/>
-            </a:pPr>
-            <a:r>
-              <a:rPr lang="en-US" sz="1800" b="0">
-                <a:solidFill>
-                  <a:srgbClr val="142030"/>
-                </a:solidFill>
-                <a:latin typeface="Aptos"/>
-              </a:rPr>
-              <a:t>A predictor estimates the next state.</a:t>
-            </a:r>
-          </a:p>
-          <a:p>
-            <a:pPr algn="l">
-              <a:buChar char="•"/>
-              <a:buFont typeface="Arial"/>
-            </a:pPr>
-            <a:r>
-              <a:rPr lang="en-US" sz="1800" b="0">
-                <a:solidFill>
-                  <a:srgbClr val="142030"/>
-                </a:solidFill>
-                <a:latin typeface="Aptos"/>
-              </a:rPr>
-              <a:t>A corrector updates the state using fractional-memory weights.</a:t>
-            </a:r>
-          </a:p>
-          <a:p>
-            <a:pPr algn="l">
-              <a:buChar char="•"/>
-              <a:buFont typeface="Arial"/>
-            </a:pPr>
-            <a:r>
-              <a:rPr lang="en-US" sz="1800" b="0">
-                <a:solidFill>
-                  <a:srgbClr val="142030"/>
-                </a:solidFill>
-                <a:latin typeface="Aptos"/>
-              </a:rPr>
-              <a:t>The same engine is used for baseline, memory, intervention, and sensitivity experiments.</a:t>
-            </a:r>
-          </a:p>
-        </p:txBody>
-      </p:sp>
-      <p:sp>
-        <p:nvSpPr>
-          <p:cNvPr id="77" name="Text 77"/>
-          <p:cNvSpPr txBox="1"/>
-          <p:nvPr/>
-        </p:nvSpPr>
-        <p:spPr>
-          <a:xfrm>
-            <a:off x="6355080" y="1170432"/>
-            <a:ext cx="4297680" cy="749808"/>
+            <a:pPr algn="l"/>
+            <a:r>
+              <a:rPr lang="en-US" sz="2400" b="1">
+                <a:solidFill>
+                  <a:srgbClr val="142030"/>
+                </a:solidFill>
+                <a:latin typeface="Aptos"/>
+              </a:rPr>
+              <a:t>D_C^q X(t) = F(t, X(t)),    0 &lt; q &lt;= 1</a:t>
+            </a:r>
+          </a:p>
+        </p:txBody>
+      </p:sp>
+      <p:sp>
+        <p:nvSpPr>
+          <p:cNvPr id="79" name="Text 79"/>
+          <p:cNvSpPr txBox="1"/>
+          <p:nvPr/>
+        </p:nvSpPr>
+        <p:spPr>
+          <a:xfrm>
+            <a:off x="749808" y="2542032"/>
+            <a:ext cx="5623560" cy="1737360"/>
+          </a:xfrm>
+          <a:prstGeom prst="rect">
+            <a:avLst/>
+          </a:prstGeom>
+          <a:noFill/>
+          <a:ln>
+            <a:noFill/>
+          </a:ln>
+        </p:spPr>
+        <p:txBody>
+          <a:bodyPr wrap="square" lIns="91440" rIns="91440" tIns="45720" bIns="45720">
+            <a:normAutofit fontScale="85000" lnSpcReduction="20000"/>
+          </a:bodyPr>
+          <a:lstStyle/>
+          <a:p>
+            <a:pPr algn="l"/>
+            <a:r>
+              <a:rPr lang="en-US" sz="1600" b="0">
+                <a:solidFill>
+                  <a:srgbClr val="142030"/>
+                </a:solidFill>
+                <a:latin typeface="Aptos"/>
+              </a:rPr>
+              <a:t>D_C^q S = Lambda - beta_eff S(I + eta T) - mu S</a:t>
+            </a:r>
+          </a:p>
+          <a:p>
+            <a:pPr algn="l"/>
+            <a:r>
+              <a:rPr lang="en-US" sz="1600" b="0">
+                <a:solidFill>
+                  <a:srgbClr val="142030"/>
+                </a:solidFill>
+                <a:latin typeface="Aptos"/>
+              </a:rPr>
+              <a:t>D_C^q I = beta_eff S(I + eta T) - (tau_eff + delta + mu)I</a:t>
+            </a:r>
+          </a:p>
+          <a:p>
+            <a:pPr algn="l"/>
+            <a:r>
+              <a:rPr lang="en-US" sz="1600" b="0">
+                <a:solidFill>
+                  <a:srgbClr val="142030"/>
+                </a:solidFill>
+                <a:latin typeface="Aptos"/>
+              </a:rPr>
+              <a:t>D_C^q T = tau_eff I - (rho_eff + mu)T</a:t>
+            </a:r>
+          </a:p>
+          <a:p>
+            <a:pPr algn="l"/>
+            <a:r>
+              <a:rPr lang="en-US" sz="1600" b="0">
+                <a:solidFill>
+                  <a:srgbClr val="142030"/>
+                </a:solidFill>
+                <a:latin typeface="Aptos"/>
+              </a:rPr>
+              <a:t>D_C^q A = delta I + rho_eff T - (d + mu)A</a:t>
+            </a:r>
+          </a:p>
+        </p:txBody>
+      </p:sp>
+      <p:sp>
+        <p:nvSpPr>
+          <p:cNvPr id="80" name="Text 80"/>
+          <p:cNvSpPr txBox="1"/>
+          <p:nvPr/>
+        </p:nvSpPr>
+        <p:spPr>
+          <a:xfrm>
+            <a:off x="6812280" y="1417320"/>
+            <a:ext cx="4206240" cy="1325880"/>
           </a:xfrm>
           <a:prstGeom prst="rect">
             <a:avLst/>
           </a:prstGeom>
           <a:solidFill>
-            <a:srgbClr val="E8F2FA"/>
+            <a:srgbClr val="FFF7E0"/>
           </a:solidFill>
           <a:ln w="9525">
             <a:solidFill>
-              <a:srgbClr val="004A80"/>
+              <a:srgbClr val="CC9900"/>
             </a:solidFill>
           </a:ln>
         </p:spPr>
@@ -5441,39 +5898,63 @@
           <a:p>
             <a:pPr algn="l"/>
             <a:r>
-              <a:rPr lang="en-US" sz="1400" b="0">
-                <a:solidFill>
-                  <a:srgbClr val="142030"/>
-                </a:solidFill>
-                <a:latin typeface="Aptos"/>
-              </a:rPr>
-              <a:t>Inputs</a:t>
-            </a:r>
-          </a:p>
-          <a:p>
-            <a:pPr algn="l"/>
-            <a:r>
-              <a:rPr lang="en-US" sz="1400" b="0">
-                <a:solidFill>
-                  <a:srgbClr val="142030"/>
-                </a:solidFill>
-                <a:latin typeface="Aptos"/>
-              </a:rPr>
-              <a:t>parameters, initial conditions, q, controls</a:t>
-            </a:r>
-          </a:p>
-        </p:txBody>
-      </p:sp>
-      <p:sp>
-        <p:nvSpPr>
-          <p:cNvPr id="78" name="Text 78"/>
-          <p:cNvSpPr txBox="1"/>
-          <p:nvPr/>
-        </p:nvSpPr>
-        <p:spPr>
-          <a:xfrm>
-            <a:off x="6355080" y="2084831"/>
-            <a:ext cx="4297680" cy="749808"/>
+              <a:rPr lang="en-US" sz="1600" b="0">
+                <a:solidFill>
+                  <a:srgbClr val="142030"/>
+                </a:solidFill>
+                <a:latin typeface="Aptos"/>
+              </a:rPr>
+              <a:t>Intervention-adjusted rates</a:t>
+            </a:r>
+          </a:p>
+          <a:p>
+            <a:pPr algn="l"/>
+            <a:r>
+              <a:rPr lang="en-US" sz="1600" b="0">
+                <a:solidFill>
+                  <a:srgbClr val="142030"/>
+                </a:solidFill>
+                <a:latin typeface="Aptos"/>
+              </a:rPr>
+              <a:t>beta_eff = beta0(1-u1)(1-u2)</a:t>
+            </a:r>
+          </a:p>
+          <a:p>
+            <a:pPr algn="l"/>
+            <a:r>
+              <a:rPr lang="en-US" sz="1600" b="0">
+                <a:solidFill>
+                  <a:srgbClr val="142030"/>
+                </a:solidFill>
+                <a:latin typeface="Aptos"/>
+              </a:rPr>
+              <a:t>tau_eff = tau(1+u3)</a:t>
+            </a:r>
+          </a:p>
+          <a:p>
+            <a:pPr algn="l"/>
+            <a:r>
+              <a:rPr lang="en-US" sz="1600" b="0">
+                <a:solidFill>
+                  <a:srgbClr val="142030"/>
+                </a:solidFill>
+                <a:latin typeface="Aptos"/>
+              </a:rPr>
+              <a:t>rho_eff = rho(1-u4)</a:t>
+            </a:r>
+          </a:p>
+        </p:txBody>
+      </p:sp>
+      <p:sp>
+        <p:nvSpPr>
+          <p:cNvPr id="81" name="Text 81"/>
+          <p:cNvSpPr txBox="1"/>
+          <p:nvPr/>
+        </p:nvSpPr>
+        <p:spPr>
+          <a:xfrm>
+            <a:off x="6812280" y="3474720"/>
+            <a:ext cx="4206240" cy="960120"/>
           </a:xfrm>
           <a:prstGeom prst="rect">
             <a:avLst/>
@@ -5495,283 +5976,25 @@
           <a:p>
             <a:pPr algn="l"/>
             <a:r>
-              <a:rPr lang="en-US" sz="1400" b="0">
-                <a:solidFill>
-                  <a:srgbClr val="142030"/>
-                </a:solidFill>
-                <a:latin typeface="Aptos"/>
-              </a:rPr>
-              <a:t>Solver</a:t>
-            </a:r>
-          </a:p>
-          <a:p>
-            <a:pPr algn="l"/>
-            <a:r>
-              <a:rPr lang="en-US" sz="1400" b="0">
-                <a:solidFill>
-                  <a:srgbClr val="142030"/>
-                </a:solidFill>
-                <a:latin typeface="Aptos"/>
-              </a:rPr>
-              <a:t>fractional ABM-type numerical method</a:t>
-            </a:r>
-          </a:p>
-        </p:txBody>
-      </p:sp>
-      <p:sp>
-        <p:nvSpPr>
-          <p:cNvPr id="79" name="Text 79"/>
-          <p:cNvSpPr txBox="1"/>
-          <p:nvPr/>
-        </p:nvSpPr>
-        <p:spPr>
-          <a:xfrm>
-            <a:off x="6355080" y="2999232"/>
-            <a:ext cx="4297680" cy="749808"/>
-          </a:xfrm>
-          <a:prstGeom prst="rect">
-            <a:avLst/>
-          </a:prstGeom>
-          <a:solidFill>
-            <a:srgbClr val="FFF7E0"/>
-          </a:solidFill>
-          <a:ln w="9525">
-            <a:solidFill>
-              <a:srgbClr val="CC9900"/>
-            </a:solidFill>
-          </a:ln>
-        </p:spPr>
-        <p:txBody>
-          <a:bodyPr wrap="square" lIns="91440" rIns="91440" tIns="45720" bIns="45720">
-            <a:normAutofit fontScale="85000" lnSpcReduction="20000"/>
-          </a:bodyPr>
-          <a:lstStyle/>
-          <a:p>
-            <a:pPr algn="l"/>
-            <a:r>
-              <a:rPr lang="en-US" sz="1400" b="0">
-                <a:solidFill>
-                  <a:srgbClr val="142030"/>
-                </a:solidFill>
-                <a:latin typeface="Aptos"/>
-              </a:rPr>
-              <a:t>Outputs</a:t>
-            </a:r>
-          </a:p>
-          <a:p>
-            <a:pPr algn="l"/>
-            <a:r>
-              <a:rPr lang="en-US" sz="1400" b="0">
-                <a:solidFill>
-                  <a:srgbClr val="142030"/>
-                </a:solidFill>
-                <a:latin typeface="Aptos"/>
-              </a:rPr>
-              <a:t>trajectories, R0, scenarios, sensitivity</a:t>
-            </a:r>
-          </a:p>
-        </p:txBody>
-      </p:sp>
-      <p:sp>
-        <p:nvSpPr>
-          <p:cNvPr id="80" name="Text 80"/>
-          <p:cNvSpPr txBox="1"/>
-          <p:nvPr/>
-        </p:nvSpPr>
-        <p:spPr>
-          <a:xfrm>
-            <a:off x="6355080" y="3913632"/>
-            <a:ext cx="4297680" cy="749808"/>
-          </a:xfrm>
-          <a:prstGeom prst="rect">
-            <a:avLst/>
-          </a:prstGeom>
-          <a:solidFill>
-            <a:srgbClr val="FFFFFF"/>
-          </a:solidFill>
-          <a:ln w="9525">
-            <a:solidFill>
-              <a:srgbClr val="B44146"/>
-            </a:solidFill>
-          </a:ln>
-        </p:spPr>
-        <p:txBody>
-          <a:bodyPr wrap="square" lIns="91440" rIns="91440" tIns="45720" bIns="45720">
-            <a:normAutofit fontScale="85000" lnSpcReduction="20000"/>
-          </a:bodyPr>
-          <a:lstStyle/>
-          <a:p>
-            <a:pPr algn="l"/>
-            <a:r>
-              <a:rPr lang="en-US" sz="1400" b="0">
-                <a:solidFill>
-                  <a:srgbClr val="142030"/>
-                </a:solidFill>
-                <a:latin typeface="Aptos"/>
-              </a:rPr>
-              <a:t>Presentation</a:t>
-            </a:r>
-          </a:p>
-          <a:p>
-            <a:pPr algn="l"/>
-            <a:r>
-              <a:rPr lang="en-US" sz="1400" b="0">
-                <a:solidFill>
-                  <a:srgbClr val="142030"/>
-                </a:solidFill>
-                <a:latin typeface="Aptos"/>
-              </a:rPr>
-              <a:t>moving graphs during the live demo</a:t>
-            </a:r>
-          </a:p>
-        </p:txBody>
-      </p:sp>
-      <p:cxnSp>
-        <p:nvCxnSpPr>
-          <p:cNvPr id="81" name="Arrow 81"/>
-          <p:cNvCxnSpPr/>
-          <p:nvPr/>
-        </p:nvCxnSpPr>
-        <p:spPr>
-          <a:xfrm>
-            <a:off x="8503920" y="1920240"/>
-            <a:ext cx="0" cy="164591"/>
-          </a:xfrm>
-          <a:prstGeom prst="line">
-            <a:avLst/>
-          </a:prstGeom>
-          <a:ln w="19050">
-            <a:solidFill>
-              <a:srgbClr val="52606C"/>
-            </a:solidFill>
-            <a:tailEnd type="triangle"/>
-          </a:ln>
-        </p:spPr>
-        <p:style>
-          <a:lnRef idx="1">
-            <a:schemeClr val="accent1"/>
-          </a:lnRef>
-          <a:fillRef idx="0">
-            <a:schemeClr val="accent1"/>
-          </a:fillRef>
-          <a:effectRef idx="0">
-            <a:schemeClr val="accent1"/>
-          </a:effectRef>
-          <a:fontRef idx="minor">
-            <a:schemeClr val="tx1"/>
-          </a:fontRef>
-        </p:style>
-      </p:cxnSp>
-      <p:cxnSp>
-        <p:nvCxnSpPr>
-          <p:cNvPr id="82" name="Arrow 82"/>
-          <p:cNvCxnSpPr/>
-          <p:nvPr/>
-        </p:nvCxnSpPr>
-        <p:spPr>
-          <a:xfrm>
-            <a:off x="8503920" y="2834640"/>
-            <a:ext cx="0" cy="164591"/>
-          </a:xfrm>
-          <a:prstGeom prst="line">
-            <a:avLst/>
-          </a:prstGeom>
-          <a:ln w="19050">
-            <a:solidFill>
-              <a:srgbClr val="52606C"/>
-            </a:solidFill>
-            <a:tailEnd type="triangle"/>
-          </a:ln>
-        </p:spPr>
-        <p:style>
-          <a:lnRef idx="1">
-            <a:schemeClr val="accent1"/>
-          </a:lnRef>
-          <a:fillRef idx="0">
-            <a:schemeClr val="accent1"/>
-          </a:fillRef>
-          <a:effectRef idx="0">
-            <a:schemeClr val="accent1"/>
-          </a:effectRef>
-          <a:fontRef idx="minor">
-            <a:schemeClr val="tx1"/>
-          </a:fontRef>
-        </p:style>
-      </p:cxnSp>
-      <p:cxnSp>
-        <p:nvCxnSpPr>
-          <p:cNvPr id="83" name="Arrow 83"/>
-          <p:cNvCxnSpPr/>
-          <p:nvPr/>
-        </p:nvCxnSpPr>
-        <p:spPr>
-          <a:xfrm>
-            <a:off x="8503920" y="3749039"/>
-            <a:ext cx="0" cy="164592"/>
-          </a:xfrm>
-          <a:prstGeom prst="line">
-            <a:avLst/>
-          </a:prstGeom>
-          <a:ln w="19050">
-            <a:solidFill>
-              <a:srgbClr val="52606C"/>
-            </a:solidFill>
-            <a:tailEnd type="triangle"/>
-          </a:ln>
-        </p:spPr>
-        <p:style>
-          <a:lnRef idx="1">
-            <a:schemeClr val="accent1"/>
-          </a:lnRef>
-          <a:fillRef idx="0">
-            <a:schemeClr val="accent1"/>
-          </a:fillRef>
-          <a:effectRef idx="0">
-            <a:schemeClr val="accent1"/>
-          </a:effectRef>
-          <a:fontRef idx="minor">
-            <a:schemeClr val="tx1"/>
-          </a:fontRef>
-        </p:style>
-      </p:cxnSp>
-      <p:sp>
-        <p:nvSpPr>
-          <p:cNvPr id="84" name="Text 84"/>
-          <p:cNvSpPr txBox="1"/>
-          <p:nvPr/>
-        </p:nvSpPr>
-        <p:spPr>
-          <a:xfrm>
-            <a:off x="896112" y="5166360"/>
-            <a:ext cx="9921240" cy="658368"/>
-          </a:xfrm>
-          <a:prstGeom prst="rect">
-            <a:avLst/>
-          </a:prstGeom>
-          <a:solidFill>
-            <a:srgbClr val="FFF7E0"/>
-          </a:solidFill>
-          <a:ln w="9525">
-            <a:solidFill>
-              <a:srgbClr val="CC9900"/>
-            </a:solidFill>
-          </a:ln>
-        </p:spPr>
-        <p:txBody>
-          <a:bodyPr wrap="square" lIns="91440" rIns="91440" tIns="45720" bIns="45720">
-            <a:normAutofit fontScale="85000" lnSpcReduction="20000"/>
-          </a:bodyPr>
-          <a:lstStyle/>
-          <a:p>
-            <a:pPr algn="l"/>
-            <a:r>
               <a:rPr lang="en-US" sz="1600" b="0">
                 <a:solidFill>
                   <a:srgbClr val="142030"/>
                 </a:solidFill>
                 <a:latin typeface="Aptos"/>
               </a:rPr>
-              <a:t>Presentation link: the mathematical model is explained in the slides; moving graphs are shown separately during the live demonstration.</a:t>
+              <a:t>Meaning of q</a:t>
+            </a:r>
+          </a:p>
+          <a:p>
+            <a:pPr algn="l"/>
+            <a:r>
+              <a:rPr lang="en-US" sz="1600" b="0">
+                <a:solidFill>
+                  <a:srgbClr val="142030"/>
+                </a:solidFill>
+                <a:latin typeface="Aptos"/>
+              </a:rPr>
+              <a:t>q = 1 gives the ordinary model. q &lt; 1 carries memory of past states.</a:t>
             </a:r>
           </a:p>
         </p:txBody>
@@ -5803,7 +6026,7 @@
       </p:grpSpPr>
       <p:sp>
         <p:nvSpPr>
-          <p:cNvPr id="86" name="Text 86"/>
+          <p:cNvPr id="82" name="Text 82"/>
           <p:cNvSpPr txBox="1"/>
           <p:nvPr/>
         </p:nvSpPr>
@@ -5834,14 +6057,14 @@
                 </a:solidFill>
                 <a:latin typeface="Aptos"/>
               </a:rPr>
-              <a:t>Baseline Simulation Result</a:t>
-            </a:r>
-          </a:p>
-        </p:txBody>
-      </p:sp>
-      <p:sp>
-        <p:nvSpPr>
-          <p:cNvPr id="87" name="Text 87"/>
+              <a:t>Numerical Scheme + Implementation</a:t>
+            </a:r>
+          </a:p>
+        </p:txBody>
+      </p:sp>
+      <p:sp>
+        <p:nvSpPr>
+          <p:cNvPr id="83" name="Text 83"/>
           <p:cNvSpPr txBox="1"/>
           <p:nvPr/>
         </p:nvSpPr>
@@ -5881,7 +6104,7 @@
       </p:sp>
       <p:sp>
         <p:nvSpPr>
-          <p:cNvPr id="88" name="Text 88"/>
+          <p:cNvPr id="84" name="Text 84"/>
           <p:cNvSpPr txBox="1"/>
           <p:nvPr/>
         </p:nvSpPr>
@@ -5919,38 +6142,16 @@
           </a:p>
         </p:txBody>
       </p:sp>
-      <p:pic>
-        <p:nvPicPr>
-          <p:cNvPr id="85" name="mainChartlinear.png"/>
-          <p:cNvPicPr/>
-          <p:nvPr/>
-        </p:nvPicPr>
-        <p:blipFill>
-          <a:blip r:embed="rId2"/>
-          <a:stretch>
-            <a:fillRect/>
-          </a:stretch>
-        </p:blipFill>
-        <p:spPr>
-          <a:xfrm>
-            <a:off x="640080" y="1261872"/>
-            <a:ext cx="6309360" cy="4251960"/>
-          </a:xfrm>
-          <a:prstGeom prst="rect">
-            <a:avLst/>
-          </a:prstGeom>
-        </p:spPr>
-      </p:pic>
-      <p:sp>
-        <p:nvSpPr>
-          <p:cNvPr id="89" name="Text 89"/>
-          <p:cNvSpPr txBox="1"/>
-          <p:nvPr/>
-        </p:nvSpPr>
-        <p:spPr>
-          <a:xfrm>
-            <a:off x="7360920" y="1234440"/>
-            <a:ext cx="3566160" cy="320040"/>
+      <p:sp>
+        <p:nvSpPr>
+          <p:cNvPr id="85" name="Text 85"/>
+          <p:cNvSpPr txBox="1"/>
+          <p:nvPr/>
+        </p:nvSpPr>
+        <p:spPr>
+          <a:xfrm>
+            <a:off x="658368" y="1234440"/>
+            <a:ext cx="4709160" cy="320040"/>
           </a:xfrm>
           <a:prstGeom prst="rect">
             <a:avLst/>
@@ -5974,21 +6175,21 @@
                 </a:solidFill>
                 <a:latin typeface="Aptos"/>
               </a:rPr>
-              <a:t>Computed baseline</a:t>
-            </a:r>
-          </a:p>
-        </p:txBody>
-      </p:sp>
-      <p:sp>
-        <p:nvSpPr>
-          <p:cNvPr id="90" name="Text 90"/>
-          <p:cNvSpPr txBox="1"/>
-          <p:nvPr/>
-        </p:nvSpPr>
-        <p:spPr>
-          <a:xfrm>
-            <a:off x="7406640" y="1627632"/>
-            <a:ext cx="3566160" cy="1234440"/>
+              <a:t>Numerical idea</a:t>
+            </a:r>
+          </a:p>
+        </p:txBody>
+      </p:sp>
+      <p:sp>
+        <p:nvSpPr>
+          <p:cNvPr id="86" name="Text 86"/>
+          <p:cNvSpPr txBox="1"/>
+          <p:nvPr/>
+        </p:nvSpPr>
+        <p:spPr>
+          <a:xfrm>
+            <a:off x="749808" y="1627632"/>
+            <a:ext cx="4937760" cy="2423160"/>
           </a:xfrm>
           <a:prstGeom prst="rect">
             <a:avLst/>
@@ -6009,13 +6210,13 @@
               <a:buFont typeface="Arial"/>
             </a:pPr>
             <a:r>
-              <a:rPr lang="en-US" sz="1500" b="0">
-                <a:solidFill>
-                  <a:srgbClr val="142030"/>
-                </a:solidFill>
-                <a:latin typeface="Aptos"/>
-              </a:rPr>
-              <a:t>R0 = 0.430, below the epidemic threshold.</a:t>
+              <a:rPr lang="en-US" sz="1800" b="0">
+                <a:solidFill>
+                  <a:srgbClr val="142030"/>
+                </a:solidFill>
+                <a:latin typeface="Aptos"/>
+              </a:rPr>
+              <a:t>Time interval is divided into discrete steps.</a:t>
             </a:r>
           </a:p>
           <a:p>
@@ -6024,13 +6225,13 @@
               <a:buFont typeface="Arial"/>
             </a:pPr>
             <a:r>
-              <a:rPr lang="en-US" sz="1500" b="0">
-                <a:solidFill>
-                  <a:srgbClr val="142030"/>
-                </a:solidFill>
-                <a:latin typeface="Aptos"/>
-              </a:rPr>
-              <a:t>Peak infected population is 150 at t = 0 years.</a:t>
+              <a:rPr lang="en-US" sz="1800" b="0">
+                <a:solidFill>
+                  <a:srgbClr val="142030"/>
+                </a:solidFill>
+                <a:latin typeface="Aptos"/>
+              </a:rPr>
+              <a:t>A predictor estimates the next state.</a:t>
             </a:r>
           </a:p>
           <a:p>
@@ -6039,27 +6240,96 @@
               <a:buFont typeface="Arial"/>
             </a:pPr>
             <a:r>
-              <a:rPr lang="en-US" sz="1500" b="0">
-                <a:solidFill>
-                  <a:srgbClr val="142030"/>
-                </a:solidFill>
-                <a:latin typeface="Aptos"/>
-              </a:rPr>
-              <a:t>Final values after 50 years: I = 3.1, T = 94.3, A = 3.6.</a:t>
-            </a:r>
-          </a:p>
-        </p:txBody>
-      </p:sp>
-      <p:sp>
-        <p:nvSpPr>
-          <p:cNvPr id="91" name="Text 91"/>
-          <p:cNvSpPr txBox="1"/>
-          <p:nvPr/>
-        </p:nvSpPr>
-        <p:spPr>
-          <a:xfrm>
-            <a:off x="7360920" y="3310128"/>
-            <a:ext cx="3657600" cy="1024128"/>
+              <a:rPr lang="en-US" sz="1800" b="0">
+                <a:solidFill>
+                  <a:srgbClr val="142030"/>
+                </a:solidFill>
+                <a:latin typeface="Aptos"/>
+              </a:rPr>
+              <a:t>A corrector updates the state using fractional-memory weights.</a:t>
+            </a:r>
+          </a:p>
+          <a:p>
+            <a:pPr algn="l">
+              <a:buChar char="•"/>
+              <a:buFont typeface="Arial"/>
+            </a:pPr>
+            <a:r>
+              <a:rPr lang="en-US" sz="1800" b="0">
+                <a:solidFill>
+                  <a:srgbClr val="142030"/>
+                </a:solidFill>
+                <a:latin typeface="Aptos"/>
+              </a:rPr>
+              <a:t>The same engine is used for baseline, memory, intervention, and sensitivity experiments.</a:t>
+            </a:r>
+          </a:p>
+        </p:txBody>
+      </p:sp>
+      <p:sp>
+        <p:nvSpPr>
+          <p:cNvPr id="87" name="Text 87"/>
+          <p:cNvSpPr txBox="1"/>
+          <p:nvPr/>
+        </p:nvSpPr>
+        <p:spPr>
+          <a:xfrm>
+            <a:off x="6355080" y="1170432"/>
+            <a:ext cx="4297680" cy="749808"/>
+          </a:xfrm>
+          <a:prstGeom prst="rect">
+            <a:avLst/>
+          </a:prstGeom>
+          <a:solidFill>
+            <a:srgbClr val="E8F2FA"/>
+          </a:solidFill>
+          <a:ln w="9525">
+            <a:solidFill>
+              <a:srgbClr val="004A80"/>
+            </a:solidFill>
+          </a:ln>
+        </p:spPr>
+        <p:txBody>
+          <a:bodyPr wrap="square" lIns="91440" rIns="91440" tIns="45720" bIns="45720">
+            <a:normAutofit fontScale="85000" lnSpcReduction="20000"/>
+          </a:bodyPr>
+          <a:lstStyle/>
+          <a:p>
+            <a:pPr algn="l"/>
+            <a:r>
+              <a:rPr lang="en-US" sz="1400" b="0">
+                <a:solidFill>
+                  <a:srgbClr val="142030"/>
+                </a:solidFill>
+                <a:latin typeface="Aptos"/>
+              </a:rPr>
+              <a:t>Inputs</a:t>
+            </a:r>
+          </a:p>
+          <a:p>
+            <a:pPr algn="l"/>
+            <a:r>
+              <a:rPr lang="en-US" sz="1400" b="0">
+                <a:solidFill>
+                  <a:srgbClr val="142030"/>
+                </a:solidFill>
+                <a:latin typeface="Aptos"/>
+              </a:rPr>
+              <a:t>parameters, initial conditions, q, controls</a:t>
+            </a:r>
+          </a:p>
+        </p:txBody>
+      </p:sp>
+      <p:sp>
+        <p:nvSpPr>
+          <p:cNvPr id="88" name="Text 88"/>
+          <p:cNvSpPr txBox="1"/>
+          <p:nvPr/>
+        </p:nvSpPr>
+        <p:spPr>
+          <a:xfrm>
+            <a:off x="6355080" y="2084831"/>
+            <a:ext cx="4297680" cy="749808"/>
           </a:xfrm>
           <a:prstGeom prst="rect">
             <a:avLst/>
@@ -6087,7 +6357,7 @@
                 </a:solidFill>
                 <a:latin typeface="Aptos"/>
               </a:rPr>
-              <a:t>Interpretation</a:t>
+              <a:t>Solver</a:t>
             </a:r>
           </a:p>
           <a:p>
@@ -6099,21 +6369,21 @@
                 </a:solidFill>
                 <a:latin typeface="Aptos"/>
               </a:rPr>
-              <a:t>The baseline intervention-adjusted configuration leads toward disease-free behaviour in the simulation.</a:t>
-            </a:r>
-          </a:p>
-        </p:txBody>
-      </p:sp>
-      <p:sp>
-        <p:nvSpPr>
-          <p:cNvPr id="92" name="Text 92"/>
-          <p:cNvSpPr txBox="1"/>
-          <p:nvPr/>
-        </p:nvSpPr>
-        <p:spPr>
-          <a:xfrm>
-            <a:off x="7360920" y="4645152"/>
-            <a:ext cx="3657600" cy="694944"/>
+              <a:t>fractional ABM-type numerical method</a:t>
+            </a:r>
+          </a:p>
+        </p:txBody>
+      </p:sp>
+      <p:sp>
+        <p:nvSpPr>
+          <p:cNvPr id="89" name="Text 89"/>
+          <p:cNvSpPr txBox="1"/>
+          <p:nvPr/>
+        </p:nvSpPr>
+        <p:spPr>
+          <a:xfrm>
+            <a:off x="6355080" y="2999232"/>
+            <a:ext cx="4297680" cy="749808"/>
           </a:xfrm>
           <a:prstGeom prst="rect">
             <a:avLst/>
@@ -6135,25 +6405,229 @@
           <a:p>
             <a:pPr algn="l"/>
             <a:r>
-              <a:rPr lang="en-US" sz="1300" b="0">
-                <a:solidFill>
-                  <a:srgbClr val="142030"/>
-                </a:solidFill>
-                <a:latin typeface="Aptos"/>
-              </a:rPr>
-              <a:t>Defense point</a:t>
-            </a:r>
-          </a:p>
-          <a:p>
-            <a:pPr algn="l"/>
-            <a:r>
-              <a:rPr lang="en-US" sz="1300" b="0">
-                <a:solidFill>
-                  <a:srgbClr val="142030"/>
-                </a:solidFill>
-                <a:latin typeface="Aptos"/>
-              </a:rPr>
-              <a:t>These numbers come from the Python simulation engine and match the dashboard summary table.</a:t>
+              <a:rPr lang="en-US" sz="1400" b="0">
+                <a:solidFill>
+                  <a:srgbClr val="142030"/>
+                </a:solidFill>
+                <a:latin typeface="Aptos"/>
+              </a:rPr>
+              <a:t>Outputs</a:t>
+            </a:r>
+          </a:p>
+          <a:p>
+            <a:pPr algn="l"/>
+            <a:r>
+              <a:rPr lang="en-US" sz="1400" b="0">
+                <a:solidFill>
+                  <a:srgbClr val="142030"/>
+                </a:solidFill>
+                <a:latin typeface="Aptos"/>
+              </a:rPr>
+              <a:t>trajectories, R0, scenarios, sensitivity</a:t>
+            </a:r>
+          </a:p>
+        </p:txBody>
+      </p:sp>
+      <p:sp>
+        <p:nvSpPr>
+          <p:cNvPr id="90" name="Text 90"/>
+          <p:cNvSpPr txBox="1"/>
+          <p:nvPr/>
+        </p:nvSpPr>
+        <p:spPr>
+          <a:xfrm>
+            <a:off x="6355080" y="3913632"/>
+            <a:ext cx="4297680" cy="749808"/>
+          </a:xfrm>
+          <a:prstGeom prst="rect">
+            <a:avLst/>
+          </a:prstGeom>
+          <a:solidFill>
+            <a:srgbClr val="FFFFFF"/>
+          </a:solidFill>
+          <a:ln w="9525">
+            <a:solidFill>
+              <a:srgbClr val="B44146"/>
+            </a:solidFill>
+          </a:ln>
+        </p:spPr>
+        <p:txBody>
+          <a:bodyPr wrap="square" lIns="91440" rIns="91440" tIns="45720" bIns="45720">
+            <a:normAutofit fontScale="85000" lnSpcReduction="20000"/>
+          </a:bodyPr>
+          <a:lstStyle/>
+          <a:p>
+            <a:pPr algn="l"/>
+            <a:r>
+              <a:rPr lang="en-US" sz="1400" b="0">
+                <a:solidFill>
+                  <a:srgbClr val="142030"/>
+                </a:solidFill>
+                <a:latin typeface="Aptos"/>
+              </a:rPr>
+              <a:t>Presentation</a:t>
+            </a:r>
+          </a:p>
+          <a:p>
+            <a:pPr algn="l"/>
+            <a:r>
+              <a:rPr lang="en-US" sz="1400" b="0">
+                <a:solidFill>
+                  <a:srgbClr val="142030"/>
+                </a:solidFill>
+                <a:latin typeface="Aptos"/>
+              </a:rPr>
+              <a:t>moving graphs during the live demo</a:t>
+            </a:r>
+          </a:p>
+        </p:txBody>
+      </p:sp>
+      <p:cxnSp>
+        <p:nvCxnSpPr>
+          <p:cNvPr id="91" name="Arrow 91"/>
+          <p:cNvCxnSpPr/>
+          <p:nvPr/>
+        </p:nvCxnSpPr>
+        <p:spPr>
+          <a:xfrm>
+            <a:off x="8503920" y="1920240"/>
+            <a:ext cx="0" cy="164591"/>
+          </a:xfrm>
+          <a:prstGeom prst="line">
+            <a:avLst/>
+          </a:prstGeom>
+          <a:ln w="19050">
+            <a:solidFill>
+              <a:srgbClr val="52606C"/>
+            </a:solidFill>
+            <a:tailEnd type="triangle"/>
+          </a:ln>
+        </p:spPr>
+        <p:style>
+          <a:lnRef idx="1">
+            <a:schemeClr val="accent1"/>
+          </a:lnRef>
+          <a:fillRef idx="0">
+            <a:schemeClr val="accent1"/>
+          </a:fillRef>
+          <a:effectRef idx="0">
+            <a:schemeClr val="accent1"/>
+          </a:effectRef>
+          <a:fontRef idx="minor">
+            <a:schemeClr val="tx1"/>
+          </a:fontRef>
+        </p:style>
+      </p:cxnSp>
+      <p:cxnSp>
+        <p:nvCxnSpPr>
+          <p:cNvPr id="92" name="Arrow 92"/>
+          <p:cNvCxnSpPr/>
+          <p:nvPr/>
+        </p:nvCxnSpPr>
+        <p:spPr>
+          <a:xfrm>
+            <a:off x="8503920" y="2834640"/>
+            <a:ext cx="0" cy="164591"/>
+          </a:xfrm>
+          <a:prstGeom prst="line">
+            <a:avLst/>
+          </a:prstGeom>
+          <a:ln w="19050">
+            <a:solidFill>
+              <a:srgbClr val="52606C"/>
+            </a:solidFill>
+            <a:tailEnd type="triangle"/>
+          </a:ln>
+        </p:spPr>
+        <p:style>
+          <a:lnRef idx="1">
+            <a:schemeClr val="accent1"/>
+          </a:lnRef>
+          <a:fillRef idx="0">
+            <a:schemeClr val="accent1"/>
+          </a:fillRef>
+          <a:effectRef idx="0">
+            <a:schemeClr val="accent1"/>
+          </a:effectRef>
+          <a:fontRef idx="minor">
+            <a:schemeClr val="tx1"/>
+          </a:fontRef>
+        </p:style>
+      </p:cxnSp>
+      <p:cxnSp>
+        <p:nvCxnSpPr>
+          <p:cNvPr id="93" name="Arrow 93"/>
+          <p:cNvCxnSpPr/>
+          <p:nvPr/>
+        </p:nvCxnSpPr>
+        <p:spPr>
+          <a:xfrm>
+            <a:off x="8503920" y="3749039"/>
+            <a:ext cx="0" cy="164592"/>
+          </a:xfrm>
+          <a:prstGeom prst="line">
+            <a:avLst/>
+          </a:prstGeom>
+          <a:ln w="19050">
+            <a:solidFill>
+              <a:srgbClr val="52606C"/>
+            </a:solidFill>
+            <a:tailEnd type="triangle"/>
+          </a:ln>
+        </p:spPr>
+        <p:style>
+          <a:lnRef idx="1">
+            <a:schemeClr val="accent1"/>
+          </a:lnRef>
+          <a:fillRef idx="0">
+            <a:schemeClr val="accent1"/>
+          </a:fillRef>
+          <a:effectRef idx="0">
+            <a:schemeClr val="accent1"/>
+          </a:effectRef>
+          <a:fontRef idx="minor">
+            <a:schemeClr val="tx1"/>
+          </a:fontRef>
+        </p:style>
+      </p:cxnSp>
+      <p:sp>
+        <p:nvSpPr>
+          <p:cNvPr id="94" name="Text 94"/>
+          <p:cNvSpPr txBox="1"/>
+          <p:nvPr/>
+        </p:nvSpPr>
+        <p:spPr>
+          <a:xfrm>
+            <a:off x="896112" y="5166360"/>
+            <a:ext cx="9921240" cy="658368"/>
+          </a:xfrm>
+          <a:prstGeom prst="rect">
+            <a:avLst/>
+          </a:prstGeom>
+          <a:solidFill>
+            <a:srgbClr val="FFF7E0"/>
+          </a:solidFill>
+          <a:ln w="9525">
+            <a:solidFill>
+              <a:srgbClr val="CC9900"/>
+            </a:solidFill>
+          </a:ln>
+        </p:spPr>
+        <p:txBody>
+          <a:bodyPr wrap="square" lIns="91440" rIns="91440" tIns="45720" bIns="45720">
+            <a:normAutofit fontScale="85000" lnSpcReduction="20000"/>
+          </a:bodyPr>
+          <a:lstStyle/>
+          <a:p>
+            <a:pPr algn="l"/>
+            <a:r>
+              <a:rPr lang="en-US" sz="1600" b="0">
+                <a:solidFill>
+                  <a:srgbClr val="142030"/>
+                </a:solidFill>
+                <a:latin typeface="Aptos"/>
+              </a:rPr>
+              <a:t>Presentation link: the mathematical model is explained in the slides; moving graphs are shown separately during the live demonstration.</a:t>
             </a:r>
           </a:p>
         </p:txBody>

</xml_diff>

<commit_message>
Update validation messages and presentation materials to clarify fractional order q and its implications
</commit_message>
<xml_diff>
--- a/presentation/FracHIV_SITA_Presentation.pptx
+++ b/presentation/FracHIV_SITA_Presentation.pptx
@@ -4247,31 +4247,43 @@
           <a:p>
             <a:pPr algn="l"/>
             <a:r>
-              <a:rPr lang="en-US" sz="1400" b="0">
-                <a:solidFill>
-                  <a:srgbClr val="142030"/>
-                </a:solidFill>
-                <a:latin typeface="Aptos"/>
-              </a:rPr>
-              <a:t>D_C^q S = Lambda - beta_eff S(I + eta T) - mu S</a:t>
-            </a:r>
-          </a:p>
-          <a:p>
-            <a:pPr algn="l"/>
-            <a:r>
-              <a:rPr lang="en-US" sz="1400" b="0">
-                <a:solidFill>
-                  <a:srgbClr val="142030"/>
-                </a:solidFill>
-                <a:latin typeface="Aptos"/>
-              </a:rPr>
-              <a:t>D_C^q I = beta_eff S(I + eta T) - (tau_eff + delta + mu)I</a:t>
-            </a:r>
-          </a:p>
-          <a:p>
-            <a:pPr algn="l"/>
-            <a:r>
-              <a:rPr lang="en-US" sz="1400" b="0">
+              <a:rPr lang="en-US" sz="1300" b="0">
+                <a:solidFill>
+                  <a:srgbClr val="142030"/>
+                </a:solidFill>
+                <a:latin typeface="Aptos"/>
+              </a:rPr>
+              <a:t>lambda(t) = beta_eff(I + eta T)/N</a:t>
+            </a:r>
+          </a:p>
+          <a:p>
+            <a:pPr algn="l"/>
+            <a:r>
+              <a:rPr lang="en-US" sz="1300" b="0">
+                <a:solidFill>
+                  <a:srgbClr val="142030"/>
+                </a:solidFill>
+                <a:latin typeface="Aptos"/>
+              </a:rPr>
+              <a:t>D_C^q S = Lambda - lambda(t)S - mu S</a:t>
+            </a:r>
+          </a:p>
+          <a:p>
+            <a:pPr algn="l"/>
+            <a:r>
+              <a:rPr lang="en-US" sz="1300" b="0">
+                <a:solidFill>
+                  <a:srgbClr val="142030"/>
+                </a:solidFill>
+                <a:latin typeface="Aptos"/>
+              </a:rPr>
+              <a:t>D_C^q I = lambda(t)S - (tau_eff + delta + mu)I</a:t>
+            </a:r>
+          </a:p>
+          <a:p>
+            <a:pPr algn="l"/>
+            <a:r>
+              <a:rPr lang="en-US" sz="1300" b="0">
                 <a:solidFill>
                   <a:srgbClr val="142030"/>
                 </a:solidFill>
@@ -4283,7 +4295,7 @@
           <a:p>
             <a:pPr algn="l"/>
             <a:r>
-              <a:rPr lang="en-US" sz="1400" b="0">
+              <a:rPr lang="en-US" sz="1300" b="0">
                 <a:solidFill>
                   <a:srgbClr val="142030"/>
                 </a:solidFill>

</xml_diff>

<commit_message>
Update presentation interventions image for improved visual quality
</commit_message>
<xml_diff>
--- a/presentation/FracHIV_SITA_Presentation.pptx
+++ b/presentation/FracHIV_SITA_Presentation.pptx
@@ -2,7 +2,7 @@
 <file path=ppt/presentation.xml><?xml version="1.0" encoding="utf-8"?>
 <p:presentation xmlns:a="http://schemas.openxmlformats.org/drawingml/2006/main" xmlns:r="http://schemas.openxmlformats.org/officeDocument/2006/relationships" xmlns:p="http://schemas.openxmlformats.org/presentationml/2006/main">
   <p:sldMasterIdLst>
-    <p:sldMasterId id="2147483648" r:id="rId14"/>
+    <p:sldMasterId id="2147483648" r:id="rId15"/>
   </p:sldMasterIdLst>
   <p:sldIdLst>
     <p:sldId id="256" r:id="rId1"/>
@@ -18,6 +18,7 @@
     <p:sldId id="266" r:id="rId11"/>
     <p:sldId id="267" r:id="rId12"/>
     <p:sldId id="268" r:id="rId13"/>
+    <p:sldId id="269" r:id="rId14"/>
   </p:sldIdLst>
   <p:sldSz cx="12191999" cy="6858000" type="screen16x9"/>
   <p:notesSz cx="6858000" cy="9144000"/>
@@ -611,7 +612,7 @@
       </p:grpSpPr>
       <p:sp>
         <p:nvSpPr>
-          <p:cNvPr id="94" name="Text 94"/>
+          <p:cNvPr id="102" name="Text 102"/>
           <p:cNvSpPr txBox="1"/>
           <p:nvPr/>
         </p:nvSpPr>
@@ -642,14 +643,14 @@
                 </a:solidFill>
                 <a:latin typeface="Aptos"/>
               </a:rPr>
-              <a:t>Simulation Results: Fractional Memory</a:t>
-            </a:r>
-          </a:p>
-        </p:txBody>
-      </p:sp>
-      <p:sp>
-        <p:nvSpPr>
-          <p:cNvPr id="95" name="Text 95"/>
+              <a:t>Simulation Results: Intervention Comparison</a:t>
+            </a:r>
+          </a:p>
+        </p:txBody>
+      </p:sp>
+      <p:sp>
+        <p:nvSpPr>
+          <p:cNvPr id="103" name="Text 103"/>
           <p:cNvSpPr txBox="1"/>
           <p:nvPr/>
         </p:nvSpPr>
@@ -689,7 +690,7 @@
       </p:sp>
       <p:sp>
         <p:nvSpPr>
-          <p:cNvPr id="96" name="Text 96"/>
+          <p:cNvPr id="104" name="Text 104"/>
           <p:cNvSpPr txBox="1"/>
           <p:nvPr/>
         </p:nvSpPr>
@@ -729,7 +730,7 @@
       </p:sp>
       <p:pic>
         <p:nvPicPr>
-          <p:cNvPr id="93" name="presentation_memory.png"/>
+          <p:cNvPr id="101" name="presentation_interventions.png"/>
           <p:cNvPicPr/>
           <p:nvPr/>
         </p:nvPicPr>
@@ -741,8 +742,8 @@
         </p:blipFill>
         <p:spPr>
           <a:xfrm>
-            <a:off x="347472" y="1078992"/>
-            <a:ext cx="11503152" cy="3922776"/>
+            <a:off x="384048" y="1078992"/>
+            <a:ext cx="11430000" cy="3730752"/>
           </a:xfrm>
           <a:prstGeom prst="rect">
             <a:avLst/>
@@ -751,7 +752,7 @@
       </p:pic>
       <p:sp>
         <p:nvSpPr>
-          <p:cNvPr id="97" name="Text 97"/>
+          <p:cNvPr id="105" name="Text 105"/>
           <p:cNvSpPr txBox="1"/>
           <p:nvPr/>
         </p:nvSpPr>
@@ -764,11 +765,11 @@
             <a:avLst/>
           </a:prstGeom>
           <a:solidFill>
-            <a:srgbClr val="FFF7E0"/>
+            <a:srgbClr val="E6F7F4"/>
           </a:solidFill>
           <a:ln w="9525">
             <a:solidFill>
-              <a:srgbClr val="CC9900"/>
+              <a:srgbClr val="007E70"/>
             </a:solidFill>
           </a:ln>
         </p:spPr>
@@ -786,7 +787,7 @@
                 </a:solidFill>
                 <a:latin typeface="Aptos"/>
               </a:rPr>
-              <a:t>▶ q = 1 is the ordinary model; q &lt; 1 introduces memory. The curve separation shows the computational effect of fractional memory. Source: submitted report, Chapter 6 memory comparison.</a:t>
+              <a:t>▶ Lower curves mean fewer infected individuals. Combined strategies act on transmission, treatment movement, and AIDS progression together. Source: submitted report, Chapter 6 intervention comparison.</a:t>
             </a:r>
           </a:p>
         </p:txBody>
@@ -818,7 +819,7 @@
       </p:grpSpPr>
       <p:sp>
         <p:nvSpPr>
-          <p:cNvPr id="99" name="Text 99"/>
+          <p:cNvPr id="107" name="Text 107"/>
           <p:cNvSpPr txBox="1"/>
           <p:nvPr/>
         </p:nvSpPr>
@@ -849,14 +850,14 @@
                 </a:solidFill>
                 <a:latin typeface="Aptos"/>
               </a:rPr>
-              <a:t>Dashboard and Sensitivity Evidence</a:t>
-            </a:r>
-          </a:p>
-        </p:txBody>
-      </p:sp>
-      <p:sp>
-        <p:nvSpPr>
-          <p:cNvPr id="100" name="Text 100"/>
+              <a:t>Simulation Results: Fractional Memory</a:t>
+            </a:r>
+          </a:p>
+        </p:txBody>
+      </p:sp>
+      <p:sp>
+        <p:nvSpPr>
+          <p:cNvPr id="108" name="Text 108"/>
           <p:cNvSpPr txBox="1"/>
           <p:nvPr/>
         </p:nvSpPr>
@@ -896,7 +897,7 @@
       </p:sp>
       <p:sp>
         <p:nvSpPr>
-          <p:cNvPr id="101" name="Text 101"/>
+          <p:cNvPr id="109" name="Text 109"/>
           <p:cNvSpPr txBox="1"/>
           <p:nvPr/>
         </p:nvSpPr>
@@ -936,7 +937,7 @@
       </p:sp>
       <p:pic>
         <p:nvPicPr>
-          <p:cNvPr id="98" name="presentation_sensitivity.png"/>
+          <p:cNvPr id="106" name="presentation_memory.png"/>
           <p:cNvPicPr/>
           <p:nvPr/>
         </p:nvPicPr>
@@ -948,8 +949,8 @@
         </p:blipFill>
         <p:spPr>
           <a:xfrm>
-            <a:off x="585216" y="1024128"/>
-            <a:ext cx="11018520" cy="4187952"/>
+            <a:off x="347472" y="1078992"/>
+            <a:ext cx="11503152" cy="3922776"/>
           </a:xfrm>
           <a:prstGeom prst="rect">
             <a:avLst/>
@@ -958,24 +959,24 @@
       </p:pic>
       <p:sp>
         <p:nvSpPr>
-          <p:cNvPr id="102" name="Text 102"/>
-          <p:cNvSpPr txBox="1"/>
-          <p:nvPr/>
-        </p:nvSpPr>
-        <p:spPr>
-          <a:xfrm>
-            <a:off x="585216" y="5413248"/>
-            <a:ext cx="11018520" cy="548640"/>
-          </a:xfrm>
-          <a:prstGeom prst="rect">
-            <a:avLst/>
-          </a:prstGeom>
-          <a:solidFill>
-            <a:srgbClr val="E6F7F4"/>
+          <p:cNvPr id="110" name="Text 110"/>
+          <p:cNvSpPr txBox="1"/>
+          <p:nvPr/>
+        </p:nvSpPr>
+        <p:spPr>
+          <a:xfrm>
+            <a:off x="585216" y="5321808"/>
+            <a:ext cx="11018520" cy="621792"/>
+          </a:xfrm>
+          <a:prstGeom prst="rect">
+            <a:avLst/>
+          </a:prstGeom>
+          <a:solidFill>
+            <a:srgbClr val="FFF7E0"/>
           </a:solidFill>
           <a:ln w="9525">
             <a:solidFill>
-              <a:srgbClr val="007E70"/>
+              <a:srgbClr val="CC9900"/>
             </a:solidFill>
           </a:ln>
         </p:spPr>
@@ -993,7 +994,7 @@
                 </a:solidFill>
                 <a:latin typeface="Aptos"/>
               </a:rPr>
-              <a:t>▶ Sensitivity index: U_p^R0=(partial R0/partial p)(p/R0). Positive bars increase R0; negative bars reduce R0. Source: submitted report, Chapter 6 sensitivity analysis.</a:t>
+              <a:t>▶ q = 1 is the ordinary model; q &lt; 1 introduces memory. The curve separation shows the computational effect of fractional memory. Source: submitted report, Chapter 6 memory comparison.</a:t>
             </a:r>
           </a:p>
         </p:txBody>
@@ -1025,7 +1026,7 @@
       </p:grpSpPr>
       <p:sp>
         <p:nvSpPr>
-          <p:cNvPr id="104" name="Text 104"/>
+          <p:cNvPr id="112" name="Text 112"/>
           <p:cNvSpPr txBox="1"/>
           <p:nvPr/>
         </p:nvSpPr>
@@ -1056,14 +1057,14 @@
                 </a:solidFill>
                 <a:latin typeface="Aptos"/>
               </a:rPr>
-              <a:t>Live Dashboard Demonstration</a:t>
-            </a:r>
-          </a:p>
-        </p:txBody>
-      </p:sp>
-      <p:sp>
-        <p:nvSpPr>
-          <p:cNvPr id="105" name="Text 105"/>
+              <a:t>Dashboard and Sensitivity Evidence</a:t>
+            </a:r>
+          </a:p>
+        </p:txBody>
+      </p:sp>
+      <p:sp>
+        <p:nvSpPr>
+          <p:cNvPr id="113" name="Text 113"/>
           <p:cNvSpPr txBox="1"/>
           <p:nvPr/>
         </p:nvSpPr>
@@ -1103,7 +1104,7 @@
       </p:sp>
       <p:sp>
         <p:nvSpPr>
-          <p:cNvPr id="106" name="Text 106"/>
+          <p:cNvPr id="114" name="Text 114"/>
           <p:cNvSpPr txBox="1"/>
           <p:nvPr/>
         </p:nvSpPr>
@@ -1141,187 +1142,9 @@
           </a:p>
         </p:txBody>
       </p:sp>
-      <p:sp>
-        <p:nvSpPr>
-          <p:cNvPr id="107" name="Text 107"/>
-          <p:cNvSpPr txBox="1"/>
-          <p:nvPr/>
-        </p:nvSpPr>
-        <p:spPr>
-          <a:xfrm>
-            <a:off x="658368" y="1234440"/>
-            <a:ext cx="5074920" cy="320040"/>
-          </a:xfrm>
-          <a:prstGeom prst="rect">
-            <a:avLst/>
-          </a:prstGeom>
-          <a:noFill/>
-          <a:ln>
-            <a:noFill/>
-          </a:ln>
-        </p:spPr>
-        <p:txBody>
-          <a:bodyPr wrap="square" lIns="91440" rIns="91440" tIns="45720" bIns="45720">
-            <a:normAutofit fontScale="85000" lnSpcReduction="20000"/>
-          </a:bodyPr>
-          <a:lstStyle/>
-          <a:p>
-            <a:pPr algn="l"/>
-            <a:r>
-              <a:rPr lang="en-US" sz="1500" b="1">
-                <a:solidFill>
-                  <a:srgbClr val="CC9900"/>
-                </a:solidFill>
-                <a:latin typeface="Aptos"/>
-              </a:rPr>
-              <a:t>Open during the defense</a:t>
-            </a:r>
-          </a:p>
-        </p:txBody>
-      </p:sp>
-      <p:sp>
-        <p:nvSpPr>
-          <p:cNvPr id="108" name="Text 108"/>
-          <p:cNvSpPr txBox="1"/>
-          <p:nvPr/>
-        </p:nvSpPr>
-        <p:spPr>
-          <a:xfrm>
-            <a:off x="749808" y="1664208"/>
-            <a:ext cx="5029200" cy="731520"/>
-          </a:xfrm>
-          <a:prstGeom prst="rect">
-            <a:avLst/>
-          </a:prstGeom>
-          <a:solidFill>
-            <a:srgbClr val="E8F2FA"/>
-          </a:solidFill>
-          <a:ln w="9525">
-            <a:solidFill>
-              <a:srgbClr val="004A80"/>
-            </a:solidFill>
-          </a:ln>
-        </p:spPr>
-        <p:txBody>
-          <a:bodyPr wrap="square" lIns="91440" rIns="91440" tIns="45720" bIns="45720">
-            <a:normAutofit fontScale="85000" lnSpcReduction="20000"/>
-          </a:bodyPr>
-          <a:lstStyle/>
-          <a:p>
-            <a:pPr algn="l"/>
-            <a:r>
-              <a:rPr lang="en-US" sz="1800" b="0">
-                <a:solidFill>
-                  <a:srgbClr val="142030"/>
-                </a:solidFill>
-                <a:latin typeface="Aptos"/>
-              </a:rPr>
-              <a:t>Dashboard link</a:t>
-            </a:r>
-          </a:p>
-          <a:p>
-            <a:pPr algn="l"/>
-            <a:r>
-              <a:rPr lang="en-US" sz="1800" b="0">
-                <a:solidFill>
-                  <a:srgbClr val="142030"/>
-                </a:solidFill>
-                <a:latin typeface="Aptos"/>
-              </a:rPr>
-              <a:t>https://hiv-model.onrender.com/</a:t>
-            </a:r>
-          </a:p>
-        </p:txBody>
-      </p:sp>
-      <p:sp>
-        <p:nvSpPr>
-          <p:cNvPr id="109" name="Text 109"/>
-          <p:cNvSpPr txBox="1"/>
-          <p:nvPr/>
-        </p:nvSpPr>
-        <p:spPr>
-          <a:xfrm>
-            <a:off x="768096" y="2788920"/>
-            <a:ext cx="5120640" cy="1645920"/>
-          </a:xfrm>
-          <a:prstGeom prst="rect">
-            <a:avLst/>
-          </a:prstGeom>
-          <a:noFill/>
-          <a:ln>
-            <a:noFill/>
-          </a:ln>
-        </p:spPr>
-        <p:txBody>
-          <a:bodyPr wrap="square" lIns="91440" rIns="91440" tIns="45720" bIns="45720">
-            <a:normAutofit fontScale="85000" lnSpcReduction="20000"/>
-          </a:bodyPr>
-          <a:lstStyle/>
-          <a:p>
-            <a:pPr algn="l">
-              <a:buChar char="•"/>
-              <a:buFont typeface="Arial"/>
-            </a:pPr>
-            <a:r>
-              <a:rPr lang="en-US" sz="1600" b="0">
-                <a:solidFill>
-                  <a:srgbClr val="142030"/>
-                </a:solidFill>
-                <a:latin typeface="Aptos"/>
-              </a:rPr>
-              <a:t>Run the baseline simulation.</a:t>
-            </a:r>
-          </a:p>
-          <a:p>
-            <a:pPr algn="l">
-              <a:buChar char="•"/>
-              <a:buFont typeface="Arial"/>
-            </a:pPr>
-            <a:r>
-              <a:rPr lang="en-US" sz="1600" b="0">
-                <a:solidFill>
-                  <a:srgbClr val="142030"/>
-                </a:solidFill>
-                <a:latin typeface="Aptos"/>
-              </a:rPr>
-              <a:t>Show the final state summary and interpretation.</a:t>
-            </a:r>
-          </a:p>
-          <a:p>
-            <a:pPr algn="l">
-              <a:buChar char="•"/>
-              <a:buFont typeface="Arial"/>
-            </a:pPr>
-            <a:r>
-              <a:rPr lang="en-US" sz="1600" b="0">
-                <a:solidFill>
-                  <a:srgbClr val="142030"/>
-                </a:solidFill>
-                <a:latin typeface="Aptos"/>
-              </a:rPr>
-              <a:t>Compare no intervention with combined intervention.</a:t>
-            </a:r>
-          </a:p>
-          <a:p>
-            <a:pPr algn="l">
-              <a:buChar char="•"/>
-              <a:buFont typeface="Arial"/>
-            </a:pPr>
-            <a:r>
-              <a:rPr lang="en-US" sz="1600" b="0">
-                <a:solidFill>
-                  <a:srgbClr val="142030"/>
-                </a:solidFill>
-                <a:latin typeface="Aptos"/>
-              </a:rPr>
-              <a:t>Change q to show the fractional memory effect.</a:t>
-            </a:r>
-          </a:p>
-        </p:txBody>
-      </p:sp>
       <p:pic>
         <p:nvPicPr>
-          <p:cNvPr id="103" name="dashboardBaselineFigure.png"/>
+          <p:cNvPr id="111" name="presentation_sensitivity.png"/>
           <p:cNvPicPr/>
           <p:nvPr/>
         </p:nvPicPr>
@@ -1333,14 +1156,56 @@
         </p:blipFill>
         <p:spPr>
           <a:xfrm>
-            <a:off x="6583680" y="1417320"/>
-            <a:ext cx="4297680" cy="2331720"/>
+            <a:off x="585216" y="1024128"/>
+            <a:ext cx="11018520" cy="4187952"/>
           </a:xfrm>
           <a:prstGeom prst="rect">
             <a:avLst/>
           </a:prstGeom>
         </p:spPr>
       </p:pic>
+      <p:sp>
+        <p:nvSpPr>
+          <p:cNvPr id="115" name="Text 115"/>
+          <p:cNvSpPr txBox="1"/>
+          <p:nvPr/>
+        </p:nvSpPr>
+        <p:spPr>
+          <a:xfrm>
+            <a:off x="585216" y="5413248"/>
+            <a:ext cx="11018520" cy="548640"/>
+          </a:xfrm>
+          <a:prstGeom prst="rect">
+            <a:avLst/>
+          </a:prstGeom>
+          <a:solidFill>
+            <a:srgbClr val="E6F7F4"/>
+          </a:solidFill>
+          <a:ln w="9525">
+            <a:solidFill>
+              <a:srgbClr val="007E70"/>
+            </a:solidFill>
+          </a:ln>
+        </p:spPr>
+        <p:txBody>
+          <a:bodyPr wrap="square" lIns="91440" rIns="91440" tIns="45720" bIns="45720">
+            <a:normAutofit fontScale="85000" lnSpcReduction="20000"/>
+          </a:bodyPr>
+          <a:lstStyle/>
+          <a:p>
+            <a:pPr algn="l"/>
+            <a:r>
+              <a:rPr lang="en-US" sz="1400" b="0">
+                <a:solidFill>
+                  <a:srgbClr val="142030"/>
+                </a:solidFill>
+                <a:latin typeface="Aptos"/>
+              </a:rPr>
+              <a:t>▶ Sensitivity index: U_p^R0=(partial R0/partial p)(p/R0). Positive bars increase R0; negative bars reduce R0. Source: submitted report, Chapter 6 sensitivity analysis.</a:t>
+            </a:r>
+          </a:p>
+        </p:txBody>
+      </p:sp>
     </p:spTree>
   </p:cSld>
   <p:clrMapOvr>
@@ -1368,7 +1233,7 @@
       </p:grpSpPr>
       <p:sp>
         <p:nvSpPr>
-          <p:cNvPr id="110" name="Text 110"/>
+          <p:cNvPr id="117" name="Text 117"/>
           <p:cNvSpPr txBox="1"/>
           <p:nvPr/>
         </p:nvSpPr>
@@ -1399,14 +1264,14 @@
                 </a:solidFill>
                 <a:latin typeface="Aptos"/>
               </a:rPr>
-              <a:t>Conclusion + Recommendations</a:t>
-            </a:r>
-          </a:p>
-        </p:txBody>
-      </p:sp>
-      <p:sp>
-        <p:nvSpPr>
-          <p:cNvPr id="111" name="Text 111"/>
+              <a:t>Live Dashboard Demonstration</a:t>
+            </a:r>
+          </a:p>
+        </p:txBody>
+      </p:sp>
+      <p:sp>
+        <p:nvSpPr>
+          <p:cNvPr id="118" name="Text 118"/>
           <p:cNvSpPr txBox="1"/>
           <p:nvPr/>
         </p:nvSpPr>
@@ -1446,7 +1311,7 @@
       </p:sp>
       <p:sp>
         <p:nvSpPr>
-          <p:cNvPr id="112" name="Text 112"/>
+          <p:cNvPr id="119" name="Text 119"/>
           <p:cNvSpPr txBox="1"/>
           <p:nvPr/>
         </p:nvSpPr>
@@ -1486,14 +1351,14 @@
       </p:sp>
       <p:sp>
         <p:nvSpPr>
-          <p:cNvPr id="113" name="Text 113"/>
+          <p:cNvPr id="120" name="Text 120"/>
           <p:cNvSpPr txBox="1"/>
           <p:nvPr/>
         </p:nvSpPr>
         <p:spPr>
           <a:xfrm>
             <a:off x="658368" y="1234440"/>
-            <a:ext cx="4709160" cy="320040"/>
+            <a:ext cx="5074920" cy="320040"/>
           </a:xfrm>
           <a:prstGeom prst="rect">
             <a:avLst/>
@@ -1517,21 +1382,75 @@
                 </a:solidFill>
                 <a:latin typeface="Aptos"/>
               </a:rPr>
-              <a:t>Conclusion</a:t>
-            </a:r>
-          </a:p>
-        </p:txBody>
-      </p:sp>
-      <p:sp>
-        <p:nvSpPr>
-          <p:cNvPr id="114" name="Text 114"/>
-          <p:cNvSpPr txBox="1"/>
-          <p:nvPr/>
-        </p:nvSpPr>
-        <p:spPr>
-          <a:xfrm>
-            <a:off x="713232" y="1627632"/>
-            <a:ext cx="4800600" cy="2880360"/>
+              <a:t>Open during the defense</a:t>
+            </a:r>
+          </a:p>
+        </p:txBody>
+      </p:sp>
+      <p:sp>
+        <p:nvSpPr>
+          <p:cNvPr id="121" name="Text 121"/>
+          <p:cNvSpPr txBox="1"/>
+          <p:nvPr/>
+        </p:nvSpPr>
+        <p:spPr>
+          <a:xfrm>
+            <a:off x="749808" y="1664208"/>
+            <a:ext cx="5029200" cy="731520"/>
+          </a:xfrm>
+          <a:prstGeom prst="rect">
+            <a:avLst/>
+          </a:prstGeom>
+          <a:solidFill>
+            <a:srgbClr val="E8F2FA"/>
+          </a:solidFill>
+          <a:ln w="9525">
+            <a:solidFill>
+              <a:srgbClr val="004A80"/>
+            </a:solidFill>
+          </a:ln>
+        </p:spPr>
+        <p:txBody>
+          <a:bodyPr wrap="square" lIns="91440" rIns="91440" tIns="45720" bIns="45720">
+            <a:normAutofit fontScale="85000" lnSpcReduction="20000"/>
+          </a:bodyPr>
+          <a:lstStyle/>
+          <a:p>
+            <a:pPr algn="l"/>
+            <a:r>
+              <a:rPr lang="en-US" sz="1800" b="0">
+                <a:solidFill>
+                  <a:srgbClr val="142030"/>
+                </a:solidFill>
+                <a:latin typeface="Aptos"/>
+              </a:rPr>
+              <a:t>Dashboard link</a:t>
+            </a:r>
+          </a:p>
+          <a:p>
+            <a:pPr algn="l"/>
+            <a:r>
+              <a:rPr lang="en-US" sz="1800" b="0">
+                <a:solidFill>
+                  <a:srgbClr val="142030"/>
+                </a:solidFill>
+                <a:latin typeface="Aptos"/>
+              </a:rPr>
+              <a:t>https://hiv-model.onrender.com/</a:t>
+            </a:r>
+          </a:p>
+        </p:txBody>
+      </p:sp>
+      <p:sp>
+        <p:nvSpPr>
+          <p:cNvPr id="122" name="Text 122"/>
+          <p:cNvSpPr txBox="1"/>
+          <p:nvPr/>
+        </p:nvSpPr>
+        <p:spPr>
+          <a:xfrm>
+            <a:off x="768096" y="2788920"/>
+            <a:ext cx="5120640" cy="1645920"/>
           </a:xfrm>
           <a:prstGeom prst="rect">
             <a:avLst/>
@@ -1552,13 +1471,13 @@
               <a:buFont typeface="Arial"/>
             </a:pPr>
             <a:r>
-              <a:rPr lang="en-US" sz="1800" b="0">
-                <a:solidFill>
-                  <a:srgbClr val="142030"/>
-                </a:solidFill>
-                <a:latin typeface="Aptos"/>
-              </a:rPr>
-              <a:t>The SITA HIV model was extended using fractional memory.</a:t>
+              <a:rPr lang="en-US" sz="1600" b="0">
+                <a:solidFill>
+                  <a:srgbClr val="142030"/>
+                </a:solidFill>
+                <a:latin typeface="Aptos"/>
+              </a:rPr>
+              <a:t>Run the baseline simulation.</a:t>
             </a:r>
           </a:p>
           <a:p>
@@ -1567,13 +1486,13 @@
               <a:buFont typeface="Arial"/>
             </a:pPr>
             <a:r>
-              <a:rPr lang="en-US" sz="1800" b="0">
-                <a:solidFill>
-                  <a:srgbClr val="142030"/>
-                </a:solidFill>
-                <a:latin typeface="Aptos"/>
-              </a:rPr>
-              <a:t>Behavioural interventions were represented through effective rates.</a:t>
+              <a:rPr lang="en-US" sz="1600" b="0">
+                <a:solidFill>
+                  <a:srgbClr val="142030"/>
+                </a:solidFill>
+                <a:latin typeface="Aptos"/>
+              </a:rPr>
+              <a:t>Show the final state summary and interpretation.</a:t>
             </a:r>
           </a:p>
           <a:p>
@@ -1582,94 +1501,259 @@
               <a:buFont typeface="Arial"/>
             </a:pPr>
             <a:r>
-              <a:rPr lang="en-US" sz="1800" b="0">
-                <a:solidFill>
-                  <a:srgbClr val="142030"/>
-                </a:solidFill>
-                <a:latin typeface="Aptos"/>
-              </a:rPr>
-              <a:t>Numerical simulations support combined intervention strategies.</a:t>
-            </a:r>
-          </a:p>
-        </p:txBody>
-      </p:sp>
-      <p:sp>
-        <p:nvSpPr>
-          <p:cNvPr id="115" name="Text 115"/>
-          <p:cNvSpPr txBox="1"/>
-          <p:nvPr/>
-        </p:nvSpPr>
-        <p:spPr>
-          <a:xfrm>
-            <a:off x="6080760" y="1234440"/>
-            <a:ext cx="4663440" cy="320040"/>
-          </a:xfrm>
-          <a:prstGeom prst="rect">
-            <a:avLst/>
-          </a:prstGeom>
-          <a:noFill/>
-          <a:ln>
-            <a:noFill/>
-          </a:ln>
-        </p:spPr>
-        <p:txBody>
-          <a:bodyPr wrap="square" lIns="91440" rIns="91440" tIns="45720" bIns="45720">
-            <a:normAutofit fontScale="85000" lnSpcReduction="20000"/>
-          </a:bodyPr>
-          <a:lstStyle/>
-          <a:p>
-            <a:pPr algn="l"/>
-            <a:r>
-              <a:rPr lang="en-US" sz="1500" b="1">
-                <a:solidFill>
-                  <a:srgbClr val="CC9900"/>
-                </a:solidFill>
-                <a:latin typeface="Aptos"/>
-              </a:rPr>
-              <a:t>Recommendations</a:t>
-            </a:r>
-          </a:p>
-        </p:txBody>
-      </p:sp>
-      <p:sp>
-        <p:nvSpPr>
-          <p:cNvPr id="116" name="Text 116"/>
-          <p:cNvSpPr txBox="1"/>
-          <p:nvPr/>
-        </p:nvSpPr>
-        <p:spPr>
-          <a:xfrm>
-            <a:off x="6144768" y="1627632"/>
-            <a:ext cx="4800600" cy="2880360"/>
-          </a:xfrm>
-          <a:prstGeom prst="rect">
-            <a:avLst/>
-          </a:prstGeom>
-          <a:noFill/>
-          <a:ln>
-            <a:noFill/>
-          </a:ln>
-        </p:spPr>
-        <p:txBody>
-          <a:bodyPr wrap="square" lIns="91440" rIns="91440" tIns="45720" bIns="45720">
-            <a:normAutofit fontScale="85000" lnSpcReduction="20000"/>
-          </a:bodyPr>
-          <a:lstStyle/>
+              <a:rPr lang="en-US" sz="1600" b="0">
+                <a:solidFill>
+                  <a:srgbClr val="142030"/>
+                </a:solidFill>
+                <a:latin typeface="Aptos"/>
+              </a:rPr>
+              <a:t>Compare no intervention with combined intervention.</a:t>
+            </a:r>
+          </a:p>
           <a:p>
             <a:pPr algn="l">
               <a:buChar char="•"/>
               <a:buFont typeface="Arial"/>
             </a:pPr>
             <a:r>
-              <a:rPr lang="en-US" sz="1800" b="0">
-                <a:solidFill>
-                  <a:srgbClr val="142030"/>
-                </a:solidFill>
-                <a:latin typeface="Aptos"/>
-              </a:rPr>
-              <a:t>Calibrate parameters with Rwanda-specific data.</a:t>
-            </a:r>
-          </a:p>
+              <a:rPr lang="en-US" sz="1600" b="0">
+                <a:solidFill>
+                  <a:srgbClr val="142030"/>
+                </a:solidFill>
+                <a:latin typeface="Aptos"/>
+              </a:rPr>
+              <a:t>Change q to show the fractional memory effect.</a:t>
+            </a:r>
+          </a:p>
+        </p:txBody>
+      </p:sp>
+      <p:pic>
+        <p:nvPicPr>
+          <p:cNvPr id="116" name="dashboardBaselineFigure.png"/>
+          <p:cNvPicPr/>
+          <p:nvPr/>
+        </p:nvPicPr>
+        <p:blipFill>
+          <a:blip r:embed="rId2"/>
+          <a:stretch>
+            <a:fillRect/>
+          </a:stretch>
+        </p:blipFill>
+        <p:spPr>
+          <a:xfrm>
+            <a:off x="6583680" y="1417320"/>
+            <a:ext cx="4297680" cy="2331720"/>
+          </a:xfrm>
+          <a:prstGeom prst="rect">
+            <a:avLst/>
+          </a:prstGeom>
+        </p:spPr>
+      </p:pic>
+    </p:spTree>
+  </p:cSld>
+  <p:clrMapOvr>
+    <a:masterClrMapping/>
+  </p:clrMapOvr>
+</p:sld>
+</file>
+
+<file path=ppt/slides/slide14.xml><?xml version="1.0" encoding="utf-8"?>
+<p:sld xmlns:a="http://schemas.openxmlformats.org/drawingml/2006/main" xmlns:r="http://schemas.openxmlformats.org/officeDocument/2006/relationships" xmlns:p="http://schemas.openxmlformats.org/presentationml/2006/main">
+  <p:cSld>
+    <p:spTree>
+      <p:nvGrpSpPr>
+        <p:cNvPr id="1" name=""/>
+        <p:cNvGrpSpPr/>
+        <p:nvPr/>
+      </p:nvGrpSpPr>
+      <p:grpSpPr>
+        <a:xfrm>
+          <a:off x="0" y="0"/>
+          <a:ext cx="0" cy="0"/>
+          <a:chOff x="0" y="0"/>
+          <a:chExt cx="0" cy="0"/>
+        </a:xfrm>
+      </p:grpSpPr>
+      <p:sp>
+        <p:nvSpPr>
+          <p:cNvPr id="123" name="Text 123"/>
+          <p:cNvSpPr txBox="1"/>
+          <p:nvPr/>
+        </p:nvSpPr>
+        <p:spPr>
+          <a:xfrm>
+            <a:off x="502920" y="292608"/>
+            <a:ext cx="10058400" cy="384048"/>
+          </a:xfrm>
+          <a:prstGeom prst="rect">
+            <a:avLst/>
+          </a:prstGeom>
+          <a:noFill/>
+          <a:ln>
+            <a:noFill/>
+          </a:ln>
+        </p:spPr>
+        <p:txBody>
+          <a:bodyPr wrap="square" lIns="91440" rIns="91440" tIns="45720" bIns="45720">
+            <a:normAutofit fontScale="85000" lnSpcReduction="20000"/>
+          </a:bodyPr>
+          <a:lstStyle/>
+          <a:p>
+            <a:pPr algn="l"/>
+            <a:r>
+              <a:rPr lang="en-US" sz="2300" b="1">
+                <a:solidFill>
+                  <a:srgbClr val="0A1B30"/>
+                </a:solidFill>
+                <a:latin typeface="Aptos"/>
+              </a:rPr>
+              <a:t>Conclusion + Recommendations</a:t>
+            </a:r>
+          </a:p>
+        </p:txBody>
+      </p:sp>
+      <p:sp>
+        <p:nvSpPr>
+          <p:cNvPr id="124" name="Text 124"/>
+          <p:cNvSpPr txBox="1"/>
+          <p:nvPr/>
+        </p:nvSpPr>
+        <p:spPr>
+          <a:xfrm>
+            <a:off x="502920" y="868680"/>
+            <a:ext cx="1828800" cy="27432"/>
+          </a:xfrm>
+          <a:prstGeom prst="rect">
+            <a:avLst/>
+          </a:prstGeom>
+          <a:solidFill>
+            <a:srgbClr val="CC9900"/>
+          </a:solidFill>
+          <a:ln>
+            <a:noFill/>
+          </a:ln>
+        </p:spPr>
+        <p:txBody>
+          <a:bodyPr wrap="square" lIns="91440" rIns="91440" tIns="45720" bIns="45720">
+            <a:normAutofit fontScale="85000" lnSpcReduction="20000"/>
+          </a:bodyPr>
+          <a:lstStyle/>
+          <a:p>
+            <a:pPr algn="l"/>
+            <a:r>
+              <a:rPr lang="en-US" sz="2400" b="0">
+                <a:solidFill>
+                  <a:srgbClr val="142030"/>
+                </a:solidFill>
+                <a:latin typeface="Aptos"/>
+              </a:rPr>
+              <a:t/>
+            </a:r>
+          </a:p>
+        </p:txBody>
+      </p:sp>
+      <p:sp>
+        <p:nvSpPr>
+          <p:cNvPr id="125" name="Text 125"/>
+          <p:cNvSpPr txBox="1"/>
+          <p:nvPr/>
+        </p:nvSpPr>
+        <p:spPr>
+          <a:xfrm>
+            <a:off x="2331720" y="868680"/>
+            <a:ext cx="6949440" cy="27432"/>
+          </a:xfrm>
+          <a:prstGeom prst="rect">
+            <a:avLst/>
+          </a:prstGeom>
+          <a:solidFill>
+            <a:srgbClr val="007E70"/>
+          </a:solidFill>
+          <a:ln>
+            <a:noFill/>
+          </a:ln>
+        </p:spPr>
+        <p:txBody>
+          <a:bodyPr wrap="square" lIns="91440" rIns="91440" tIns="45720" bIns="45720">
+            <a:normAutofit fontScale="85000" lnSpcReduction="20000"/>
+          </a:bodyPr>
+          <a:lstStyle/>
+          <a:p>
+            <a:pPr algn="l"/>
+            <a:r>
+              <a:rPr lang="en-US" sz="2400" b="0">
+                <a:solidFill>
+                  <a:srgbClr val="142030"/>
+                </a:solidFill>
+                <a:latin typeface="Aptos"/>
+              </a:rPr>
+              <a:t/>
+            </a:r>
+          </a:p>
+        </p:txBody>
+      </p:sp>
+      <p:sp>
+        <p:nvSpPr>
+          <p:cNvPr id="126" name="Text 126"/>
+          <p:cNvSpPr txBox="1"/>
+          <p:nvPr/>
+        </p:nvSpPr>
+        <p:spPr>
+          <a:xfrm>
+            <a:off x="658368" y="1234440"/>
+            <a:ext cx="4709160" cy="320040"/>
+          </a:xfrm>
+          <a:prstGeom prst="rect">
+            <a:avLst/>
+          </a:prstGeom>
+          <a:noFill/>
+          <a:ln>
+            <a:noFill/>
+          </a:ln>
+        </p:spPr>
+        <p:txBody>
+          <a:bodyPr wrap="square" lIns="91440" rIns="91440" tIns="45720" bIns="45720">
+            <a:normAutofit fontScale="85000" lnSpcReduction="20000"/>
+          </a:bodyPr>
+          <a:lstStyle/>
+          <a:p>
+            <a:pPr algn="l"/>
+            <a:r>
+              <a:rPr lang="en-US" sz="1500" b="1">
+                <a:solidFill>
+                  <a:srgbClr val="CC9900"/>
+                </a:solidFill>
+                <a:latin typeface="Aptos"/>
+              </a:rPr>
+              <a:t>Conclusion</a:t>
+            </a:r>
+          </a:p>
+        </p:txBody>
+      </p:sp>
+      <p:sp>
+        <p:nvSpPr>
+          <p:cNvPr id="127" name="Text 127"/>
+          <p:cNvSpPr txBox="1"/>
+          <p:nvPr/>
+        </p:nvSpPr>
+        <p:spPr>
+          <a:xfrm>
+            <a:off x="713232" y="1627632"/>
+            <a:ext cx="4800600" cy="2880360"/>
+          </a:xfrm>
+          <a:prstGeom prst="rect">
+            <a:avLst/>
+          </a:prstGeom>
+          <a:noFill/>
+          <a:ln>
+            <a:noFill/>
+          </a:ln>
+        </p:spPr>
+        <p:txBody>
+          <a:bodyPr wrap="square" lIns="91440" rIns="91440" tIns="45720" bIns="45720">
+            <a:normAutofit fontScale="85000" lnSpcReduction="20000"/>
+          </a:bodyPr>
+          <a:lstStyle/>
           <a:p>
             <a:pPr algn="l">
               <a:buChar char="•"/>
@@ -1682,7 +1766,7 @@
                 </a:solidFill>
                 <a:latin typeface="Aptos"/>
               </a:rPr>
-              <a:t>Extend the model using age, gender, or stochastic structure.</a:t>
+              <a:t>The SITA HIV model was extended using fractional memory.</a:t>
             </a:r>
           </a:p>
           <a:p>
@@ -1697,7 +1781,7 @@
                 </a:solidFill>
                 <a:latin typeface="Aptos"/>
               </a:rPr>
-              <a:t>Compare other fractional operators.</a:t>
+              <a:t>Behavioural interventions were represented through effective rates.</a:t>
             </a:r>
           </a:p>
           <a:p>
@@ -1712,6 +1796,130 @@
                 </a:solidFill>
                 <a:latin typeface="Aptos"/>
               </a:rPr>
+              <a:t>Numerical simulations support combined intervention strategies.</a:t>
+            </a:r>
+          </a:p>
+        </p:txBody>
+      </p:sp>
+      <p:sp>
+        <p:nvSpPr>
+          <p:cNvPr id="128" name="Text 128"/>
+          <p:cNvSpPr txBox="1"/>
+          <p:nvPr/>
+        </p:nvSpPr>
+        <p:spPr>
+          <a:xfrm>
+            <a:off x="6080760" y="1234440"/>
+            <a:ext cx="4663440" cy="320040"/>
+          </a:xfrm>
+          <a:prstGeom prst="rect">
+            <a:avLst/>
+          </a:prstGeom>
+          <a:noFill/>
+          <a:ln>
+            <a:noFill/>
+          </a:ln>
+        </p:spPr>
+        <p:txBody>
+          <a:bodyPr wrap="square" lIns="91440" rIns="91440" tIns="45720" bIns="45720">
+            <a:normAutofit fontScale="85000" lnSpcReduction="20000"/>
+          </a:bodyPr>
+          <a:lstStyle/>
+          <a:p>
+            <a:pPr algn="l"/>
+            <a:r>
+              <a:rPr lang="en-US" sz="1500" b="1">
+                <a:solidFill>
+                  <a:srgbClr val="CC9900"/>
+                </a:solidFill>
+                <a:latin typeface="Aptos"/>
+              </a:rPr>
+              <a:t>Recommendations</a:t>
+            </a:r>
+          </a:p>
+        </p:txBody>
+      </p:sp>
+      <p:sp>
+        <p:nvSpPr>
+          <p:cNvPr id="129" name="Text 129"/>
+          <p:cNvSpPr txBox="1"/>
+          <p:nvPr/>
+        </p:nvSpPr>
+        <p:spPr>
+          <a:xfrm>
+            <a:off x="6144768" y="1627632"/>
+            <a:ext cx="4800600" cy="2880360"/>
+          </a:xfrm>
+          <a:prstGeom prst="rect">
+            <a:avLst/>
+          </a:prstGeom>
+          <a:noFill/>
+          <a:ln>
+            <a:noFill/>
+          </a:ln>
+        </p:spPr>
+        <p:txBody>
+          <a:bodyPr wrap="square" lIns="91440" rIns="91440" tIns="45720" bIns="45720">
+            <a:normAutofit fontScale="85000" lnSpcReduction="20000"/>
+          </a:bodyPr>
+          <a:lstStyle/>
+          <a:p>
+            <a:pPr algn="l">
+              <a:buChar char="•"/>
+              <a:buFont typeface="Arial"/>
+            </a:pPr>
+            <a:r>
+              <a:rPr lang="en-US" sz="1800" b="0">
+                <a:solidFill>
+                  <a:srgbClr val="142030"/>
+                </a:solidFill>
+                <a:latin typeface="Aptos"/>
+              </a:rPr>
+              <a:t>Calibrate parameters with Rwanda-specific data.</a:t>
+            </a:r>
+          </a:p>
+          <a:p>
+            <a:pPr algn="l">
+              <a:buChar char="•"/>
+              <a:buFont typeface="Arial"/>
+            </a:pPr>
+            <a:r>
+              <a:rPr lang="en-US" sz="1800" b="0">
+                <a:solidFill>
+                  <a:srgbClr val="142030"/>
+                </a:solidFill>
+                <a:latin typeface="Aptos"/>
+              </a:rPr>
+              <a:t>Extend the model using age, gender, or stochastic structure.</a:t>
+            </a:r>
+          </a:p>
+          <a:p>
+            <a:pPr algn="l">
+              <a:buChar char="•"/>
+              <a:buFont typeface="Arial"/>
+            </a:pPr>
+            <a:r>
+              <a:rPr lang="en-US" sz="1800" b="0">
+                <a:solidFill>
+                  <a:srgbClr val="142030"/>
+                </a:solidFill>
+                <a:latin typeface="Aptos"/>
+              </a:rPr>
+              <a:t>Compare other fractional operators.</a:t>
+            </a:r>
+          </a:p>
+          <a:p>
+            <a:pPr algn="l">
+              <a:buChar char="•"/>
+              <a:buFont typeface="Arial"/>
+            </a:pPr>
+            <a:r>
+              <a:rPr lang="en-US" sz="1800" b="0">
+                <a:solidFill>
+                  <a:srgbClr val="142030"/>
+                </a:solidFill>
+                <a:latin typeface="Aptos"/>
+              </a:rPr>
               <a:t>Improve the dashboard into an educational decision-support tool.</a:t>
             </a:r>
           </a:p>
@@ -1719,7 +1927,7 @@
       </p:sp>
       <p:sp>
         <p:nvSpPr>
-          <p:cNvPr id="117" name="Text 117"/>
+          <p:cNvPr id="130" name="Text 130"/>
           <p:cNvSpPr txBox="1"/>
           <p:nvPr/>
         </p:nvSpPr>
@@ -3901,7 +4109,7 @@
                 </a:solidFill>
                 <a:latin typeface="Aptos"/>
               </a:rPr>
-              <a:t>Fractional-Order Model and Analysis Evidence</a:t>
+              <a:t>Fractional-Order SITA Model</a:t>
             </a:r>
           </a:p>
         </p:txBody>
@@ -4259,7 +4467,7 @@
                 </a:solidFill>
                 <a:latin typeface="Aptos"/>
               </a:rPr>
-              <a:t>Objective 2: analysis completed</a:t>
+              <a:t>Meaning of interventions</a:t>
             </a:r>
           </a:p>
         </p:txBody>
@@ -4274,6 +4482,114 @@
           <a:xfrm>
             <a:off x="6720840" y="1572768"/>
             <a:ext cx="4343400" cy="676656"/>
+          </a:xfrm>
+          <a:prstGeom prst="rect">
+            <a:avLst/>
+          </a:prstGeom>
+          <a:solidFill>
+            <a:srgbClr val="FFF7E0"/>
+          </a:solidFill>
+          <a:ln w="9525">
+            <a:solidFill>
+              <a:srgbClr val="CC9900"/>
+            </a:solidFill>
+          </a:ln>
+        </p:spPr>
+        <p:txBody>
+          <a:bodyPr wrap="square" lIns="91440" rIns="91440" tIns="45720" bIns="45720">
+            <a:normAutofit fontScale="85000" lnSpcReduction="20000"/>
+          </a:bodyPr>
+          <a:lstStyle/>
+          <a:p>
+            <a:pPr algn="l"/>
+            <a:r>
+              <a:rPr lang="en-US" sz="1200" b="0">
+                <a:solidFill>
+                  <a:srgbClr val="142030"/>
+                </a:solidFill>
+                <a:latin typeface="Aptos"/>
+              </a:rPr>
+              <a:t>u1 and u2</a:t>
+            </a:r>
+          </a:p>
+          <a:p>
+            <a:pPr algn="l"/>
+            <a:r>
+              <a:rPr lang="en-US" sz="1200" b="0">
+                <a:solidFill>
+                  <a:srgbClr val="142030"/>
+                </a:solidFill>
+                <a:latin typeface="Aptos"/>
+              </a:rPr>
+              <a:t>Reduce effective transmission through awareness and safer behaviour.</a:t>
+            </a:r>
+          </a:p>
+        </p:txBody>
+      </p:sp>
+      <p:sp>
+        <p:nvSpPr>
+          <p:cNvPr id="67" name="Text 67"/>
+          <p:cNvSpPr txBox="1"/>
+          <p:nvPr/>
+        </p:nvSpPr>
+        <p:spPr>
+          <a:xfrm>
+            <a:off x="6720840" y="2395728"/>
+            <a:ext cx="4343400" cy="676656"/>
+          </a:xfrm>
+          <a:prstGeom prst="rect">
+            <a:avLst/>
+          </a:prstGeom>
+          <a:solidFill>
+            <a:srgbClr val="E6F7F4"/>
+          </a:solidFill>
+          <a:ln w="9525">
+            <a:solidFill>
+              <a:srgbClr val="007E70"/>
+            </a:solidFill>
+          </a:ln>
+        </p:spPr>
+        <p:txBody>
+          <a:bodyPr wrap="square" lIns="91440" rIns="91440" tIns="45720" bIns="45720">
+            <a:normAutofit fontScale="85000" lnSpcReduction="20000"/>
+          </a:bodyPr>
+          <a:lstStyle/>
+          <a:p>
+            <a:pPr algn="l"/>
+            <a:r>
+              <a:rPr lang="en-US" sz="1200" b="0">
+                <a:solidFill>
+                  <a:srgbClr val="142030"/>
+                </a:solidFill>
+                <a:latin typeface="Aptos"/>
+              </a:rPr>
+              <a:t>u3</a:t>
+            </a:r>
+          </a:p>
+          <a:p>
+            <a:pPr algn="l"/>
+            <a:r>
+              <a:rPr lang="en-US" sz="1200" b="0">
+                <a:solidFill>
+                  <a:srgbClr val="142030"/>
+                </a:solidFill>
+                <a:latin typeface="Aptos"/>
+              </a:rPr>
+              <a:t>Increases testing/treatment movement from infected to treated.</a:t>
+            </a:r>
+          </a:p>
+        </p:txBody>
+      </p:sp>
+      <p:sp>
+        <p:nvSpPr>
+          <p:cNvPr id="68" name="Text 68"/>
+          <p:cNvSpPr txBox="1"/>
+          <p:nvPr/>
+        </p:nvSpPr>
+        <p:spPr>
+          <a:xfrm>
+            <a:off x="6720840" y="3218688"/>
+            <a:ext cx="4343400" cy="713232"/>
           </a:xfrm>
           <a:prstGeom prst="rect">
             <a:avLst/>
@@ -4301,7 +4617,7 @@
                 </a:solidFill>
                 <a:latin typeface="Aptos"/>
               </a:rPr>
-              <a:t>Positivity</a:t>
+              <a:t>u4</a:t>
             </a:r>
           </a:p>
           <a:p>
@@ -4313,74 +4629,20 @@
                 </a:solidFill>
                 <a:latin typeface="Aptos"/>
               </a:rPr>
-              <a:t>Boundary derivatives are nonnegative, so S, I, T, A stay nonnegative.</a:t>
-            </a:r>
-          </a:p>
-        </p:txBody>
-      </p:sp>
-      <p:sp>
-        <p:nvSpPr>
-          <p:cNvPr id="67" name="Text 67"/>
-          <p:cNvSpPr txBox="1"/>
-          <p:nvPr/>
-        </p:nvSpPr>
-        <p:spPr>
-          <a:xfrm>
-            <a:off x="6720840" y="2395728"/>
-            <a:ext cx="4343400" cy="676656"/>
-          </a:xfrm>
-          <a:prstGeom prst="rect">
-            <a:avLst/>
-          </a:prstGeom>
-          <a:solidFill>
-            <a:srgbClr val="E6F7F4"/>
-          </a:solidFill>
-          <a:ln w="9525">
-            <a:solidFill>
-              <a:srgbClr val="007E70"/>
-            </a:solidFill>
-          </a:ln>
-        </p:spPr>
-        <p:txBody>
-          <a:bodyPr wrap="square" lIns="91440" rIns="91440" tIns="45720" bIns="45720">
-            <a:normAutofit fontScale="85000" lnSpcReduction="20000"/>
-          </a:bodyPr>
-          <a:lstStyle/>
-          <a:p>
-            <a:pPr algn="l"/>
-            <a:r>
-              <a:rPr lang="en-US" sz="1200" b="0">
-                <a:solidFill>
-                  <a:srgbClr val="142030"/>
-                </a:solidFill>
-                <a:latin typeface="Aptos"/>
-              </a:rPr>
-              <a:t>Boundedness</a:t>
-            </a:r>
-          </a:p>
-          <a:p>
-            <a:pPr algn="l"/>
-            <a:r>
-              <a:rPr lang="en-US" sz="1200" b="0">
-                <a:solidFill>
-                  <a:srgbClr val="142030"/>
-                </a:solidFill>
-                <a:latin typeface="Aptos"/>
-              </a:rPr>
-              <a:t>D_C^q N = Lambda - mu N - dA &lt;= Lambda - mu N.</a:t>
-            </a:r>
-          </a:p>
-        </p:txBody>
-      </p:sp>
-      <p:sp>
-        <p:nvSpPr>
-          <p:cNvPr id="68" name="Text 68"/>
-          <p:cNvSpPr txBox="1"/>
-          <p:nvPr/>
-        </p:nvSpPr>
-        <p:spPr>
-          <a:xfrm>
-            <a:off x="6720840" y="3218688"/>
+              <a:t>Reduces progression from treatment to AIDS stage through adherence support.</a:t>
+            </a:r>
+          </a:p>
+        </p:txBody>
+      </p:sp>
+      <p:sp>
+        <p:nvSpPr>
+          <p:cNvPr id="69" name="Text 69"/>
+          <p:cNvSpPr txBox="1"/>
+          <p:nvPr/>
+        </p:nvSpPr>
+        <p:spPr>
+          <a:xfrm>
+            <a:off x="6720840" y="4096512"/>
             <a:ext cx="4343400" cy="713232"/>
           </a:xfrm>
           <a:prstGeom prst="rect">
@@ -4409,7 +4671,7 @@
                 </a:solidFill>
                 <a:latin typeface="Aptos"/>
               </a:rPr>
-              <a:t>DFE and R0</a:t>
+              <a:t>q</a:t>
             </a:r>
           </a:p>
           <a:p>
@@ -4421,61 +4683,7 @@
                 </a:solidFill>
                 <a:latin typeface="Aptos"/>
               </a:rPr>
-              <a:t>E0=(Lambda/mu,0,0,0); R0 is obtained by next-generation method.</a:t>
-            </a:r>
-          </a:p>
-        </p:txBody>
-      </p:sp>
-      <p:sp>
-        <p:nvSpPr>
-          <p:cNvPr id="69" name="Text 69"/>
-          <p:cNvSpPr txBox="1"/>
-          <p:nvPr/>
-        </p:nvSpPr>
-        <p:spPr>
-          <a:xfrm>
-            <a:off x="6720840" y="4096512"/>
-            <a:ext cx="4343400" cy="713232"/>
-          </a:xfrm>
-          <a:prstGeom prst="rect">
-            <a:avLst/>
-          </a:prstGeom>
-          <a:solidFill>
-            <a:srgbClr val="E6F7F4"/>
-          </a:solidFill>
-          <a:ln w="9525">
-            <a:solidFill>
-              <a:srgbClr val="007E70"/>
-            </a:solidFill>
-          </a:ln>
-        </p:spPr>
-        <p:txBody>
-          <a:bodyPr wrap="square" lIns="91440" rIns="91440" tIns="45720" bIns="45720">
-            <a:normAutofit fontScale="85000" lnSpcReduction="20000"/>
-          </a:bodyPr>
-          <a:lstStyle/>
-          <a:p>
-            <a:pPr algn="l"/>
-            <a:r>
-              <a:rPr lang="en-US" sz="1200" b="0">
-                <a:solidFill>
-                  <a:srgbClr val="142030"/>
-                </a:solidFill>
-                <a:latin typeface="Aptos"/>
-              </a:rPr>
-              <a:t>Fractional stability</a:t>
-            </a:r>
-          </a:p>
-          <a:p>
-            <a:pPr algn="l"/>
-            <a:r>
-              <a:rPr lang="en-US" sz="1200" b="0">
-                <a:solidFill>
-                  <a:srgbClr val="142030"/>
-                </a:solidFill>
-                <a:latin typeface="Aptos"/>
-              </a:rPr>
-              <a:t>DFE stability uses |arg(lambda_i)| &gt; q*pi/2 when R0 &lt; 1.</a:t>
+              <a:t>q=1 is ordinary; q&lt;1 means previous states influence the present trajectory.</a:t>
             </a:r>
           </a:p>
         </p:txBody>
@@ -4538,7 +4746,7 @@
                 </a:solidFill>
                 <a:latin typeface="Aptos"/>
               </a:rPr>
-              <a:t>Numerical Scheme + Implementation</a:t>
+              <a:t>Objective 2: Mathematical Analysis Evidence</a:t>
             </a:r>
           </a:p>
         </p:txBody>
@@ -4631,8 +4839,8 @@
         </p:nvSpPr>
         <p:spPr>
           <a:xfrm>
-            <a:off x="658368" y="1234440"/>
-            <a:ext cx="4709160" cy="320040"/>
+            <a:off x="658368" y="1078992"/>
+            <a:ext cx="5074920" cy="310896"/>
           </a:xfrm>
           <a:prstGeom prst="rect">
             <a:avLst/>
@@ -4650,13 +4858,13 @@
           <a:p>
             <a:pPr algn="l"/>
             <a:r>
-              <a:rPr lang="en-US" sz="1500" b="1">
+              <a:rPr lang="en-US" sz="1400" b="1">
                 <a:solidFill>
                   <a:srgbClr val="CC9900"/>
                 </a:solidFill>
                 <a:latin typeface="Aptos"/>
               </a:rPr>
-              <a:t>Numerical idea</a:t>
+              <a:t>Positivity proof</a:t>
             </a:r>
           </a:p>
         </p:txBody>
@@ -4669,94 +4877,8 @@
         </p:nvSpPr>
         <p:spPr>
           <a:xfrm>
-            <a:off x="749808" y="1627632"/>
-            <a:ext cx="4937760" cy="2423160"/>
-          </a:xfrm>
-          <a:prstGeom prst="rect">
-            <a:avLst/>
-          </a:prstGeom>
-          <a:noFill/>
-          <a:ln>
-            <a:noFill/>
-          </a:ln>
-        </p:spPr>
-        <p:txBody>
-          <a:bodyPr wrap="square" lIns="91440" rIns="91440" tIns="45720" bIns="45720">
-            <a:normAutofit fontScale="85000" lnSpcReduction="20000"/>
-          </a:bodyPr>
-          <a:lstStyle/>
-          <a:p>
-            <a:pPr algn="l">
-              <a:buChar char="•"/>
-              <a:buFont typeface="Arial"/>
-            </a:pPr>
-            <a:r>
-              <a:rPr lang="en-US" sz="1800" b="0">
-                <a:solidFill>
-                  <a:srgbClr val="142030"/>
-                </a:solidFill>
-                <a:latin typeface="Aptos"/>
-              </a:rPr>
-              <a:t>Time interval is divided into discrete steps.</a:t>
-            </a:r>
-          </a:p>
-          <a:p>
-            <a:pPr algn="l">
-              <a:buChar char="•"/>
-              <a:buFont typeface="Arial"/>
-            </a:pPr>
-            <a:r>
-              <a:rPr lang="en-US" sz="1800" b="0">
-                <a:solidFill>
-                  <a:srgbClr val="142030"/>
-                </a:solidFill>
-                <a:latin typeface="Aptos"/>
-              </a:rPr>
-              <a:t>A predictor estimates the next state.</a:t>
-            </a:r>
-          </a:p>
-          <a:p>
-            <a:pPr algn="l">
-              <a:buChar char="•"/>
-              <a:buFont typeface="Arial"/>
-            </a:pPr>
-            <a:r>
-              <a:rPr lang="en-US" sz="1800" b="0">
-                <a:solidFill>
-                  <a:srgbClr val="142030"/>
-                </a:solidFill>
-                <a:latin typeface="Aptos"/>
-              </a:rPr>
-              <a:t>A corrector updates the state using fractional-memory weights.</a:t>
-            </a:r>
-          </a:p>
-          <a:p>
-            <a:pPr algn="l">
-              <a:buChar char="•"/>
-              <a:buFont typeface="Arial"/>
-            </a:pPr>
-            <a:r>
-              <a:rPr lang="en-US" sz="1800" b="0">
-                <a:solidFill>
-                  <a:srgbClr val="142030"/>
-                </a:solidFill>
-                <a:latin typeface="Aptos"/>
-              </a:rPr>
-              <a:t>The same engine is used for baseline, memory, intervention, and sensitivity experiments.</a:t>
-            </a:r>
-          </a:p>
-        </p:txBody>
-      </p:sp>
-      <p:sp>
-        <p:nvSpPr>
-          <p:cNvPr id="75" name="Text 75"/>
-          <p:cNvSpPr txBox="1"/>
-          <p:nvPr/>
-        </p:nvSpPr>
-        <p:spPr>
-          <a:xfrm>
-            <a:off x="6355080" y="1170432"/>
-            <a:ext cx="4297680" cy="749808"/>
+            <a:off x="713232" y="1444752"/>
+            <a:ext cx="5349240" cy="877824"/>
           </a:xfrm>
           <a:prstGeom prst="rect">
             <a:avLst/>
@@ -4778,25 +4900,67 @@
           <a:p>
             <a:pPr algn="l"/>
             <a:r>
-              <a:rPr lang="en-US" sz="1400" b="0">
-                <a:solidFill>
-                  <a:srgbClr val="142030"/>
-                </a:solidFill>
-                <a:latin typeface="Aptos"/>
-              </a:rPr>
-              <a:t>Inputs</a:t>
-            </a:r>
-          </a:p>
-          <a:p>
-            <a:pPr algn="l"/>
-            <a:r>
-              <a:rPr lang="en-US" sz="1400" b="0">
-                <a:solidFill>
-                  <a:srgbClr val="142030"/>
-                </a:solidFill>
-                <a:latin typeface="Aptos"/>
-              </a:rPr>
-              <a:t>parameters, initial conditions, q, controls</a:t>
+              <a:rPr lang="en-US" sz="1200" b="0">
+                <a:solidFill>
+                  <a:srgbClr val="142030"/>
+                </a:solidFill>
+                <a:latin typeface="Aptos"/>
+              </a:rPr>
+              <a:t>S=0: D_C^q S = Lambda &gt;= 0;    I=0: D_C^q I = lambda(t)S &gt;= 0</a:t>
+            </a:r>
+          </a:p>
+          <a:p>
+            <a:pPr algn="l"/>
+            <a:r>
+              <a:rPr lang="en-US" sz="1200" b="0">
+                <a:solidFill>
+                  <a:srgbClr val="142030"/>
+                </a:solidFill>
+                <a:latin typeface="Aptos"/>
+              </a:rPr>
+              <a:t>T=0: D_C^q T = tau_eff I &gt;= 0; A=0: D_C^q A = delta I + rho_eff T &gt;= 0</a:t>
+            </a:r>
+          </a:p>
+        </p:txBody>
+      </p:sp>
+      <p:sp>
+        <p:nvSpPr>
+          <p:cNvPr id="75" name="Text 75"/>
+          <p:cNvSpPr txBox="1"/>
+          <p:nvPr/>
+        </p:nvSpPr>
+        <p:spPr>
+          <a:xfrm>
+            <a:off x="713232" y="2487168"/>
+            <a:ext cx="5349240" cy="603504"/>
+          </a:xfrm>
+          <a:prstGeom prst="rect">
+            <a:avLst/>
+          </a:prstGeom>
+          <a:solidFill>
+            <a:srgbClr val="E8F2FA"/>
+          </a:solidFill>
+          <a:ln w="9525">
+            <a:solidFill>
+              <a:srgbClr val="004A80"/>
+            </a:solidFill>
+          </a:ln>
+        </p:spPr>
+        <p:txBody>
+          <a:bodyPr wrap="square" lIns="91440" rIns="91440" tIns="45720" bIns="45720">
+            <a:normAutofit fontScale="85000" lnSpcReduction="20000"/>
+          </a:bodyPr>
+          <a:lstStyle/>
+          <a:p>
+            <a:pPr algn="l"/>
+            <a:r>
+              <a:rPr lang="en-US" sz="1200" b="0">
+                <a:solidFill>
+                  <a:srgbClr val="142030"/>
+                </a:solidFill>
+                <a:latin typeface="Aptos"/>
+              </a:rPr>
+              <a:t>Therefore the vector field points inward on the boundary, so R_+^4 is positively invariant.</a:t>
             </a:r>
           </a:p>
         </p:txBody>
@@ -4809,8 +4973,46 @@
         </p:nvSpPr>
         <p:spPr>
           <a:xfrm>
-            <a:off x="6355080" y="2084831"/>
-            <a:ext cx="4297680" cy="749808"/>
+            <a:off x="658368" y="3310128"/>
+            <a:ext cx="5074920" cy="310896"/>
+          </a:xfrm>
+          <a:prstGeom prst="rect">
+            <a:avLst/>
+          </a:prstGeom>
+          <a:noFill/>
+          <a:ln>
+            <a:noFill/>
+          </a:ln>
+        </p:spPr>
+        <p:txBody>
+          <a:bodyPr wrap="square" lIns="91440" rIns="91440" tIns="45720" bIns="45720">
+            <a:normAutofit fontScale="85000" lnSpcReduction="20000"/>
+          </a:bodyPr>
+          <a:lstStyle/>
+          <a:p>
+            <a:pPr algn="l"/>
+            <a:r>
+              <a:rPr lang="en-US" sz="1400" b="1">
+                <a:solidFill>
+                  <a:srgbClr val="CC9900"/>
+                </a:solidFill>
+                <a:latin typeface="Aptos"/>
+              </a:rPr>
+              <a:t>Boundedness proof</a:t>
+            </a:r>
+          </a:p>
+        </p:txBody>
+      </p:sp>
+      <p:sp>
+        <p:nvSpPr>
+          <p:cNvPr id="77" name="Text 77"/>
+          <p:cNvSpPr txBox="1"/>
+          <p:nvPr/>
+        </p:nvSpPr>
+        <p:spPr>
+          <a:xfrm>
+            <a:off x="713232" y="3675887"/>
+            <a:ext cx="5349240" cy="950976"/>
           </a:xfrm>
           <a:prstGeom prst="rect">
             <a:avLst/>
@@ -4832,39 +5034,89 @@
           <a:p>
             <a:pPr algn="l"/>
             <a:r>
-              <a:rPr lang="en-US" sz="1400" b="0">
-                <a:solidFill>
-                  <a:srgbClr val="142030"/>
-                </a:solidFill>
-                <a:latin typeface="Aptos"/>
-              </a:rPr>
-              <a:t>Solver</a:t>
-            </a:r>
-          </a:p>
-          <a:p>
-            <a:pPr algn="l"/>
-            <a:r>
-              <a:rPr lang="en-US" sz="1400" b="0">
-                <a:solidFill>
-                  <a:srgbClr val="142030"/>
-                </a:solidFill>
-                <a:latin typeface="Aptos"/>
-              </a:rPr>
-              <a:t>fractional ABM-type numerical method</a:t>
-            </a:r>
-          </a:p>
-        </p:txBody>
-      </p:sp>
-      <p:sp>
-        <p:nvSpPr>
-          <p:cNvPr id="77" name="Text 77"/>
-          <p:cNvSpPr txBox="1"/>
-          <p:nvPr/>
-        </p:nvSpPr>
-        <p:spPr>
-          <a:xfrm>
-            <a:off x="6355080" y="2999232"/>
-            <a:ext cx="4297680" cy="749808"/>
+              <a:rPr lang="en-US" sz="1200" b="0">
+                <a:solidFill>
+                  <a:srgbClr val="142030"/>
+                </a:solidFill>
+                <a:latin typeface="Aptos"/>
+              </a:rPr>
+              <a:t>N = S + I + T + A</a:t>
+            </a:r>
+          </a:p>
+          <a:p>
+            <a:pPr algn="l"/>
+            <a:r>
+              <a:rPr lang="en-US" sz="1200" b="0">
+                <a:solidFill>
+                  <a:srgbClr val="142030"/>
+                </a:solidFill>
+                <a:latin typeface="Aptos"/>
+              </a:rPr>
+              <a:t>D_C^q N = Lambda - mu N - dA &lt;= Lambda - mu N</a:t>
+            </a:r>
+          </a:p>
+          <a:p>
+            <a:pPr algn="l"/>
+            <a:r>
+              <a:rPr lang="en-US" sz="1200" b="0">
+                <a:solidFill>
+                  <a:srgbClr val="142030"/>
+                </a:solidFill>
+                <a:latin typeface="Aptos"/>
+              </a:rPr>
+              <a:t>By fractional comparison, limsup N(t) &lt;= Lambda/mu.</a:t>
+            </a:r>
+          </a:p>
+        </p:txBody>
+      </p:sp>
+      <p:sp>
+        <p:nvSpPr>
+          <p:cNvPr id="78" name="Text 78"/>
+          <p:cNvSpPr txBox="1"/>
+          <p:nvPr/>
+        </p:nvSpPr>
+        <p:spPr>
+          <a:xfrm>
+            <a:off x="6355080" y="1078992"/>
+            <a:ext cx="4983480" cy="310896"/>
+          </a:xfrm>
+          <a:prstGeom prst="rect">
+            <a:avLst/>
+          </a:prstGeom>
+          <a:noFill/>
+          <a:ln>
+            <a:noFill/>
+          </a:ln>
+        </p:spPr>
+        <p:txBody>
+          <a:bodyPr wrap="square" lIns="91440" rIns="91440" tIns="45720" bIns="45720">
+            <a:normAutofit fontScale="85000" lnSpcReduction="20000"/>
+          </a:bodyPr>
+          <a:lstStyle/>
+          <a:p>
+            <a:pPr algn="l"/>
+            <a:r>
+              <a:rPr lang="en-US" sz="1400" b="1">
+                <a:solidFill>
+                  <a:srgbClr val="CC9900"/>
+                </a:solidFill>
+                <a:latin typeface="Aptos"/>
+              </a:rPr>
+              <a:t>Disease-free equilibrium and threshold</a:t>
+            </a:r>
+          </a:p>
+        </p:txBody>
+      </p:sp>
+      <p:sp>
+        <p:nvSpPr>
+          <p:cNvPr id="79" name="Text 79"/>
+          <p:cNvSpPr txBox="1"/>
+          <p:nvPr/>
+        </p:nvSpPr>
+        <p:spPr>
+          <a:xfrm>
+            <a:off x="6400800" y="1444752"/>
+            <a:ext cx="5074920" cy="804672"/>
           </a:xfrm>
           <a:prstGeom prst="rect">
             <a:avLst/>
@@ -4886,49 +5138,87 @@
           <a:p>
             <a:pPr algn="l"/>
             <a:r>
-              <a:rPr lang="en-US" sz="1400" b="0">
-                <a:solidFill>
-                  <a:srgbClr val="142030"/>
-                </a:solidFill>
-                <a:latin typeface="Aptos"/>
-              </a:rPr>
-              <a:t>Outputs</a:t>
-            </a:r>
-          </a:p>
-          <a:p>
-            <a:pPr algn="l"/>
-            <a:r>
-              <a:rPr lang="en-US" sz="1400" b="0">
-                <a:solidFill>
-                  <a:srgbClr val="142030"/>
-                </a:solidFill>
-                <a:latin typeface="Aptos"/>
-              </a:rPr>
-              <a:t>trajectories, R0, scenarios, sensitivity</a:t>
-            </a:r>
-          </a:p>
-        </p:txBody>
-      </p:sp>
-      <p:sp>
-        <p:nvSpPr>
-          <p:cNvPr id="78" name="Text 78"/>
-          <p:cNvSpPr txBox="1"/>
-          <p:nvPr/>
-        </p:nvSpPr>
-        <p:spPr>
-          <a:xfrm>
-            <a:off x="6355080" y="3913632"/>
-            <a:ext cx="4297680" cy="749808"/>
-          </a:xfrm>
-          <a:prstGeom prst="rect">
-            <a:avLst/>
-          </a:prstGeom>
-          <a:solidFill>
-            <a:srgbClr val="FFFFFF"/>
+              <a:rPr lang="en-US" sz="1200" b="0">
+                <a:solidFill>
+                  <a:srgbClr val="142030"/>
+                </a:solidFill>
+                <a:latin typeface="Aptos"/>
+              </a:rPr>
+              <a:t>E0 = (Lambda/mu, 0, 0, 0),     R0 = rho(FV^-1)</a:t>
+            </a:r>
+          </a:p>
+          <a:p>
+            <a:pPr algn="l"/>
+            <a:r>
+              <a:rPr lang="en-US" sz="1200" b="0">
+                <a:solidFill>
+                  <a:srgbClr val="142030"/>
+                </a:solidFill>
+                <a:latin typeface="Aptos"/>
+              </a:rPr>
+              <a:t>F contains new infections; V contains transition/removal terms.</a:t>
+            </a:r>
+          </a:p>
+        </p:txBody>
+      </p:sp>
+      <p:sp>
+        <p:nvSpPr>
+          <p:cNvPr id="80" name="Text 80"/>
+          <p:cNvSpPr txBox="1"/>
+          <p:nvPr/>
+        </p:nvSpPr>
+        <p:spPr>
+          <a:xfrm>
+            <a:off x="6355080" y="2615184"/>
+            <a:ext cx="4983480" cy="310896"/>
+          </a:xfrm>
+          <a:prstGeom prst="rect">
+            <a:avLst/>
+          </a:prstGeom>
+          <a:noFill/>
+          <a:ln>
+            <a:noFill/>
+          </a:ln>
+        </p:spPr>
+        <p:txBody>
+          <a:bodyPr wrap="square" lIns="91440" rIns="91440" tIns="45720" bIns="45720">
+            <a:normAutofit fontScale="85000" lnSpcReduction="20000"/>
+          </a:bodyPr>
+          <a:lstStyle/>
+          <a:p>
+            <a:pPr algn="l"/>
+            <a:r>
+              <a:rPr lang="en-US" sz="1400" b="1">
+                <a:solidFill>
+                  <a:srgbClr val="CC9900"/>
+                </a:solidFill>
+                <a:latin typeface="Aptos"/>
+              </a:rPr>
+              <a:t>Fractional stability condition</a:t>
+            </a:r>
+          </a:p>
+        </p:txBody>
+      </p:sp>
+      <p:sp>
+        <p:nvSpPr>
+          <p:cNvPr id="81" name="Text 81"/>
+          <p:cNvSpPr txBox="1"/>
+          <p:nvPr/>
+        </p:nvSpPr>
+        <p:spPr>
+          <a:xfrm>
+            <a:off x="6400800" y="2980944"/>
+            <a:ext cx="5074920" cy="786384"/>
+          </a:xfrm>
+          <a:prstGeom prst="rect">
+            <a:avLst/>
+          </a:prstGeom>
+          <a:solidFill>
+            <a:srgbClr val="E6F7F4"/>
           </a:solidFill>
           <a:ln w="9525">
             <a:solidFill>
-              <a:srgbClr val="B44146"/>
+              <a:srgbClr val="007E70"/>
             </a:solidFill>
           </a:ln>
         </p:spPr>
@@ -4940,137 +5230,29 @@
           <a:p>
             <a:pPr algn="l"/>
             <a:r>
-              <a:rPr lang="en-US" sz="1400" b="0">
-                <a:solidFill>
-                  <a:srgbClr val="142030"/>
-                </a:solidFill>
-                <a:latin typeface="Aptos"/>
-              </a:rPr>
-              <a:t>Presentation</a:t>
-            </a:r>
-          </a:p>
-          <a:p>
-            <a:pPr algn="l"/>
-            <a:r>
-              <a:rPr lang="en-US" sz="1400" b="0">
-                <a:solidFill>
-                  <a:srgbClr val="142030"/>
-                </a:solidFill>
-                <a:latin typeface="Aptos"/>
-              </a:rPr>
-              <a:t>moving graphs during the live demo</a:t>
-            </a:r>
-          </a:p>
-        </p:txBody>
-      </p:sp>
-      <p:cxnSp>
-        <p:nvCxnSpPr>
-          <p:cNvPr id="79" name="Arrow 79"/>
-          <p:cNvCxnSpPr/>
-          <p:nvPr/>
-        </p:nvCxnSpPr>
-        <p:spPr>
-          <a:xfrm>
-            <a:off x="8503920" y="1920240"/>
-            <a:ext cx="0" cy="164591"/>
-          </a:xfrm>
-          <a:prstGeom prst="line">
-            <a:avLst/>
-          </a:prstGeom>
-          <a:ln w="19050">
-            <a:solidFill>
-              <a:srgbClr val="52606C"/>
-            </a:solidFill>
-            <a:tailEnd type="triangle"/>
-          </a:ln>
-        </p:spPr>
-        <p:style>
-          <a:lnRef idx="1">
-            <a:schemeClr val="accent1"/>
-          </a:lnRef>
-          <a:fillRef idx="0">
-            <a:schemeClr val="accent1"/>
-          </a:fillRef>
-          <a:effectRef idx="0">
-            <a:schemeClr val="accent1"/>
-          </a:effectRef>
-          <a:fontRef idx="minor">
-            <a:schemeClr val="tx1"/>
-          </a:fontRef>
-        </p:style>
-      </p:cxnSp>
-      <p:cxnSp>
-        <p:nvCxnSpPr>
-          <p:cNvPr id="80" name="Arrow 80"/>
-          <p:cNvCxnSpPr/>
-          <p:nvPr/>
-        </p:nvCxnSpPr>
-        <p:spPr>
-          <a:xfrm>
-            <a:off x="8503920" y="2834640"/>
-            <a:ext cx="0" cy="164591"/>
-          </a:xfrm>
-          <a:prstGeom prst="line">
-            <a:avLst/>
-          </a:prstGeom>
-          <a:ln w="19050">
-            <a:solidFill>
-              <a:srgbClr val="52606C"/>
-            </a:solidFill>
-            <a:tailEnd type="triangle"/>
-          </a:ln>
-        </p:spPr>
-        <p:style>
-          <a:lnRef idx="1">
-            <a:schemeClr val="accent1"/>
-          </a:lnRef>
-          <a:fillRef idx="0">
-            <a:schemeClr val="accent1"/>
-          </a:fillRef>
-          <a:effectRef idx="0">
-            <a:schemeClr val="accent1"/>
-          </a:effectRef>
-          <a:fontRef idx="minor">
-            <a:schemeClr val="tx1"/>
-          </a:fontRef>
-        </p:style>
-      </p:cxnSp>
-      <p:cxnSp>
-        <p:nvCxnSpPr>
-          <p:cNvPr id="81" name="Arrow 81"/>
-          <p:cNvCxnSpPr/>
-          <p:nvPr/>
-        </p:nvCxnSpPr>
-        <p:spPr>
-          <a:xfrm>
-            <a:off x="8503920" y="3749039"/>
-            <a:ext cx="0" cy="164592"/>
-          </a:xfrm>
-          <a:prstGeom prst="line">
-            <a:avLst/>
-          </a:prstGeom>
-          <a:ln w="19050">
-            <a:solidFill>
-              <a:srgbClr val="52606C"/>
-            </a:solidFill>
-            <a:tailEnd type="triangle"/>
-          </a:ln>
-        </p:spPr>
-        <p:style>
-          <a:lnRef idx="1">
-            <a:schemeClr val="accent1"/>
-          </a:lnRef>
-          <a:fillRef idx="0">
-            <a:schemeClr val="accent1"/>
-          </a:fillRef>
-          <a:effectRef idx="0">
-            <a:schemeClr val="accent1"/>
-          </a:effectRef>
-          <a:fontRef idx="minor">
-            <a:schemeClr val="tx1"/>
-          </a:fontRef>
-        </p:style>
-      </p:cxnSp>
+              <a:rPr lang="en-US" sz="1200" b="0">
+                <a:solidFill>
+                  <a:srgbClr val="142030"/>
+                </a:solidFill>
+                <a:latin typeface="Aptos"/>
+              </a:rPr>
+              <a:t>|arg(lambda_i)| &gt; q*pi/2 for every eigenvalue lambda_i.</a:t>
+            </a:r>
+          </a:p>
+          <a:p>
+            <a:pPr algn="l"/>
+            <a:r>
+              <a:rPr lang="en-US" sz="1200" b="0">
+                <a:solidFill>
+                  <a:srgbClr val="142030"/>
+                </a:solidFill>
+                <a:latin typeface="Aptos"/>
+              </a:rPr>
+              <a:t>When R0 &lt; 1 and this condition holds, E0 is locally asymptotically stable.</a:t>
+            </a:r>
+          </a:p>
+        </p:txBody>
+      </p:sp>
       <p:sp>
         <p:nvSpPr>
           <p:cNvPr id="82" name="Text 82"/>
@@ -5079,18 +5261,18 @@
         </p:nvSpPr>
         <p:spPr>
           <a:xfrm>
-            <a:off x="896112" y="5166360"/>
-            <a:ext cx="9921240" cy="658368"/>
-          </a:xfrm>
-          <a:prstGeom prst="rect">
-            <a:avLst/>
-          </a:prstGeom>
-          <a:solidFill>
-            <a:srgbClr val="FFF7E0"/>
+            <a:off x="6400800" y="4151376"/>
+            <a:ext cx="5074920" cy="585216"/>
+          </a:xfrm>
+          <a:prstGeom prst="rect">
+            <a:avLst/>
+          </a:prstGeom>
+          <a:solidFill>
+            <a:srgbClr val="FFFFFF"/>
           </a:solidFill>
           <a:ln w="9525">
             <a:solidFill>
-              <a:srgbClr val="CC9900"/>
+              <a:srgbClr val="004A80"/>
             </a:solidFill>
           </a:ln>
         </p:spPr>
@@ -5102,13 +5284,25 @@
           <a:p>
             <a:pPr algn="l"/>
             <a:r>
-              <a:rPr lang="en-US" sz="1600" b="0">
-                <a:solidFill>
-                  <a:srgbClr val="142030"/>
-                </a:solidFill>
-                <a:latin typeface="Aptos"/>
-              </a:rPr>
-              <a:t>Presentation link: the mathematical model is explained in the slides; moving graphs are shown separately during the live demonstration.</a:t>
+              <a:rPr lang="en-US" sz="1200" b="0">
+                <a:solidFill>
+                  <a:srgbClr val="142030"/>
+                </a:solidFill>
+                <a:latin typeface="Aptos"/>
+              </a:rPr>
+              <a:t>Defense line</a:t>
+            </a:r>
+          </a:p>
+          <a:p>
+            <a:pPr algn="l"/>
+            <a:r>
+              <a:rPr lang="en-US" sz="1200" b="0">
+                <a:solidFill>
+                  <a:srgbClr val="142030"/>
+                </a:solidFill>
+                <a:latin typeface="Aptos"/>
+              </a:rPr>
+              <a:t>Objective 2 is fulfilled by positivity, boundedness, DFE/R0 threshold analysis, and fractional stability.</a:t>
             </a:r>
           </a:p>
         </p:txBody>
@@ -5140,7 +5334,7 @@
       </p:grpSpPr>
       <p:sp>
         <p:nvSpPr>
-          <p:cNvPr id="84" name="Text 84"/>
+          <p:cNvPr id="83" name="Text 83"/>
           <p:cNvSpPr txBox="1"/>
           <p:nvPr/>
         </p:nvSpPr>
@@ -5171,14 +5365,14 @@
                 </a:solidFill>
                 <a:latin typeface="Aptos"/>
               </a:rPr>
-              <a:t>Baseline Simulation Result</a:t>
-            </a:r>
-          </a:p>
-        </p:txBody>
-      </p:sp>
-      <p:sp>
-        <p:nvSpPr>
-          <p:cNvPr id="85" name="Text 85"/>
+              <a:t>Numerical Scheme + Implementation</a:t>
+            </a:r>
+          </a:p>
+        </p:txBody>
+      </p:sp>
+      <p:sp>
+        <p:nvSpPr>
+          <p:cNvPr id="84" name="Text 84"/>
           <p:cNvSpPr txBox="1"/>
           <p:nvPr/>
         </p:nvSpPr>
@@ -5218,7 +5412,7 @@
       </p:sp>
       <p:sp>
         <p:nvSpPr>
-          <p:cNvPr id="86" name="Text 86"/>
+          <p:cNvPr id="85" name="Text 85"/>
           <p:cNvSpPr txBox="1"/>
           <p:nvPr/>
         </p:nvSpPr>
@@ -5256,28 +5450,44 @@
           </a:p>
         </p:txBody>
       </p:sp>
-      <p:pic>
-        <p:nvPicPr>
-          <p:cNvPr id="83" name="presentation_baseline.png"/>
-          <p:cNvPicPr/>
-          <p:nvPr/>
-        </p:nvPicPr>
-        <p:blipFill>
-          <a:blip r:embed="rId2"/>
-          <a:stretch>
-            <a:fillRect/>
-          </a:stretch>
-        </p:blipFill>
-        <p:spPr>
-          <a:xfrm>
-            <a:off x="292608" y="1078992"/>
-            <a:ext cx="11631168" cy="3931920"/>
-          </a:xfrm>
-          <a:prstGeom prst="rect">
-            <a:avLst/>
-          </a:prstGeom>
-        </p:spPr>
-      </p:pic>
+      <p:sp>
+        <p:nvSpPr>
+          <p:cNvPr id="86" name="Text 86"/>
+          <p:cNvSpPr txBox="1"/>
+          <p:nvPr/>
+        </p:nvSpPr>
+        <p:spPr>
+          <a:xfrm>
+            <a:off x="658368" y="1234440"/>
+            <a:ext cx="4709160" cy="320040"/>
+          </a:xfrm>
+          <a:prstGeom prst="rect">
+            <a:avLst/>
+          </a:prstGeom>
+          <a:noFill/>
+          <a:ln>
+            <a:noFill/>
+          </a:ln>
+        </p:spPr>
+        <p:txBody>
+          <a:bodyPr wrap="square" lIns="91440" rIns="91440" tIns="45720" bIns="45720">
+            <a:normAutofit fontScale="85000" lnSpcReduction="20000"/>
+          </a:bodyPr>
+          <a:lstStyle/>
+          <a:p>
+            <a:pPr algn="l"/>
+            <a:r>
+              <a:rPr lang="en-US" sz="1500" b="1">
+                <a:solidFill>
+                  <a:srgbClr val="CC9900"/>
+                </a:solidFill>
+                <a:latin typeface="Aptos"/>
+              </a:rPr>
+              <a:t>Numerical idea</a:t>
+            </a:r>
+          </a:p>
+        </p:txBody>
+      </p:sp>
       <p:sp>
         <p:nvSpPr>
           <p:cNvPr id="87" name="Text 87"/>
@@ -5286,8 +5496,148 @@
         </p:nvSpPr>
         <p:spPr>
           <a:xfrm>
-            <a:off x="585216" y="5321808"/>
-            <a:ext cx="11018520" cy="621792"/>
+            <a:off x="749808" y="1627632"/>
+            <a:ext cx="4937760" cy="2423160"/>
+          </a:xfrm>
+          <a:prstGeom prst="rect">
+            <a:avLst/>
+          </a:prstGeom>
+          <a:noFill/>
+          <a:ln>
+            <a:noFill/>
+          </a:ln>
+        </p:spPr>
+        <p:txBody>
+          <a:bodyPr wrap="square" lIns="91440" rIns="91440" tIns="45720" bIns="45720">
+            <a:normAutofit fontScale="85000" lnSpcReduction="20000"/>
+          </a:bodyPr>
+          <a:lstStyle/>
+          <a:p>
+            <a:pPr algn="l">
+              <a:buChar char="•"/>
+              <a:buFont typeface="Arial"/>
+            </a:pPr>
+            <a:r>
+              <a:rPr lang="en-US" sz="1800" b="0">
+                <a:solidFill>
+                  <a:srgbClr val="142030"/>
+                </a:solidFill>
+                <a:latin typeface="Aptos"/>
+              </a:rPr>
+              <a:t>Time interval is divided into discrete steps.</a:t>
+            </a:r>
+          </a:p>
+          <a:p>
+            <a:pPr algn="l">
+              <a:buChar char="•"/>
+              <a:buFont typeface="Arial"/>
+            </a:pPr>
+            <a:r>
+              <a:rPr lang="en-US" sz="1800" b="0">
+                <a:solidFill>
+                  <a:srgbClr val="142030"/>
+                </a:solidFill>
+                <a:latin typeface="Aptos"/>
+              </a:rPr>
+              <a:t>A predictor estimates the next state.</a:t>
+            </a:r>
+          </a:p>
+          <a:p>
+            <a:pPr algn="l">
+              <a:buChar char="•"/>
+              <a:buFont typeface="Arial"/>
+            </a:pPr>
+            <a:r>
+              <a:rPr lang="en-US" sz="1800" b="0">
+                <a:solidFill>
+                  <a:srgbClr val="142030"/>
+                </a:solidFill>
+                <a:latin typeface="Aptos"/>
+              </a:rPr>
+              <a:t>A corrector updates the state using fractional-memory weights.</a:t>
+            </a:r>
+          </a:p>
+          <a:p>
+            <a:pPr algn="l">
+              <a:buChar char="•"/>
+              <a:buFont typeface="Arial"/>
+            </a:pPr>
+            <a:r>
+              <a:rPr lang="en-US" sz="1800" b="0">
+                <a:solidFill>
+                  <a:srgbClr val="142030"/>
+                </a:solidFill>
+                <a:latin typeface="Aptos"/>
+              </a:rPr>
+              <a:t>The same engine is used for baseline, memory, intervention, and sensitivity experiments.</a:t>
+            </a:r>
+          </a:p>
+        </p:txBody>
+      </p:sp>
+      <p:sp>
+        <p:nvSpPr>
+          <p:cNvPr id="88" name="Text 88"/>
+          <p:cNvSpPr txBox="1"/>
+          <p:nvPr/>
+        </p:nvSpPr>
+        <p:spPr>
+          <a:xfrm>
+            <a:off x="6355080" y="1170432"/>
+            <a:ext cx="4297680" cy="749808"/>
+          </a:xfrm>
+          <a:prstGeom prst="rect">
+            <a:avLst/>
+          </a:prstGeom>
+          <a:solidFill>
+            <a:srgbClr val="E8F2FA"/>
+          </a:solidFill>
+          <a:ln w="9525">
+            <a:solidFill>
+              <a:srgbClr val="004A80"/>
+            </a:solidFill>
+          </a:ln>
+        </p:spPr>
+        <p:txBody>
+          <a:bodyPr wrap="square" lIns="91440" rIns="91440" tIns="45720" bIns="45720">
+            <a:normAutofit fontScale="85000" lnSpcReduction="20000"/>
+          </a:bodyPr>
+          <a:lstStyle/>
+          <a:p>
+            <a:pPr algn="l"/>
+            <a:r>
+              <a:rPr lang="en-US" sz="1400" b="0">
+                <a:solidFill>
+                  <a:srgbClr val="142030"/>
+                </a:solidFill>
+                <a:latin typeface="Aptos"/>
+              </a:rPr>
+              <a:t>Inputs</a:t>
+            </a:r>
+          </a:p>
+          <a:p>
+            <a:pPr algn="l"/>
+            <a:r>
+              <a:rPr lang="en-US" sz="1400" b="0">
+                <a:solidFill>
+                  <a:srgbClr val="142030"/>
+                </a:solidFill>
+                <a:latin typeface="Aptos"/>
+              </a:rPr>
+              <a:t>parameters, initial conditions, q, controls</a:t>
+            </a:r>
+          </a:p>
+        </p:txBody>
+      </p:sp>
+      <p:sp>
+        <p:nvSpPr>
+          <p:cNvPr id="89" name="Text 89"/>
+          <p:cNvSpPr txBox="1"/>
+          <p:nvPr/>
+        </p:nvSpPr>
+        <p:spPr>
+          <a:xfrm>
+            <a:off x="6355080" y="2084831"/>
+            <a:ext cx="4297680" cy="749808"/>
           </a:xfrm>
           <a:prstGeom prst="rect">
             <a:avLst/>
@@ -5315,7 +5665,277 @@
                 </a:solidFill>
                 <a:latin typeface="Aptos"/>
               </a:rPr>
-              <a:t>▶ R0 = 0.430 &lt; 1. The infected class starts at I(0)=150 and declines to I=3.1; treatment remains visible at T=94.3. Source: submitted report, Chapter 6 baseline simulation.</a:t>
+              <a:t>Solver</a:t>
+            </a:r>
+          </a:p>
+          <a:p>
+            <a:pPr algn="l"/>
+            <a:r>
+              <a:rPr lang="en-US" sz="1400" b="0">
+                <a:solidFill>
+                  <a:srgbClr val="142030"/>
+                </a:solidFill>
+                <a:latin typeface="Aptos"/>
+              </a:rPr>
+              <a:t>fractional ABM-type numerical method</a:t>
+            </a:r>
+          </a:p>
+        </p:txBody>
+      </p:sp>
+      <p:sp>
+        <p:nvSpPr>
+          <p:cNvPr id="90" name="Text 90"/>
+          <p:cNvSpPr txBox="1"/>
+          <p:nvPr/>
+        </p:nvSpPr>
+        <p:spPr>
+          <a:xfrm>
+            <a:off x="6355080" y="2999232"/>
+            <a:ext cx="4297680" cy="749808"/>
+          </a:xfrm>
+          <a:prstGeom prst="rect">
+            <a:avLst/>
+          </a:prstGeom>
+          <a:solidFill>
+            <a:srgbClr val="FFF7E0"/>
+          </a:solidFill>
+          <a:ln w="9525">
+            <a:solidFill>
+              <a:srgbClr val="CC9900"/>
+            </a:solidFill>
+          </a:ln>
+        </p:spPr>
+        <p:txBody>
+          <a:bodyPr wrap="square" lIns="91440" rIns="91440" tIns="45720" bIns="45720">
+            <a:normAutofit fontScale="85000" lnSpcReduction="20000"/>
+          </a:bodyPr>
+          <a:lstStyle/>
+          <a:p>
+            <a:pPr algn="l"/>
+            <a:r>
+              <a:rPr lang="en-US" sz="1400" b="0">
+                <a:solidFill>
+                  <a:srgbClr val="142030"/>
+                </a:solidFill>
+                <a:latin typeface="Aptos"/>
+              </a:rPr>
+              <a:t>Outputs</a:t>
+            </a:r>
+          </a:p>
+          <a:p>
+            <a:pPr algn="l"/>
+            <a:r>
+              <a:rPr lang="en-US" sz="1400" b="0">
+                <a:solidFill>
+                  <a:srgbClr val="142030"/>
+                </a:solidFill>
+                <a:latin typeface="Aptos"/>
+              </a:rPr>
+              <a:t>trajectories, R0, scenarios, sensitivity</a:t>
+            </a:r>
+          </a:p>
+        </p:txBody>
+      </p:sp>
+      <p:sp>
+        <p:nvSpPr>
+          <p:cNvPr id="91" name="Text 91"/>
+          <p:cNvSpPr txBox="1"/>
+          <p:nvPr/>
+        </p:nvSpPr>
+        <p:spPr>
+          <a:xfrm>
+            <a:off x="6355080" y="3913632"/>
+            <a:ext cx="4297680" cy="749808"/>
+          </a:xfrm>
+          <a:prstGeom prst="rect">
+            <a:avLst/>
+          </a:prstGeom>
+          <a:solidFill>
+            <a:srgbClr val="FFFFFF"/>
+          </a:solidFill>
+          <a:ln w="9525">
+            <a:solidFill>
+              <a:srgbClr val="B44146"/>
+            </a:solidFill>
+          </a:ln>
+        </p:spPr>
+        <p:txBody>
+          <a:bodyPr wrap="square" lIns="91440" rIns="91440" tIns="45720" bIns="45720">
+            <a:normAutofit fontScale="85000" lnSpcReduction="20000"/>
+          </a:bodyPr>
+          <a:lstStyle/>
+          <a:p>
+            <a:pPr algn="l"/>
+            <a:r>
+              <a:rPr lang="en-US" sz="1400" b="0">
+                <a:solidFill>
+                  <a:srgbClr val="142030"/>
+                </a:solidFill>
+                <a:latin typeface="Aptos"/>
+              </a:rPr>
+              <a:t>Presentation</a:t>
+            </a:r>
+          </a:p>
+          <a:p>
+            <a:pPr algn="l"/>
+            <a:r>
+              <a:rPr lang="en-US" sz="1400" b="0">
+                <a:solidFill>
+                  <a:srgbClr val="142030"/>
+                </a:solidFill>
+                <a:latin typeface="Aptos"/>
+              </a:rPr>
+              <a:t>moving graphs during the live demo</a:t>
+            </a:r>
+          </a:p>
+        </p:txBody>
+      </p:sp>
+      <p:cxnSp>
+        <p:nvCxnSpPr>
+          <p:cNvPr id="92" name="Arrow 92"/>
+          <p:cNvCxnSpPr/>
+          <p:nvPr/>
+        </p:nvCxnSpPr>
+        <p:spPr>
+          <a:xfrm>
+            <a:off x="8503920" y="1920240"/>
+            <a:ext cx="0" cy="164591"/>
+          </a:xfrm>
+          <a:prstGeom prst="line">
+            <a:avLst/>
+          </a:prstGeom>
+          <a:ln w="19050">
+            <a:solidFill>
+              <a:srgbClr val="52606C"/>
+            </a:solidFill>
+            <a:tailEnd type="triangle"/>
+          </a:ln>
+        </p:spPr>
+        <p:style>
+          <a:lnRef idx="1">
+            <a:schemeClr val="accent1"/>
+          </a:lnRef>
+          <a:fillRef idx="0">
+            <a:schemeClr val="accent1"/>
+          </a:fillRef>
+          <a:effectRef idx="0">
+            <a:schemeClr val="accent1"/>
+          </a:effectRef>
+          <a:fontRef idx="minor">
+            <a:schemeClr val="tx1"/>
+          </a:fontRef>
+        </p:style>
+      </p:cxnSp>
+      <p:cxnSp>
+        <p:nvCxnSpPr>
+          <p:cNvPr id="93" name="Arrow 93"/>
+          <p:cNvCxnSpPr/>
+          <p:nvPr/>
+        </p:nvCxnSpPr>
+        <p:spPr>
+          <a:xfrm>
+            <a:off x="8503920" y="2834640"/>
+            <a:ext cx="0" cy="164591"/>
+          </a:xfrm>
+          <a:prstGeom prst="line">
+            <a:avLst/>
+          </a:prstGeom>
+          <a:ln w="19050">
+            <a:solidFill>
+              <a:srgbClr val="52606C"/>
+            </a:solidFill>
+            <a:tailEnd type="triangle"/>
+          </a:ln>
+        </p:spPr>
+        <p:style>
+          <a:lnRef idx="1">
+            <a:schemeClr val="accent1"/>
+          </a:lnRef>
+          <a:fillRef idx="0">
+            <a:schemeClr val="accent1"/>
+          </a:fillRef>
+          <a:effectRef idx="0">
+            <a:schemeClr val="accent1"/>
+          </a:effectRef>
+          <a:fontRef idx="minor">
+            <a:schemeClr val="tx1"/>
+          </a:fontRef>
+        </p:style>
+      </p:cxnSp>
+      <p:cxnSp>
+        <p:nvCxnSpPr>
+          <p:cNvPr id="94" name="Arrow 94"/>
+          <p:cNvCxnSpPr/>
+          <p:nvPr/>
+        </p:nvCxnSpPr>
+        <p:spPr>
+          <a:xfrm>
+            <a:off x="8503920" y="3749039"/>
+            <a:ext cx="0" cy="164592"/>
+          </a:xfrm>
+          <a:prstGeom prst="line">
+            <a:avLst/>
+          </a:prstGeom>
+          <a:ln w="19050">
+            <a:solidFill>
+              <a:srgbClr val="52606C"/>
+            </a:solidFill>
+            <a:tailEnd type="triangle"/>
+          </a:ln>
+        </p:spPr>
+        <p:style>
+          <a:lnRef idx="1">
+            <a:schemeClr val="accent1"/>
+          </a:lnRef>
+          <a:fillRef idx="0">
+            <a:schemeClr val="accent1"/>
+          </a:fillRef>
+          <a:effectRef idx="0">
+            <a:schemeClr val="accent1"/>
+          </a:effectRef>
+          <a:fontRef idx="minor">
+            <a:schemeClr val="tx1"/>
+          </a:fontRef>
+        </p:style>
+      </p:cxnSp>
+      <p:sp>
+        <p:nvSpPr>
+          <p:cNvPr id="95" name="Text 95"/>
+          <p:cNvSpPr txBox="1"/>
+          <p:nvPr/>
+        </p:nvSpPr>
+        <p:spPr>
+          <a:xfrm>
+            <a:off x="896112" y="5166360"/>
+            <a:ext cx="9921240" cy="658368"/>
+          </a:xfrm>
+          <a:prstGeom prst="rect">
+            <a:avLst/>
+          </a:prstGeom>
+          <a:solidFill>
+            <a:srgbClr val="FFF7E0"/>
+          </a:solidFill>
+          <a:ln w="9525">
+            <a:solidFill>
+              <a:srgbClr val="CC9900"/>
+            </a:solidFill>
+          </a:ln>
+        </p:spPr>
+        <p:txBody>
+          <a:bodyPr wrap="square" lIns="91440" rIns="91440" tIns="45720" bIns="45720">
+            <a:normAutofit fontScale="85000" lnSpcReduction="20000"/>
+          </a:bodyPr>
+          <a:lstStyle/>
+          <a:p>
+            <a:pPr algn="l"/>
+            <a:r>
+              <a:rPr lang="en-US" sz="1600" b="0">
+                <a:solidFill>
+                  <a:srgbClr val="142030"/>
+                </a:solidFill>
+                <a:latin typeface="Aptos"/>
+              </a:rPr>
+              <a:t>Presentation link: the mathematical model is explained in the slides; moving graphs are shown separately during the live demonstration.</a:t>
             </a:r>
           </a:p>
         </p:txBody>
@@ -5347,7 +5967,7 @@
       </p:grpSpPr>
       <p:sp>
         <p:nvSpPr>
-          <p:cNvPr id="89" name="Text 89"/>
+          <p:cNvPr id="97" name="Text 97"/>
           <p:cNvSpPr txBox="1"/>
           <p:nvPr/>
         </p:nvSpPr>
@@ -5378,14 +5998,14 @@
                 </a:solidFill>
                 <a:latin typeface="Aptos"/>
               </a:rPr>
-              <a:t>Simulation Results: Intervention Comparison</a:t>
-            </a:r>
-          </a:p>
-        </p:txBody>
-      </p:sp>
-      <p:sp>
-        <p:nvSpPr>
-          <p:cNvPr id="90" name="Text 90"/>
+              <a:t>Baseline Simulation Result</a:t>
+            </a:r>
+          </a:p>
+        </p:txBody>
+      </p:sp>
+      <p:sp>
+        <p:nvSpPr>
+          <p:cNvPr id="98" name="Text 98"/>
           <p:cNvSpPr txBox="1"/>
           <p:nvPr/>
         </p:nvSpPr>
@@ -5425,7 +6045,7 @@
       </p:sp>
       <p:sp>
         <p:nvSpPr>
-          <p:cNvPr id="91" name="Text 91"/>
+          <p:cNvPr id="99" name="Text 99"/>
           <p:cNvSpPr txBox="1"/>
           <p:nvPr/>
         </p:nvSpPr>
@@ -5465,7 +6085,7 @@
       </p:sp>
       <p:pic>
         <p:nvPicPr>
-          <p:cNvPr id="88" name="presentation_interventions.png"/>
+          <p:cNvPr id="96" name="presentation_baseline.png"/>
           <p:cNvPicPr/>
           <p:nvPr/>
         </p:nvPicPr>
@@ -5477,8 +6097,8 @@
         </p:blipFill>
         <p:spPr>
           <a:xfrm>
-            <a:off x="384048" y="1078992"/>
-            <a:ext cx="11430000" cy="3730752"/>
+            <a:off x="292608" y="1078992"/>
+            <a:ext cx="11631168" cy="3931920"/>
           </a:xfrm>
           <a:prstGeom prst="rect">
             <a:avLst/>
@@ -5487,7 +6107,7 @@
       </p:pic>
       <p:sp>
         <p:nvSpPr>
-          <p:cNvPr id="92" name="Text 92"/>
+          <p:cNvPr id="100" name="Text 100"/>
           <p:cNvSpPr txBox="1"/>
           <p:nvPr/>
         </p:nvSpPr>
@@ -5522,7 +6142,7 @@
                 </a:solidFill>
                 <a:latin typeface="Aptos"/>
               </a:rPr>
-              <a:t>▶ Lower curves mean fewer infected individuals. Combined strategies act on transmission, treatment movement, and AIDS progression together. Source: submitted report, Chapter 6 intervention comparison.</a:t>
+              <a:t>▶ R0 = 0.430 &lt; 1. The infected class starts at I(0)=150 and declines to I=3.1; treatment remains visible at T=94.3. Source: submitted report, Chapter 6 baseline simulation.</a:t>
             </a:r>
           </a:p>
         </p:txBody>

</xml_diff>

<commit_message>
Update presentation links for live demo access and local backup
</commit_message>
<xml_diff>
--- a/presentation/FracHIV_SITA_Presentation.pptx
+++ b/presentation/FracHIV_SITA_Presentation.pptx
@@ -5906,8 +5906,8 @@
         </p:nvSpPr>
         <p:spPr>
           <a:xfrm>
-            <a:off x="896112" y="5166360"/>
-            <a:ext cx="9921240" cy="658368"/>
+            <a:off x="896112" y="5074920"/>
+            <a:ext cx="9921240" cy="841248"/>
           </a:xfrm>
           <a:prstGeom prst="rect">
             <a:avLst/>
@@ -5929,13 +5929,37 @@
           <a:p>
             <a:pPr algn="l"/>
             <a:r>
-              <a:rPr lang="en-US" sz="1600" b="0">
-                <a:solidFill>
-                  <a:srgbClr val="142030"/>
-                </a:solidFill>
-                <a:latin typeface="Aptos"/>
-              </a:rPr>
-              <a:t>Presentation link: the mathematical model is explained in the slides; moving graphs are shown separately during the live demonstration.</a:t>
+              <a:rPr lang="en-US" sz="1400" b="0">
+                <a:solidFill>
+                  <a:srgbClr val="142030"/>
+                </a:solidFill>
+                <a:latin typeface="Aptos"/>
+              </a:rPr>
+              <a:t>Dashboard access for the live demo</a:t>
+            </a:r>
+          </a:p>
+          <a:p>
+            <a:pPr algn="l"/>
+            <a:r>
+              <a:rPr lang="en-US" sz="1400" b="0">
+                <a:solidFill>
+                  <a:srgbClr val="142030"/>
+                </a:solidFill>
+                <a:latin typeface="Aptos"/>
+              </a:rPr>
+              <a:t>Hosted: https://hiv-model.onrender.com/dashboard</a:t>
+            </a:r>
+          </a:p>
+          <a:p>
+            <a:pPr algn="l"/>
+            <a:r>
+              <a:rPr lang="en-US" sz="1400" b="0">
+                <a:solidFill>
+                  <a:srgbClr val="142030"/>
+                </a:solidFill>
+                <a:latin typeface="Aptos"/>
+              </a:rPr>
+              <a:t>Local backup: http://127.0.0.1:5000/dashboard</a:t>
             </a:r>
           </a:p>
         </p:txBody>

</xml_diff>